<commit_message>
Regenerated PyMol plots for Zorya. Wrote out results as .tsv.
</commit_message>
<xml_diff>
--- a/reports/2026-04-10_projectUpdate_2_jmoran.pptx
+++ b/reports/2026-04-10_projectUpdate_2_jmoran.pptx
@@ -5,14 +5,17 @@
     <p:sldMasterId id="2147483648" r:id="rId1"/>
   </p:sldMasterIdLst>
   <p:notesMasterIdLst>
-    <p:notesMasterId r:id="rId7"/>
+    <p:notesMasterId r:id="rId10"/>
   </p:notesMasterIdLst>
   <p:sldIdLst>
     <p:sldId id="256" r:id="rId2"/>
     <p:sldId id="266" r:id="rId3"/>
     <p:sldId id="268" r:id="rId4"/>
     <p:sldId id="257" r:id="rId5"/>
-    <p:sldId id="267" r:id="rId6"/>
+    <p:sldId id="269" r:id="rId6"/>
+    <p:sldId id="271" r:id="rId7"/>
+    <p:sldId id="270" r:id="rId8"/>
+    <p:sldId id="267" r:id="rId9"/>
   </p:sldIdLst>
   <p:sldSz cx="12192000" cy="6858000"/>
   <p:notesSz cx="6858000" cy="9144000"/>
@@ -5799,7 +5802,7 @@
             <p:spPr>
               <a:xfrm>
                 <a:off x="5450258" y="6236616"/>
-                <a:ext cx="2715972" cy="567143"/>
+                <a:ext cx="2715972" cy="401777"/>
               </a:xfrm>
               <a:prstGeom prst="rect">
                 <a:avLst/>
@@ -5824,13 +5827,13 @@
                 <a14:m>
                   <m:oMath xmlns:m="http://schemas.openxmlformats.org/officeDocument/2006/math">
                     <m:r>
-                      <a:rPr lang="en-US" sz="1000" i="1" dirty="0" smtClean="0">
+                      <a:rPr lang="en-US" sz="1000" b="0" i="1" dirty="0" smtClean="0">
                         <a:solidFill>
                           <a:srgbClr val="FF0000"/>
                         </a:solidFill>
                         <a:latin typeface="Cambria Math" panose="02040503050406030204" pitchFamily="18" charset="0"/>
                       </a:rPr>
-                      <m:t>𝑝𝑟𝑜𝑏𝑎𝑏𝑖𝑙𝑖𝑡𝑦</m:t>
+                      <m:t>𝑒</m:t>
                     </m:r>
                     <m:r>
                       <a:rPr lang="en-US" sz="1000" i="1" dirty="0" smtClean="0">
@@ -5914,7 +5917,7 @@
             <p:spPr>
               <a:xfrm>
                 <a:off x="5450258" y="6236616"/>
-                <a:ext cx="2715972" cy="567143"/>
+                <a:ext cx="2715972" cy="401777"/>
               </a:xfrm>
               <a:prstGeom prst="rect">
                 <a:avLst/>
@@ -5922,7 +5925,7 @@
               <a:blipFill>
                 <a:blip r:embed="rId3"/>
                 <a:stretch>
-                  <a:fillRect b="-3226"/>
+                  <a:fillRect b="-7576"/>
                 </a:stretch>
               </a:blipFill>
             </p:spPr>
@@ -6402,6 +6405,696 @@
 </file>
 
 <file path=ppt/slides/slide5.xml><?xml version="1.0" encoding="utf-8"?>
+<p:sld xmlns:a="http://schemas.openxmlformats.org/drawingml/2006/main" xmlns:r="http://schemas.openxmlformats.org/officeDocument/2006/relationships" xmlns:p="http://schemas.openxmlformats.org/presentationml/2006/main">
+  <p:cSld>
+    <p:spTree>
+      <p:nvGrpSpPr>
+        <p:cNvPr id="1" name=""/>
+        <p:cNvGrpSpPr/>
+        <p:nvPr/>
+      </p:nvGrpSpPr>
+      <p:grpSpPr>
+        <a:xfrm>
+          <a:off x="0" y="0"/>
+          <a:ext cx="0" cy="0"/>
+          <a:chOff x="0" y="0"/>
+          <a:chExt cx="0" cy="0"/>
+        </a:xfrm>
+      </p:grpSpPr>
+      <p:pic>
+        <p:nvPicPr>
+          <p:cNvPr id="9" name="Graphic 8">
+            <a:extLst>
+              <a:ext uri="{FF2B5EF4-FFF2-40B4-BE49-F238E27FC236}">
+                <a16:creationId xmlns:a16="http://schemas.microsoft.com/office/drawing/2014/main" id="{14782A36-411B-BF91-D3A3-983BB97D924E}"/>
+              </a:ext>
+            </a:extLst>
+          </p:cNvPr>
+          <p:cNvPicPr>
+            <a:picLocks noChangeAspect="1"/>
+          </p:cNvPicPr>
+          <p:nvPr/>
+        </p:nvPicPr>
+        <p:blipFill>
+          <a:blip>
+            <a:extLst>
+              <a:ext uri="{96DAC541-7B7A-43D3-8B79-37D633B846F1}">
+                <asvg:svgBlip xmlns:asvg="http://schemas.microsoft.com/office/drawing/2016/SVG/main" r:embed="rId2"/>
+              </a:ext>
+            </a:extLst>
+          </a:blip>
+          <a:srcRect t="8368" r="7181"/>
+          <a:stretch>
+            <a:fillRect/>
+          </a:stretch>
+        </p:blipFill>
+        <p:spPr>
+          <a:xfrm>
+            <a:off x="875222" y="1297636"/>
+            <a:ext cx="5092460" cy="5027303"/>
+          </a:xfrm>
+          <a:prstGeom prst="rect">
+            <a:avLst/>
+          </a:prstGeom>
+        </p:spPr>
+      </p:pic>
+      <p:sp>
+        <p:nvSpPr>
+          <p:cNvPr id="11" name="TextBox 10">
+            <a:extLst>
+              <a:ext uri="{FF2B5EF4-FFF2-40B4-BE49-F238E27FC236}">
+                <a16:creationId xmlns:a16="http://schemas.microsoft.com/office/drawing/2014/main" id="{65200952-412A-5895-354A-B719DD9272A7}"/>
+              </a:ext>
+            </a:extLst>
+          </p:cNvPr>
+          <p:cNvSpPr txBox="1"/>
+          <p:nvPr/>
+        </p:nvSpPr>
+        <p:spPr>
+          <a:xfrm>
+            <a:off x="4791075" y="1503203"/>
+            <a:ext cx="946150" cy="246221"/>
+          </a:xfrm>
+          <a:prstGeom prst="rect">
+            <a:avLst/>
+          </a:prstGeom>
+          <a:noFill/>
+        </p:spPr>
+        <p:txBody>
+          <a:bodyPr wrap="square" rtlCol="0">
+            <a:spAutoFit/>
+          </a:bodyPr>
+          <a:lstStyle/>
+          <a:p>
+            <a:pPr algn="r"/>
+            <a:r>
+              <a:rPr lang="en-US" sz="1000" dirty="0">
+                <a:latin typeface="Verdana Pro" panose="020B0604030504040204" pitchFamily="34" charset="0"/>
+              </a:rPr>
+              <a:t>n = 237</a:t>
+            </a:r>
+            <a:endParaRPr lang="en-CA" sz="1000" dirty="0">
+              <a:latin typeface="Verdana Pro" panose="020B0604030504040204" pitchFamily="34" charset="0"/>
+            </a:endParaRPr>
+          </a:p>
+        </p:txBody>
+      </p:sp>
+      <p:sp>
+        <p:nvSpPr>
+          <p:cNvPr id="4" name="Rectangle: Rounded Corners 3">
+            <a:extLst>
+              <a:ext uri="{FF2B5EF4-FFF2-40B4-BE49-F238E27FC236}">
+                <a16:creationId xmlns:a16="http://schemas.microsoft.com/office/drawing/2014/main" id="{89DE0692-D05C-BB80-EDC6-E37435C6FA25}"/>
+              </a:ext>
+            </a:extLst>
+          </p:cNvPr>
+          <p:cNvSpPr/>
+          <p:nvPr/>
+        </p:nvSpPr>
+        <p:spPr>
+          <a:xfrm>
+            <a:off x="315257" y="267370"/>
+            <a:ext cx="9363581" cy="628742"/>
+          </a:xfrm>
+          <a:prstGeom prst="roundRect">
+            <a:avLst/>
+          </a:prstGeom>
+          <a:solidFill>
+            <a:srgbClr val="0162B3"/>
+          </a:solidFill>
+          <a:ln>
+            <a:solidFill>
+              <a:srgbClr val="0162B3"/>
+            </a:solidFill>
+          </a:ln>
+        </p:spPr>
+        <p:style>
+          <a:lnRef idx="2">
+            <a:schemeClr val="accent1">
+              <a:shade val="50000"/>
+            </a:schemeClr>
+          </a:lnRef>
+          <a:fillRef idx="1">
+            <a:schemeClr val="accent1"/>
+          </a:fillRef>
+          <a:effectRef idx="0">
+            <a:schemeClr val="accent1"/>
+          </a:effectRef>
+          <a:fontRef idx="minor">
+            <a:schemeClr val="lt1"/>
+          </a:fontRef>
+        </p:style>
+        <p:txBody>
+          <a:bodyPr rtlCol="0" anchor="ctr"/>
+          <a:lstStyle>
+            <a:defPPr>
+              <a:defRPr lang="en-US"/>
+            </a:defPPr>
+            <a:lvl1pPr marL="0" algn="l" defTabSz="914400" rtl="0" eaLnBrk="1" latinLnBrk="0" hangingPunct="1">
+              <a:defRPr sz="1800" kern="1200">
+                <a:solidFill>
+                  <a:schemeClr val="lt1"/>
+                </a:solidFill>
+                <a:latin typeface="+mn-lt"/>
+                <a:ea typeface="+mn-ea"/>
+                <a:cs typeface="+mn-cs"/>
+              </a:defRPr>
+            </a:lvl1pPr>
+            <a:lvl2pPr marL="457200" algn="l" defTabSz="914400" rtl="0" eaLnBrk="1" latinLnBrk="0" hangingPunct="1">
+              <a:defRPr sz="1800" kern="1200">
+                <a:solidFill>
+                  <a:schemeClr val="lt1"/>
+                </a:solidFill>
+                <a:latin typeface="+mn-lt"/>
+                <a:ea typeface="+mn-ea"/>
+                <a:cs typeface="+mn-cs"/>
+              </a:defRPr>
+            </a:lvl2pPr>
+            <a:lvl3pPr marL="914400" algn="l" defTabSz="914400" rtl="0" eaLnBrk="1" latinLnBrk="0" hangingPunct="1">
+              <a:defRPr sz="1800" kern="1200">
+                <a:solidFill>
+                  <a:schemeClr val="lt1"/>
+                </a:solidFill>
+                <a:latin typeface="+mn-lt"/>
+                <a:ea typeface="+mn-ea"/>
+                <a:cs typeface="+mn-cs"/>
+              </a:defRPr>
+            </a:lvl3pPr>
+            <a:lvl4pPr marL="1371600" algn="l" defTabSz="914400" rtl="0" eaLnBrk="1" latinLnBrk="0" hangingPunct="1">
+              <a:defRPr sz="1800" kern="1200">
+                <a:solidFill>
+                  <a:schemeClr val="lt1"/>
+                </a:solidFill>
+                <a:latin typeface="+mn-lt"/>
+                <a:ea typeface="+mn-ea"/>
+                <a:cs typeface="+mn-cs"/>
+              </a:defRPr>
+            </a:lvl4pPr>
+            <a:lvl5pPr marL="1828800" algn="l" defTabSz="914400" rtl="0" eaLnBrk="1" latinLnBrk="0" hangingPunct="1">
+              <a:defRPr sz="1800" kern="1200">
+                <a:solidFill>
+                  <a:schemeClr val="lt1"/>
+                </a:solidFill>
+                <a:latin typeface="+mn-lt"/>
+                <a:ea typeface="+mn-ea"/>
+                <a:cs typeface="+mn-cs"/>
+              </a:defRPr>
+            </a:lvl5pPr>
+            <a:lvl6pPr marL="2286000" algn="l" defTabSz="914400" rtl="0" eaLnBrk="1" latinLnBrk="0" hangingPunct="1">
+              <a:defRPr sz="1800" kern="1200">
+                <a:solidFill>
+                  <a:schemeClr val="lt1"/>
+                </a:solidFill>
+                <a:latin typeface="+mn-lt"/>
+                <a:ea typeface="+mn-ea"/>
+                <a:cs typeface="+mn-cs"/>
+              </a:defRPr>
+            </a:lvl6pPr>
+            <a:lvl7pPr marL="2743200" algn="l" defTabSz="914400" rtl="0" eaLnBrk="1" latinLnBrk="0" hangingPunct="1">
+              <a:defRPr sz="1800" kern="1200">
+                <a:solidFill>
+                  <a:schemeClr val="lt1"/>
+                </a:solidFill>
+                <a:latin typeface="+mn-lt"/>
+                <a:ea typeface="+mn-ea"/>
+                <a:cs typeface="+mn-cs"/>
+              </a:defRPr>
+            </a:lvl7pPr>
+            <a:lvl8pPr marL="3200400" algn="l" defTabSz="914400" rtl="0" eaLnBrk="1" latinLnBrk="0" hangingPunct="1">
+              <a:defRPr sz="1800" kern="1200">
+                <a:solidFill>
+                  <a:schemeClr val="lt1"/>
+                </a:solidFill>
+                <a:latin typeface="+mn-lt"/>
+                <a:ea typeface="+mn-ea"/>
+                <a:cs typeface="+mn-cs"/>
+              </a:defRPr>
+            </a:lvl8pPr>
+            <a:lvl9pPr marL="3657600" algn="l" defTabSz="914400" rtl="0" eaLnBrk="1" latinLnBrk="0" hangingPunct="1">
+              <a:defRPr sz="1800" kern="1200">
+                <a:solidFill>
+                  <a:schemeClr val="lt1"/>
+                </a:solidFill>
+                <a:latin typeface="+mn-lt"/>
+                <a:ea typeface="+mn-ea"/>
+                <a:cs typeface="+mn-cs"/>
+              </a:defRPr>
+            </a:lvl9pPr>
+          </a:lstStyle>
+          <a:p>
+            <a:pPr algn="ctr"/>
+            <a:endParaRPr lang="en-CA"/>
+          </a:p>
+        </p:txBody>
+      </p:sp>
+      <p:sp>
+        <p:nvSpPr>
+          <p:cNvPr id="5" name="TextBox 4">
+            <a:extLst>
+              <a:ext uri="{FF2B5EF4-FFF2-40B4-BE49-F238E27FC236}">
+                <a16:creationId xmlns:a16="http://schemas.microsoft.com/office/drawing/2014/main" id="{6526F973-03F9-14B6-88BB-FABBEC18960C}"/>
+              </a:ext>
+            </a:extLst>
+          </p:cNvPr>
+          <p:cNvSpPr txBox="1"/>
+          <p:nvPr/>
+        </p:nvSpPr>
+        <p:spPr>
+          <a:xfrm>
+            <a:off x="527959" y="335519"/>
+            <a:ext cx="8710932" cy="492443"/>
+          </a:xfrm>
+          <a:prstGeom prst="rect">
+            <a:avLst/>
+          </a:prstGeom>
+          <a:noFill/>
+        </p:spPr>
+        <p:txBody>
+          <a:bodyPr wrap="square" rtlCol="0">
+            <a:spAutoFit/>
+          </a:bodyPr>
+          <a:lstStyle/>
+          <a:p>
+            <a:r>
+              <a:rPr lang="en-US" sz="2600" b="1" dirty="0">
+                <a:solidFill>
+                  <a:schemeClr val="bg1"/>
+                </a:solidFill>
+                <a:latin typeface="Georgia Pro" panose="02040502050405020303" pitchFamily="18" charset="0"/>
+              </a:rPr>
+              <a:t>Why use PyMol to check structural alignment?</a:t>
+            </a:r>
+            <a:endParaRPr lang="en-CA" sz="2600" b="1" dirty="0">
+              <a:solidFill>
+                <a:schemeClr val="bg1"/>
+              </a:solidFill>
+              <a:latin typeface="Georgia Pro" panose="02040502050405020303" pitchFamily="18" charset="0"/>
+            </a:endParaRPr>
+          </a:p>
+        </p:txBody>
+      </p:sp>
+      <p:sp>
+        <p:nvSpPr>
+          <p:cNvPr id="10" name="Oval 9">
+            <a:extLst>
+              <a:ext uri="{FF2B5EF4-FFF2-40B4-BE49-F238E27FC236}">
+                <a16:creationId xmlns:a16="http://schemas.microsoft.com/office/drawing/2014/main" id="{986CD2DF-6E36-8BCD-7326-6881563C8621}"/>
+              </a:ext>
+            </a:extLst>
+          </p:cNvPr>
+          <p:cNvSpPr/>
+          <p:nvPr/>
+        </p:nvSpPr>
+        <p:spPr>
+          <a:xfrm>
+            <a:off x="4885922" y="1588212"/>
+            <a:ext cx="92075" cy="95250"/>
+          </a:xfrm>
+          <a:prstGeom prst="ellipse">
+            <a:avLst/>
+          </a:prstGeom>
+          <a:solidFill>
+            <a:srgbClr val="0000FF"/>
+          </a:solidFill>
+          <a:ln>
+            <a:noFill/>
+          </a:ln>
+        </p:spPr>
+        <p:style>
+          <a:lnRef idx="2">
+            <a:schemeClr val="accent1">
+              <a:shade val="15000"/>
+            </a:schemeClr>
+          </a:lnRef>
+          <a:fillRef idx="1">
+            <a:schemeClr val="accent1"/>
+          </a:fillRef>
+          <a:effectRef idx="0">
+            <a:schemeClr val="accent1"/>
+          </a:effectRef>
+          <a:fontRef idx="minor">
+            <a:schemeClr val="lt1"/>
+          </a:fontRef>
+        </p:style>
+        <p:txBody>
+          <a:bodyPr rtlCol="0" anchor="ctr"/>
+          <a:lstStyle/>
+          <a:p>
+            <a:pPr algn="ctr"/>
+            <a:endParaRPr lang="en-CA"/>
+          </a:p>
+        </p:txBody>
+      </p:sp>
+      <p:sp>
+        <p:nvSpPr>
+          <p:cNvPr id="12" name="Rectangle: Rounded Corners 11">
+            <a:extLst>
+              <a:ext uri="{FF2B5EF4-FFF2-40B4-BE49-F238E27FC236}">
+                <a16:creationId xmlns:a16="http://schemas.microsoft.com/office/drawing/2014/main" id="{0ECBBA88-A498-EFBE-EAFC-A118DADA2326}"/>
+              </a:ext>
+            </a:extLst>
+          </p:cNvPr>
+          <p:cNvSpPr/>
+          <p:nvPr/>
+        </p:nvSpPr>
+        <p:spPr>
+          <a:xfrm>
+            <a:off x="4791073" y="1530576"/>
+            <a:ext cx="946151" cy="212498"/>
+          </a:xfrm>
+          <a:prstGeom prst="roundRect">
+            <a:avLst/>
+          </a:prstGeom>
+          <a:noFill/>
+          <a:ln w="9525">
+            <a:solidFill>
+              <a:schemeClr val="bg1">
+                <a:lumMod val="85000"/>
+              </a:schemeClr>
+            </a:solidFill>
+          </a:ln>
+        </p:spPr>
+        <p:style>
+          <a:lnRef idx="2">
+            <a:schemeClr val="accent1">
+              <a:shade val="15000"/>
+            </a:schemeClr>
+          </a:lnRef>
+          <a:fillRef idx="1">
+            <a:schemeClr val="accent1"/>
+          </a:fillRef>
+          <a:effectRef idx="0">
+            <a:schemeClr val="accent1"/>
+          </a:effectRef>
+          <a:fontRef idx="minor">
+            <a:schemeClr val="lt1"/>
+          </a:fontRef>
+        </p:style>
+        <p:txBody>
+          <a:bodyPr rtlCol="0" anchor="ctr"/>
+          <a:lstStyle/>
+          <a:p>
+            <a:pPr algn="ctr"/>
+            <a:endParaRPr lang="en-CA"/>
+          </a:p>
+        </p:txBody>
+      </p:sp>
+      <mc:AlternateContent xmlns:mc="http://schemas.openxmlformats.org/markup-compatibility/2006">
+        <mc:Choice xmlns:a14="http://schemas.microsoft.com/office/drawing/2010/main" Requires="a14">
+          <p:sp>
+            <p:nvSpPr>
+              <p:cNvPr id="13" name="TextBox 12">
+                <a:extLst>
+                  <a:ext uri="{FF2B5EF4-FFF2-40B4-BE49-F238E27FC236}">
+                    <a16:creationId xmlns:a16="http://schemas.microsoft.com/office/drawing/2014/main" id="{1996BCAD-5AA8-ED57-A337-0FC563367AAA}"/>
+                  </a:ext>
+                </a:extLst>
+              </p:cNvPr>
+              <p:cNvSpPr txBox="1"/>
+              <p:nvPr/>
+            </p:nvSpPr>
+            <p:spPr>
+              <a:xfrm>
+                <a:off x="6644626" y="1992440"/>
+                <a:ext cx="4406900" cy="2585323"/>
+              </a:xfrm>
+              <a:prstGeom prst="rect">
+                <a:avLst/>
+              </a:prstGeom>
+              <a:noFill/>
+            </p:spPr>
+            <p:txBody>
+              <a:bodyPr wrap="square" rtlCol="0">
+                <a:spAutoFit/>
+              </a:bodyPr>
+              <a:lstStyle/>
+              <a:p>
+                <a:r>
+                  <a:rPr lang="en-US" dirty="0">
+                    <a:latin typeface="Georgia Pro" panose="02040502050405020303" pitchFamily="18" charset="0"/>
+                  </a:rPr>
+                  <a:t>PyMol super can achieve good alignment when TM-align cannot </a:t>
+                </a:r>
+              </a:p>
+              <a:p>
+                <a:r>
+                  <a:rPr lang="en-US" dirty="0">
+                    <a:latin typeface="Georgia Pro" panose="02040502050405020303" pitchFamily="18" charset="0"/>
+                  </a:rPr>
+                  <a:t>(see top-left quadrant vs. bottom-right).</a:t>
+                </a:r>
+              </a:p>
+              <a:p>
+                <a:endParaRPr lang="en-US" dirty="0">
+                  <a:latin typeface="Georgia Pro" panose="02040502050405020303" pitchFamily="18" charset="0"/>
+                </a:endParaRPr>
+              </a:p>
+              <a:p>
+                <a:r>
+                  <a:rPr lang="en-US" dirty="0">
+                    <a:latin typeface="Georgia Pro" panose="02040502050405020303" pitchFamily="18" charset="0"/>
+                  </a:rPr>
+                  <a:t>However, this should always be checked against a threshold of </a:t>
+                </a:r>
+                <a14:m>
+                  <m:oMath xmlns:m="http://schemas.openxmlformats.org/officeDocument/2006/math">
+                    <m:r>
+                      <a:rPr lang="en-US" b="0" i="1" smtClean="0">
+                        <a:latin typeface="Cambria Math" panose="02040503050406030204" pitchFamily="18" charset="0"/>
+                      </a:rPr>
+                      <m:t>𝑒</m:t>
+                    </m:r>
+                    <m:r>
+                      <a:rPr lang="en-US" b="0" i="1" smtClean="0">
+                        <a:latin typeface="Cambria Math" panose="02040503050406030204" pitchFamily="18" charset="0"/>
+                      </a:rPr>
+                      <m:t>&lt;0.05</m:t>
+                    </m:r>
+                  </m:oMath>
+                </a14:m>
+                <a:r>
+                  <a:rPr lang="en-CA" dirty="0">
+                    <a:latin typeface="Georgia Pro" panose="02040502050405020303" pitchFamily="18" charset="0"/>
+                  </a:rPr>
+                  <a:t> (after multiple hypothesis correction) to confirm that the alignment is not due to random chance.</a:t>
+                </a:r>
+              </a:p>
+            </p:txBody>
+          </p:sp>
+        </mc:Choice>
+        <mc:Fallback>
+          <p:sp>
+            <p:nvSpPr>
+              <p:cNvPr id="13" name="TextBox 12">
+                <a:extLst>
+                  <a:ext uri="{FF2B5EF4-FFF2-40B4-BE49-F238E27FC236}">
+                    <a16:creationId xmlns:a16="http://schemas.microsoft.com/office/drawing/2014/main" id="{1996BCAD-5AA8-ED57-A337-0FC563367AAA}"/>
+                  </a:ext>
+                </a:extLst>
+              </p:cNvPr>
+              <p:cNvSpPr txBox="1">
+                <a:spLocks noRot="1" noChangeAspect="1" noMove="1" noResize="1" noEditPoints="1" noAdjustHandles="1" noChangeArrowheads="1" noChangeShapeType="1" noTextEdit="1"/>
+              </p:cNvSpPr>
+              <p:nvPr/>
+            </p:nvSpPr>
+            <p:spPr>
+              <a:xfrm>
+                <a:off x="6644626" y="1992440"/>
+                <a:ext cx="4406900" cy="2585323"/>
+              </a:xfrm>
+              <a:prstGeom prst="rect">
+                <a:avLst/>
+              </a:prstGeom>
+              <a:blipFill>
+                <a:blip r:embed="rId3"/>
+                <a:stretch>
+                  <a:fillRect l="-1245" t="-1415" r="-138" b="-2830"/>
+                </a:stretch>
+              </a:blipFill>
+            </p:spPr>
+            <p:txBody>
+              <a:bodyPr/>
+              <a:lstStyle/>
+              <a:p>
+                <a:r>
+                  <a:rPr lang="en-CA">
+                    <a:noFill/>
+                  </a:rPr>
+                  <a:t> </a:t>
+                </a:r>
+              </a:p>
+            </p:txBody>
+          </p:sp>
+        </mc:Fallback>
+      </mc:AlternateContent>
+    </p:spTree>
+    <p:extLst>
+      <p:ext uri="{BB962C8B-B14F-4D97-AF65-F5344CB8AC3E}">
+        <p14:creationId xmlns:p14="http://schemas.microsoft.com/office/powerpoint/2010/main" val="3384810624"/>
+      </p:ext>
+    </p:extLst>
+  </p:cSld>
+  <p:clrMapOvr>
+    <a:masterClrMapping/>
+  </p:clrMapOvr>
+</p:sld>
+</file>
+
+<file path=ppt/slides/slide6.xml><?xml version="1.0" encoding="utf-8"?>
+<p:sld xmlns:a="http://schemas.openxmlformats.org/drawingml/2006/main" xmlns:r="http://schemas.openxmlformats.org/officeDocument/2006/relationships" xmlns:p="http://schemas.openxmlformats.org/presentationml/2006/main">
+  <p:cSld>
+    <p:spTree>
+      <p:nvGrpSpPr>
+        <p:cNvPr id="1" name=""/>
+        <p:cNvGrpSpPr/>
+        <p:nvPr/>
+      </p:nvGrpSpPr>
+      <p:grpSpPr>
+        <a:xfrm>
+          <a:off x="0" y="0"/>
+          <a:ext cx="0" cy="0"/>
+          <a:chOff x="0" y="0"/>
+          <a:chExt cx="0" cy="0"/>
+        </a:xfrm>
+      </p:grpSpPr>
+      <p:sp>
+        <p:nvSpPr>
+          <p:cNvPr id="4" name="TextBox 3">
+            <a:extLst>
+              <a:ext uri="{FF2B5EF4-FFF2-40B4-BE49-F238E27FC236}">
+                <a16:creationId xmlns:a16="http://schemas.microsoft.com/office/drawing/2014/main" id="{EA095454-CFCD-6352-613B-E7BB2E9CF28C}"/>
+              </a:ext>
+            </a:extLst>
+          </p:cNvPr>
+          <p:cNvSpPr txBox="1"/>
+          <p:nvPr/>
+        </p:nvSpPr>
+        <p:spPr>
+          <a:xfrm>
+            <a:off x="197644" y="98985"/>
+            <a:ext cx="4406900" cy="646331"/>
+          </a:xfrm>
+          <a:prstGeom prst="rect">
+            <a:avLst/>
+          </a:prstGeom>
+          <a:noFill/>
+        </p:spPr>
+        <p:txBody>
+          <a:bodyPr wrap="square" rtlCol="0">
+            <a:spAutoFit/>
+          </a:bodyPr>
+          <a:lstStyle/>
+          <a:p>
+            <a:r>
+              <a:rPr lang="en-US" dirty="0">
+                <a:latin typeface="Georgia Pro" panose="02040502050405020303" pitchFamily="18" charset="0"/>
+              </a:rPr>
+              <a:t>To add – show examples of structural alignment from Zorya</a:t>
+            </a:r>
+            <a:endParaRPr lang="en-CA" dirty="0">
+              <a:latin typeface="Georgia Pro" panose="02040502050405020303" pitchFamily="18" charset="0"/>
+            </a:endParaRPr>
+          </a:p>
+        </p:txBody>
+      </p:sp>
+    </p:spTree>
+    <p:extLst>
+      <p:ext uri="{BB962C8B-B14F-4D97-AF65-F5344CB8AC3E}">
+        <p14:creationId xmlns:p14="http://schemas.microsoft.com/office/powerpoint/2010/main" val="2736092599"/>
+      </p:ext>
+    </p:extLst>
+  </p:cSld>
+  <p:clrMapOvr>
+    <a:masterClrMapping/>
+  </p:clrMapOvr>
+</p:sld>
+</file>
+
+<file path=ppt/slides/slide7.xml><?xml version="1.0" encoding="utf-8"?>
+<p:sld xmlns:a="http://schemas.openxmlformats.org/drawingml/2006/main" xmlns:r="http://schemas.openxmlformats.org/officeDocument/2006/relationships" xmlns:p="http://schemas.openxmlformats.org/presentationml/2006/main">
+  <p:cSld>
+    <p:bg>
+      <p:bgPr>
+        <a:solidFill>
+          <a:srgbClr val="0162B3"/>
+        </a:solidFill>
+        <a:effectLst/>
+      </p:bgPr>
+    </p:bg>
+    <p:spTree>
+      <p:nvGrpSpPr>
+        <p:cNvPr id="1" name=""/>
+        <p:cNvGrpSpPr/>
+        <p:nvPr/>
+      </p:nvGrpSpPr>
+      <p:grpSpPr>
+        <a:xfrm>
+          <a:off x="0" y="0"/>
+          <a:ext cx="0" cy="0"/>
+          <a:chOff x="0" y="0"/>
+          <a:chExt cx="0" cy="0"/>
+        </a:xfrm>
+      </p:grpSpPr>
+      <p:sp>
+        <p:nvSpPr>
+          <p:cNvPr id="5" name="TextBox 4">
+            <a:extLst>
+              <a:ext uri="{FF2B5EF4-FFF2-40B4-BE49-F238E27FC236}">
+                <a16:creationId xmlns:a16="http://schemas.microsoft.com/office/drawing/2014/main" id="{7461CE14-D010-B97D-F7F8-7C47881F3AD7}"/>
+              </a:ext>
+            </a:extLst>
+          </p:cNvPr>
+          <p:cNvSpPr txBox="1"/>
+          <p:nvPr/>
+        </p:nvSpPr>
+        <p:spPr>
+          <a:xfrm>
+            <a:off x="1072904" y="2312101"/>
+            <a:ext cx="5484914" cy="1692771"/>
+          </a:xfrm>
+          <a:prstGeom prst="rect">
+            <a:avLst/>
+          </a:prstGeom>
+          <a:noFill/>
+        </p:spPr>
+        <p:txBody>
+          <a:bodyPr wrap="square" rtlCol="0">
+            <a:spAutoFit/>
+          </a:bodyPr>
+          <a:lstStyle/>
+          <a:p>
+            <a:r>
+              <a:rPr lang="en-US" sz="2600" b="1" dirty="0">
+                <a:solidFill>
+                  <a:schemeClr val="bg1"/>
+                </a:solidFill>
+                <a:latin typeface="Georgia Pro" panose="02040502050405020303" pitchFamily="18" charset="0"/>
+              </a:rPr>
+              <a:t>To this end, we have incorporated PyMol super into our pipeline for interactive filtering</a:t>
+            </a:r>
+            <a:endParaRPr lang="en-CA" sz="2600" b="1" dirty="0">
+              <a:solidFill>
+                <a:schemeClr val="bg1"/>
+              </a:solidFill>
+              <a:latin typeface="Georgia Pro" panose="02040502050405020303" pitchFamily="18" charset="0"/>
+            </a:endParaRPr>
+          </a:p>
+        </p:txBody>
+      </p:sp>
+    </p:spTree>
+    <p:extLst>
+      <p:ext uri="{BB962C8B-B14F-4D97-AF65-F5344CB8AC3E}">
+        <p14:creationId xmlns:p14="http://schemas.microsoft.com/office/powerpoint/2010/main" val="2973388213"/>
+      </p:ext>
+    </p:extLst>
+  </p:cSld>
+  <p:clrMapOvr>
+    <a:masterClrMapping/>
+  </p:clrMapOvr>
+</p:sld>
+</file>
+
+<file path=ppt/slides/slide8.xml><?xml version="1.0" encoding="utf-8"?>
 <p:sld xmlns:a="http://schemas.openxmlformats.org/drawingml/2006/main" xmlns:r="http://schemas.openxmlformats.org/officeDocument/2006/relationships" xmlns:p="http://schemas.openxmlformats.org/presentationml/2006/main">
   <p:cSld>
     <p:spTree>

</xml_diff>

<commit_message>
Generated plot of PyMol pairwise alignment results for gold standard gene list.
</commit_message>
<xml_diff>
--- a/reports/2026-04-10_projectUpdate_2_jmoran.pptx
+++ b/reports/2026-04-10_projectUpdate_2_jmoran.pptx
@@ -208,7 +208,7 @@
           <a:p>
             <a:fld id="{1479C651-C459-48E3-86F1-CED449A3498B}" type="datetimeFigureOut">
               <a:rPr lang="en-CA" smtClean="0"/>
-              <a:t>2026-04-07</a:t>
+              <a:t>2026-04-08</a:t>
             </a:fld>
             <a:endParaRPr lang="en-CA"/>
           </a:p>
@@ -730,7 +730,7 @@
           <a:p>
             <a:fld id="{643EFF56-2492-48E5-B1E7-E04EEB44BBAA}" type="datetimeFigureOut">
               <a:rPr lang="en-CA" smtClean="0"/>
-              <a:t>2026-04-07</a:t>
+              <a:t>2026-04-08</a:t>
             </a:fld>
             <a:endParaRPr lang="en-CA"/>
           </a:p>
@@ -930,7 +930,7 @@
           <a:p>
             <a:fld id="{643EFF56-2492-48E5-B1E7-E04EEB44BBAA}" type="datetimeFigureOut">
               <a:rPr lang="en-CA" smtClean="0"/>
-              <a:t>2026-04-07</a:t>
+              <a:t>2026-04-08</a:t>
             </a:fld>
             <a:endParaRPr lang="en-CA"/>
           </a:p>
@@ -1140,7 +1140,7 @@
           <a:p>
             <a:fld id="{643EFF56-2492-48E5-B1E7-E04EEB44BBAA}" type="datetimeFigureOut">
               <a:rPr lang="en-CA" smtClean="0"/>
-              <a:t>2026-04-07</a:t>
+              <a:t>2026-04-08</a:t>
             </a:fld>
             <a:endParaRPr lang="en-CA"/>
           </a:p>
@@ -1340,7 +1340,7 @@
           <a:p>
             <a:fld id="{643EFF56-2492-48E5-B1E7-E04EEB44BBAA}" type="datetimeFigureOut">
               <a:rPr lang="en-CA" smtClean="0"/>
-              <a:t>2026-04-07</a:t>
+              <a:t>2026-04-08</a:t>
             </a:fld>
             <a:endParaRPr lang="en-CA"/>
           </a:p>
@@ -1616,7 +1616,7 @@
           <a:p>
             <a:fld id="{643EFF56-2492-48E5-B1E7-E04EEB44BBAA}" type="datetimeFigureOut">
               <a:rPr lang="en-CA" smtClean="0"/>
-              <a:t>2026-04-07</a:t>
+              <a:t>2026-04-08</a:t>
             </a:fld>
             <a:endParaRPr lang="en-CA"/>
           </a:p>
@@ -1884,7 +1884,7 @@
           <a:p>
             <a:fld id="{643EFF56-2492-48E5-B1E7-E04EEB44BBAA}" type="datetimeFigureOut">
               <a:rPr lang="en-CA" smtClean="0"/>
-              <a:t>2026-04-07</a:t>
+              <a:t>2026-04-08</a:t>
             </a:fld>
             <a:endParaRPr lang="en-CA"/>
           </a:p>
@@ -2299,7 +2299,7 @@
           <a:p>
             <a:fld id="{643EFF56-2492-48E5-B1E7-E04EEB44BBAA}" type="datetimeFigureOut">
               <a:rPr lang="en-CA" smtClean="0"/>
-              <a:t>2026-04-07</a:t>
+              <a:t>2026-04-08</a:t>
             </a:fld>
             <a:endParaRPr lang="en-CA"/>
           </a:p>
@@ -2441,7 +2441,7 @@
           <a:p>
             <a:fld id="{643EFF56-2492-48E5-B1E7-E04EEB44BBAA}" type="datetimeFigureOut">
               <a:rPr lang="en-CA" smtClean="0"/>
-              <a:t>2026-04-07</a:t>
+              <a:t>2026-04-08</a:t>
             </a:fld>
             <a:endParaRPr lang="en-CA"/>
           </a:p>
@@ -2554,7 +2554,7 @@
           <a:p>
             <a:fld id="{643EFF56-2492-48E5-B1E7-E04EEB44BBAA}" type="datetimeFigureOut">
               <a:rPr lang="en-CA" smtClean="0"/>
-              <a:t>2026-04-07</a:t>
+              <a:t>2026-04-08</a:t>
             </a:fld>
             <a:endParaRPr lang="en-CA"/>
           </a:p>
@@ -2867,7 +2867,7 @@
           <a:p>
             <a:fld id="{643EFF56-2492-48E5-B1E7-E04EEB44BBAA}" type="datetimeFigureOut">
               <a:rPr lang="en-CA" smtClean="0"/>
-              <a:t>2026-04-07</a:t>
+              <a:t>2026-04-08</a:t>
             </a:fld>
             <a:endParaRPr lang="en-CA"/>
           </a:p>
@@ -3156,7 +3156,7 @@
           <a:p>
             <a:fld id="{643EFF56-2492-48E5-B1E7-E04EEB44BBAA}" type="datetimeFigureOut">
               <a:rPr lang="en-CA" smtClean="0"/>
-              <a:t>2026-04-07</a:t>
+              <a:t>2026-04-08</a:t>
             </a:fld>
             <a:endParaRPr lang="en-CA"/>
           </a:p>
@@ -3399,7 +3399,7 @@
           <a:p>
             <a:fld id="{643EFF56-2492-48E5-B1E7-E04EEB44BBAA}" type="datetimeFigureOut">
               <a:rPr lang="en-CA" smtClean="0"/>
-              <a:t>2026-04-07</a:t>
+              <a:t>2026-04-08</a:t>
             </a:fld>
             <a:endParaRPr lang="en-CA"/>
           </a:p>
@@ -10406,6 +10406,43 @@
           </a:p>
         </p:txBody>
       </p:sp>
+      <p:pic>
+        <p:nvPicPr>
+          <p:cNvPr id="6" name="Graphic 5">
+            <a:extLst>
+              <a:ext uri="{FF2B5EF4-FFF2-40B4-BE49-F238E27FC236}">
+                <a16:creationId xmlns:a16="http://schemas.microsoft.com/office/drawing/2014/main" id="{E97A16E8-B5E1-C5E3-E508-1CB08B5FBDB1}"/>
+              </a:ext>
+            </a:extLst>
+          </p:cNvPr>
+          <p:cNvPicPr>
+            <a:picLocks noChangeAspect="1"/>
+          </p:cNvPicPr>
+          <p:nvPr/>
+        </p:nvPicPr>
+        <p:blipFill>
+          <a:blip>
+            <a:extLst>
+              <a:ext uri="{96DAC541-7B7A-43D3-8B79-37D633B846F1}">
+                <asvg:svgBlip xmlns:asvg="http://schemas.microsoft.com/office/drawing/2016/SVG/main" r:embed="rId2"/>
+              </a:ext>
+            </a:extLst>
+          </a:blip>
+          <a:srcRect t="10849" r="8850"/>
+          <a:stretch>
+            <a:fillRect/>
+          </a:stretch>
+        </p:blipFill>
+        <p:spPr>
+          <a:xfrm>
+            <a:off x="6931613" y="1587259"/>
+            <a:ext cx="4559865" cy="4459858"/>
+          </a:xfrm>
+          <a:prstGeom prst="rect">
+            <a:avLst/>
+          </a:prstGeom>
+        </p:spPr>
+      </p:pic>
     </p:spTree>
     <p:extLst>
       <p:ext uri="{BB962C8B-B14F-4D97-AF65-F5344CB8AC3E}">
@@ -10560,43 +10597,6 @@
           </a:p>
         </p:txBody>
       </p:sp>
-      <p:pic>
-        <p:nvPicPr>
-          <p:cNvPr id="5" name="Graphic 4">
-            <a:extLst>
-              <a:ext uri="{FF2B5EF4-FFF2-40B4-BE49-F238E27FC236}">
-                <a16:creationId xmlns:a16="http://schemas.microsoft.com/office/drawing/2014/main" id="{B0E63486-0799-AD73-7B2C-7A985FEA449A}"/>
-              </a:ext>
-            </a:extLst>
-          </p:cNvPr>
-          <p:cNvPicPr>
-            <a:picLocks noChangeAspect="1"/>
-          </p:cNvPicPr>
-          <p:nvPr/>
-        </p:nvPicPr>
-        <p:blipFill>
-          <a:blip>
-            <a:extLst>
-              <a:ext uri="{96DAC541-7B7A-43D3-8B79-37D633B846F1}">
-                <asvg:svgBlip xmlns:asvg="http://schemas.microsoft.com/office/drawing/2016/SVG/main" r:embed="rId4"/>
-              </a:ext>
-            </a:extLst>
-          </a:blip>
-          <a:srcRect t="9961" r="11111"/>
-          <a:stretch>
-            <a:fillRect/>
-          </a:stretch>
-        </p:blipFill>
-        <p:spPr>
-          <a:xfrm>
-            <a:off x="276405" y="405443"/>
-            <a:ext cx="2955856" cy="2994101"/>
-          </a:xfrm>
-          <a:prstGeom prst="rect">
-            <a:avLst/>
-          </a:prstGeom>
-        </p:spPr>
-      </p:pic>
       <p:sp>
         <p:nvSpPr>
           <p:cNvPr id="15" name="TextBox 14">
@@ -10760,7 +10760,7 @@
           <p:nvPr/>
         </p:nvPicPr>
         <p:blipFill>
-          <a:blip r:embed="rId5"/>
+          <a:blip r:embed="rId4"/>
           <a:stretch>
             <a:fillRect/>
           </a:stretch>
@@ -11092,14 +11092,14 @@
           <p:nvPr>
             <p:extLst>
               <p:ext uri="{D42A27DB-BD31-4B8C-83A1-F6EECF244321}">
-                <p14:modId xmlns:p14="http://schemas.microsoft.com/office/powerpoint/2010/main" val="2744018598"/>
+                <p14:modId xmlns:p14="http://schemas.microsoft.com/office/powerpoint/2010/main" val="1769177759"/>
               </p:ext>
             </p:extLst>
           </p:nvPr>
         </p:nvGraphicFramePr>
         <p:xfrm>
-          <a:off x="411929" y="3754941"/>
-          <a:ext cx="2782890" cy="1097280"/>
+          <a:off x="350302" y="3647248"/>
+          <a:ext cx="2782890" cy="822960"/>
         </p:xfrm>
         <a:graphic>
           <a:graphicData uri="http://schemas.openxmlformats.org/drawingml/2006/table">
@@ -11252,125 +11252,6 @@
                         <a:rPr lang="en-US" sz="1200" dirty="0">
                           <a:latin typeface="Verdana Pro" panose="020B0604030504040204" pitchFamily="34" charset="0"/>
                         </a:rPr>
-                        <a:t>e-value</a:t>
-                      </a:r>
-                      <a:endParaRPr lang="en-CA" sz="1200" dirty="0">
-                        <a:latin typeface="Verdana Pro" panose="020B0604030504040204" pitchFamily="34" charset="0"/>
-                      </a:endParaRPr>
-                    </a:p>
-                  </a:txBody>
-                  <a:tcPr>
-                    <a:lnL w="6350" cap="flat" cmpd="sng" algn="ctr">
-                      <a:solidFill>
-                        <a:schemeClr val="tx1"/>
-                      </a:solidFill>
-                      <a:prstDash val="solid"/>
-                      <a:round/>
-                      <a:headEnd type="none" w="med" len="med"/>
-                      <a:tailEnd type="none" w="med" len="med"/>
-                    </a:lnL>
-                    <a:lnR w="6350" cap="flat" cmpd="sng" algn="ctr">
-                      <a:solidFill>
-                        <a:schemeClr val="tx1"/>
-                      </a:solidFill>
-                      <a:prstDash val="solid"/>
-                      <a:round/>
-                      <a:headEnd type="none" w="med" len="med"/>
-                      <a:tailEnd type="none" w="med" len="med"/>
-                    </a:lnR>
-                    <a:lnT w="6350" cap="flat" cmpd="sng" algn="ctr">
-                      <a:solidFill>
-                        <a:schemeClr val="tx1"/>
-                      </a:solidFill>
-                      <a:prstDash val="solid"/>
-                      <a:round/>
-                      <a:headEnd type="none" w="med" len="med"/>
-                      <a:tailEnd type="none" w="med" len="med"/>
-                    </a:lnT>
-                    <a:lnB w="6350" cap="flat" cmpd="sng" algn="ctr">
-                      <a:solidFill>
-                        <a:schemeClr val="tx1"/>
-                      </a:solidFill>
-                      <a:prstDash val="solid"/>
-                      <a:round/>
-                      <a:headEnd type="none" w="med" len="med"/>
-                      <a:tailEnd type="none" w="med" len="med"/>
-                    </a:lnB>
-                  </a:tcPr>
-                </a:tc>
-                <a:tc>
-                  <a:txBody>
-                    <a:bodyPr/>
-                    <a:lstStyle/>
-                    <a:p>
-                      <a:r>
-                        <a:rPr lang="en-US" sz="1200" dirty="0">
-                          <a:latin typeface="Verdana Pro" panose="020B0604030504040204" pitchFamily="34" charset="0"/>
-                          <a:cs typeface="Courier New" panose="02070309020205020404" pitchFamily="49" charset="0"/>
-                        </a:rPr>
-                        <a:t>txt</a:t>
-                      </a:r>
-                      <a:endParaRPr lang="en-CA" sz="1200" dirty="0">
-                        <a:latin typeface="Verdana Pro" panose="020B0604030504040204" pitchFamily="34" charset="0"/>
-                        <a:cs typeface="Courier New" panose="02070309020205020404" pitchFamily="49" charset="0"/>
-                      </a:endParaRPr>
-                    </a:p>
-                  </a:txBody>
-                  <a:tcPr>
-                    <a:lnL w="6350" cap="flat" cmpd="sng" algn="ctr">
-                      <a:solidFill>
-                        <a:schemeClr val="tx1"/>
-                      </a:solidFill>
-                      <a:prstDash val="solid"/>
-                      <a:round/>
-                      <a:headEnd type="none" w="med" len="med"/>
-                      <a:tailEnd type="none" w="med" len="med"/>
-                    </a:lnL>
-                    <a:lnR w="6350" cap="flat" cmpd="sng" algn="ctr">
-                      <a:solidFill>
-                        <a:schemeClr val="tx1"/>
-                      </a:solidFill>
-                      <a:prstDash val="solid"/>
-                      <a:round/>
-                      <a:headEnd type="none" w="med" len="med"/>
-                      <a:tailEnd type="none" w="med" len="med"/>
-                    </a:lnR>
-                    <a:lnT w="6350" cap="flat" cmpd="sng" algn="ctr">
-                      <a:solidFill>
-                        <a:schemeClr val="tx1"/>
-                      </a:solidFill>
-                      <a:prstDash val="solid"/>
-                      <a:round/>
-                      <a:headEnd type="none" w="med" len="med"/>
-                      <a:tailEnd type="none" w="med" len="med"/>
-                    </a:lnT>
-                    <a:lnB w="6350" cap="flat" cmpd="sng" algn="ctr">
-                      <a:solidFill>
-                        <a:schemeClr val="tx1"/>
-                      </a:solidFill>
-                      <a:prstDash val="solid"/>
-                      <a:round/>
-                      <a:headEnd type="none" w="med" len="med"/>
-                      <a:tailEnd type="none" w="med" len="med"/>
-                    </a:lnB>
-                  </a:tcPr>
-                </a:tc>
-                <a:extLst>
-                  <a:ext uri="{0D108BD9-81ED-4DB2-BD59-A6C34878D82A}">
-                    <a16:rowId xmlns:a16="http://schemas.microsoft.com/office/drawing/2014/main" val="2282598284"/>
-                  </a:ext>
-                </a:extLst>
-              </a:tr>
-              <a:tr h="204265">
-                <a:tc>
-                  <a:txBody>
-                    <a:bodyPr/>
-                    <a:lstStyle/>
-                    <a:p>
-                      <a:r>
-                        <a:rPr lang="en-US" sz="1200" dirty="0">
-                          <a:latin typeface="Verdana Pro" panose="020B0604030504040204" pitchFamily="34" charset="0"/>
-                        </a:rPr>
                         <a:t>PyMol RMSD</a:t>
                       </a:r>
                       <a:endParaRPr lang="en-CA" sz="1200" dirty="0">
@@ -11546,7 +11427,7 @@
                           <a:latin typeface="Verdana Pro" panose="020B0604030504040204" pitchFamily="34" charset="0"/>
                           <a:cs typeface="Courier New" panose="02070309020205020404" pitchFamily="49" charset="0"/>
                         </a:rPr>
-                        <a:t>txt AAs</a:t>
+                        <a:t>txt atoms</a:t>
                       </a:r>
                       <a:endParaRPr lang="en-CA" sz="1200" dirty="0">
                         <a:latin typeface="Verdana Pro" panose="020B0604030504040204" pitchFamily="34" charset="0"/>
@@ -11603,58 +11484,43 @@
           </a:graphicData>
         </a:graphic>
       </p:graphicFrame>
-      <p:sp>
-        <p:nvSpPr>
-          <p:cNvPr id="2" name="Rectangle 1">
-            <a:extLst>
-              <a:ext uri="{FF2B5EF4-FFF2-40B4-BE49-F238E27FC236}">
-                <a16:creationId xmlns:a16="http://schemas.microsoft.com/office/drawing/2014/main" id="{86174E7A-99F5-9D90-8801-343C4A48BE9A}"/>
-              </a:ext>
-            </a:extLst>
-          </p:cNvPr>
-          <p:cNvSpPr/>
+      <p:pic>
+        <p:nvPicPr>
+          <p:cNvPr id="3" name="Graphic 2">
+            <a:extLst>
+              <a:ext uri="{FF2B5EF4-FFF2-40B4-BE49-F238E27FC236}">
+                <a16:creationId xmlns:a16="http://schemas.microsoft.com/office/drawing/2014/main" id="{0C580C62-E4AB-4F46-7942-18AC8424A7E1}"/>
+              </a:ext>
+            </a:extLst>
+          </p:cNvPr>
+          <p:cNvPicPr>
+            <a:picLocks noChangeAspect="1"/>
+          </p:cNvPicPr>
           <p:nvPr/>
-        </p:nvSpPr>
+        </p:nvPicPr>
+        <p:blipFill>
+          <a:blip>
+            <a:extLst>
+              <a:ext uri="{96DAC541-7B7A-43D3-8B79-37D633B846F1}">
+                <asvg:svgBlip xmlns:asvg="http://schemas.microsoft.com/office/drawing/2016/SVG/main" r:embed="rId5"/>
+              </a:ext>
+            </a:extLst>
+          </a:blip>
+          <a:srcRect t="10849" r="8850"/>
+          <a:stretch>
+            <a:fillRect/>
+          </a:stretch>
+        </p:blipFill>
         <p:spPr>
           <a:xfrm>
-            <a:off x="1405374" y="2750222"/>
-            <a:ext cx="160146" cy="121490"/>
+            <a:off x="219800" y="483593"/>
+            <a:ext cx="3011454" cy="2945407"/>
           </a:xfrm>
           <a:prstGeom prst="rect">
             <a:avLst/>
           </a:prstGeom>
-          <a:noFill/>
-          <a:ln>
-            <a:solidFill>
-              <a:srgbClr val="FF0000"/>
-            </a:solidFill>
-          </a:ln>
         </p:spPr>
-        <p:style>
-          <a:lnRef idx="2">
-            <a:schemeClr val="accent1">
-              <a:shade val="15000"/>
-            </a:schemeClr>
-          </a:lnRef>
-          <a:fillRef idx="1">
-            <a:schemeClr val="accent1"/>
-          </a:fillRef>
-          <a:effectRef idx="0">
-            <a:schemeClr val="accent1"/>
-          </a:effectRef>
-          <a:fontRef idx="minor">
-            <a:schemeClr val="lt1"/>
-          </a:fontRef>
-        </p:style>
-        <p:txBody>
-          <a:bodyPr rtlCol="0" anchor="ctr"/>
-          <a:lstStyle/>
-          <a:p>
-            <a:pPr algn="ctr"/>
-            <a:endParaRPr lang="en-CA"/>
-          </a:p>
-        </p:txBody>
-      </p:sp>
+      </p:pic>
     </p:spTree>
     <p:extLst>
       <p:ext uri="{BB962C8B-B14F-4D97-AF65-F5344CB8AC3E}">
@@ -12899,8 +12765,8 @@
           </a:p>
         </p:txBody>
       </p:sp>
-      <mc:AlternateContent xmlns:mc="http://schemas.openxmlformats.org/markup-compatibility/2006">
-        <mc:Choice xmlns:a14="http://schemas.microsoft.com/office/drawing/2010/main" Requires="a14">
+      <mc:AlternateContent xmlns:mc="http://schemas.openxmlformats.org/markup-compatibility/2006" xmlns:a14="http://schemas.microsoft.com/office/drawing/2010/main">
+        <mc:Choice Requires="a14">
           <p:sp>
             <p:nvSpPr>
               <p:cNvPr id="13" name="TextBox 12">
@@ -13013,7 +12879,7 @@
             </p:txBody>
           </p:sp>
         </mc:Choice>
-        <mc:Fallback>
+        <mc:Fallback xmlns="">
           <p:sp>
             <p:nvSpPr>
               <p:cNvPr id="13" name="TextBox 12">
@@ -13913,8 +13779,8 @@
           </a:p>
         </p:txBody>
       </p:sp>
-      <mc:AlternateContent xmlns:mc="http://schemas.openxmlformats.org/markup-compatibility/2006">
-        <mc:Choice xmlns:a14="http://schemas.microsoft.com/office/drawing/2010/main" Requires="a14">
+      <mc:AlternateContent xmlns:mc="http://schemas.openxmlformats.org/markup-compatibility/2006" xmlns:a14="http://schemas.microsoft.com/office/drawing/2010/main">
+        <mc:Choice Requires="a14">
           <p:sp>
             <p:nvSpPr>
               <p:cNvPr id="13" name="TextBox 12">
@@ -13996,7 +13862,7 @@
             </p:txBody>
           </p:sp>
         </mc:Choice>
-        <mc:Fallback>
+        <mc:Fallback xmlns="">
           <p:sp>
             <p:nvSpPr>
               <p:cNvPr id="13" name="TextBox 12">

</xml_diff>

<commit_message>
Added slide for gold standard point of interest 1. Added slide for introducing gold standard curation.
</commit_message>
<xml_diff>
--- a/reports/2026-04-10_projectUpdate_2_jmoran.pptx
+++ b/reports/2026-04-10_projectUpdate_2_jmoran.pptx
@@ -5,7 +5,7 @@
     <p:sldMasterId id="2147483648" r:id="rId1"/>
   </p:sldMasterIdLst>
   <p:notesMasterIdLst>
-    <p:notesMasterId r:id="rId14"/>
+    <p:notesMasterId r:id="rId15"/>
   </p:notesMasterIdLst>
   <p:sldIdLst>
     <p:sldId id="256" r:id="rId2"/>
@@ -18,8 +18,9 @@
     <p:sldId id="275" r:id="rId9"/>
     <p:sldId id="274" r:id="rId10"/>
     <p:sldId id="277" r:id="rId11"/>
-    <p:sldId id="267" r:id="rId12"/>
-    <p:sldId id="276" r:id="rId13"/>
+    <p:sldId id="278" r:id="rId12"/>
+    <p:sldId id="267" r:id="rId13"/>
+    <p:sldId id="276" r:id="rId14"/>
   </p:sldIdLst>
   <p:sldSz cx="12192000" cy="6858000"/>
   <p:notesSz cx="6858000" cy="9144000"/>
@@ -5864,6 +5865,715 @@
 <file path=ppt/slides/slide11.xml><?xml version="1.0" encoding="utf-8"?>
 <p:sld xmlns:a="http://schemas.openxmlformats.org/drawingml/2006/main" xmlns:r="http://schemas.openxmlformats.org/officeDocument/2006/relationships" xmlns:p="http://schemas.openxmlformats.org/presentationml/2006/main">
   <p:cSld>
+    <p:bg>
+      <p:bgPr>
+        <a:solidFill>
+          <a:srgbClr val="0162B3"/>
+        </a:solidFill>
+        <a:effectLst/>
+      </p:bgPr>
+    </p:bg>
+    <p:spTree>
+      <p:nvGrpSpPr>
+        <p:cNvPr id="1" name="">
+          <a:extLst>
+            <a:ext uri="{FF2B5EF4-FFF2-40B4-BE49-F238E27FC236}">
+              <a16:creationId xmlns:a16="http://schemas.microsoft.com/office/drawing/2014/main" id="{4F69E216-7F09-313F-5677-BFC8F304021D}"/>
+            </a:ext>
+          </a:extLst>
+        </p:cNvPr>
+        <p:cNvGrpSpPr/>
+        <p:nvPr/>
+      </p:nvGrpSpPr>
+      <p:grpSpPr>
+        <a:xfrm>
+          <a:off x="0" y="0"/>
+          <a:ext cx="0" cy="0"/>
+          <a:chOff x="0" y="0"/>
+          <a:chExt cx="0" cy="0"/>
+        </a:xfrm>
+      </p:grpSpPr>
+      <p:sp>
+        <p:nvSpPr>
+          <p:cNvPr id="5" name="TextBox 4">
+            <a:extLst>
+              <a:ext uri="{FF2B5EF4-FFF2-40B4-BE49-F238E27FC236}">
+                <a16:creationId xmlns:a16="http://schemas.microsoft.com/office/drawing/2014/main" id="{A9F58D43-2BF7-3E2C-D998-E51F09ABC191}"/>
+              </a:ext>
+            </a:extLst>
+          </p:cNvPr>
+          <p:cNvSpPr txBox="1"/>
+          <p:nvPr/>
+        </p:nvSpPr>
+        <p:spPr>
+          <a:xfrm>
+            <a:off x="1047504" y="889701"/>
+            <a:ext cx="5484914" cy="1692771"/>
+          </a:xfrm>
+          <a:prstGeom prst="rect">
+            <a:avLst/>
+          </a:prstGeom>
+          <a:noFill/>
+        </p:spPr>
+        <p:txBody>
+          <a:bodyPr wrap="square" rtlCol="0">
+            <a:spAutoFit/>
+          </a:bodyPr>
+          <a:lstStyle/>
+          <a:p>
+            <a:r>
+              <a:rPr lang="en-US" sz="2600" b="1" dirty="0">
+                <a:solidFill>
+                  <a:schemeClr val="bg1"/>
+                </a:solidFill>
+                <a:latin typeface="Georgia Pro" panose="02040502050405020303" pitchFamily="18" charset="0"/>
+              </a:rPr>
+              <a:t>Procuring a gold-standard list of homologous bacterial-human protein pairs from high-impact literature</a:t>
+            </a:r>
+          </a:p>
+        </p:txBody>
+      </p:sp>
+      <p:graphicFrame>
+        <p:nvGraphicFramePr>
+          <p:cNvPr id="4" name="Table 3">
+            <a:extLst>
+              <a:ext uri="{FF2B5EF4-FFF2-40B4-BE49-F238E27FC236}">
+                <a16:creationId xmlns:a16="http://schemas.microsoft.com/office/drawing/2014/main" id="{D6B90585-0040-3FBD-8C49-2A58A5C3C18A}"/>
+              </a:ext>
+            </a:extLst>
+          </p:cNvPr>
+          <p:cNvGraphicFramePr>
+            <a:graphicFrameLocks noGrp="1"/>
+          </p:cNvGraphicFramePr>
+          <p:nvPr>
+            <p:extLst>
+              <p:ext uri="{D42A27DB-BD31-4B8C-83A1-F6EECF244321}">
+                <p14:modId xmlns:p14="http://schemas.microsoft.com/office/powerpoint/2010/main" val="1510471206"/>
+              </p:ext>
+            </p:extLst>
+          </p:nvPr>
+        </p:nvGraphicFramePr>
+        <p:xfrm>
+          <a:off x="1288804" y="3429000"/>
+          <a:ext cx="3372096" cy="2255520"/>
+        </p:xfrm>
+        <a:graphic>
+          <a:graphicData uri="http://schemas.openxmlformats.org/drawingml/2006/table">
+            <a:tbl>
+              <a:tblPr firstRow="1" bandRow="1">
+                <a:tableStyleId>{5940675A-B579-460E-94D1-54222C63F5DA}</a:tableStyleId>
+              </a:tblPr>
+              <a:tblGrid>
+                <a:gridCol w="3372096">
+                  <a:extLst>
+                    <a:ext uri="{9D8B030D-6E8A-4147-A177-3AD203B41FA5}">
+                      <a16:colId xmlns:a16="http://schemas.microsoft.com/office/drawing/2014/main" val="2740920184"/>
+                    </a:ext>
+                  </a:extLst>
+                </a:gridCol>
+              </a:tblGrid>
+              <a:tr h="401488">
+                <a:tc>
+                  <a:txBody>
+                    <a:bodyPr/>
+                    <a:lstStyle/>
+                    <a:p>
+                      <a:pPr marL="0" marR="0" lvl="0" indent="0" algn="l" defTabSz="914400" rtl="0" eaLnBrk="1" fontAlgn="auto" latinLnBrk="0" hangingPunct="1">
+                        <a:lnSpc>
+                          <a:spcPct val="100000"/>
+                        </a:lnSpc>
+                        <a:spcBef>
+                          <a:spcPts val="0"/>
+                        </a:spcBef>
+                        <a:spcAft>
+                          <a:spcPts val="0"/>
+                        </a:spcAft>
+                        <a:buClrTx/>
+                        <a:buSzTx/>
+                        <a:buFontTx/>
+                        <a:buNone/>
+                        <a:tabLst/>
+                        <a:defRPr/>
+                      </a:pPr>
+                      <a:r>
+                        <a:rPr lang="en-US" sz="2000" dirty="0">
+                          <a:solidFill>
+                            <a:schemeClr val="bg1"/>
+                          </a:solidFill>
+                          <a:latin typeface="Courier New" panose="02070309020205020404" pitchFamily="49" charset="0"/>
+                          <a:cs typeface="Courier New" panose="02070309020205020404" pitchFamily="49" charset="0"/>
+                        </a:rPr>
+                        <a:t>Experimental criteria</a:t>
+                      </a:r>
+                    </a:p>
+                  </a:txBody>
+                  <a:tcPr>
+                    <a:lnL w="6350" cap="flat" cmpd="sng" algn="ctr">
+                      <a:solidFill>
+                        <a:schemeClr val="bg1"/>
+                      </a:solidFill>
+                      <a:prstDash val="solid"/>
+                      <a:round/>
+                      <a:headEnd type="none" w="med" len="med"/>
+                      <a:tailEnd type="none" w="med" len="med"/>
+                    </a:lnL>
+                    <a:lnR w="6350" cap="flat" cmpd="sng" algn="ctr">
+                      <a:solidFill>
+                        <a:schemeClr val="bg1"/>
+                      </a:solidFill>
+                      <a:prstDash val="solid"/>
+                      <a:round/>
+                      <a:headEnd type="none" w="med" len="med"/>
+                      <a:tailEnd type="none" w="med" len="med"/>
+                    </a:lnR>
+                    <a:lnT w="6350" cap="flat" cmpd="sng" algn="ctr">
+                      <a:solidFill>
+                        <a:schemeClr val="bg1"/>
+                      </a:solidFill>
+                      <a:prstDash val="solid"/>
+                      <a:round/>
+                      <a:headEnd type="none" w="med" len="med"/>
+                      <a:tailEnd type="none" w="med" len="med"/>
+                    </a:lnT>
+                    <a:lnB w="6350" cap="flat" cmpd="sng" algn="ctr">
+                      <a:solidFill>
+                        <a:schemeClr val="bg1"/>
+                      </a:solidFill>
+                      <a:prstDash val="solid"/>
+                      <a:round/>
+                      <a:headEnd type="none" w="med" len="med"/>
+                      <a:tailEnd type="none" w="med" len="med"/>
+                    </a:lnB>
+                  </a:tcPr>
+                </a:tc>
+                <a:extLst>
+                  <a:ext uri="{0D108BD9-81ED-4DB2-BD59-A6C34878D82A}">
+                    <a16:rowId xmlns:a16="http://schemas.microsoft.com/office/drawing/2014/main" val="2809478066"/>
+                  </a:ext>
+                </a:extLst>
+              </a:tr>
+              <a:tr h="282449">
+                <a:tc>
+                  <a:txBody>
+                    <a:bodyPr/>
+                    <a:lstStyle/>
+                    <a:p>
+                      <a:r>
+                        <a:rPr lang="en-US" sz="1400" dirty="0">
+                          <a:solidFill>
+                            <a:schemeClr val="bg1"/>
+                          </a:solidFill>
+                          <a:latin typeface="Courier New" panose="02070309020205020404" pitchFamily="49" charset="0"/>
+                          <a:cs typeface="Courier New" panose="02070309020205020404" pitchFamily="49" charset="0"/>
+                        </a:rPr>
+                        <a:t>provide protein accession for bacterial protein</a:t>
+                      </a:r>
+                      <a:endParaRPr lang="en-CA" sz="1400" dirty="0">
+                        <a:solidFill>
+                          <a:schemeClr val="bg1"/>
+                        </a:solidFill>
+                        <a:latin typeface="Courier New" panose="02070309020205020404" pitchFamily="49" charset="0"/>
+                        <a:cs typeface="Courier New" panose="02070309020205020404" pitchFamily="49" charset="0"/>
+                      </a:endParaRPr>
+                    </a:p>
+                  </a:txBody>
+                  <a:tcPr>
+                    <a:lnL w="6350" cap="flat" cmpd="sng" algn="ctr">
+                      <a:solidFill>
+                        <a:schemeClr val="bg1"/>
+                      </a:solidFill>
+                      <a:prstDash val="solid"/>
+                      <a:round/>
+                      <a:headEnd type="none" w="med" len="med"/>
+                      <a:tailEnd type="none" w="med" len="med"/>
+                    </a:lnL>
+                    <a:lnR w="6350" cap="flat" cmpd="sng" algn="ctr">
+                      <a:solidFill>
+                        <a:schemeClr val="bg1"/>
+                      </a:solidFill>
+                      <a:prstDash val="solid"/>
+                      <a:round/>
+                      <a:headEnd type="none" w="med" len="med"/>
+                      <a:tailEnd type="none" w="med" len="med"/>
+                    </a:lnR>
+                    <a:lnT w="6350" cap="flat" cmpd="sng" algn="ctr">
+                      <a:solidFill>
+                        <a:schemeClr val="bg1"/>
+                      </a:solidFill>
+                      <a:prstDash val="solid"/>
+                      <a:round/>
+                      <a:headEnd type="none" w="med" len="med"/>
+                      <a:tailEnd type="none" w="med" len="med"/>
+                    </a:lnT>
+                    <a:lnB w="6350" cap="flat" cmpd="sng" algn="ctr">
+                      <a:solidFill>
+                        <a:schemeClr val="bg1"/>
+                      </a:solidFill>
+                      <a:prstDash val="solid"/>
+                      <a:round/>
+                      <a:headEnd type="none" w="med" len="med"/>
+                      <a:tailEnd type="none" w="med" len="med"/>
+                    </a:lnB>
+                  </a:tcPr>
+                </a:tc>
+                <a:extLst>
+                  <a:ext uri="{0D108BD9-81ED-4DB2-BD59-A6C34878D82A}">
+                    <a16:rowId xmlns:a16="http://schemas.microsoft.com/office/drawing/2014/main" val="2031214207"/>
+                  </a:ext>
+                </a:extLst>
+              </a:tr>
+              <a:tr h="282449">
+                <a:tc>
+                  <a:txBody>
+                    <a:bodyPr/>
+                    <a:lstStyle/>
+                    <a:p>
+                      <a:r>
+                        <a:rPr lang="en-US" sz="1400" dirty="0">
+                          <a:solidFill>
+                            <a:schemeClr val="bg1"/>
+                          </a:solidFill>
+                          <a:latin typeface="Courier New" panose="02070309020205020404" pitchFamily="49" charset="0"/>
+                          <a:cs typeface="Courier New" panose="02070309020205020404" pitchFamily="49" charset="0"/>
+                        </a:rPr>
+                        <a:t>express in new organism</a:t>
+                      </a:r>
+                      <a:endParaRPr lang="en-CA" sz="1400" dirty="0">
+                        <a:solidFill>
+                          <a:schemeClr val="bg1"/>
+                        </a:solidFill>
+                        <a:latin typeface="Courier New" panose="02070309020205020404" pitchFamily="49" charset="0"/>
+                        <a:cs typeface="Courier New" panose="02070309020205020404" pitchFamily="49" charset="0"/>
+                      </a:endParaRPr>
+                    </a:p>
+                  </a:txBody>
+                  <a:tcPr>
+                    <a:lnL w="6350" cap="flat" cmpd="sng" algn="ctr">
+                      <a:solidFill>
+                        <a:schemeClr val="bg1"/>
+                      </a:solidFill>
+                      <a:prstDash val="solid"/>
+                      <a:round/>
+                      <a:headEnd type="none" w="med" len="med"/>
+                      <a:tailEnd type="none" w="med" len="med"/>
+                    </a:lnL>
+                    <a:lnR w="6350" cap="flat" cmpd="sng" algn="ctr">
+                      <a:solidFill>
+                        <a:schemeClr val="bg1"/>
+                      </a:solidFill>
+                      <a:prstDash val="solid"/>
+                      <a:round/>
+                      <a:headEnd type="none" w="med" len="med"/>
+                      <a:tailEnd type="none" w="med" len="med"/>
+                    </a:lnR>
+                    <a:lnT w="6350" cap="flat" cmpd="sng" algn="ctr">
+                      <a:solidFill>
+                        <a:schemeClr val="bg1"/>
+                      </a:solidFill>
+                      <a:prstDash val="solid"/>
+                      <a:round/>
+                      <a:headEnd type="none" w="med" len="med"/>
+                      <a:tailEnd type="none" w="med" len="med"/>
+                    </a:lnT>
+                    <a:lnB w="6350" cap="flat" cmpd="sng" algn="ctr">
+                      <a:solidFill>
+                        <a:schemeClr val="bg1"/>
+                      </a:solidFill>
+                      <a:prstDash val="solid"/>
+                      <a:round/>
+                      <a:headEnd type="none" w="med" len="med"/>
+                      <a:tailEnd type="none" w="med" len="med"/>
+                    </a:lnB>
+                  </a:tcPr>
+                </a:tc>
+                <a:extLst>
+                  <a:ext uri="{0D108BD9-81ED-4DB2-BD59-A6C34878D82A}">
+                    <a16:rowId xmlns:a16="http://schemas.microsoft.com/office/drawing/2014/main" val="202640798"/>
+                  </a:ext>
+                </a:extLst>
+              </a:tr>
+              <a:tr h="282449">
+                <a:tc>
+                  <a:txBody>
+                    <a:bodyPr/>
+                    <a:lstStyle/>
+                    <a:p>
+                      <a:r>
+                        <a:rPr lang="en-US" sz="1400" dirty="0">
+                          <a:solidFill>
+                            <a:schemeClr val="bg1"/>
+                          </a:solidFill>
+                          <a:latin typeface="Courier New" panose="02070309020205020404" pitchFamily="49" charset="0"/>
+                          <a:cs typeface="Courier New" panose="02070309020205020404" pitchFamily="49" charset="0"/>
+                        </a:rPr>
+                        <a:t>perform functional assay proving bacterial immune system action</a:t>
+                      </a:r>
+                      <a:endParaRPr lang="en-CA" sz="1400" dirty="0">
+                        <a:solidFill>
+                          <a:schemeClr val="bg1"/>
+                        </a:solidFill>
+                        <a:latin typeface="Courier New" panose="02070309020205020404" pitchFamily="49" charset="0"/>
+                        <a:cs typeface="Courier New" panose="02070309020205020404" pitchFamily="49" charset="0"/>
+                      </a:endParaRPr>
+                    </a:p>
+                  </a:txBody>
+                  <a:tcPr>
+                    <a:lnL w="6350" cap="flat" cmpd="sng" algn="ctr">
+                      <a:solidFill>
+                        <a:schemeClr val="bg1"/>
+                      </a:solidFill>
+                      <a:prstDash val="solid"/>
+                      <a:round/>
+                      <a:headEnd type="none" w="med" len="med"/>
+                      <a:tailEnd type="none" w="med" len="med"/>
+                    </a:lnL>
+                    <a:lnR w="6350" cap="flat" cmpd="sng" algn="ctr">
+                      <a:solidFill>
+                        <a:schemeClr val="bg1"/>
+                      </a:solidFill>
+                      <a:prstDash val="solid"/>
+                      <a:round/>
+                      <a:headEnd type="none" w="med" len="med"/>
+                      <a:tailEnd type="none" w="med" len="med"/>
+                    </a:lnR>
+                    <a:lnT w="6350" cap="flat" cmpd="sng" algn="ctr">
+                      <a:solidFill>
+                        <a:schemeClr val="bg1"/>
+                      </a:solidFill>
+                      <a:prstDash val="solid"/>
+                      <a:round/>
+                      <a:headEnd type="none" w="med" len="med"/>
+                      <a:tailEnd type="none" w="med" len="med"/>
+                    </a:lnT>
+                    <a:lnB w="6350" cap="flat" cmpd="sng" algn="ctr">
+                      <a:solidFill>
+                        <a:schemeClr val="bg1"/>
+                      </a:solidFill>
+                      <a:prstDash val="solid"/>
+                      <a:round/>
+                      <a:headEnd type="none" w="med" len="med"/>
+                      <a:tailEnd type="none" w="med" len="med"/>
+                    </a:lnB>
+                  </a:tcPr>
+                </a:tc>
+                <a:extLst>
+                  <a:ext uri="{0D108BD9-81ED-4DB2-BD59-A6C34878D82A}">
+                    <a16:rowId xmlns:a16="http://schemas.microsoft.com/office/drawing/2014/main" val="2712390552"/>
+                  </a:ext>
+                </a:extLst>
+              </a:tr>
+            </a:tbl>
+          </a:graphicData>
+        </a:graphic>
+      </p:graphicFrame>
+      <p:graphicFrame>
+        <p:nvGraphicFramePr>
+          <p:cNvPr id="6" name="Table 5">
+            <a:extLst>
+              <a:ext uri="{FF2B5EF4-FFF2-40B4-BE49-F238E27FC236}">
+                <a16:creationId xmlns:a16="http://schemas.microsoft.com/office/drawing/2014/main" id="{74647ED3-0B8A-D494-D0B1-8E84549A81FC}"/>
+              </a:ext>
+            </a:extLst>
+          </p:cNvPr>
+          <p:cNvGraphicFramePr>
+            <a:graphicFrameLocks noGrp="1"/>
+          </p:cNvGraphicFramePr>
+          <p:nvPr>
+            <p:extLst>
+              <p:ext uri="{D42A27DB-BD31-4B8C-83A1-F6EECF244321}">
+                <p14:modId xmlns:p14="http://schemas.microsoft.com/office/powerpoint/2010/main" val="3159404553"/>
+              </p:ext>
+            </p:extLst>
+          </p:nvPr>
+        </p:nvGraphicFramePr>
+        <p:xfrm>
+          <a:off x="5606804" y="3429000"/>
+          <a:ext cx="3372096" cy="1950720"/>
+        </p:xfrm>
+        <a:graphic>
+          <a:graphicData uri="http://schemas.openxmlformats.org/drawingml/2006/table">
+            <a:tbl>
+              <a:tblPr firstRow="1" bandRow="1">
+                <a:tableStyleId>{5940675A-B579-460E-94D1-54222C63F5DA}</a:tableStyleId>
+              </a:tblPr>
+              <a:tblGrid>
+                <a:gridCol w="3372096">
+                  <a:extLst>
+                    <a:ext uri="{9D8B030D-6E8A-4147-A177-3AD203B41FA5}">
+                      <a16:colId xmlns:a16="http://schemas.microsoft.com/office/drawing/2014/main" val="2740920184"/>
+                    </a:ext>
+                  </a:extLst>
+                </a:gridCol>
+              </a:tblGrid>
+              <a:tr h="401488">
+                <a:tc>
+                  <a:txBody>
+                    <a:bodyPr/>
+                    <a:lstStyle/>
+                    <a:p>
+                      <a:pPr marL="0" marR="0" lvl="0" indent="0" algn="l" defTabSz="914400" rtl="0" eaLnBrk="1" fontAlgn="auto" latinLnBrk="0" hangingPunct="1">
+                        <a:lnSpc>
+                          <a:spcPct val="100000"/>
+                        </a:lnSpc>
+                        <a:spcBef>
+                          <a:spcPts val="0"/>
+                        </a:spcBef>
+                        <a:spcAft>
+                          <a:spcPts val="0"/>
+                        </a:spcAft>
+                        <a:buClrTx/>
+                        <a:buSzTx/>
+                        <a:buFontTx/>
+                        <a:buNone/>
+                        <a:tabLst/>
+                        <a:defRPr/>
+                      </a:pPr>
+                      <a:r>
+                        <a:rPr lang="en-US" sz="2000" dirty="0">
+                          <a:solidFill>
+                            <a:schemeClr val="bg1"/>
+                          </a:solidFill>
+                          <a:latin typeface="Courier New" panose="02070309020205020404" pitchFamily="49" charset="0"/>
+                          <a:cs typeface="Courier New" panose="02070309020205020404" pitchFamily="49" charset="0"/>
+                        </a:rPr>
+                        <a:t>Homology</a:t>
+                      </a:r>
+                    </a:p>
+                    <a:p>
+                      <a:pPr marL="0" marR="0" lvl="0" indent="0" algn="l" defTabSz="914400" rtl="0" eaLnBrk="1" fontAlgn="auto" latinLnBrk="0" hangingPunct="1">
+                        <a:lnSpc>
+                          <a:spcPct val="100000"/>
+                        </a:lnSpc>
+                        <a:spcBef>
+                          <a:spcPts val="0"/>
+                        </a:spcBef>
+                        <a:spcAft>
+                          <a:spcPts val="0"/>
+                        </a:spcAft>
+                        <a:buClrTx/>
+                        <a:buSzTx/>
+                        <a:buFontTx/>
+                        <a:buNone/>
+                        <a:tabLst/>
+                        <a:defRPr/>
+                      </a:pPr>
+                      <a:r>
+                        <a:rPr lang="en-US" sz="2000" dirty="0">
+                          <a:solidFill>
+                            <a:schemeClr val="bg1"/>
+                          </a:solidFill>
+                          <a:latin typeface="Courier New" panose="02070309020205020404" pitchFamily="49" charset="0"/>
+                          <a:cs typeface="Courier New" panose="02070309020205020404" pitchFamily="49" charset="0"/>
+                        </a:rPr>
+                        <a:t>criteria</a:t>
+                      </a:r>
+                    </a:p>
+                  </a:txBody>
+                  <a:tcPr>
+                    <a:lnL w="6350" cap="flat" cmpd="sng" algn="ctr">
+                      <a:solidFill>
+                        <a:schemeClr val="bg1"/>
+                      </a:solidFill>
+                      <a:prstDash val="solid"/>
+                      <a:round/>
+                      <a:headEnd type="none" w="med" len="med"/>
+                      <a:tailEnd type="none" w="med" len="med"/>
+                    </a:lnL>
+                    <a:lnR w="6350" cap="flat" cmpd="sng" algn="ctr">
+                      <a:solidFill>
+                        <a:schemeClr val="bg1"/>
+                      </a:solidFill>
+                      <a:prstDash val="solid"/>
+                      <a:round/>
+                      <a:headEnd type="none" w="med" len="med"/>
+                      <a:tailEnd type="none" w="med" len="med"/>
+                    </a:lnR>
+                    <a:lnT w="6350" cap="flat" cmpd="sng" algn="ctr">
+                      <a:solidFill>
+                        <a:schemeClr val="bg1"/>
+                      </a:solidFill>
+                      <a:prstDash val="solid"/>
+                      <a:round/>
+                      <a:headEnd type="none" w="med" len="med"/>
+                      <a:tailEnd type="none" w="med" len="med"/>
+                    </a:lnT>
+                    <a:lnB w="6350" cap="flat" cmpd="sng" algn="ctr">
+                      <a:solidFill>
+                        <a:schemeClr val="bg1"/>
+                      </a:solidFill>
+                      <a:prstDash val="solid"/>
+                      <a:round/>
+                      <a:headEnd type="none" w="med" len="med"/>
+                      <a:tailEnd type="none" w="med" len="med"/>
+                    </a:lnB>
+                  </a:tcPr>
+                </a:tc>
+                <a:extLst>
+                  <a:ext uri="{0D108BD9-81ED-4DB2-BD59-A6C34878D82A}">
+                    <a16:rowId xmlns:a16="http://schemas.microsoft.com/office/drawing/2014/main" val="2809478066"/>
+                  </a:ext>
+                </a:extLst>
+              </a:tr>
+              <a:tr h="282449">
+                <a:tc>
+                  <a:txBody>
+                    <a:bodyPr/>
+                    <a:lstStyle/>
+                    <a:p>
+                      <a:r>
+                        <a:rPr lang="en-US" sz="1400" dirty="0">
+                          <a:solidFill>
+                            <a:schemeClr val="bg1"/>
+                          </a:solidFill>
+                          <a:latin typeface="Courier New" panose="02070309020205020404" pitchFamily="49" charset="0"/>
+                          <a:cs typeface="Courier New" panose="02070309020205020404" pitchFamily="49" charset="0"/>
+                        </a:rPr>
+                        <a:t>provide protein accession for human protein</a:t>
+                      </a:r>
+                      <a:endParaRPr lang="en-CA" sz="1400" dirty="0">
+                        <a:solidFill>
+                          <a:schemeClr val="bg1"/>
+                        </a:solidFill>
+                        <a:latin typeface="Courier New" panose="02070309020205020404" pitchFamily="49" charset="0"/>
+                        <a:cs typeface="Courier New" panose="02070309020205020404" pitchFamily="49" charset="0"/>
+                      </a:endParaRPr>
+                    </a:p>
+                  </a:txBody>
+                  <a:tcPr>
+                    <a:lnL w="6350" cap="flat" cmpd="sng" algn="ctr">
+                      <a:solidFill>
+                        <a:schemeClr val="bg1"/>
+                      </a:solidFill>
+                      <a:prstDash val="solid"/>
+                      <a:round/>
+                      <a:headEnd type="none" w="med" len="med"/>
+                      <a:tailEnd type="none" w="med" len="med"/>
+                    </a:lnL>
+                    <a:lnR w="6350" cap="flat" cmpd="sng" algn="ctr">
+                      <a:solidFill>
+                        <a:schemeClr val="bg1"/>
+                      </a:solidFill>
+                      <a:prstDash val="solid"/>
+                      <a:round/>
+                      <a:headEnd type="none" w="med" len="med"/>
+                      <a:tailEnd type="none" w="med" len="med"/>
+                    </a:lnR>
+                    <a:lnT w="6350" cap="flat" cmpd="sng" algn="ctr">
+                      <a:solidFill>
+                        <a:schemeClr val="bg1"/>
+                      </a:solidFill>
+                      <a:prstDash val="solid"/>
+                      <a:round/>
+                      <a:headEnd type="none" w="med" len="med"/>
+                      <a:tailEnd type="none" w="med" len="med"/>
+                    </a:lnT>
+                    <a:lnB w="6350" cap="flat" cmpd="sng" algn="ctr">
+                      <a:solidFill>
+                        <a:schemeClr val="bg1"/>
+                      </a:solidFill>
+                      <a:prstDash val="solid"/>
+                      <a:round/>
+                      <a:headEnd type="none" w="med" len="med"/>
+                      <a:tailEnd type="none" w="med" len="med"/>
+                    </a:lnB>
+                  </a:tcPr>
+                </a:tc>
+                <a:extLst>
+                  <a:ext uri="{0D108BD9-81ED-4DB2-BD59-A6C34878D82A}">
+                    <a16:rowId xmlns:a16="http://schemas.microsoft.com/office/drawing/2014/main" val="2031214207"/>
+                  </a:ext>
+                </a:extLst>
+              </a:tr>
+              <a:tr h="282449">
+                <a:tc>
+                  <a:txBody>
+                    <a:bodyPr/>
+                    <a:lstStyle/>
+                    <a:p>
+                      <a:r>
+                        <a:rPr lang="en-US" sz="1400" dirty="0">
+                          <a:solidFill>
+                            <a:schemeClr val="bg1"/>
+                          </a:solidFill>
+                          <a:latin typeface="Courier New" panose="02070309020205020404" pitchFamily="49" charset="0"/>
+                          <a:cs typeface="Courier New" panose="02070309020205020404" pitchFamily="49" charset="0"/>
+                        </a:rPr>
+                        <a:t>present convincing evidence of sequence or structure homology</a:t>
+                      </a:r>
+                      <a:endParaRPr lang="en-CA" sz="1400" dirty="0">
+                        <a:solidFill>
+                          <a:schemeClr val="bg1"/>
+                        </a:solidFill>
+                        <a:latin typeface="Courier New" panose="02070309020205020404" pitchFamily="49" charset="0"/>
+                        <a:cs typeface="Courier New" panose="02070309020205020404" pitchFamily="49" charset="0"/>
+                      </a:endParaRPr>
+                    </a:p>
+                  </a:txBody>
+                  <a:tcPr>
+                    <a:lnL w="6350" cap="flat" cmpd="sng" algn="ctr">
+                      <a:solidFill>
+                        <a:schemeClr val="bg1"/>
+                      </a:solidFill>
+                      <a:prstDash val="solid"/>
+                      <a:round/>
+                      <a:headEnd type="none" w="med" len="med"/>
+                      <a:tailEnd type="none" w="med" len="med"/>
+                    </a:lnL>
+                    <a:lnR w="6350" cap="flat" cmpd="sng" algn="ctr">
+                      <a:solidFill>
+                        <a:schemeClr val="bg1"/>
+                      </a:solidFill>
+                      <a:prstDash val="solid"/>
+                      <a:round/>
+                      <a:headEnd type="none" w="med" len="med"/>
+                      <a:tailEnd type="none" w="med" len="med"/>
+                    </a:lnR>
+                    <a:lnT w="6350" cap="flat" cmpd="sng" algn="ctr">
+                      <a:solidFill>
+                        <a:schemeClr val="bg1"/>
+                      </a:solidFill>
+                      <a:prstDash val="solid"/>
+                      <a:round/>
+                      <a:headEnd type="none" w="med" len="med"/>
+                      <a:tailEnd type="none" w="med" len="med"/>
+                    </a:lnT>
+                    <a:lnB w="6350" cap="flat" cmpd="sng" algn="ctr">
+                      <a:solidFill>
+                        <a:schemeClr val="bg1"/>
+                      </a:solidFill>
+                      <a:prstDash val="solid"/>
+                      <a:round/>
+                      <a:headEnd type="none" w="med" len="med"/>
+                      <a:tailEnd type="none" w="med" len="med"/>
+                    </a:lnB>
+                  </a:tcPr>
+                </a:tc>
+                <a:extLst>
+                  <a:ext uri="{0D108BD9-81ED-4DB2-BD59-A6C34878D82A}">
+                    <a16:rowId xmlns:a16="http://schemas.microsoft.com/office/drawing/2014/main" val="1913818302"/>
+                  </a:ext>
+                </a:extLst>
+              </a:tr>
+            </a:tbl>
+          </a:graphicData>
+        </a:graphic>
+      </p:graphicFrame>
+    </p:spTree>
+    <p:extLst>
+      <p:ext uri="{BB962C8B-B14F-4D97-AF65-F5344CB8AC3E}">
+        <p14:creationId xmlns:p14="http://schemas.microsoft.com/office/powerpoint/2010/main" val="894168848"/>
+      </p:ext>
+    </p:extLst>
+  </p:cSld>
+  <p:clrMapOvr>
+    <a:masterClrMapping/>
+  </p:clrMapOvr>
+</p:sld>
+</file>
+
+<file path=ppt/slides/slide12.xml><?xml version="1.0" encoding="utf-8"?>
+<p:sld xmlns:a="http://schemas.openxmlformats.org/drawingml/2006/main" xmlns:r="http://schemas.openxmlformats.org/officeDocument/2006/relationships" xmlns:p="http://schemas.openxmlformats.org/presentationml/2006/main">
+  <p:cSld>
     <p:spTree>
       <p:nvGrpSpPr>
         <p:cNvPr id="1" name="">
@@ -10456,7 +11166,7 @@
 </p:sld>
 </file>
 
-<file path=ppt/slides/slide12.xml><?xml version="1.0" encoding="utf-8"?>
+<file path=ppt/slides/slide13.xml><?xml version="1.0" encoding="utf-8"?>
 <p:sld xmlns:a="http://schemas.openxmlformats.org/drawingml/2006/main" xmlns:r="http://schemas.openxmlformats.org/officeDocument/2006/relationships" xmlns:p="http://schemas.openxmlformats.org/presentationml/2006/main">
   <p:cSld>
     <p:spTree>
@@ -10481,10 +11191,10 @@
       </p:grpSpPr>
       <p:pic>
         <p:nvPicPr>
-          <p:cNvPr id="11" name="Picture 10">
+          <p:cNvPr id="19" name="Picture 18">
             <a:extLst>
               <a:ext uri="{FF2B5EF4-FFF2-40B4-BE49-F238E27FC236}">
-                <a16:creationId xmlns:a16="http://schemas.microsoft.com/office/drawing/2014/main" id="{226B94E5-A8B0-D7E4-D948-58A57B210283}"/>
+                <a16:creationId xmlns:a16="http://schemas.microsoft.com/office/drawing/2014/main" id="{60892281-A612-FA53-E8FB-6D1DE9E9A3DA}"/>
               </a:ext>
             </a:extLst>
           </p:cNvPr>
@@ -10494,21 +11204,15 @@
           <p:nvPr/>
         </p:nvPicPr>
         <p:blipFill>
-          <a:blip r:embed="rId2">
-            <a:extLst>
-              <a:ext uri="{28A0092B-C50C-407E-A947-70E740481C1C}">
-                <a14:useLocalDpi xmlns:a14="http://schemas.microsoft.com/office/drawing/2010/main" val="0"/>
-              </a:ext>
-            </a:extLst>
-          </a:blip>
+          <a:blip r:embed="rId2"/>
           <a:stretch>
             <a:fillRect/>
           </a:stretch>
         </p:blipFill>
         <p:spPr>
           <a:xfrm>
-            <a:off x="8711460" y="405443"/>
-            <a:ext cx="3068612" cy="2541348"/>
+            <a:off x="8703998" y="518096"/>
+            <a:ext cx="3055583" cy="3250207"/>
           </a:xfrm>
           <a:prstGeom prst="rect">
             <a:avLst/>
@@ -10517,10 +11221,10 @@
       </p:pic>
       <p:pic>
         <p:nvPicPr>
-          <p:cNvPr id="27" name="Picture 26">
+          <p:cNvPr id="13" name="Picture 12">
             <a:extLst>
               <a:ext uri="{FF2B5EF4-FFF2-40B4-BE49-F238E27FC236}">
-                <a16:creationId xmlns:a16="http://schemas.microsoft.com/office/drawing/2014/main" id="{A74506DE-11C2-1C10-17E2-3E8CE1F00E9E}"/>
+                <a16:creationId xmlns:a16="http://schemas.microsoft.com/office/drawing/2014/main" id="{92532399-C48E-5C46-EC46-47F6748A9249}"/>
               </a:ext>
             </a:extLst>
           </p:cNvPr>
@@ -10537,8 +11241,8 @@
         </p:blipFill>
         <p:spPr>
           <a:xfrm>
-            <a:off x="8711460" y="2946790"/>
-            <a:ext cx="3068611" cy="2791517"/>
+            <a:off x="8703999" y="3696091"/>
+            <a:ext cx="3074211" cy="2395740"/>
           </a:xfrm>
           <a:prstGeom prst="rect">
             <a:avLst/>
@@ -10559,7 +11263,7 @@
         </p:nvSpPr>
         <p:spPr>
           <a:xfrm>
-            <a:off x="3540154" y="4749290"/>
+            <a:off x="3540154" y="4447846"/>
             <a:ext cx="5156171" cy="845389"/>
           </a:xfrm>
           <a:prstGeom prst="rect">
@@ -10611,7 +11315,7 @@
         </p:nvSpPr>
         <p:spPr>
           <a:xfrm>
-            <a:off x="3590957" y="4744527"/>
+            <a:off x="3590957" y="4443083"/>
             <a:ext cx="4781518" cy="307777"/>
           </a:xfrm>
           <a:prstGeom prst="rect">
@@ -10632,7 +11336,7 @@
                 </a:solidFill>
                 <a:latin typeface="Verdana Pro" panose="020B0604030504040204" pitchFamily="34" charset="0"/>
               </a:rPr>
-              <a:t>txt [txt]</a:t>
+              <a:t>A0A1S1YUU1 [F. pacifica][vip47]</a:t>
             </a:r>
             <a:endParaRPr lang="en-CA" sz="1400" dirty="0">
               <a:solidFill>
@@ -10657,7 +11361,7 @@
         </p:nvSpPr>
         <p:spPr>
           <a:xfrm>
-            <a:off x="3590957" y="5631956"/>
+            <a:off x="3590957" y="5330512"/>
             <a:ext cx="3314668" cy="307777"/>
           </a:xfrm>
           <a:prstGeom prst="rect">
@@ -10678,7 +11382,7 @@
                 </a:solidFill>
                 <a:latin typeface="Verdana Pro" panose="020B0604030504040204" pitchFamily="34" charset="0"/>
               </a:rPr>
-              <a:t>txt [H. sapiens][txt]</a:t>
+              <a:t>Q8WXG1 [H. sapiens][RSAD2]</a:t>
             </a:r>
             <a:endParaRPr lang="en-CA" sz="1400" dirty="0">
               <a:solidFill>
@@ -10703,7 +11407,7 @@
         </p:nvSpPr>
         <p:spPr>
           <a:xfrm>
-            <a:off x="3540154" y="5607169"/>
+            <a:off x="3540154" y="5305725"/>
             <a:ext cx="5156172" cy="845389"/>
           </a:xfrm>
           <a:prstGeom prst="rect">
@@ -10745,36 +11449,6 @@
           </a:p>
         </p:txBody>
       </p:sp>
-      <p:pic>
-        <p:nvPicPr>
-          <p:cNvPr id="20" name="Picture 19">
-            <a:extLst>
-              <a:ext uri="{FF2B5EF4-FFF2-40B4-BE49-F238E27FC236}">
-                <a16:creationId xmlns:a16="http://schemas.microsoft.com/office/drawing/2014/main" id="{5A470E5D-62D8-6B57-EFB1-5495D21A205B}"/>
-              </a:ext>
-            </a:extLst>
-          </p:cNvPr>
-          <p:cNvPicPr>
-            <a:picLocks noChangeAspect="1"/>
-          </p:cNvPicPr>
-          <p:nvPr/>
-        </p:nvPicPr>
-        <p:blipFill>
-          <a:blip r:embed="rId4"/>
-          <a:stretch>
-            <a:fillRect/>
-          </a:stretch>
-        </p:blipFill>
-        <p:spPr>
-          <a:xfrm>
-            <a:off x="3533804" y="405443"/>
-            <a:ext cx="5171306" cy="4339086"/>
-          </a:xfrm>
-          <a:prstGeom prst="rect">
-            <a:avLst/>
-          </a:prstGeom>
-        </p:spPr>
-      </p:pic>
       <p:sp>
         <p:nvSpPr>
           <p:cNvPr id="21" name="TextBox 20">
@@ -10789,7 +11463,7 @@
         </p:nvSpPr>
         <p:spPr>
           <a:xfrm>
-            <a:off x="9394672" y="405443"/>
+            <a:off x="9394672" y="595943"/>
             <a:ext cx="2421147" cy="307777"/>
           </a:xfrm>
           <a:prstGeom prst="rect">
@@ -10811,7 +11485,7 @@
                 </a:solidFill>
                 <a:latin typeface="Verdana Pro" panose="020B0604030504040204" pitchFamily="34" charset="0"/>
               </a:rPr>
-              <a:t>txt</a:t>
+              <a:t>A0A1S1YUU1</a:t>
             </a:r>
             <a:endParaRPr lang="en-CA" sz="1400" dirty="0">
               <a:solidFill>
@@ -10836,7 +11510,7 @@
         </p:nvSpPr>
         <p:spPr>
           <a:xfrm>
-            <a:off x="3590958" y="4961302"/>
+            <a:off x="3590958" y="4659858"/>
             <a:ext cx="5107802" cy="276999"/>
           </a:xfrm>
           <a:prstGeom prst="rect">
@@ -10862,7 +11536,7 @@
                 <a:latin typeface="Courier New" panose="02070309020205020404" pitchFamily="49" charset="0"/>
                 <a:cs typeface="Courier New" panose="02070309020205020404" pitchFamily="49" charset="0"/>
               </a:rPr>
-              <a:t>txt</a:t>
+              <a:t>confers resistance to phage P1</a:t>
             </a:r>
             <a:endParaRPr lang="en-CA" sz="1200" dirty="0">
               <a:solidFill>
@@ -10876,10 +11550,10 @@
       </p:sp>
       <p:sp>
         <p:nvSpPr>
-          <p:cNvPr id="23" name="TextBox 22">
+          <p:cNvPr id="24" name="TextBox 23">
             <a:extLst>
               <a:ext uri="{FF2B5EF4-FFF2-40B4-BE49-F238E27FC236}">
-                <a16:creationId xmlns:a16="http://schemas.microsoft.com/office/drawing/2014/main" id="{288658D8-1D35-A3A3-4E73-0A27B49BF945}"/>
+                <a16:creationId xmlns:a16="http://schemas.microsoft.com/office/drawing/2014/main" id="{46048DEE-644A-8143-97BE-0B642B879A33}"/>
               </a:ext>
             </a:extLst>
           </p:cNvPr>
@@ -10888,60 +11562,8 @@
         </p:nvSpPr>
         <p:spPr>
           <a:xfrm>
-            <a:off x="3590957" y="5163595"/>
-            <a:ext cx="5114152" cy="276999"/>
-          </a:xfrm>
-          <a:prstGeom prst="rect">
-            <a:avLst/>
-          </a:prstGeom>
-          <a:noFill/>
-        </p:spPr>
-        <p:txBody>
-          <a:bodyPr wrap="square" rtlCol="0">
-            <a:spAutoFit/>
-          </a:bodyPr>
-          <a:lstStyle/>
-          <a:p>
-            <a:pPr marL="171450" indent="-171450">
-              <a:buFont typeface="Arial" panose="020B0604020202020204" pitchFamily="34" charset="0"/>
-              <a:buChar char="•"/>
-            </a:pPr>
-            <a:r>
-              <a:rPr lang="en-US" sz="1200" dirty="0">
-                <a:solidFill>
-                  <a:srgbClr val="0000FF"/>
-                </a:solidFill>
-                <a:latin typeface="Courier New" panose="02070309020205020404" pitchFamily="49" charset="0"/>
-                <a:cs typeface="Courier New" panose="02070309020205020404" pitchFamily="49" charset="0"/>
-              </a:rPr>
-              <a:t>txt</a:t>
-            </a:r>
-            <a:endParaRPr lang="en-CA" sz="1200" dirty="0">
-              <a:solidFill>
-                <a:srgbClr val="0000FF"/>
-              </a:solidFill>
-              <a:latin typeface="Courier New" panose="02070309020205020404" pitchFamily="49" charset="0"/>
-              <a:cs typeface="Courier New" panose="02070309020205020404" pitchFamily="49" charset="0"/>
-            </a:endParaRPr>
-          </a:p>
-        </p:txBody>
-      </p:sp>
-      <p:sp>
-        <p:nvSpPr>
-          <p:cNvPr id="24" name="TextBox 23">
-            <a:extLst>
-              <a:ext uri="{FF2B5EF4-FFF2-40B4-BE49-F238E27FC236}">
-                <a16:creationId xmlns:a16="http://schemas.microsoft.com/office/drawing/2014/main" id="{46048DEE-644A-8143-97BE-0B642B879A33}"/>
-              </a:ext>
-            </a:extLst>
-          </p:cNvPr>
-          <p:cNvSpPr txBox="1"/>
-          <p:nvPr/>
-        </p:nvSpPr>
-        <p:spPr>
-          <a:xfrm>
-            <a:off x="3540154" y="5866698"/>
-            <a:ext cx="5419693" cy="276999"/>
+            <a:off x="3548781" y="5565254"/>
+            <a:ext cx="4982744" cy="276999"/>
           </a:xfrm>
           <a:prstGeom prst="rect">
             <a:avLst/>
@@ -10966,7 +11588,7 @@
                 <a:latin typeface="Courier New" panose="02070309020205020404" pitchFamily="49" charset="0"/>
                 <a:cs typeface="Courier New" panose="02070309020205020404" pitchFamily="49" charset="0"/>
               </a:rPr>
-              <a:t>txt</a:t>
+              <a:t>interferon-inducible antiviral protein</a:t>
             </a:r>
             <a:endParaRPr lang="en-CA" sz="1200" dirty="0">
               <a:solidFill>
@@ -10992,8 +11614,8 @@
         </p:nvSpPr>
         <p:spPr>
           <a:xfrm>
-            <a:off x="3533804" y="6045500"/>
-            <a:ext cx="5164955" cy="276999"/>
+            <a:off x="3547827" y="5744056"/>
+            <a:ext cx="5078736" cy="276999"/>
           </a:xfrm>
           <a:prstGeom prst="rect">
             <a:avLst/>
@@ -11018,7 +11640,7 @@
                 <a:latin typeface="Courier New" panose="02070309020205020404" pitchFamily="49" charset="0"/>
                 <a:cs typeface="Courier New" panose="02070309020205020404" pitchFamily="49" charset="0"/>
               </a:rPr>
-              <a:t>txt</a:t>
+              <a:t>initiates pathway to repress RNA polymerase action</a:t>
             </a:r>
             <a:endParaRPr lang="en-CA" sz="1200" dirty="0">
               <a:solidFill>
@@ -11044,7 +11666,7 @@
         </p:nvSpPr>
         <p:spPr>
           <a:xfrm>
-            <a:off x="9349399" y="3091767"/>
+            <a:off x="9349399" y="3773967"/>
             <a:ext cx="2421147" cy="307777"/>
           </a:xfrm>
           <a:prstGeom prst="rect">
@@ -11066,7 +11688,7 @@
                 </a:solidFill>
                 <a:latin typeface="Verdana Pro" panose="020B0604030504040204" pitchFamily="34" charset="0"/>
               </a:rPr>
-              <a:t>txt</a:t>
+              <a:t>Q8WXG1</a:t>
             </a:r>
             <a:endParaRPr lang="en-CA" sz="1400" dirty="0">
               <a:solidFill>
@@ -11092,14 +11714,14 @@
           <p:nvPr>
             <p:extLst>
               <p:ext uri="{D42A27DB-BD31-4B8C-83A1-F6EECF244321}">
-                <p14:modId xmlns:p14="http://schemas.microsoft.com/office/powerpoint/2010/main" val="1769177759"/>
+                <p14:modId xmlns:p14="http://schemas.microsoft.com/office/powerpoint/2010/main" val="1319146353"/>
               </p:ext>
             </p:extLst>
           </p:nvPr>
         </p:nvGraphicFramePr>
         <p:xfrm>
-          <a:off x="350302" y="3647248"/>
-          <a:ext cx="2782890" cy="822960"/>
+          <a:off x="411929" y="3828403"/>
+          <a:ext cx="2782890" cy="1005840"/>
         </p:xfrm>
         <a:graphic>
           <a:graphicData uri="http://schemas.openxmlformats.org/drawingml/2006/table">
@@ -11189,7 +11811,7 @@
                           <a:latin typeface="Verdana Pro" panose="020B0604030504040204" pitchFamily="34" charset="0"/>
                           <a:cs typeface="Courier New" panose="02070309020205020404" pitchFamily="49" charset="0"/>
                         </a:rPr>
-                        <a:t>Zorya</a:t>
+                        <a:t>Vipirin</a:t>
                       </a:r>
                       <a:endParaRPr lang="en-CA" sz="1200" dirty="0">
                         <a:latin typeface="Verdana Pro" panose="020B0604030504040204" pitchFamily="34" charset="0"/>
@@ -11308,7 +11930,7 @@
                           <a:latin typeface="Verdana Pro" panose="020B0604030504040204" pitchFamily="34" charset="0"/>
                           <a:cs typeface="Courier New" panose="02070309020205020404" pitchFamily="49" charset="0"/>
                         </a:rPr>
-                        <a:t>txt Å</a:t>
+                        <a:t>0.89 Å</a:t>
                       </a:r>
                       <a:endParaRPr lang="en-CA" sz="1200" dirty="0">
                         <a:latin typeface="Verdana Pro" panose="020B0604030504040204" pitchFamily="34" charset="0"/>
@@ -11427,7 +12049,16 @@
                           <a:latin typeface="Verdana Pro" panose="020B0604030504040204" pitchFamily="34" charset="0"/>
                           <a:cs typeface="Courier New" panose="02070309020205020404" pitchFamily="49" charset="0"/>
                         </a:rPr>
-                        <a:t>txt atoms</a:t>
+                        <a:t>1423 atoms</a:t>
+                      </a:r>
+                    </a:p>
+                    <a:p>
+                      <a:r>
+                        <a:rPr lang="en-US" sz="1200" dirty="0">
+                          <a:latin typeface="Verdana Pro" panose="020B0604030504040204" pitchFamily="34" charset="0"/>
+                          <a:cs typeface="Courier New" panose="02070309020205020404" pitchFamily="49" charset="0"/>
+                        </a:rPr>
+                        <a:t>[75 AAs]</a:t>
                       </a:r>
                       <a:endParaRPr lang="en-CA" sz="1200" dirty="0">
                         <a:latin typeface="Verdana Pro" panose="020B0604030504040204" pitchFamily="34" charset="0"/>
@@ -11502,7 +12133,7 @@
           <a:blip>
             <a:extLst>
               <a:ext uri="{96DAC541-7B7A-43D3-8B79-37D633B846F1}">
-                <asvg:svgBlip xmlns:asvg="http://schemas.microsoft.com/office/drawing/2016/SVG/main" r:embed="rId5"/>
+                <asvg:svgBlip xmlns:asvg="http://schemas.microsoft.com/office/drawing/2016/SVG/main" r:embed="rId4"/>
               </a:ext>
             </a:extLst>
           </a:blip>
@@ -11521,6 +12152,140 @@
           </a:prstGeom>
         </p:spPr>
       </p:pic>
+      <p:sp>
+        <p:nvSpPr>
+          <p:cNvPr id="4" name="Rectangle 3">
+            <a:extLst>
+              <a:ext uri="{FF2B5EF4-FFF2-40B4-BE49-F238E27FC236}">
+                <a16:creationId xmlns:a16="http://schemas.microsoft.com/office/drawing/2014/main" id="{CE0CA59B-CC7E-D170-4365-9D00A04D14C8}"/>
+              </a:ext>
+            </a:extLst>
+          </p:cNvPr>
+          <p:cNvSpPr/>
+          <p:nvPr/>
+        </p:nvSpPr>
+        <p:spPr>
+          <a:xfrm>
+            <a:off x="723900" y="586752"/>
+            <a:ext cx="158750" cy="93382"/>
+          </a:xfrm>
+          <a:prstGeom prst="rect">
+            <a:avLst/>
+          </a:prstGeom>
+          <a:noFill/>
+          <a:ln>
+            <a:solidFill>
+              <a:srgbClr val="FF0000"/>
+            </a:solidFill>
+          </a:ln>
+        </p:spPr>
+        <p:style>
+          <a:lnRef idx="2">
+            <a:schemeClr val="accent1">
+              <a:shade val="15000"/>
+            </a:schemeClr>
+          </a:lnRef>
+          <a:fillRef idx="1">
+            <a:schemeClr val="accent1"/>
+          </a:fillRef>
+          <a:effectRef idx="0">
+            <a:schemeClr val="accent1"/>
+          </a:effectRef>
+          <a:fontRef idx="minor">
+            <a:schemeClr val="lt1"/>
+          </a:fontRef>
+        </p:style>
+        <p:txBody>
+          <a:bodyPr rtlCol="0" anchor="ctr"/>
+          <a:lstStyle/>
+          <a:p>
+            <a:pPr algn="ctr"/>
+            <a:endParaRPr lang="en-CA"/>
+          </a:p>
+        </p:txBody>
+      </p:sp>
+      <p:pic>
+        <p:nvPicPr>
+          <p:cNvPr id="7" name="Picture 6">
+            <a:extLst>
+              <a:ext uri="{FF2B5EF4-FFF2-40B4-BE49-F238E27FC236}">
+                <a16:creationId xmlns:a16="http://schemas.microsoft.com/office/drawing/2014/main" id="{2FE5CB3A-1BF6-F93D-2280-4A448917748C}"/>
+              </a:ext>
+            </a:extLst>
+          </p:cNvPr>
+          <p:cNvPicPr>
+            <a:picLocks noChangeAspect="1"/>
+          </p:cNvPicPr>
+          <p:nvPr/>
+        </p:nvPicPr>
+        <p:blipFill>
+          <a:blip r:embed="rId5"/>
+          <a:stretch>
+            <a:fillRect/>
+          </a:stretch>
+        </p:blipFill>
+        <p:spPr>
+          <a:xfrm>
+            <a:off x="3540162" y="516376"/>
+            <a:ext cx="5156163" cy="3886555"/>
+          </a:xfrm>
+          <a:prstGeom prst="rect">
+            <a:avLst/>
+          </a:prstGeom>
+        </p:spPr>
+      </p:pic>
+      <p:sp>
+        <p:nvSpPr>
+          <p:cNvPr id="10" name="TextBox 9">
+            <a:extLst>
+              <a:ext uri="{FF2B5EF4-FFF2-40B4-BE49-F238E27FC236}">
+                <a16:creationId xmlns:a16="http://schemas.microsoft.com/office/drawing/2014/main" id="{19B2F44B-8358-1567-FCC1-1319D17054EF}"/>
+              </a:ext>
+            </a:extLst>
+          </p:cNvPr>
+          <p:cNvSpPr txBox="1"/>
+          <p:nvPr/>
+        </p:nvSpPr>
+        <p:spPr>
+          <a:xfrm>
+            <a:off x="3590957" y="4839476"/>
+            <a:ext cx="5114152" cy="276999"/>
+          </a:xfrm>
+          <a:prstGeom prst="rect">
+            <a:avLst/>
+          </a:prstGeom>
+          <a:noFill/>
+        </p:spPr>
+        <p:txBody>
+          <a:bodyPr wrap="square" rtlCol="0">
+            <a:spAutoFit/>
+          </a:bodyPr>
+          <a:lstStyle/>
+          <a:p>
+            <a:pPr marL="171450" indent="-171450">
+              <a:buFont typeface="Arial" panose="020B0604020202020204" pitchFamily="34" charset="0"/>
+              <a:buChar char="•"/>
+            </a:pPr>
+            <a:r>
+              <a:rPr lang="en-US" sz="1200" dirty="0">
+                <a:solidFill>
+                  <a:srgbClr val="0000FF"/>
+                </a:solidFill>
+                <a:latin typeface="Courier New" panose="02070309020205020404" pitchFamily="49" charset="0"/>
+                <a:cs typeface="Courier New" panose="02070309020205020404" pitchFamily="49" charset="0"/>
+              </a:rPr>
+              <a:t>represses T7 RNA-polymerase action</a:t>
+            </a:r>
+            <a:endParaRPr lang="en-CA" sz="1200" dirty="0">
+              <a:solidFill>
+                <a:srgbClr val="0000FF"/>
+              </a:solidFill>
+              <a:latin typeface="Courier New" panose="02070309020205020404" pitchFamily="49" charset="0"/>
+              <a:cs typeface="Courier New" panose="02070309020205020404" pitchFamily="49" charset="0"/>
+            </a:endParaRPr>
+          </a:p>
+        </p:txBody>
+      </p:sp>
     </p:spTree>
     <p:extLst>
       <p:ext uri="{BB962C8B-B14F-4D97-AF65-F5344CB8AC3E}">

</xml_diff>

<commit_message>
Finished first draft of slides.
</commit_message>
<xml_diff>
--- a/reports/2026-04-10_projectUpdate_2_jmoran.pptx
+++ b/reports/2026-04-10_projectUpdate_2_jmoran.pptx
@@ -5,7 +5,7 @@
     <p:sldMasterId id="2147483648" r:id="rId1"/>
   </p:sldMasterIdLst>
   <p:notesMasterIdLst>
-    <p:notesMasterId r:id="rId15"/>
+    <p:notesMasterId r:id="rId17"/>
   </p:notesMasterIdLst>
   <p:sldIdLst>
     <p:sldId id="256" r:id="rId2"/>
@@ -21,6 +21,8 @@
     <p:sldId id="278" r:id="rId12"/>
     <p:sldId id="267" r:id="rId13"/>
     <p:sldId id="276" r:id="rId14"/>
+    <p:sldId id="279" r:id="rId15"/>
+    <p:sldId id="280" r:id="rId16"/>
   </p:sldIdLst>
   <p:sldSz cx="12192000" cy="6858000"/>
   <p:notesSz cx="6858000" cy="9144000"/>
@@ -12290,6 +12292,2108 @@
     <p:extLst>
       <p:ext uri="{BB962C8B-B14F-4D97-AF65-F5344CB8AC3E}">
         <p14:creationId xmlns:p14="http://schemas.microsoft.com/office/powerpoint/2010/main" val="4190603527"/>
+      </p:ext>
+    </p:extLst>
+  </p:cSld>
+  <p:clrMapOvr>
+    <a:masterClrMapping/>
+  </p:clrMapOvr>
+</p:sld>
+</file>
+
+<file path=ppt/slides/slide14.xml><?xml version="1.0" encoding="utf-8"?>
+<p:sld xmlns:a="http://schemas.openxmlformats.org/drawingml/2006/main" xmlns:r="http://schemas.openxmlformats.org/officeDocument/2006/relationships" xmlns:p="http://schemas.openxmlformats.org/presentationml/2006/main">
+  <p:cSld>
+    <p:spTree>
+      <p:nvGrpSpPr>
+        <p:cNvPr id="1" name="">
+          <a:extLst>
+            <a:ext uri="{FF2B5EF4-FFF2-40B4-BE49-F238E27FC236}">
+              <a16:creationId xmlns:a16="http://schemas.microsoft.com/office/drawing/2014/main" id="{93285337-A1A9-09A2-FDE4-7696368E4803}"/>
+            </a:ext>
+          </a:extLst>
+        </p:cNvPr>
+        <p:cNvGrpSpPr/>
+        <p:nvPr/>
+      </p:nvGrpSpPr>
+      <p:grpSpPr>
+        <a:xfrm>
+          <a:off x="0" y="0"/>
+          <a:ext cx="0" cy="0"/>
+          <a:chOff x="0" y="0"/>
+          <a:chExt cx="0" cy="0"/>
+        </a:xfrm>
+      </p:grpSpPr>
+      <p:pic>
+        <p:nvPicPr>
+          <p:cNvPr id="23" name="Picture 22">
+            <a:extLst>
+              <a:ext uri="{FF2B5EF4-FFF2-40B4-BE49-F238E27FC236}">
+                <a16:creationId xmlns:a16="http://schemas.microsoft.com/office/drawing/2014/main" id="{B1769DC9-071C-942B-7241-1434998AFAA4}"/>
+              </a:ext>
+            </a:extLst>
+          </p:cNvPr>
+          <p:cNvPicPr>
+            <a:picLocks noChangeAspect="1"/>
+          </p:cNvPicPr>
+          <p:nvPr/>
+        </p:nvPicPr>
+        <p:blipFill>
+          <a:blip r:embed="rId2"/>
+          <a:stretch>
+            <a:fillRect/>
+          </a:stretch>
+        </p:blipFill>
+        <p:spPr>
+          <a:xfrm>
+            <a:off x="8717360" y="3607360"/>
+            <a:ext cx="3067478" cy="2866392"/>
+          </a:xfrm>
+          <a:prstGeom prst="rect">
+            <a:avLst/>
+          </a:prstGeom>
+        </p:spPr>
+      </p:pic>
+      <p:pic>
+        <p:nvPicPr>
+          <p:cNvPr id="11" name="Picture 10">
+            <a:extLst>
+              <a:ext uri="{FF2B5EF4-FFF2-40B4-BE49-F238E27FC236}">
+                <a16:creationId xmlns:a16="http://schemas.microsoft.com/office/drawing/2014/main" id="{3550C085-A054-8291-7541-982601739DB5}"/>
+              </a:ext>
+            </a:extLst>
+          </p:cNvPr>
+          <p:cNvPicPr>
+            <a:picLocks noChangeAspect="1"/>
+          </p:cNvPicPr>
+          <p:nvPr/>
+        </p:nvPicPr>
+        <p:blipFill>
+          <a:blip r:embed="rId3"/>
+          <a:stretch>
+            <a:fillRect/>
+          </a:stretch>
+        </p:blipFill>
+        <p:spPr>
+          <a:xfrm>
+            <a:off x="8720959" y="504772"/>
+            <a:ext cx="3060280" cy="3106647"/>
+          </a:xfrm>
+          <a:prstGeom prst="rect">
+            <a:avLst/>
+          </a:prstGeom>
+        </p:spPr>
+      </p:pic>
+      <p:sp>
+        <p:nvSpPr>
+          <p:cNvPr id="17" name="Rectangle 16">
+            <a:extLst>
+              <a:ext uri="{FF2B5EF4-FFF2-40B4-BE49-F238E27FC236}">
+                <a16:creationId xmlns:a16="http://schemas.microsoft.com/office/drawing/2014/main" id="{812599B7-D838-FDFF-8B87-B69F97760476}"/>
+              </a:ext>
+            </a:extLst>
+          </p:cNvPr>
+          <p:cNvSpPr/>
+          <p:nvPr/>
+        </p:nvSpPr>
+        <p:spPr>
+          <a:xfrm>
+            <a:off x="3540154" y="4761874"/>
+            <a:ext cx="5156171" cy="845389"/>
+          </a:xfrm>
+          <a:prstGeom prst="rect">
+            <a:avLst/>
+          </a:prstGeom>
+          <a:noFill/>
+          <a:ln w="6350">
+            <a:solidFill>
+              <a:srgbClr val="0000FF"/>
+            </a:solidFill>
+          </a:ln>
+        </p:spPr>
+        <p:style>
+          <a:lnRef idx="2">
+            <a:schemeClr val="accent1">
+              <a:shade val="15000"/>
+            </a:schemeClr>
+          </a:lnRef>
+          <a:fillRef idx="1">
+            <a:schemeClr val="accent1"/>
+          </a:fillRef>
+          <a:effectRef idx="0">
+            <a:schemeClr val="accent1"/>
+          </a:effectRef>
+          <a:fontRef idx="minor">
+            <a:schemeClr val="lt1"/>
+          </a:fontRef>
+        </p:style>
+        <p:txBody>
+          <a:bodyPr rtlCol="0" anchor="ctr"/>
+          <a:lstStyle/>
+          <a:p>
+            <a:pPr algn="ctr"/>
+            <a:endParaRPr lang="en-CA"/>
+          </a:p>
+        </p:txBody>
+      </p:sp>
+      <p:sp>
+        <p:nvSpPr>
+          <p:cNvPr id="15" name="TextBox 14">
+            <a:extLst>
+              <a:ext uri="{FF2B5EF4-FFF2-40B4-BE49-F238E27FC236}">
+                <a16:creationId xmlns:a16="http://schemas.microsoft.com/office/drawing/2014/main" id="{8513B0A3-8D80-DC7F-37F6-BADD830D5CAB}"/>
+              </a:ext>
+            </a:extLst>
+          </p:cNvPr>
+          <p:cNvSpPr txBox="1"/>
+          <p:nvPr/>
+        </p:nvSpPr>
+        <p:spPr>
+          <a:xfrm>
+            <a:off x="3590957" y="4757111"/>
+            <a:ext cx="4781518" cy="307777"/>
+          </a:xfrm>
+          <a:prstGeom prst="rect">
+            <a:avLst/>
+          </a:prstGeom>
+          <a:noFill/>
+        </p:spPr>
+        <p:txBody>
+          <a:bodyPr wrap="square" rtlCol="0">
+            <a:spAutoFit/>
+          </a:bodyPr>
+          <a:lstStyle/>
+          <a:p>
+            <a:r>
+              <a:rPr lang="en-US" sz="1400" dirty="0">
+                <a:solidFill>
+                  <a:srgbClr val="0000FF"/>
+                </a:solidFill>
+                <a:latin typeface="Verdana Pro" panose="020B0604030504040204" pitchFamily="34" charset="0"/>
+              </a:rPr>
+              <a:t>Q6XGD5 [E. coli][cdnE]</a:t>
+            </a:r>
+            <a:endParaRPr lang="en-CA" sz="1400" dirty="0">
+              <a:solidFill>
+                <a:srgbClr val="0000FF"/>
+              </a:solidFill>
+              <a:latin typeface="Verdana Pro" panose="020B0604030504040204" pitchFamily="34" charset="0"/>
+            </a:endParaRPr>
+          </a:p>
+        </p:txBody>
+      </p:sp>
+      <p:sp>
+        <p:nvSpPr>
+          <p:cNvPr id="16" name="TextBox 15">
+            <a:extLst>
+              <a:ext uri="{FF2B5EF4-FFF2-40B4-BE49-F238E27FC236}">
+                <a16:creationId xmlns:a16="http://schemas.microsoft.com/office/drawing/2014/main" id="{CD05969E-BA91-1E8F-3740-1C4EBCE5EB28}"/>
+              </a:ext>
+            </a:extLst>
+          </p:cNvPr>
+          <p:cNvSpPr txBox="1"/>
+          <p:nvPr/>
+        </p:nvSpPr>
+        <p:spPr>
+          <a:xfrm>
+            <a:off x="3590957" y="5644540"/>
+            <a:ext cx="3314668" cy="307777"/>
+          </a:xfrm>
+          <a:prstGeom prst="rect">
+            <a:avLst/>
+          </a:prstGeom>
+          <a:noFill/>
+        </p:spPr>
+        <p:txBody>
+          <a:bodyPr wrap="square" rtlCol="0">
+            <a:spAutoFit/>
+          </a:bodyPr>
+          <a:lstStyle/>
+          <a:p>
+            <a:r>
+              <a:rPr lang="en-US" sz="1400" dirty="0">
+                <a:solidFill>
+                  <a:srgbClr val="FF0000"/>
+                </a:solidFill>
+                <a:latin typeface="Verdana Pro" panose="020B0604030504040204" pitchFamily="34" charset="0"/>
+              </a:rPr>
+              <a:t>Q8N884 [H. sapiens][CGAS]</a:t>
+            </a:r>
+            <a:endParaRPr lang="en-CA" sz="1400" dirty="0">
+              <a:solidFill>
+                <a:srgbClr val="FF0000"/>
+              </a:solidFill>
+              <a:latin typeface="Verdana Pro" panose="020B0604030504040204" pitchFamily="34" charset="0"/>
+            </a:endParaRPr>
+          </a:p>
+        </p:txBody>
+      </p:sp>
+      <p:sp>
+        <p:nvSpPr>
+          <p:cNvPr id="18" name="Rectangle 17">
+            <a:extLst>
+              <a:ext uri="{FF2B5EF4-FFF2-40B4-BE49-F238E27FC236}">
+                <a16:creationId xmlns:a16="http://schemas.microsoft.com/office/drawing/2014/main" id="{C863E170-939F-9687-F701-832A6C5E8A7E}"/>
+              </a:ext>
+            </a:extLst>
+          </p:cNvPr>
+          <p:cNvSpPr/>
+          <p:nvPr/>
+        </p:nvSpPr>
+        <p:spPr>
+          <a:xfrm>
+            <a:off x="3540154" y="5619753"/>
+            <a:ext cx="5156172" cy="845389"/>
+          </a:xfrm>
+          <a:prstGeom prst="rect">
+            <a:avLst/>
+          </a:prstGeom>
+          <a:noFill/>
+          <a:ln w="6350">
+            <a:solidFill>
+              <a:srgbClr val="FF0000"/>
+            </a:solidFill>
+          </a:ln>
+        </p:spPr>
+        <p:style>
+          <a:lnRef idx="2">
+            <a:schemeClr val="accent1">
+              <a:shade val="15000"/>
+            </a:schemeClr>
+          </a:lnRef>
+          <a:fillRef idx="1">
+            <a:schemeClr val="accent1"/>
+          </a:fillRef>
+          <a:effectRef idx="0">
+            <a:schemeClr val="accent1"/>
+          </a:effectRef>
+          <a:fontRef idx="minor">
+            <a:schemeClr val="lt1"/>
+          </a:fontRef>
+        </p:style>
+        <p:txBody>
+          <a:bodyPr rtlCol="0" anchor="ctr"/>
+          <a:lstStyle/>
+          <a:p>
+            <a:pPr algn="ctr"/>
+            <a:endParaRPr lang="en-CA">
+              <a:solidFill>
+                <a:srgbClr val="FF0000"/>
+              </a:solidFill>
+            </a:endParaRPr>
+          </a:p>
+        </p:txBody>
+      </p:sp>
+      <p:sp>
+        <p:nvSpPr>
+          <p:cNvPr id="21" name="TextBox 20">
+            <a:extLst>
+              <a:ext uri="{FF2B5EF4-FFF2-40B4-BE49-F238E27FC236}">
+                <a16:creationId xmlns:a16="http://schemas.microsoft.com/office/drawing/2014/main" id="{8E8A91DA-7491-BECE-5A94-ED7ED4100471}"/>
+              </a:ext>
+            </a:extLst>
+          </p:cNvPr>
+          <p:cNvSpPr txBox="1"/>
+          <p:nvPr/>
+        </p:nvSpPr>
+        <p:spPr>
+          <a:xfrm>
+            <a:off x="9394672" y="568235"/>
+            <a:ext cx="2421147" cy="307777"/>
+          </a:xfrm>
+          <a:prstGeom prst="rect">
+            <a:avLst/>
+          </a:prstGeom>
+          <a:noFill/>
+        </p:spPr>
+        <p:txBody>
+          <a:bodyPr wrap="square" rtlCol="0">
+            <a:spAutoFit/>
+          </a:bodyPr>
+          <a:lstStyle/>
+          <a:p>
+            <a:pPr algn="r"/>
+            <a:r>
+              <a:rPr lang="en-US" sz="1400" dirty="0">
+                <a:solidFill>
+                  <a:srgbClr val="0000FF"/>
+                </a:solidFill>
+                <a:latin typeface="Verdana Pro" panose="020B0604030504040204" pitchFamily="34" charset="0"/>
+              </a:rPr>
+              <a:t>Q6XGD5</a:t>
+            </a:r>
+            <a:endParaRPr lang="en-CA" sz="1400" dirty="0">
+              <a:solidFill>
+                <a:srgbClr val="0000FF"/>
+              </a:solidFill>
+              <a:latin typeface="Verdana Pro" panose="020B0604030504040204" pitchFamily="34" charset="0"/>
+            </a:endParaRPr>
+          </a:p>
+        </p:txBody>
+      </p:sp>
+      <p:sp>
+        <p:nvSpPr>
+          <p:cNvPr id="22" name="TextBox 21">
+            <a:extLst>
+              <a:ext uri="{FF2B5EF4-FFF2-40B4-BE49-F238E27FC236}">
+                <a16:creationId xmlns:a16="http://schemas.microsoft.com/office/drawing/2014/main" id="{CC4F3F6C-FACB-BB70-E369-56D6801E91D9}"/>
+              </a:ext>
+            </a:extLst>
+          </p:cNvPr>
+          <p:cNvSpPr txBox="1"/>
+          <p:nvPr/>
+        </p:nvSpPr>
+        <p:spPr>
+          <a:xfrm>
+            <a:off x="3590958" y="4973886"/>
+            <a:ext cx="5107802" cy="461665"/>
+          </a:xfrm>
+          <a:prstGeom prst="rect">
+            <a:avLst/>
+          </a:prstGeom>
+          <a:noFill/>
+        </p:spPr>
+        <p:txBody>
+          <a:bodyPr wrap="square" rtlCol="0">
+            <a:spAutoFit/>
+          </a:bodyPr>
+          <a:lstStyle/>
+          <a:p>
+            <a:pPr marL="171450" indent="-171450">
+              <a:buFont typeface="Arial" panose="020B0604020202020204" pitchFamily="34" charset="0"/>
+              <a:buChar char="•"/>
+            </a:pPr>
+            <a:r>
+              <a:rPr lang="en-US" sz="1200" dirty="0">
+                <a:solidFill>
+                  <a:srgbClr val="0000FF"/>
+                </a:solidFill>
+                <a:latin typeface="Courier New" panose="02070309020205020404" pitchFamily="49" charset="0"/>
+                <a:cs typeface="Courier New" panose="02070309020205020404" pitchFamily="49" charset="0"/>
+              </a:rPr>
+              <a:t>Cyclic nucleotide synthase (second messenger synthesis) in CBASS system</a:t>
+            </a:r>
+            <a:endParaRPr lang="en-CA" sz="1200" dirty="0">
+              <a:solidFill>
+                <a:srgbClr val="0000FF"/>
+              </a:solidFill>
+              <a:latin typeface="Courier New" panose="02070309020205020404" pitchFamily="49" charset="0"/>
+              <a:cs typeface="Courier New" panose="02070309020205020404" pitchFamily="49" charset="0"/>
+            </a:endParaRPr>
+          </a:p>
+        </p:txBody>
+      </p:sp>
+      <p:sp>
+        <p:nvSpPr>
+          <p:cNvPr id="24" name="TextBox 23">
+            <a:extLst>
+              <a:ext uri="{FF2B5EF4-FFF2-40B4-BE49-F238E27FC236}">
+                <a16:creationId xmlns:a16="http://schemas.microsoft.com/office/drawing/2014/main" id="{70FB4D5A-77F8-7F70-776B-9183BB442DE5}"/>
+              </a:ext>
+            </a:extLst>
+          </p:cNvPr>
+          <p:cNvSpPr txBox="1"/>
+          <p:nvPr/>
+        </p:nvSpPr>
+        <p:spPr>
+          <a:xfrm>
+            <a:off x="3548781" y="5879282"/>
+            <a:ext cx="4982744" cy="461665"/>
+          </a:xfrm>
+          <a:prstGeom prst="rect">
+            <a:avLst/>
+          </a:prstGeom>
+          <a:noFill/>
+        </p:spPr>
+        <p:txBody>
+          <a:bodyPr wrap="square" rtlCol="0">
+            <a:spAutoFit/>
+          </a:bodyPr>
+          <a:lstStyle/>
+          <a:p>
+            <a:pPr marL="171450" indent="-171450">
+              <a:buFont typeface="Arial" panose="020B0604020202020204" pitchFamily="34" charset="0"/>
+              <a:buChar char="•"/>
+            </a:pPr>
+            <a:r>
+              <a:rPr lang="en-US" sz="1200" dirty="0">
+                <a:solidFill>
+                  <a:srgbClr val="FF0000"/>
+                </a:solidFill>
+                <a:latin typeface="Courier New" panose="02070309020205020404" pitchFamily="49" charset="0"/>
+                <a:cs typeface="Courier New" panose="02070309020205020404" pitchFamily="49" charset="0"/>
+              </a:rPr>
+              <a:t>nucleotidyltransferase catalyzing formation of cyclic GMP-AMP; plays role in innate immunity</a:t>
+            </a:r>
+            <a:endParaRPr lang="en-CA" sz="1200" dirty="0">
+              <a:solidFill>
+                <a:srgbClr val="FF0000"/>
+              </a:solidFill>
+              <a:latin typeface="Courier New" panose="02070309020205020404" pitchFamily="49" charset="0"/>
+              <a:cs typeface="Courier New" panose="02070309020205020404" pitchFamily="49" charset="0"/>
+            </a:endParaRPr>
+          </a:p>
+        </p:txBody>
+      </p:sp>
+      <p:sp>
+        <p:nvSpPr>
+          <p:cNvPr id="28" name="TextBox 27">
+            <a:extLst>
+              <a:ext uri="{FF2B5EF4-FFF2-40B4-BE49-F238E27FC236}">
+                <a16:creationId xmlns:a16="http://schemas.microsoft.com/office/drawing/2014/main" id="{F4F06483-848C-7C5D-27F2-45278FA99187}"/>
+              </a:ext>
+            </a:extLst>
+          </p:cNvPr>
+          <p:cNvSpPr txBox="1"/>
+          <p:nvPr/>
+        </p:nvSpPr>
+        <p:spPr>
+          <a:xfrm>
+            <a:off x="9375440" y="3520993"/>
+            <a:ext cx="2421147" cy="307777"/>
+          </a:xfrm>
+          <a:prstGeom prst="rect">
+            <a:avLst/>
+          </a:prstGeom>
+          <a:noFill/>
+        </p:spPr>
+        <p:txBody>
+          <a:bodyPr wrap="square" rtlCol="0">
+            <a:spAutoFit/>
+          </a:bodyPr>
+          <a:lstStyle/>
+          <a:p>
+            <a:pPr algn="r"/>
+            <a:r>
+              <a:rPr lang="en-US" sz="1400" dirty="0">
+                <a:solidFill>
+                  <a:srgbClr val="FF0000"/>
+                </a:solidFill>
+                <a:latin typeface="Verdana Pro" panose="020B0604030504040204" pitchFamily="34" charset="0"/>
+              </a:rPr>
+              <a:t>Q8N884</a:t>
+            </a:r>
+            <a:endParaRPr lang="en-CA" sz="1400" dirty="0">
+              <a:solidFill>
+                <a:srgbClr val="FF0000"/>
+              </a:solidFill>
+              <a:latin typeface="Verdana Pro" panose="020B0604030504040204" pitchFamily="34" charset="0"/>
+            </a:endParaRPr>
+          </a:p>
+        </p:txBody>
+      </p:sp>
+      <p:graphicFrame>
+        <p:nvGraphicFramePr>
+          <p:cNvPr id="29" name="Table 28">
+            <a:extLst>
+              <a:ext uri="{FF2B5EF4-FFF2-40B4-BE49-F238E27FC236}">
+                <a16:creationId xmlns:a16="http://schemas.microsoft.com/office/drawing/2014/main" id="{BB5E299E-F9C4-86A8-9515-04FA20C80E2B}"/>
+              </a:ext>
+            </a:extLst>
+          </p:cNvPr>
+          <p:cNvGraphicFramePr>
+            <a:graphicFrameLocks noGrp="1"/>
+          </p:cNvGraphicFramePr>
+          <p:nvPr>
+            <p:extLst>
+              <p:ext uri="{D42A27DB-BD31-4B8C-83A1-F6EECF244321}">
+                <p14:modId xmlns:p14="http://schemas.microsoft.com/office/powerpoint/2010/main" val="561089354"/>
+              </p:ext>
+            </p:extLst>
+          </p:nvPr>
+        </p:nvGraphicFramePr>
+        <p:xfrm>
+          <a:off x="411929" y="3828403"/>
+          <a:ext cx="2782890" cy="1005840"/>
+        </p:xfrm>
+        <a:graphic>
+          <a:graphicData uri="http://schemas.openxmlformats.org/drawingml/2006/table">
+            <a:tbl>
+              <a:tblPr firstRow="1" bandRow="1">
+                <a:tableStyleId>{5940675A-B579-460E-94D1-54222C63F5DA}</a:tableStyleId>
+              </a:tblPr>
+              <a:tblGrid>
+                <a:gridCol w="1158079">
+                  <a:extLst>
+                    <a:ext uri="{9D8B030D-6E8A-4147-A177-3AD203B41FA5}">
+                      <a16:colId xmlns:a16="http://schemas.microsoft.com/office/drawing/2014/main" val="1461492322"/>
+                    </a:ext>
+                  </a:extLst>
+                </a:gridCol>
+                <a:gridCol w="1624811">
+                  <a:extLst>
+                    <a:ext uri="{9D8B030D-6E8A-4147-A177-3AD203B41FA5}">
+                      <a16:colId xmlns:a16="http://schemas.microsoft.com/office/drawing/2014/main" val="3072927139"/>
+                    </a:ext>
+                  </a:extLst>
+                </a:gridCol>
+              </a:tblGrid>
+              <a:tr h="204265">
+                <a:tc>
+                  <a:txBody>
+                    <a:bodyPr/>
+                    <a:lstStyle/>
+                    <a:p>
+                      <a:r>
+                        <a:rPr lang="en-US" sz="1200" dirty="0">
+                          <a:latin typeface="Verdana Pro" panose="020B0604030504040204" pitchFamily="34" charset="0"/>
+                        </a:rPr>
+                        <a:t>System</a:t>
+                      </a:r>
+                      <a:endParaRPr lang="en-CA" sz="1200" dirty="0">
+                        <a:latin typeface="Verdana Pro" panose="020B0604030504040204" pitchFamily="34" charset="0"/>
+                      </a:endParaRPr>
+                    </a:p>
+                  </a:txBody>
+                  <a:tcPr>
+                    <a:lnL w="6350" cap="flat" cmpd="sng" algn="ctr">
+                      <a:solidFill>
+                        <a:schemeClr val="tx1"/>
+                      </a:solidFill>
+                      <a:prstDash val="solid"/>
+                      <a:round/>
+                      <a:headEnd type="none" w="med" len="med"/>
+                      <a:tailEnd type="none" w="med" len="med"/>
+                    </a:lnL>
+                    <a:lnR w="6350" cap="flat" cmpd="sng" algn="ctr">
+                      <a:solidFill>
+                        <a:schemeClr val="tx1"/>
+                      </a:solidFill>
+                      <a:prstDash val="solid"/>
+                      <a:round/>
+                      <a:headEnd type="none" w="med" len="med"/>
+                      <a:tailEnd type="none" w="med" len="med"/>
+                    </a:lnR>
+                    <a:lnT w="6350" cap="flat" cmpd="sng" algn="ctr">
+                      <a:solidFill>
+                        <a:schemeClr val="tx1"/>
+                      </a:solidFill>
+                      <a:prstDash val="solid"/>
+                      <a:round/>
+                      <a:headEnd type="none" w="med" len="med"/>
+                      <a:tailEnd type="none" w="med" len="med"/>
+                    </a:lnT>
+                    <a:lnB w="6350" cap="flat" cmpd="sng" algn="ctr">
+                      <a:solidFill>
+                        <a:schemeClr val="tx1"/>
+                      </a:solidFill>
+                      <a:prstDash val="solid"/>
+                      <a:round/>
+                      <a:headEnd type="none" w="med" len="med"/>
+                      <a:tailEnd type="none" w="med" len="med"/>
+                    </a:lnB>
+                  </a:tcPr>
+                </a:tc>
+                <a:tc>
+                  <a:txBody>
+                    <a:bodyPr/>
+                    <a:lstStyle/>
+                    <a:p>
+                      <a:r>
+                        <a:rPr lang="en-US" sz="1200" dirty="0">
+                          <a:latin typeface="Verdana Pro" panose="020B0604030504040204" pitchFamily="34" charset="0"/>
+                          <a:cs typeface="Courier New" panose="02070309020205020404" pitchFamily="49" charset="0"/>
+                        </a:rPr>
+                        <a:t>CBASS</a:t>
+                      </a:r>
+                      <a:endParaRPr lang="en-CA" sz="1200" dirty="0">
+                        <a:latin typeface="Verdana Pro" panose="020B0604030504040204" pitchFamily="34" charset="0"/>
+                        <a:cs typeface="Courier New" panose="02070309020205020404" pitchFamily="49" charset="0"/>
+                      </a:endParaRPr>
+                    </a:p>
+                  </a:txBody>
+                  <a:tcPr>
+                    <a:lnL w="6350" cap="flat" cmpd="sng" algn="ctr">
+                      <a:solidFill>
+                        <a:schemeClr val="tx1"/>
+                      </a:solidFill>
+                      <a:prstDash val="solid"/>
+                      <a:round/>
+                      <a:headEnd type="none" w="med" len="med"/>
+                      <a:tailEnd type="none" w="med" len="med"/>
+                    </a:lnL>
+                    <a:lnR w="6350" cap="flat" cmpd="sng" algn="ctr">
+                      <a:solidFill>
+                        <a:schemeClr val="tx1"/>
+                      </a:solidFill>
+                      <a:prstDash val="solid"/>
+                      <a:round/>
+                      <a:headEnd type="none" w="med" len="med"/>
+                      <a:tailEnd type="none" w="med" len="med"/>
+                    </a:lnR>
+                    <a:lnT w="6350" cap="flat" cmpd="sng" algn="ctr">
+                      <a:solidFill>
+                        <a:schemeClr val="tx1"/>
+                      </a:solidFill>
+                      <a:prstDash val="solid"/>
+                      <a:round/>
+                      <a:headEnd type="none" w="med" len="med"/>
+                      <a:tailEnd type="none" w="med" len="med"/>
+                    </a:lnT>
+                    <a:lnB w="6350" cap="flat" cmpd="sng" algn="ctr">
+                      <a:solidFill>
+                        <a:schemeClr val="tx1"/>
+                      </a:solidFill>
+                      <a:prstDash val="solid"/>
+                      <a:round/>
+                      <a:headEnd type="none" w="med" len="med"/>
+                      <a:tailEnd type="none" w="med" len="med"/>
+                    </a:lnB>
+                  </a:tcPr>
+                </a:tc>
+                <a:extLst>
+                  <a:ext uri="{0D108BD9-81ED-4DB2-BD59-A6C34878D82A}">
+                    <a16:rowId xmlns:a16="http://schemas.microsoft.com/office/drawing/2014/main" val="1515812024"/>
+                  </a:ext>
+                </a:extLst>
+              </a:tr>
+              <a:tr h="204265">
+                <a:tc>
+                  <a:txBody>
+                    <a:bodyPr/>
+                    <a:lstStyle/>
+                    <a:p>
+                      <a:r>
+                        <a:rPr lang="en-US" sz="1200" dirty="0">
+                          <a:latin typeface="Verdana Pro" panose="020B0604030504040204" pitchFamily="34" charset="0"/>
+                        </a:rPr>
+                        <a:t>PyMol RMSD</a:t>
+                      </a:r>
+                      <a:endParaRPr lang="en-CA" sz="1200" dirty="0">
+                        <a:latin typeface="Verdana Pro" panose="020B0604030504040204" pitchFamily="34" charset="0"/>
+                      </a:endParaRPr>
+                    </a:p>
+                  </a:txBody>
+                  <a:tcPr>
+                    <a:lnL w="6350" cap="flat" cmpd="sng" algn="ctr">
+                      <a:solidFill>
+                        <a:schemeClr val="tx1"/>
+                      </a:solidFill>
+                      <a:prstDash val="solid"/>
+                      <a:round/>
+                      <a:headEnd type="none" w="med" len="med"/>
+                      <a:tailEnd type="none" w="med" len="med"/>
+                    </a:lnL>
+                    <a:lnR w="6350" cap="flat" cmpd="sng" algn="ctr">
+                      <a:solidFill>
+                        <a:schemeClr val="tx1"/>
+                      </a:solidFill>
+                      <a:prstDash val="solid"/>
+                      <a:round/>
+                      <a:headEnd type="none" w="med" len="med"/>
+                      <a:tailEnd type="none" w="med" len="med"/>
+                    </a:lnR>
+                    <a:lnT w="6350" cap="flat" cmpd="sng" algn="ctr">
+                      <a:solidFill>
+                        <a:schemeClr val="tx1"/>
+                      </a:solidFill>
+                      <a:prstDash val="solid"/>
+                      <a:round/>
+                      <a:headEnd type="none" w="med" len="med"/>
+                      <a:tailEnd type="none" w="med" len="med"/>
+                    </a:lnT>
+                    <a:lnB w="6350" cap="flat" cmpd="sng" algn="ctr">
+                      <a:solidFill>
+                        <a:schemeClr val="tx1"/>
+                      </a:solidFill>
+                      <a:prstDash val="solid"/>
+                      <a:round/>
+                      <a:headEnd type="none" w="med" len="med"/>
+                      <a:tailEnd type="none" w="med" len="med"/>
+                    </a:lnB>
+                  </a:tcPr>
+                </a:tc>
+                <a:tc>
+                  <a:txBody>
+                    <a:bodyPr/>
+                    <a:lstStyle/>
+                    <a:p>
+                      <a:r>
+                        <a:rPr lang="en-US" sz="1200" dirty="0">
+                          <a:latin typeface="Verdana Pro" panose="020B0604030504040204" pitchFamily="34" charset="0"/>
+                          <a:cs typeface="Courier New" panose="02070309020205020404" pitchFamily="49" charset="0"/>
+                        </a:rPr>
+                        <a:t>5.53 Å</a:t>
+                      </a:r>
+                      <a:endParaRPr lang="en-CA" sz="1200" dirty="0">
+                        <a:latin typeface="Verdana Pro" panose="020B0604030504040204" pitchFamily="34" charset="0"/>
+                        <a:cs typeface="Courier New" panose="02070309020205020404" pitchFamily="49" charset="0"/>
+                      </a:endParaRPr>
+                    </a:p>
+                  </a:txBody>
+                  <a:tcPr>
+                    <a:lnL w="6350" cap="flat" cmpd="sng" algn="ctr">
+                      <a:solidFill>
+                        <a:schemeClr val="tx1"/>
+                      </a:solidFill>
+                      <a:prstDash val="solid"/>
+                      <a:round/>
+                      <a:headEnd type="none" w="med" len="med"/>
+                      <a:tailEnd type="none" w="med" len="med"/>
+                    </a:lnL>
+                    <a:lnR w="6350" cap="flat" cmpd="sng" algn="ctr">
+                      <a:solidFill>
+                        <a:schemeClr val="tx1"/>
+                      </a:solidFill>
+                      <a:prstDash val="solid"/>
+                      <a:round/>
+                      <a:headEnd type="none" w="med" len="med"/>
+                      <a:tailEnd type="none" w="med" len="med"/>
+                    </a:lnR>
+                    <a:lnT w="6350" cap="flat" cmpd="sng" algn="ctr">
+                      <a:solidFill>
+                        <a:schemeClr val="tx1"/>
+                      </a:solidFill>
+                      <a:prstDash val="solid"/>
+                      <a:round/>
+                      <a:headEnd type="none" w="med" len="med"/>
+                      <a:tailEnd type="none" w="med" len="med"/>
+                    </a:lnT>
+                    <a:lnB w="6350" cap="flat" cmpd="sng" algn="ctr">
+                      <a:solidFill>
+                        <a:schemeClr val="tx1"/>
+                      </a:solidFill>
+                      <a:prstDash val="solid"/>
+                      <a:round/>
+                      <a:headEnd type="none" w="med" len="med"/>
+                      <a:tailEnd type="none" w="med" len="med"/>
+                    </a:lnB>
+                  </a:tcPr>
+                </a:tc>
+                <a:extLst>
+                  <a:ext uri="{0D108BD9-81ED-4DB2-BD59-A6C34878D82A}">
+                    <a16:rowId xmlns:a16="http://schemas.microsoft.com/office/drawing/2014/main" val="3727042579"/>
+                  </a:ext>
+                </a:extLst>
+              </a:tr>
+              <a:tr h="204265">
+                <a:tc>
+                  <a:txBody>
+                    <a:bodyPr/>
+                    <a:lstStyle/>
+                    <a:p>
+                      <a:r>
+                        <a:rPr lang="en-US" sz="1200" dirty="0">
+                          <a:latin typeface="Verdana Pro" panose="020B0604030504040204" pitchFamily="34" charset="0"/>
+                        </a:rPr>
+                        <a:t>Aln length</a:t>
+                      </a:r>
+                      <a:endParaRPr lang="en-CA" sz="1200" dirty="0">
+                        <a:latin typeface="Verdana Pro" panose="020B0604030504040204" pitchFamily="34" charset="0"/>
+                      </a:endParaRPr>
+                    </a:p>
+                  </a:txBody>
+                  <a:tcPr>
+                    <a:lnL w="6350" cap="flat" cmpd="sng" algn="ctr">
+                      <a:solidFill>
+                        <a:schemeClr val="tx1"/>
+                      </a:solidFill>
+                      <a:prstDash val="solid"/>
+                      <a:round/>
+                      <a:headEnd type="none" w="med" len="med"/>
+                      <a:tailEnd type="none" w="med" len="med"/>
+                    </a:lnL>
+                    <a:lnR w="6350" cap="flat" cmpd="sng" algn="ctr">
+                      <a:solidFill>
+                        <a:schemeClr val="tx1"/>
+                      </a:solidFill>
+                      <a:prstDash val="solid"/>
+                      <a:round/>
+                      <a:headEnd type="none" w="med" len="med"/>
+                      <a:tailEnd type="none" w="med" len="med"/>
+                    </a:lnR>
+                    <a:lnT w="6350" cap="flat" cmpd="sng" algn="ctr">
+                      <a:solidFill>
+                        <a:schemeClr val="tx1"/>
+                      </a:solidFill>
+                      <a:prstDash val="solid"/>
+                      <a:round/>
+                      <a:headEnd type="none" w="med" len="med"/>
+                      <a:tailEnd type="none" w="med" len="med"/>
+                    </a:lnT>
+                    <a:lnB w="6350" cap="flat" cmpd="sng" algn="ctr">
+                      <a:solidFill>
+                        <a:schemeClr val="tx1"/>
+                      </a:solidFill>
+                      <a:prstDash val="solid"/>
+                      <a:round/>
+                      <a:headEnd type="none" w="med" len="med"/>
+                      <a:tailEnd type="none" w="med" len="med"/>
+                    </a:lnB>
+                  </a:tcPr>
+                </a:tc>
+                <a:tc>
+                  <a:txBody>
+                    <a:bodyPr/>
+                    <a:lstStyle/>
+                    <a:p>
+                      <a:r>
+                        <a:rPr lang="en-US" sz="1200" dirty="0">
+                          <a:latin typeface="Verdana Pro" panose="020B0604030504040204" pitchFamily="34" charset="0"/>
+                          <a:cs typeface="Courier New" panose="02070309020205020404" pitchFamily="49" charset="0"/>
+                        </a:rPr>
+                        <a:t>1385 atoms</a:t>
+                      </a:r>
+                    </a:p>
+                    <a:p>
+                      <a:r>
+                        <a:rPr lang="en-US" sz="1200" dirty="0">
+                          <a:latin typeface="Verdana Pro" panose="020B0604030504040204" pitchFamily="34" charset="0"/>
+                          <a:cs typeface="Courier New" panose="02070309020205020404" pitchFamily="49" charset="0"/>
+                        </a:rPr>
+                        <a:t>[73 AAs]</a:t>
+                      </a:r>
+                      <a:endParaRPr lang="en-CA" sz="1200" dirty="0">
+                        <a:latin typeface="Verdana Pro" panose="020B0604030504040204" pitchFamily="34" charset="0"/>
+                        <a:cs typeface="Courier New" panose="02070309020205020404" pitchFamily="49" charset="0"/>
+                      </a:endParaRPr>
+                    </a:p>
+                  </a:txBody>
+                  <a:tcPr>
+                    <a:lnL w="6350" cap="flat" cmpd="sng" algn="ctr">
+                      <a:solidFill>
+                        <a:schemeClr val="tx1"/>
+                      </a:solidFill>
+                      <a:prstDash val="solid"/>
+                      <a:round/>
+                      <a:headEnd type="none" w="med" len="med"/>
+                      <a:tailEnd type="none" w="med" len="med"/>
+                    </a:lnL>
+                    <a:lnR w="6350" cap="flat" cmpd="sng" algn="ctr">
+                      <a:solidFill>
+                        <a:schemeClr val="tx1"/>
+                      </a:solidFill>
+                      <a:prstDash val="solid"/>
+                      <a:round/>
+                      <a:headEnd type="none" w="med" len="med"/>
+                      <a:tailEnd type="none" w="med" len="med"/>
+                    </a:lnR>
+                    <a:lnT w="6350" cap="flat" cmpd="sng" algn="ctr">
+                      <a:solidFill>
+                        <a:schemeClr val="tx1"/>
+                      </a:solidFill>
+                      <a:prstDash val="solid"/>
+                      <a:round/>
+                      <a:headEnd type="none" w="med" len="med"/>
+                      <a:tailEnd type="none" w="med" len="med"/>
+                    </a:lnT>
+                    <a:lnB w="6350" cap="flat" cmpd="sng" algn="ctr">
+                      <a:solidFill>
+                        <a:schemeClr val="tx1"/>
+                      </a:solidFill>
+                      <a:prstDash val="solid"/>
+                      <a:round/>
+                      <a:headEnd type="none" w="med" len="med"/>
+                      <a:tailEnd type="none" w="med" len="med"/>
+                    </a:lnB>
+                  </a:tcPr>
+                </a:tc>
+                <a:extLst>
+                  <a:ext uri="{0D108BD9-81ED-4DB2-BD59-A6C34878D82A}">
+                    <a16:rowId xmlns:a16="http://schemas.microsoft.com/office/drawing/2014/main" val="4069461568"/>
+                  </a:ext>
+                </a:extLst>
+              </a:tr>
+            </a:tbl>
+          </a:graphicData>
+        </a:graphic>
+      </p:graphicFrame>
+      <p:pic>
+        <p:nvPicPr>
+          <p:cNvPr id="3" name="Graphic 2">
+            <a:extLst>
+              <a:ext uri="{FF2B5EF4-FFF2-40B4-BE49-F238E27FC236}">
+                <a16:creationId xmlns:a16="http://schemas.microsoft.com/office/drawing/2014/main" id="{3D7881BF-EBA7-A1A0-8F19-0FD5880F2FAF}"/>
+              </a:ext>
+            </a:extLst>
+          </p:cNvPr>
+          <p:cNvPicPr>
+            <a:picLocks noChangeAspect="1"/>
+          </p:cNvPicPr>
+          <p:nvPr/>
+        </p:nvPicPr>
+        <p:blipFill>
+          <a:blip>
+            <a:extLst>
+              <a:ext uri="{96DAC541-7B7A-43D3-8B79-37D633B846F1}">
+                <asvg:svgBlip xmlns:asvg="http://schemas.microsoft.com/office/drawing/2016/SVG/main" r:embed="rId4"/>
+              </a:ext>
+            </a:extLst>
+          </a:blip>
+          <a:srcRect t="10849" r="8850"/>
+          <a:stretch>
+            <a:fillRect/>
+          </a:stretch>
+        </p:blipFill>
+        <p:spPr>
+          <a:xfrm>
+            <a:off x="219800" y="483593"/>
+            <a:ext cx="3011454" cy="2945407"/>
+          </a:xfrm>
+          <a:prstGeom prst="rect">
+            <a:avLst/>
+          </a:prstGeom>
+        </p:spPr>
+      </p:pic>
+      <p:sp>
+        <p:nvSpPr>
+          <p:cNvPr id="26" name="Rectangle 25">
+            <a:extLst>
+              <a:ext uri="{FF2B5EF4-FFF2-40B4-BE49-F238E27FC236}">
+                <a16:creationId xmlns:a16="http://schemas.microsoft.com/office/drawing/2014/main" id="{5DBEF63E-33ED-8D98-5B30-F4F5C5956DEA}"/>
+              </a:ext>
+            </a:extLst>
+          </p:cNvPr>
+          <p:cNvSpPr/>
+          <p:nvPr/>
+        </p:nvSpPr>
+        <p:spPr>
+          <a:xfrm>
+            <a:off x="1860550" y="759356"/>
+            <a:ext cx="158750" cy="93382"/>
+          </a:xfrm>
+          <a:prstGeom prst="rect">
+            <a:avLst/>
+          </a:prstGeom>
+          <a:noFill/>
+          <a:ln>
+            <a:solidFill>
+              <a:srgbClr val="FF0000"/>
+            </a:solidFill>
+          </a:ln>
+        </p:spPr>
+        <p:style>
+          <a:lnRef idx="2">
+            <a:schemeClr val="accent1">
+              <a:shade val="15000"/>
+            </a:schemeClr>
+          </a:lnRef>
+          <a:fillRef idx="1">
+            <a:schemeClr val="accent1"/>
+          </a:fillRef>
+          <a:effectRef idx="0">
+            <a:schemeClr val="accent1"/>
+          </a:effectRef>
+          <a:fontRef idx="minor">
+            <a:schemeClr val="lt1"/>
+          </a:fontRef>
+        </p:style>
+        <p:txBody>
+          <a:bodyPr rtlCol="0" anchor="ctr"/>
+          <a:lstStyle/>
+          <a:p>
+            <a:pPr algn="ctr"/>
+            <a:endParaRPr lang="en-CA"/>
+          </a:p>
+        </p:txBody>
+      </p:sp>
+      <p:pic>
+        <p:nvPicPr>
+          <p:cNvPr id="8" name="Picture 7">
+            <a:extLst>
+              <a:ext uri="{FF2B5EF4-FFF2-40B4-BE49-F238E27FC236}">
+                <a16:creationId xmlns:a16="http://schemas.microsoft.com/office/drawing/2014/main" id="{88E56A6B-1F75-72CB-CF5D-77E89748A917}"/>
+              </a:ext>
+            </a:extLst>
+          </p:cNvPr>
+          <p:cNvPicPr>
+            <a:picLocks noChangeAspect="1"/>
+          </p:cNvPicPr>
+          <p:nvPr/>
+        </p:nvPicPr>
+        <p:blipFill>
+          <a:blip r:embed="rId5"/>
+          <a:stretch>
+            <a:fillRect/>
+          </a:stretch>
+        </p:blipFill>
+        <p:spPr>
+          <a:xfrm>
+            <a:off x="3540154" y="505185"/>
+            <a:ext cx="5173131" cy="4235970"/>
+          </a:xfrm>
+          <a:prstGeom prst="rect">
+            <a:avLst/>
+          </a:prstGeom>
+        </p:spPr>
+      </p:pic>
+      <p:sp>
+        <p:nvSpPr>
+          <p:cNvPr id="30" name="TextBox 29">
+            <a:extLst>
+              <a:ext uri="{FF2B5EF4-FFF2-40B4-BE49-F238E27FC236}">
+                <a16:creationId xmlns:a16="http://schemas.microsoft.com/office/drawing/2014/main" id="{815541B2-51F2-28FA-A2E0-CE5A70B2B1C1}"/>
+              </a:ext>
+            </a:extLst>
+          </p:cNvPr>
+          <p:cNvSpPr txBox="1"/>
+          <p:nvPr/>
+        </p:nvSpPr>
+        <p:spPr>
+          <a:xfrm>
+            <a:off x="8769613" y="6248589"/>
+            <a:ext cx="1796787" cy="246221"/>
+          </a:xfrm>
+          <a:prstGeom prst="rect">
+            <a:avLst/>
+          </a:prstGeom>
+          <a:noFill/>
+        </p:spPr>
+        <p:txBody>
+          <a:bodyPr wrap="square" rtlCol="0">
+            <a:spAutoFit/>
+          </a:bodyPr>
+          <a:lstStyle/>
+          <a:p>
+            <a:r>
+              <a:rPr lang="en-US" sz="1000" dirty="0">
+                <a:latin typeface="Courier New" panose="02070309020205020404" pitchFamily="49" charset="0"/>
+                <a:cs typeface="Courier New" panose="02070309020205020404" pitchFamily="49" charset="0"/>
+              </a:rPr>
+              <a:t>X-ray cryst. [PDB]</a:t>
+            </a:r>
+            <a:endParaRPr lang="en-CA" sz="1000" dirty="0">
+              <a:latin typeface="Courier New" panose="02070309020205020404" pitchFamily="49" charset="0"/>
+              <a:cs typeface="Courier New" panose="02070309020205020404" pitchFamily="49" charset="0"/>
+            </a:endParaRPr>
+          </a:p>
+        </p:txBody>
+      </p:sp>
+    </p:spTree>
+    <p:extLst>
+      <p:ext uri="{BB962C8B-B14F-4D97-AF65-F5344CB8AC3E}">
+        <p14:creationId xmlns:p14="http://schemas.microsoft.com/office/powerpoint/2010/main" val="3241318112"/>
+      </p:ext>
+    </p:extLst>
+  </p:cSld>
+  <p:clrMapOvr>
+    <a:masterClrMapping/>
+  </p:clrMapOvr>
+</p:sld>
+</file>
+
+<file path=ppt/slides/slide15.xml><?xml version="1.0" encoding="utf-8"?>
+<p:sld xmlns:a="http://schemas.openxmlformats.org/drawingml/2006/main" xmlns:r="http://schemas.openxmlformats.org/officeDocument/2006/relationships" xmlns:p="http://schemas.openxmlformats.org/presentationml/2006/main">
+  <p:cSld>
+    <p:spTree>
+      <p:nvGrpSpPr>
+        <p:cNvPr id="1" name="">
+          <a:extLst>
+            <a:ext uri="{FF2B5EF4-FFF2-40B4-BE49-F238E27FC236}">
+              <a16:creationId xmlns:a16="http://schemas.microsoft.com/office/drawing/2014/main" id="{5F852B96-FB69-526B-80F1-486BE5154496}"/>
+            </a:ext>
+          </a:extLst>
+        </p:cNvPr>
+        <p:cNvGrpSpPr/>
+        <p:nvPr/>
+      </p:nvGrpSpPr>
+      <p:grpSpPr>
+        <a:xfrm>
+          <a:off x="0" y="0"/>
+          <a:ext cx="0" cy="0"/>
+          <a:chOff x="0" y="0"/>
+          <a:chExt cx="0" cy="0"/>
+        </a:xfrm>
+      </p:grpSpPr>
+      <p:pic>
+        <p:nvPicPr>
+          <p:cNvPr id="9" name="Picture 8">
+            <a:extLst>
+              <a:ext uri="{FF2B5EF4-FFF2-40B4-BE49-F238E27FC236}">
+                <a16:creationId xmlns:a16="http://schemas.microsoft.com/office/drawing/2014/main" id="{0A7EA34A-389B-294B-1509-395D7C80363C}"/>
+              </a:ext>
+            </a:extLst>
+          </p:cNvPr>
+          <p:cNvPicPr>
+            <a:picLocks noChangeAspect="1"/>
+          </p:cNvPicPr>
+          <p:nvPr/>
+        </p:nvPicPr>
+        <p:blipFill>
+          <a:blip r:embed="rId2"/>
+          <a:srcRect l="4961" r="6923"/>
+          <a:stretch>
+            <a:fillRect/>
+          </a:stretch>
+        </p:blipFill>
+        <p:spPr>
+          <a:xfrm>
+            <a:off x="9396646" y="522917"/>
+            <a:ext cx="2216709" cy="4208488"/>
+          </a:xfrm>
+          <a:prstGeom prst="rect">
+            <a:avLst/>
+          </a:prstGeom>
+        </p:spPr>
+      </p:pic>
+      <p:pic>
+        <p:nvPicPr>
+          <p:cNvPr id="4" name="Picture 3">
+            <a:extLst>
+              <a:ext uri="{FF2B5EF4-FFF2-40B4-BE49-F238E27FC236}">
+                <a16:creationId xmlns:a16="http://schemas.microsoft.com/office/drawing/2014/main" id="{98002850-0030-6EF1-A0D7-7E47C33C2AD5}"/>
+              </a:ext>
+            </a:extLst>
+          </p:cNvPr>
+          <p:cNvPicPr>
+            <a:picLocks noChangeAspect="1"/>
+          </p:cNvPicPr>
+          <p:nvPr/>
+        </p:nvPicPr>
+        <p:blipFill>
+          <a:blip r:embed="rId3"/>
+          <a:srcRect l="6805" r="7569"/>
+          <a:stretch>
+            <a:fillRect/>
+          </a:stretch>
+        </p:blipFill>
+        <p:spPr>
+          <a:xfrm>
+            <a:off x="6764284" y="522917"/>
+            <a:ext cx="2632363" cy="4208488"/>
+          </a:xfrm>
+          <a:prstGeom prst="rect">
+            <a:avLst/>
+          </a:prstGeom>
+        </p:spPr>
+      </p:pic>
+      <p:sp>
+        <p:nvSpPr>
+          <p:cNvPr id="17" name="Rectangle 16">
+            <a:extLst>
+              <a:ext uri="{FF2B5EF4-FFF2-40B4-BE49-F238E27FC236}">
+                <a16:creationId xmlns:a16="http://schemas.microsoft.com/office/drawing/2014/main" id="{527B76DD-E0D2-F564-E423-3A77E5A1E798}"/>
+              </a:ext>
+            </a:extLst>
+          </p:cNvPr>
+          <p:cNvSpPr/>
+          <p:nvPr/>
+        </p:nvSpPr>
+        <p:spPr>
+          <a:xfrm>
+            <a:off x="3540154" y="4761874"/>
+            <a:ext cx="5156171" cy="845389"/>
+          </a:xfrm>
+          <a:prstGeom prst="rect">
+            <a:avLst/>
+          </a:prstGeom>
+          <a:noFill/>
+          <a:ln w="6350">
+            <a:solidFill>
+              <a:srgbClr val="0000FF"/>
+            </a:solidFill>
+          </a:ln>
+        </p:spPr>
+        <p:style>
+          <a:lnRef idx="2">
+            <a:schemeClr val="accent1">
+              <a:shade val="15000"/>
+            </a:schemeClr>
+          </a:lnRef>
+          <a:fillRef idx="1">
+            <a:schemeClr val="accent1"/>
+          </a:fillRef>
+          <a:effectRef idx="0">
+            <a:schemeClr val="accent1"/>
+          </a:effectRef>
+          <a:fontRef idx="minor">
+            <a:schemeClr val="lt1"/>
+          </a:fontRef>
+        </p:style>
+        <p:txBody>
+          <a:bodyPr rtlCol="0" anchor="ctr"/>
+          <a:lstStyle/>
+          <a:p>
+            <a:pPr algn="ctr"/>
+            <a:endParaRPr lang="en-CA"/>
+          </a:p>
+        </p:txBody>
+      </p:sp>
+      <p:sp>
+        <p:nvSpPr>
+          <p:cNvPr id="15" name="TextBox 14">
+            <a:extLst>
+              <a:ext uri="{FF2B5EF4-FFF2-40B4-BE49-F238E27FC236}">
+                <a16:creationId xmlns:a16="http://schemas.microsoft.com/office/drawing/2014/main" id="{0D1D4D55-792F-E6CB-7F48-9704C1D9C701}"/>
+              </a:ext>
+            </a:extLst>
+          </p:cNvPr>
+          <p:cNvSpPr txBox="1"/>
+          <p:nvPr/>
+        </p:nvSpPr>
+        <p:spPr>
+          <a:xfrm>
+            <a:off x="3590957" y="4757111"/>
+            <a:ext cx="4781518" cy="307777"/>
+          </a:xfrm>
+          <a:prstGeom prst="rect">
+            <a:avLst/>
+          </a:prstGeom>
+          <a:noFill/>
+        </p:spPr>
+        <p:txBody>
+          <a:bodyPr wrap="square" rtlCol="0">
+            <a:spAutoFit/>
+          </a:bodyPr>
+          <a:lstStyle/>
+          <a:p>
+            <a:r>
+              <a:rPr lang="en-US" sz="1400" dirty="0">
+                <a:solidFill>
+                  <a:srgbClr val="0000FF"/>
+                </a:solidFill>
+                <a:latin typeface="Verdana Pro" panose="020B0604030504040204" pitchFamily="34" charset="0"/>
+              </a:rPr>
+              <a:t>J8G6Z1 [B. cereus][thsA]</a:t>
+            </a:r>
+            <a:endParaRPr lang="en-CA" sz="1400" dirty="0">
+              <a:solidFill>
+                <a:srgbClr val="0000FF"/>
+              </a:solidFill>
+              <a:latin typeface="Verdana Pro" panose="020B0604030504040204" pitchFamily="34" charset="0"/>
+            </a:endParaRPr>
+          </a:p>
+        </p:txBody>
+      </p:sp>
+      <p:sp>
+        <p:nvSpPr>
+          <p:cNvPr id="16" name="TextBox 15">
+            <a:extLst>
+              <a:ext uri="{FF2B5EF4-FFF2-40B4-BE49-F238E27FC236}">
+                <a16:creationId xmlns:a16="http://schemas.microsoft.com/office/drawing/2014/main" id="{7D300AA5-4C4C-00DF-4E9A-AAF9B5650E0D}"/>
+              </a:ext>
+            </a:extLst>
+          </p:cNvPr>
+          <p:cNvSpPr txBox="1"/>
+          <p:nvPr/>
+        </p:nvSpPr>
+        <p:spPr>
+          <a:xfrm>
+            <a:off x="3590957" y="5644540"/>
+            <a:ext cx="3314668" cy="307777"/>
+          </a:xfrm>
+          <a:prstGeom prst="rect">
+            <a:avLst/>
+          </a:prstGeom>
+          <a:noFill/>
+        </p:spPr>
+        <p:txBody>
+          <a:bodyPr wrap="square" rtlCol="0">
+            <a:spAutoFit/>
+          </a:bodyPr>
+          <a:lstStyle/>
+          <a:p>
+            <a:r>
+              <a:rPr lang="en-US" sz="1400" dirty="0">
+                <a:solidFill>
+                  <a:srgbClr val="FF0000"/>
+                </a:solidFill>
+                <a:latin typeface="Verdana Pro" panose="020B0604030504040204" pitchFamily="34" charset="0"/>
+              </a:rPr>
+              <a:t>Q9BPY3 [H. sapiens][FAM118B]</a:t>
+            </a:r>
+            <a:endParaRPr lang="en-CA" sz="1400" dirty="0">
+              <a:solidFill>
+                <a:srgbClr val="FF0000"/>
+              </a:solidFill>
+              <a:latin typeface="Verdana Pro" panose="020B0604030504040204" pitchFamily="34" charset="0"/>
+            </a:endParaRPr>
+          </a:p>
+        </p:txBody>
+      </p:sp>
+      <p:sp>
+        <p:nvSpPr>
+          <p:cNvPr id="18" name="Rectangle 17">
+            <a:extLst>
+              <a:ext uri="{FF2B5EF4-FFF2-40B4-BE49-F238E27FC236}">
+                <a16:creationId xmlns:a16="http://schemas.microsoft.com/office/drawing/2014/main" id="{99E8BE26-53CA-8612-2BF2-34D7549440C7}"/>
+              </a:ext>
+            </a:extLst>
+          </p:cNvPr>
+          <p:cNvSpPr/>
+          <p:nvPr/>
+        </p:nvSpPr>
+        <p:spPr>
+          <a:xfrm>
+            <a:off x="3540154" y="5619753"/>
+            <a:ext cx="5156172" cy="845389"/>
+          </a:xfrm>
+          <a:prstGeom prst="rect">
+            <a:avLst/>
+          </a:prstGeom>
+          <a:noFill/>
+          <a:ln w="6350">
+            <a:solidFill>
+              <a:srgbClr val="FF0000"/>
+            </a:solidFill>
+          </a:ln>
+        </p:spPr>
+        <p:style>
+          <a:lnRef idx="2">
+            <a:schemeClr val="accent1">
+              <a:shade val="15000"/>
+            </a:schemeClr>
+          </a:lnRef>
+          <a:fillRef idx="1">
+            <a:schemeClr val="accent1"/>
+          </a:fillRef>
+          <a:effectRef idx="0">
+            <a:schemeClr val="accent1"/>
+          </a:effectRef>
+          <a:fontRef idx="minor">
+            <a:schemeClr val="lt1"/>
+          </a:fontRef>
+        </p:style>
+        <p:txBody>
+          <a:bodyPr rtlCol="0" anchor="ctr"/>
+          <a:lstStyle/>
+          <a:p>
+            <a:pPr algn="ctr"/>
+            <a:endParaRPr lang="en-CA">
+              <a:solidFill>
+                <a:srgbClr val="FF0000"/>
+              </a:solidFill>
+            </a:endParaRPr>
+          </a:p>
+        </p:txBody>
+      </p:sp>
+      <p:sp>
+        <p:nvSpPr>
+          <p:cNvPr id="21" name="TextBox 20">
+            <a:extLst>
+              <a:ext uri="{FF2B5EF4-FFF2-40B4-BE49-F238E27FC236}">
+                <a16:creationId xmlns:a16="http://schemas.microsoft.com/office/drawing/2014/main" id="{AB15CA2F-4F07-6703-1917-EF06DBBCDC7C}"/>
+              </a:ext>
+            </a:extLst>
+          </p:cNvPr>
+          <p:cNvSpPr txBox="1"/>
+          <p:nvPr/>
+        </p:nvSpPr>
+        <p:spPr>
+          <a:xfrm>
+            <a:off x="6869891" y="526109"/>
+            <a:ext cx="2421147" cy="307777"/>
+          </a:xfrm>
+          <a:prstGeom prst="rect">
+            <a:avLst/>
+          </a:prstGeom>
+          <a:noFill/>
+        </p:spPr>
+        <p:txBody>
+          <a:bodyPr wrap="square" rtlCol="0">
+            <a:spAutoFit/>
+          </a:bodyPr>
+          <a:lstStyle/>
+          <a:p>
+            <a:pPr algn="r"/>
+            <a:r>
+              <a:rPr lang="en-US" sz="1400" dirty="0">
+                <a:solidFill>
+                  <a:srgbClr val="0000FF"/>
+                </a:solidFill>
+                <a:latin typeface="Verdana Pro" panose="020B0604030504040204" pitchFamily="34" charset="0"/>
+              </a:rPr>
+              <a:t>J8G6Z1</a:t>
+            </a:r>
+            <a:endParaRPr lang="en-CA" sz="1400" dirty="0">
+              <a:solidFill>
+                <a:srgbClr val="0000FF"/>
+              </a:solidFill>
+              <a:latin typeface="Verdana Pro" panose="020B0604030504040204" pitchFamily="34" charset="0"/>
+            </a:endParaRPr>
+          </a:p>
+        </p:txBody>
+      </p:sp>
+      <p:sp>
+        <p:nvSpPr>
+          <p:cNvPr id="22" name="TextBox 21">
+            <a:extLst>
+              <a:ext uri="{FF2B5EF4-FFF2-40B4-BE49-F238E27FC236}">
+                <a16:creationId xmlns:a16="http://schemas.microsoft.com/office/drawing/2014/main" id="{11696AAF-EF99-A7A2-3A32-7483C0EF0E63}"/>
+              </a:ext>
+            </a:extLst>
+          </p:cNvPr>
+          <p:cNvSpPr txBox="1"/>
+          <p:nvPr/>
+        </p:nvSpPr>
+        <p:spPr>
+          <a:xfrm>
+            <a:off x="3590958" y="4973886"/>
+            <a:ext cx="5107802" cy="461665"/>
+          </a:xfrm>
+          <a:prstGeom prst="rect">
+            <a:avLst/>
+          </a:prstGeom>
+          <a:noFill/>
+        </p:spPr>
+        <p:txBody>
+          <a:bodyPr wrap="square" rtlCol="0">
+            <a:spAutoFit/>
+          </a:bodyPr>
+          <a:lstStyle/>
+          <a:p>
+            <a:pPr marL="171450" indent="-171450">
+              <a:buFont typeface="Arial" panose="020B0604020202020204" pitchFamily="34" charset="0"/>
+              <a:buChar char="•"/>
+            </a:pPr>
+            <a:r>
+              <a:rPr lang="en-US" sz="1200" dirty="0">
+                <a:solidFill>
+                  <a:srgbClr val="0000FF"/>
+                </a:solidFill>
+                <a:latin typeface="Courier New" panose="02070309020205020404" pitchFamily="49" charset="0"/>
+                <a:cs typeface="Courier New" panose="02070309020205020404" pitchFamily="49" charset="0"/>
+              </a:rPr>
+              <a:t>NAD+ hydrolyzing component (NADase) of Thoeris antiviral defense system</a:t>
+            </a:r>
+            <a:endParaRPr lang="en-CA" sz="1200" dirty="0">
+              <a:solidFill>
+                <a:srgbClr val="0000FF"/>
+              </a:solidFill>
+              <a:latin typeface="Courier New" panose="02070309020205020404" pitchFamily="49" charset="0"/>
+              <a:cs typeface="Courier New" panose="02070309020205020404" pitchFamily="49" charset="0"/>
+            </a:endParaRPr>
+          </a:p>
+        </p:txBody>
+      </p:sp>
+      <p:sp>
+        <p:nvSpPr>
+          <p:cNvPr id="24" name="TextBox 23">
+            <a:extLst>
+              <a:ext uri="{FF2B5EF4-FFF2-40B4-BE49-F238E27FC236}">
+                <a16:creationId xmlns:a16="http://schemas.microsoft.com/office/drawing/2014/main" id="{999CF23C-ACC0-0A61-1F9A-D137D7927C64}"/>
+              </a:ext>
+            </a:extLst>
+          </p:cNvPr>
+          <p:cNvSpPr txBox="1"/>
+          <p:nvPr/>
+        </p:nvSpPr>
+        <p:spPr>
+          <a:xfrm>
+            <a:off x="3548781" y="5879282"/>
+            <a:ext cx="4982744" cy="276999"/>
+          </a:xfrm>
+          <a:prstGeom prst="rect">
+            <a:avLst/>
+          </a:prstGeom>
+          <a:noFill/>
+        </p:spPr>
+        <p:txBody>
+          <a:bodyPr wrap="square" rtlCol="0">
+            <a:spAutoFit/>
+          </a:bodyPr>
+          <a:lstStyle/>
+          <a:p>
+            <a:pPr marL="171450" indent="-171450">
+              <a:buFont typeface="Arial" panose="020B0604020202020204" pitchFamily="34" charset="0"/>
+              <a:buChar char="•"/>
+            </a:pPr>
+            <a:r>
+              <a:rPr lang="en-US" sz="1200" dirty="0">
+                <a:solidFill>
+                  <a:srgbClr val="FF0000"/>
+                </a:solidFill>
+                <a:latin typeface="Courier New" panose="02070309020205020404" pitchFamily="49" charset="0"/>
+                <a:cs typeface="Courier New" panose="02070309020205020404" pitchFamily="49" charset="0"/>
+              </a:rPr>
+              <a:t>Cajal body regulation</a:t>
+            </a:r>
+            <a:endParaRPr lang="en-CA" sz="1200" dirty="0">
+              <a:solidFill>
+                <a:srgbClr val="FF0000"/>
+              </a:solidFill>
+              <a:latin typeface="Courier New" panose="02070309020205020404" pitchFamily="49" charset="0"/>
+              <a:cs typeface="Courier New" panose="02070309020205020404" pitchFamily="49" charset="0"/>
+            </a:endParaRPr>
+          </a:p>
+        </p:txBody>
+      </p:sp>
+      <p:sp>
+        <p:nvSpPr>
+          <p:cNvPr id="28" name="TextBox 27">
+            <a:extLst>
+              <a:ext uri="{FF2B5EF4-FFF2-40B4-BE49-F238E27FC236}">
+                <a16:creationId xmlns:a16="http://schemas.microsoft.com/office/drawing/2014/main" id="{297BDDA1-243D-C75E-752F-BCD63BCB3EF9}"/>
+              </a:ext>
+            </a:extLst>
+          </p:cNvPr>
+          <p:cNvSpPr txBox="1"/>
+          <p:nvPr/>
+        </p:nvSpPr>
+        <p:spPr>
+          <a:xfrm>
+            <a:off x="9192208" y="517361"/>
+            <a:ext cx="2421147" cy="307777"/>
+          </a:xfrm>
+          <a:prstGeom prst="rect">
+            <a:avLst/>
+          </a:prstGeom>
+          <a:noFill/>
+        </p:spPr>
+        <p:txBody>
+          <a:bodyPr wrap="square" rtlCol="0">
+            <a:spAutoFit/>
+          </a:bodyPr>
+          <a:lstStyle/>
+          <a:p>
+            <a:pPr algn="r"/>
+            <a:r>
+              <a:rPr lang="en-US" sz="1400" dirty="0">
+                <a:solidFill>
+                  <a:srgbClr val="FF0000"/>
+                </a:solidFill>
+                <a:latin typeface="Verdana Pro" panose="020B0604030504040204" pitchFamily="34" charset="0"/>
+              </a:rPr>
+              <a:t>Q9BPY3</a:t>
+            </a:r>
+            <a:endParaRPr lang="en-CA" sz="1400" dirty="0">
+              <a:solidFill>
+                <a:srgbClr val="FF0000"/>
+              </a:solidFill>
+              <a:latin typeface="Verdana Pro" panose="020B0604030504040204" pitchFamily="34" charset="0"/>
+            </a:endParaRPr>
+          </a:p>
+        </p:txBody>
+      </p:sp>
+      <p:graphicFrame>
+        <p:nvGraphicFramePr>
+          <p:cNvPr id="29" name="Table 28">
+            <a:extLst>
+              <a:ext uri="{FF2B5EF4-FFF2-40B4-BE49-F238E27FC236}">
+                <a16:creationId xmlns:a16="http://schemas.microsoft.com/office/drawing/2014/main" id="{57BD3758-FFC0-88EE-19AE-21535738F4FC}"/>
+              </a:ext>
+            </a:extLst>
+          </p:cNvPr>
+          <p:cNvGraphicFramePr>
+            <a:graphicFrameLocks noGrp="1"/>
+          </p:cNvGraphicFramePr>
+          <p:nvPr>
+            <p:extLst>
+              <p:ext uri="{D42A27DB-BD31-4B8C-83A1-F6EECF244321}">
+                <p14:modId xmlns:p14="http://schemas.microsoft.com/office/powerpoint/2010/main" val="2977545053"/>
+              </p:ext>
+            </p:extLst>
+          </p:nvPr>
+        </p:nvGraphicFramePr>
+        <p:xfrm>
+          <a:off x="411929" y="3828403"/>
+          <a:ext cx="2782890" cy="1005840"/>
+        </p:xfrm>
+        <a:graphic>
+          <a:graphicData uri="http://schemas.openxmlformats.org/drawingml/2006/table">
+            <a:tbl>
+              <a:tblPr firstRow="1" bandRow="1">
+                <a:tableStyleId>{5940675A-B579-460E-94D1-54222C63F5DA}</a:tableStyleId>
+              </a:tblPr>
+              <a:tblGrid>
+                <a:gridCol w="1158079">
+                  <a:extLst>
+                    <a:ext uri="{9D8B030D-6E8A-4147-A177-3AD203B41FA5}">
+                      <a16:colId xmlns:a16="http://schemas.microsoft.com/office/drawing/2014/main" val="1461492322"/>
+                    </a:ext>
+                  </a:extLst>
+                </a:gridCol>
+                <a:gridCol w="1624811">
+                  <a:extLst>
+                    <a:ext uri="{9D8B030D-6E8A-4147-A177-3AD203B41FA5}">
+                      <a16:colId xmlns:a16="http://schemas.microsoft.com/office/drawing/2014/main" val="3072927139"/>
+                    </a:ext>
+                  </a:extLst>
+                </a:gridCol>
+              </a:tblGrid>
+              <a:tr h="204265">
+                <a:tc>
+                  <a:txBody>
+                    <a:bodyPr/>
+                    <a:lstStyle/>
+                    <a:p>
+                      <a:r>
+                        <a:rPr lang="en-US" sz="1200" dirty="0">
+                          <a:latin typeface="Verdana Pro" panose="020B0604030504040204" pitchFamily="34" charset="0"/>
+                        </a:rPr>
+                        <a:t>System</a:t>
+                      </a:r>
+                      <a:endParaRPr lang="en-CA" sz="1200" dirty="0">
+                        <a:latin typeface="Verdana Pro" panose="020B0604030504040204" pitchFamily="34" charset="0"/>
+                      </a:endParaRPr>
+                    </a:p>
+                  </a:txBody>
+                  <a:tcPr>
+                    <a:lnL w="6350" cap="flat" cmpd="sng" algn="ctr">
+                      <a:solidFill>
+                        <a:schemeClr val="tx1"/>
+                      </a:solidFill>
+                      <a:prstDash val="solid"/>
+                      <a:round/>
+                      <a:headEnd type="none" w="med" len="med"/>
+                      <a:tailEnd type="none" w="med" len="med"/>
+                    </a:lnL>
+                    <a:lnR w="6350" cap="flat" cmpd="sng" algn="ctr">
+                      <a:solidFill>
+                        <a:schemeClr val="tx1"/>
+                      </a:solidFill>
+                      <a:prstDash val="solid"/>
+                      <a:round/>
+                      <a:headEnd type="none" w="med" len="med"/>
+                      <a:tailEnd type="none" w="med" len="med"/>
+                    </a:lnR>
+                    <a:lnT w="6350" cap="flat" cmpd="sng" algn="ctr">
+                      <a:solidFill>
+                        <a:schemeClr val="tx1"/>
+                      </a:solidFill>
+                      <a:prstDash val="solid"/>
+                      <a:round/>
+                      <a:headEnd type="none" w="med" len="med"/>
+                      <a:tailEnd type="none" w="med" len="med"/>
+                    </a:lnT>
+                    <a:lnB w="6350" cap="flat" cmpd="sng" algn="ctr">
+                      <a:solidFill>
+                        <a:schemeClr val="tx1"/>
+                      </a:solidFill>
+                      <a:prstDash val="solid"/>
+                      <a:round/>
+                      <a:headEnd type="none" w="med" len="med"/>
+                      <a:tailEnd type="none" w="med" len="med"/>
+                    </a:lnB>
+                  </a:tcPr>
+                </a:tc>
+                <a:tc>
+                  <a:txBody>
+                    <a:bodyPr/>
+                    <a:lstStyle/>
+                    <a:p>
+                      <a:r>
+                        <a:rPr lang="en-US" sz="1200" dirty="0">
+                          <a:latin typeface="Verdana Pro" panose="020B0604030504040204" pitchFamily="34" charset="0"/>
+                          <a:cs typeface="Courier New" panose="02070309020205020404" pitchFamily="49" charset="0"/>
+                        </a:rPr>
+                        <a:t>SIR2 antiphage</a:t>
+                      </a:r>
+                      <a:endParaRPr lang="en-CA" sz="1200" dirty="0">
+                        <a:latin typeface="Verdana Pro" panose="020B0604030504040204" pitchFamily="34" charset="0"/>
+                        <a:cs typeface="Courier New" panose="02070309020205020404" pitchFamily="49" charset="0"/>
+                      </a:endParaRPr>
+                    </a:p>
+                  </a:txBody>
+                  <a:tcPr>
+                    <a:lnL w="6350" cap="flat" cmpd="sng" algn="ctr">
+                      <a:solidFill>
+                        <a:schemeClr val="tx1"/>
+                      </a:solidFill>
+                      <a:prstDash val="solid"/>
+                      <a:round/>
+                      <a:headEnd type="none" w="med" len="med"/>
+                      <a:tailEnd type="none" w="med" len="med"/>
+                    </a:lnL>
+                    <a:lnR w="6350" cap="flat" cmpd="sng" algn="ctr">
+                      <a:solidFill>
+                        <a:schemeClr val="tx1"/>
+                      </a:solidFill>
+                      <a:prstDash val="solid"/>
+                      <a:round/>
+                      <a:headEnd type="none" w="med" len="med"/>
+                      <a:tailEnd type="none" w="med" len="med"/>
+                    </a:lnR>
+                    <a:lnT w="6350" cap="flat" cmpd="sng" algn="ctr">
+                      <a:solidFill>
+                        <a:schemeClr val="tx1"/>
+                      </a:solidFill>
+                      <a:prstDash val="solid"/>
+                      <a:round/>
+                      <a:headEnd type="none" w="med" len="med"/>
+                      <a:tailEnd type="none" w="med" len="med"/>
+                    </a:lnT>
+                    <a:lnB w="6350" cap="flat" cmpd="sng" algn="ctr">
+                      <a:solidFill>
+                        <a:schemeClr val="tx1"/>
+                      </a:solidFill>
+                      <a:prstDash val="solid"/>
+                      <a:round/>
+                      <a:headEnd type="none" w="med" len="med"/>
+                      <a:tailEnd type="none" w="med" len="med"/>
+                    </a:lnB>
+                  </a:tcPr>
+                </a:tc>
+                <a:extLst>
+                  <a:ext uri="{0D108BD9-81ED-4DB2-BD59-A6C34878D82A}">
+                    <a16:rowId xmlns:a16="http://schemas.microsoft.com/office/drawing/2014/main" val="1515812024"/>
+                  </a:ext>
+                </a:extLst>
+              </a:tr>
+              <a:tr h="204265">
+                <a:tc>
+                  <a:txBody>
+                    <a:bodyPr/>
+                    <a:lstStyle/>
+                    <a:p>
+                      <a:r>
+                        <a:rPr lang="en-US" sz="1200" dirty="0">
+                          <a:latin typeface="Verdana Pro" panose="020B0604030504040204" pitchFamily="34" charset="0"/>
+                        </a:rPr>
+                        <a:t>PyMol RMSD</a:t>
+                      </a:r>
+                      <a:endParaRPr lang="en-CA" sz="1200" dirty="0">
+                        <a:latin typeface="Verdana Pro" panose="020B0604030504040204" pitchFamily="34" charset="0"/>
+                      </a:endParaRPr>
+                    </a:p>
+                  </a:txBody>
+                  <a:tcPr>
+                    <a:lnL w="6350" cap="flat" cmpd="sng" algn="ctr">
+                      <a:solidFill>
+                        <a:schemeClr val="tx1"/>
+                      </a:solidFill>
+                      <a:prstDash val="solid"/>
+                      <a:round/>
+                      <a:headEnd type="none" w="med" len="med"/>
+                      <a:tailEnd type="none" w="med" len="med"/>
+                    </a:lnL>
+                    <a:lnR w="6350" cap="flat" cmpd="sng" algn="ctr">
+                      <a:solidFill>
+                        <a:schemeClr val="tx1"/>
+                      </a:solidFill>
+                      <a:prstDash val="solid"/>
+                      <a:round/>
+                      <a:headEnd type="none" w="med" len="med"/>
+                      <a:tailEnd type="none" w="med" len="med"/>
+                    </a:lnR>
+                    <a:lnT w="6350" cap="flat" cmpd="sng" algn="ctr">
+                      <a:solidFill>
+                        <a:schemeClr val="tx1"/>
+                      </a:solidFill>
+                      <a:prstDash val="solid"/>
+                      <a:round/>
+                      <a:headEnd type="none" w="med" len="med"/>
+                      <a:tailEnd type="none" w="med" len="med"/>
+                    </a:lnT>
+                    <a:lnB w="6350" cap="flat" cmpd="sng" algn="ctr">
+                      <a:solidFill>
+                        <a:schemeClr val="tx1"/>
+                      </a:solidFill>
+                      <a:prstDash val="solid"/>
+                      <a:round/>
+                      <a:headEnd type="none" w="med" len="med"/>
+                      <a:tailEnd type="none" w="med" len="med"/>
+                    </a:lnB>
+                  </a:tcPr>
+                </a:tc>
+                <a:tc>
+                  <a:txBody>
+                    <a:bodyPr/>
+                    <a:lstStyle/>
+                    <a:p>
+                      <a:r>
+                        <a:rPr lang="en-US" sz="1200" dirty="0">
+                          <a:latin typeface="Verdana Pro" panose="020B0604030504040204" pitchFamily="34" charset="0"/>
+                          <a:cs typeface="Courier New" panose="02070309020205020404" pitchFamily="49" charset="0"/>
+                        </a:rPr>
+                        <a:t>3.88 Å</a:t>
+                      </a:r>
+                      <a:endParaRPr lang="en-CA" sz="1200" dirty="0">
+                        <a:latin typeface="Verdana Pro" panose="020B0604030504040204" pitchFamily="34" charset="0"/>
+                        <a:cs typeface="Courier New" panose="02070309020205020404" pitchFamily="49" charset="0"/>
+                      </a:endParaRPr>
+                    </a:p>
+                  </a:txBody>
+                  <a:tcPr>
+                    <a:lnL w="6350" cap="flat" cmpd="sng" algn="ctr">
+                      <a:solidFill>
+                        <a:schemeClr val="tx1"/>
+                      </a:solidFill>
+                      <a:prstDash val="solid"/>
+                      <a:round/>
+                      <a:headEnd type="none" w="med" len="med"/>
+                      <a:tailEnd type="none" w="med" len="med"/>
+                    </a:lnL>
+                    <a:lnR w="6350" cap="flat" cmpd="sng" algn="ctr">
+                      <a:solidFill>
+                        <a:schemeClr val="tx1"/>
+                      </a:solidFill>
+                      <a:prstDash val="solid"/>
+                      <a:round/>
+                      <a:headEnd type="none" w="med" len="med"/>
+                      <a:tailEnd type="none" w="med" len="med"/>
+                    </a:lnR>
+                    <a:lnT w="6350" cap="flat" cmpd="sng" algn="ctr">
+                      <a:solidFill>
+                        <a:schemeClr val="tx1"/>
+                      </a:solidFill>
+                      <a:prstDash val="solid"/>
+                      <a:round/>
+                      <a:headEnd type="none" w="med" len="med"/>
+                      <a:tailEnd type="none" w="med" len="med"/>
+                    </a:lnT>
+                    <a:lnB w="6350" cap="flat" cmpd="sng" algn="ctr">
+                      <a:solidFill>
+                        <a:schemeClr val="tx1"/>
+                      </a:solidFill>
+                      <a:prstDash val="solid"/>
+                      <a:round/>
+                      <a:headEnd type="none" w="med" len="med"/>
+                      <a:tailEnd type="none" w="med" len="med"/>
+                    </a:lnB>
+                  </a:tcPr>
+                </a:tc>
+                <a:extLst>
+                  <a:ext uri="{0D108BD9-81ED-4DB2-BD59-A6C34878D82A}">
+                    <a16:rowId xmlns:a16="http://schemas.microsoft.com/office/drawing/2014/main" val="3727042579"/>
+                  </a:ext>
+                </a:extLst>
+              </a:tr>
+              <a:tr h="204265">
+                <a:tc>
+                  <a:txBody>
+                    <a:bodyPr/>
+                    <a:lstStyle/>
+                    <a:p>
+                      <a:r>
+                        <a:rPr lang="en-US" sz="1200" dirty="0">
+                          <a:latin typeface="Verdana Pro" panose="020B0604030504040204" pitchFamily="34" charset="0"/>
+                        </a:rPr>
+                        <a:t>Aln length</a:t>
+                      </a:r>
+                      <a:endParaRPr lang="en-CA" sz="1200" dirty="0">
+                        <a:latin typeface="Verdana Pro" panose="020B0604030504040204" pitchFamily="34" charset="0"/>
+                      </a:endParaRPr>
+                    </a:p>
+                  </a:txBody>
+                  <a:tcPr>
+                    <a:lnL w="6350" cap="flat" cmpd="sng" algn="ctr">
+                      <a:solidFill>
+                        <a:schemeClr val="tx1"/>
+                      </a:solidFill>
+                      <a:prstDash val="solid"/>
+                      <a:round/>
+                      <a:headEnd type="none" w="med" len="med"/>
+                      <a:tailEnd type="none" w="med" len="med"/>
+                    </a:lnL>
+                    <a:lnR w="6350" cap="flat" cmpd="sng" algn="ctr">
+                      <a:solidFill>
+                        <a:schemeClr val="tx1"/>
+                      </a:solidFill>
+                      <a:prstDash val="solid"/>
+                      <a:round/>
+                      <a:headEnd type="none" w="med" len="med"/>
+                      <a:tailEnd type="none" w="med" len="med"/>
+                    </a:lnR>
+                    <a:lnT w="6350" cap="flat" cmpd="sng" algn="ctr">
+                      <a:solidFill>
+                        <a:schemeClr val="tx1"/>
+                      </a:solidFill>
+                      <a:prstDash val="solid"/>
+                      <a:round/>
+                      <a:headEnd type="none" w="med" len="med"/>
+                      <a:tailEnd type="none" w="med" len="med"/>
+                    </a:lnT>
+                    <a:lnB w="6350" cap="flat" cmpd="sng" algn="ctr">
+                      <a:solidFill>
+                        <a:schemeClr val="tx1"/>
+                      </a:solidFill>
+                      <a:prstDash val="solid"/>
+                      <a:round/>
+                      <a:headEnd type="none" w="med" len="med"/>
+                      <a:tailEnd type="none" w="med" len="med"/>
+                    </a:lnB>
+                  </a:tcPr>
+                </a:tc>
+                <a:tc>
+                  <a:txBody>
+                    <a:bodyPr/>
+                    <a:lstStyle/>
+                    <a:p>
+                      <a:r>
+                        <a:rPr lang="en-US" sz="1200" dirty="0">
+                          <a:latin typeface="Verdana Pro" panose="020B0604030504040204" pitchFamily="34" charset="0"/>
+                          <a:cs typeface="Courier New" panose="02070309020205020404" pitchFamily="49" charset="0"/>
+                        </a:rPr>
+                        <a:t>1252 atoms</a:t>
+                      </a:r>
+                    </a:p>
+                    <a:p>
+                      <a:r>
+                        <a:rPr lang="en-US" sz="1200" dirty="0">
+                          <a:latin typeface="Verdana Pro" panose="020B0604030504040204" pitchFamily="34" charset="0"/>
+                          <a:cs typeface="Courier New" panose="02070309020205020404" pitchFamily="49" charset="0"/>
+                        </a:rPr>
+                        <a:t>[66 AAs]</a:t>
+                      </a:r>
+                      <a:endParaRPr lang="en-CA" sz="1200" dirty="0">
+                        <a:latin typeface="Verdana Pro" panose="020B0604030504040204" pitchFamily="34" charset="0"/>
+                        <a:cs typeface="Courier New" panose="02070309020205020404" pitchFamily="49" charset="0"/>
+                      </a:endParaRPr>
+                    </a:p>
+                  </a:txBody>
+                  <a:tcPr>
+                    <a:lnL w="6350" cap="flat" cmpd="sng" algn="ctr">
+                      <a:solidFill>
+                        <a:schemeClr val="tx1"/>
+                      </a:solidFill>
+                      <a:prstDash val="solid"/>
+                      <a:round/>
+                      <a:headEnd type="none" w="med" len="med"/>
+                      <a:tailEnd type="none" w="med" len="med"/>
+                    </a:lnL>
+                    <a:lnR w="6350" cap="flat" cmpd="sng" algn="ctr">
+                      <a:solidFill>
+                        <a:schemeClr val="tx1"/>
+                      </a:solidFill>
+                      <a:prstDash val="solid"/>
+                      <a:round/>
+                      <a:headEnd type="none" w="med" len="med"/>
+                      <a:tailEnd type="none" w="med" len="med"/>
+                    </a:lnR>
+                    <a:lnT w="6350" cap="flat" cmpd="sng" algn="ctr">
+                      <a:solidFill>
+                        <a:schemeClr val="tx1"/>
+                      </a:solidFill>
+                      <a:prstDash val="solid"/>
+                      <a:round/>
+                      <a:headEnd type="none" w="med" len="med"/>
+                      <a:tailEnd type="none" w="med" len="med"/>
+                    </a:lnT>
+                    <a:lnB w="6350" cap="flat" cmpd="sng" algn="ctr">
+                      <a:solidFill>
+                        <a:schemeClr val="tx1"/>
+                      </a:solidFill>
+                      <a:prstDash val="solid"/>
+                      <a:round/>
+                      <a:headEnd type="none" w="med" len="med"/>
+                      <a:tailEnd type="none" w="med" len="med"/>
+                    </a:lnB>
+                  </a:tcPr>
+                </a:tc>
+                <a:extLst>
+                  <a:ext uri="{0D108BD9-81ED-4DB2-BD59-A6C34878D82A}">
+                    <a16:rowId xmlns:a16="http://schemas.microsoft.com/office/drawing/2014/main" val="4069461568"/>
+                  </a:ext>
+                </a:extLst>
+              </a:tr>
+            </a:tbl>
+          </a:graphicData>
+        </a:graphic>
+      </p:graphicFrame>
+      <p:pic>
+        <p:nvPicPr>
+          <p:cNvPr id="3" name="Graphic 2">
+            <a:extLst>
+              <a:ext uri="{FF2B5EF4-FFF2-40B4-BE49-F238E27FC236}">
+                <a16:creationId xmlns:a16="http://schemas.microsoft.com/office/drawing/2014/main" id="{9AF6A182-4FF9-CFAE-0BC9-E814B90DA5B2}"/>
+              </a:ext>
+            </a:extLst>
+          </p:cNvPr>
+          <p:cNvPicPr>
+            <a:picLocks noChangeAspect="1"/>
+          </p:cNvPicPr>
+          <p:nvPr/>
+        </p:nvPicPr>
+        <p:blipFill>
+          <a:blip>
+            <a:extLst>
+              <a:ext uri="{96DAC541-7B7A-43D3-8B79-37D633B846F1}">
+                <asvg:svgBlip xmlns:asvg="http://schemas.microsoft.com/office/drawing/2016/SVG/main" r:embed="rId4"/>
+              </a:ext>
+            </a:extLst>
+          </a:blip>
+          <a:srcRect t="10849" r="8850"/>
+          <a:stretch>
+            <a:fillRect/>
+          </a:stretch>
+        </p:blipFill>
+        <p:spPr>
+          <a:xfrm>
+            <a:off x="219800" y="483593"/>
+            <a:ext cx="3011454" cy="2945407"/>
+          </a:xfrm>
+          <a:prstGeom prst="rect">
+            <a:avLst/>
+          </a:prstGeom>
+        </p:spPr>
+      </p:pic>
+      <p:sp>
+        <p:nvSpPr>
+          <p:cNvPr id="26" name="Rectangle 25">
+            <a:extLst>
+              <a:ext uri="{FF2B5EF4-FFF2-40B4-BE49-F238E27FC236}">
+                <a16:creationId xmlns:a16="http://schemas.microsoft.com/office/drawing/2014/main" id="{07B46E29-E8BA-FD3A-1927-3AADE4609CA7}"/>
+              </a:ext>
+            </a:extLst>
+          </p:cNvPr>
+          <p:cNvSpPr/>
+          <p:nvPr/>
+        </p:nvSpPr>
+        <p:spPr>
+          <a:xfrm>
+            <a:off x="1454150" y="1024261"/>
+            <a:ext cx="158750" cy="93382"/>
+          </a:xfrm>
+          <a:prstGeom prst="rect">
+            <a:avLst/>
+          </a:prstGeom>
+          <a:noFill/>
+          <a:ln>
+            <a:solidFill>
+              <a:srgbClr val="FF0000"/>
+            </a:solidFill>
+          </a:ln>
+        </p:spPr>
+        <p:style>
+          <a:lnRef idx="2">
+            <a:schemeClr val="accent1">
+              <a:shade val="15000"/>
+            </a:schemeClr>
+          </a:lnRef>
+          <a:fillRef idx="1">
+            <a:schemeClr val="accent1"/>
+          </a:fillRef>
+          <a:effectRef idx="0">
+            <a:schemeClr val="accent1"/>
+          </a:effectRef>
+          <a:fontRef idx="minor">
+            <a:schemeClr val="lt1"/>
+          </a:fontRef>
+        </p:style>
+        <p:txBody>
+          <a:bodyPr rtlCol="0" anchor="ctr"/>
+          <a:lstStyle/>
+          <a:p>
+            <a:pPr algn="ctr"/>
+            <a:endParaRPr lang="en-CA"/>
+          </a:p>
+        </p:txBody>
+      </p:sp>
+      <p:pic>
+        <p:nvPicPr>
+          <p:cNvPr id="6" name="Picture 5">
+            <a:extLst>
+              <a:ext uri="{FF2B5EF4-FFF2-40B4-BE49-F238E27FC236}">
+                <a16:creationId xmlns:a16="http://schemas.microsoft.com/office/drawing/2014/main" id="{F6E9BAA3-133D-6128-ADED-040408343B27}"/>
+              </a:ext>
+            </a:extLst>
+          </p:cNvPr>
+          <p:cNvPicPr>
+            <a:picLocks noChangeAspect="1"/>
+          </p:cNvPicPr>
+          <p:nvPr/>
+        </p:nvPicPr>
+        <p:blipFill>
+          <a:blip r:embed="rId5"/>
+          <a:stretch>
+            <a:fillRect/>
+          </a:stretch>
+        </p:blipFill>
+        <p:spPr>
+          <a:xfrm>
+            <a:off x="3540154" y="522917"/>
+            <a:ext cx="3224130" cy="4208488"/>
+          </a:xfrm>
+          <a:prstGeom prst="rect">
+            <a:avLst/>
+          </a:prstGeom>
+        </p:spPr>
+      </p:pic>
+    </p:spTree>
+    <p:extLst>
+      <p:ext uri="{BB962C8B-B14F-4D97-AF65-F5344CB8AC3E}">
+        <p14:creationId xmlns:p14="http://schemas.microsoft.com/office/powerpoint/2010/main" val="1180917802"/>
       </p:ext>
     </p:extLst>
   </p:cSld>

</xml_diff>

<commit_message>
Added draft code for automatically capturing PNGs from .pse in PyMOL.
</commit_message>
<xml_diff>
--- a/reports/2026-04-10_projectUpdate_2_jmoran.pptx
+++ b/reports/2026-04-10_projectUpdate_2_jmoran.pptx
@@ -5930,7 +5930,7 @@
                 </a:solidFill>
                 <a:latin typeface="Georgia Pro" panose="02040502050405020303" pitchFamily="18" charset="0"/>
               </a:rPr>
-              <a:t>Procuring a gold-standard list of homologous bacterial-human protein pairs from high-impact literature</a:t>
+              <a:t>Curating a positive control set of homologous bacterial-human protein pairs from high-impact literature</a:t>
             </a:r>
           </a:p>
         </p:txBody>
@@ -6779,7 +6779,7 @@
                 </a:solidFill>
                 <a:latin typeface="Georgia Pro" panose="02040502050405020303" pitchFamily="18" charset="0"/>
               </a:rPr>
-              <a:t>Gold standard list</a:t>
+              <a:t>Positive control set</a:t>
             </a:r>
             <a:endParaRPr lang="en-CA" sz="2600" b="1" dirty="0">
               <a:solidFill>
@@ -14522,7 +14522,7 @@
               <a:rPr lang="en-US" dirty="0">
                 <a:latin typeface="Georgia Pro" panose="02040502050405020303" pitchFamily="18" charset="0"/>
               </a:rPr>
-              <a:t>Finalize manually curated list of gold-standard bacteria-human protein pairs</a:t>
+              <a:t>Manually curate positive control set of bacteria-human protein pairs</a:t>
             </a:r>
           </a:p>
           <a:p>

</xml_diff>

<commit_message>
Added UniProt IDs to positive control set.
</commit_message>
<xml_diff>
--- a/reports/2026-04-10_projectUpdate_2_jmoran.pptx
+++ b/reports/2026-04-10_projectUpdate_2_jmoran.pptx
@@ -6805,14 +6805,14 @@
           <p:nvPr>
             <p:extLst>
               <p:ext uri="{D42A27DB-BD31-4B8C-83A1-F6EECF244321}">
-                <p14:modId xmlns:p14="http://schemas.microsoft.com/office/powerpoint/2010/main" val="3404926015"/>
+                <p14:modId xmlns:p14="http://schemas.microsoft.com/office/powerpoint/2010/main" val="981801861"/>
               </p:ext>
             </p:extLst>
           </p:nvPr>
         </p:nvGraphicFramePr>
         <p:xfrm>
-          <a:off x="1241192" y="2618867"/>
-          <a:ext cx="5347208" cy="3595370"/>
+          <a:off x="181153" y="2618867"/>
+          <a:ext cx="6476258" cy="3595370"/>
         </p:xfrm>
         <a:graphic>
           <a:graphicData uri="http://schemas.openxmlformats.org/drawingml/2006/table">
@@ -6821,21 +6821,35 @@
                 <a:tableStyleId>{5940675A-B579-460E-94D1-54222C63F5DA}</a:tableStyleId>
               </a:tblPr>
               <a:tblGrid>
-                <a:gridCol w="930540">
+                <a:gridCol w="914399">
                   <a:extLst>
                     <a:ext uri="{9D8B030D-6E8A-4147-A177-3AD203B41FA5}">
                       <a16:colId xmlns:a16="http://schemas.microsoft.com/office/drawing/2014/main" val="529853741"/>
                     </a:ext>
                   </a:extLst>
                 </a:gridCol>
-                <a:gridCol w="2130668">
+                <a:gridCol w="1354348">
+                  <a:extLst>
+                    <a:ext uri="{9D8B030D-6E8A-4147-A177-3AD203B41FA5}">
+                      <a16:colId xmlns:a16="http://schemas.microsoft.com/office/drawing/2014/main" val="165409373"/>
+                    </a:ext>
+                  </a:extLst>
+                </a:gridCol>
+                <a:gridCol w="1509622">
                   <a:extLst>
                     <a:ext uri="{9D8B030D-6E8A-4147-A177-3AD203B41FA5}">
                       <a16:colId xmlns:a16="http://schemas.microsoft.com/office/drawing/2014/main" val="2430019957"/>
                     </a:ext>
                   </a:extLst>
                 </a:gridCol>
-                <a:gridCol w="2286000">
+                <a:gridCol w="1270553">
+                  <a:extLst>
+                    <a:ext uri="{9D8B030D-6E8A-4147-A177-3AD203B41FA5}">
+                      <a16:colId xmlns:a16="http://schemas.microsoft.com/office/drawing/2014/main" val="3918155899"/>
+                    </a:ext>
+                  </a:extLst>
+                </a:gridCol>
+                <a:gridCol w="1427336">
                   <a:extLst>
                     <a:ext uri="{9D8B030D-6E8A-4147-A177-3AD203B41FA5}">
                       <a16:colId xmlns:a16="http://schemas.microsoft.com/office/drawing/2014/main" val="3749239967"/>
@@ -6935,7 +6949,7 @@
                           <a:effectLst/>
                           <a:latin typeface="Lucida Console" panose="020B0609040504020204" pitchFamily="49" charset="0"/>
                         </a:rPr>
-                        <a:t>Bacterial gene name</a:t>
+                        <a:t>Bact. UniProt</a:t>
                       </a:r>
                       <a:endParaRPr lang="en-CA" sz="1200" b="0" i="0" u="none" strike="noStrike" dirty="0">
                         <a:solidFill>
@@ -7007,7 +7021,151 @@
                           <a:effectLst/>
                           <a:latin typeface="Lucida Console" panose="020B0609040504020204" pitchFamily="49" charset="0"/>
                         </a:rPr>
-                        <a:t>Human gene name</a:t>
+                        <a:t>Bact. gene name</a:t>
+                      </a:r>
+                      <a:endParaRPr lang="en-CA" sz="1200" b="0" i="0" u="none" strike="noStrike" dirty="0">
+                        <a:solidFill>
+                          <a:srgbClr val="000000"/>
+                        </a:solidFill>
+                        <a:effectLst/>
+                        <a:latin typeface="Lucida Console" panose="020B0609040504020204" pitchFamily="49" charset="0"/>
+                      </a:endParaRPr>
+                    </a:p>
+                  </a:txBody>
+                  <a:tcPr marL="6350" marR="6350" marT="6350" marB="0" anchor="b">
+                    <a:lnL w="3175" cap="flat" cmpd="sng" algn="ctr">
+                      <a:solidFill>
+                        <a:schemeClr val="tx1"/>
+                      </a:solidFill>
+                      <a:prstDash val="solid"/>
+                      <a:round/>
+                      <a:headEnd type="none" w="med" len="med"/>
+                      <a:tailEnd type="none" w="med" len="med"/>
+                    </a:lnL>
+                    <a:lnR w="3175" cap="flat" cmpd="sng" algn="ctr">
+                      <a:solidFill>
+                        <a:schemeClr val="tx1"/>
+                      </a:solidFill>
+                      <a:prstDash val="solid"/>
+                      <a:round/>
+                      <a:headEnd type="none" w="med" len="med"/>
+                      <a:tailEnd type="none" w="med" len="med"/>
+                    </a:lnR>
+                    <a:lnT w="6350" cap="flat" cmpd="sng" algn="ctr">
+                      <a:solidFill>
+                        <a:schemeClr val="tx1">
+                          <a:lumMod val="95000"/>
+                          <a:lumOff val="5000"/>
+                        </a:schemeClr>
+                      </a:solidFill>
+                      <a:prstDash val="solid"/>
+                      <a:round/>
+                      <a:headEnd type="none" w="med" len="med"/>
+                      <a:tailEnd type="none" w="med" len="med"/>
+                    </a:lnT>
+                    <a:lnB w="6350" cap="flat" cmpd="sng" algn="ctr">
+                      <a:solidFill>
+                        <a:schemeClr val="tx1">
+                          <a:lumMod val="95000"/>
+                          <a:lumOff val="5000"/>
+                        </a:schemeClr>
+                      </a:solidFill>
+                      <a:prstDash val="solid"/>
+                      <a:round/>
+                      <a:headEnd type="none" w="med" len="med"/>
+                      <a:tailEnd type="none" w="med" len="med"/>
+                    </a:lnB>
+                  </a:tcPr>
+                </a:tc>
+                <a:tc>
+                  <a:txBody>
+                    <a:bodyPr/>
+                    <a:lstStyle/>
+                    <a:p>
+                      <a:pPr algn="l" fontAlgn="b">
+                        <a:buNone/>
+                      </a:pPr>
+                      <a:r>
+                        <a:rPr lang="en-US" sz="1200" b="0" i="0" u="none" strike="noStrike" dirty="0">
+                          <a:solidFill>
+                            <a:srgbClr val="000000"/>
+                          </a:solidFill>
+                          <a:effectLst/>
+                          <a:latin typeface="Lucida Console" panose="020B0609040504020204" pitchFamily="49" charset="0"/>
+                        </a:rPr>
+                        <a:t>H.s. UniProt</a:t>
+                      </a:r>
+                      <a:endParaRPr lang="en-CA" sz="1200" b="0" i="0" u="none" strike="noStrike" dirty="0">
+                        <a:solidFill>
+                          <a:srgbClr val="000000"/>
+                        </a:solidFill>
+                        <a:effectLst/>
+                        <a:latin typeface="Lucida Console" panose="020B0609040504020204" pitchFamily="49" charset="0"/>
+                      </a:endParaRPr>
+                    </a:p>
+                  </a:txBody>
+                  <a:tcPr marL="6350" marR="6350" marT="6350" marB="0" anchor="b">
+                    <a:lnL w="3175" cap="flat" cmpd="sng" algn="ctr">
+                      <a:solidFill>
+                        <a:schemeClr val="tx1"/>
+                      </a:solidFill>
+                      <a:prstDash val="solid"/>
+                      <a:round/>
+                      <a:headEnd type="none" w="med" len="med"/>
+                      <a:tailEnd type="none" w="med" len="med"/>
+                    </a:lnL>
+                    <a:lnR w="3175" cap="flat" cmpd="sng" algn="ctr">
+                      <a:solidFill>
+                        <a:schemeClr val="tx1"/>
+                      </a:solidFill>
+                      <a:prstDash val="solid"/>
+                      <a:round/>
+                      <a:headEnd type="none" w="med" len="med"/>
+                      <a:tailEnd type="none" w="med" len="med"/>
+                    </a:lnR>
+                    <a:lnT w="6350" cap="flat" cmpd="sng" algn="ctr">
+                      <a:solidFill>
+                        <a:schemeClr val="tx1">
+                          <a:lumMod val="95000"/>
+                          <a:lumOff val="5000"/>
+                        </a:schemeClr>
+                      </a:solidFill>
+                      <a:prstDash val="solid"/>
+                      <a:round/>
+                      <a:headEnd type="none" w="med" len="med"/>
+                      <a:tailEnd type="none" w="med" len="med"/>
+                    </a:lnT>
+                    <a:lnB w="6350" cap="flat" cmpd="sng" algn="ctr">
+                      <a:solidFill>
+                        <a:schemeClr val="tx1">
+                          <a:lumMod val="95000"/>
+                          <a:lumOff val="5000"/>
+                        </a:schemeClr>
+                      </a:solidFill>
+                      <a:prstDash val="solid"/>
+                      <a:round/>
+                      <a:headEnd type="none" w="med" len="med"/>
+                      <a:tailEnd type="none" w="med" len="med"/>
+                    </a:lnB>
+                  </a:tcPr>
+                </a:tc>
+                <a:tc>
+                  <a:txBody>
+                    <a:bodyPr/>
+                    <a:lstStyle/>
+                    <a:p>
+                      <a:pPr algn="l" fontAlgn="b">
+                        <a:buNone/>
+                      </a:pPr>
+                      <a:r>
+                        <a:rPr lang="en-US" sz="1200" b="0" i="0" u="none" strike="noStrike" dirty="0">
+                          <a:solidFill>
+                            <a:srgbClr val="000000"/>
+                          </a:solidFill>
+                          <a:effectLst/>
+                          <a:latin typeface="Lucida Console" panose="020B0609040504020204" pitchFamily="49" charset="0"/>
+                        </a:rPr>
+                        <a:t>H.s. gene name</a:t>
                       </a:r>
                       <a:endParaRPr lang="en-CA" sz="1200" b="0" i="0" u="none" strike="noStrike" dirty="0">
                         <a:solidFill>
@@ -7078,7 +7236,7 @@
                     <a:bodyPr/>
                     <a:lstStyle/>
                     <a:p>
-                      <a:pPr algn="ctr" fontAlgn="b">
+                      <a:pPr algn="l" fontAlgn="b">
                         <a:buNone/>
                       </a:pPr>
                       <a:r>
@@ -7152,6 +7310,75 @@
                         <a:buNone/>
                       </a:pPr>
                       <a:r>
+                        <a:rPr lang="en-CA" sz="1100" b="0" i="0" u="none" strike="noStrike" dirty="0">
+                          <a:solidFill>
+                            <a:srgbClr val="000000"/>
+                          </a:solidFill>
+                          <a:effectLst/>
+                          <a:latin typeface="Courier New" panose="02070309020205020404" pitchFamily="49" charset="0"/>
+                          <a:cs typeface="Courier New" panose="02070309020205020404" pitchFamily="49" charset="0"/>
+                        </a:rPr>
+                        <a:t>Q6XGD5</a:t>
+                      </a:r>
+                    </a:p>
+                  </a:txBody>
+                  <a:tcPr marL="6350" marR="6350" marT="6350" marB="0" anchor="b">
+                    <a:lnL w="3175" cap="flat" cmpd="sng" algn="ctr">
+                      <a:solidFill>
+                        <a:schemeClr val="bg1">
+                          <a:lumMod val="65000"/>
+                        </a:schemeClr>
+                      </a:solidFill>
+                      <a:prstDash val="solid"/>
+                      <a:round/>
+                      <a:headEnd type="none" w="med" len="med"/>
+                      <a:tailEnd type="none" w="med" len="med"/>
+                    </a:lnL>
+                    <a:lnR w="3175" cap="flat" cmpd="sng" algn="ctr">
+                      <a:solidFill>
+                        <a:schemeClr val="bg1">
+                          <a:lumMod val="65000"/>
+                        </a:schemeClr>
+                      </a:solidFill>
+                      <a:prstDash val="solid"/>
+                      <a:round/>
+                      <a:headEnd type="none" w="med" len="med"/>
+                      <a:tailEnd type="none" w="med" len="med"/>
+                    </a:lnR>
+                    <a:lnT w="6350" cap="flat" cmpd="sng" algn="ctr">
+                      <a:solidFill>
+                        <a:schemeClr val="tx1">
+                          <a:lumMod val="95000"/>
+                          <a:lumOff val="5000"/>
+                        </a:schemeClr>
+                      </a:solidFill>
+                      <a:prstDash val="solid"/>
+                      <a:round/>
+                      <a:headEnd type="none" w="med" len="med"/>
+                      <a:tailEnd type="none" w="med" len="med"/>
+                    </a:lnT>
+                    <a:lnB w="3175" cap="flat" cmpd="sng" algn="ctr">
+                      <a:solidFill>
+                        <a:schemeClr val="bg1">
+                          <a:lumMod val="65000"/>
+                        </a:schemeClr>
+                      </a:solidFill>
+                      <a:prstDash val="solid"/>
+                      <a:round/>
+                      <a:headEnd type="none" w="med" len="med"/>
+                      <a:tailEnd type="none" w="med" len="med"/>
+                    </a:lnB>
+                  </a:tcPr>
+                </a:tc>
+                <a:tc>
+                  <a:txBody>
+                    <a:bodyPr/>
+                    <a:lstStyle/>
+                    <a:p>
+                      <a:pPr algn="l" fontAlgn="b">
+                        <a:buNone/>
+                      </a:pPr>
+                      <a:r>
                         <a:rPr lang="en-CA" sz="1200" b="0" i="0" u="none" strike="noStrike" dirty="0">
                           <a:solidFill>
                             <a:srgbClr val="000000"/>
@@ -7218,6 +7445,75 @@
                     <a:lstStyle/>
                     <a:p>
                       <a:pPr algn="ctr" fontAlgn="b">
+                        <a:buNone/>
+                      </a:pPr>
+                      <a:r>
+                        <a:rPr lang="en-CA" sz="1100" b="0" i="0" u="none" strike="noStrike" dirty="0">
+                          <a:solidFill>
+                            <a:srgbClr val="000000"/>
+                          </a:solidFill>
+                          <a:effectLst/>
+                          <a:latin typeface="Courier New" panose="02070309020205020404" pitchFamily="49" charset="0"/>
+                          <a:cs typeface="Courier New" panose="02070309020205020404" pitchFamily="49" charset="0"/>
+                        </a:rPr>
+                        <a:t>Q8N884</a:t>
+                      </a:r>
+                    </a:p>
+                  </a:txBody>
+                  <a:tcPr marL="6350" marR="6350" marT="6350" marB="0" anchor="b">
+                    <a:lnL w="3175" cap="flat" cmpd="sng" algn="ctr">
+                      <a:solidFill>
+                        <a:schemeClr val="bg1">
+                          <a:lumMod val="65000"/>
+                        </a:schemeClr>
+                      </a:solidFill>
+                      <a:prstDash val="solid"/>
+                      <a:round/>
+                      <a:headEnd type="none" w="med" len="med"/>
+                      <a:tailEnd type="none" w="med" len="med"/>
+                    </a:lnL>
+                    <a:lnR w="3175" cap="flat" cmpd="sng" algn="ctr">
+                      <a:solidFill>
+                        <a:schemeClr val="bg1">
+                          <a:lumMod val="65000"/>
+                        </a:schemeClr>
+                      </a:solidFill>
+                      <a:prstDash val="solid"/>
+                      <a:round/>
+                      <a:headEnd type="none" w="med" len="med"/>
+                      <a:tailEnd type="none" w="med" len="med"/>
+                    </a:lnR>
+                    <a:lnT w="6350" cap="flat" cmpd="sng" algn="ctr">
+                      <a:solidFill>
+                        <a:schemeClr val="tx1">
+                          <a:lumMod val="95000"/>
+                          <a:lumOff val="5000"/>
+                        </a:schemeClr>
+                      </a:solidFill>
+                      <a:prstDash val="solid"/>
+                      <a:round/>
+                      <a:headEnd type="none" w="med" len="med"/>
+                      <a:tailEnd type="none" w="med" len="med"/>
+                    </a:lnT>
+                    <a:lnB w="3175" cap="flat" cmpd="sng" algn="ctr">
+                      <a:solidFill>
+                        <a:schemeClr val="bg1">
+                          <a:lumMod val="65000"/>
+                        </a:schemeClr>
+                      </a:solidFill>
+                      <a:prstDash val="solid"/>
+                      <a:round/>
+                      <a:headEnd type="none" w="med" len="med"/>
+                      <a:tailEnd type="none" w="med" len="med"/>
+                    </a:lnB>
+                  </a:tcPr>
+                </a:tc>
+                <a:tc>
+                  <a:txBody>
+                    <a:bodyPr/>
+                    <a:lstStyle/>
+                    <a:p>
+                      <a:pPr algn="l" fontAlgn="b">
                         <a:buNone/>
                       </a:pPr>
                       <a:r>
@@ -7294,7 +7590,7 @@
                     <a:bodyPr/>
                     <a:lstStyle/>
                     <a:p>
-                      <a:pPr algn="ctr" fontAlgn="b">
+                      <a:pPr algn="l" fontAlgn="b">
                         <a:buNone/>
                       </a:pPr>
                       <a:r>
@@ -7367,6 +7663,74 @@
                         <a:buNone/>
                       </a:pPr>
                       <a:r>
+                        <a:rPr lang="en-CA" sz="1100" b="0" i="0" u="none" strike="noStrike" dirty="0">
+                          <a:solidFill>
+                            <a:srgbClr val="000000"/>
+                          </a:solidFill>
+                          <a:effectLst/>
+                          <a:latin typeface="Courier New" panose="02070309020205020404" pitchFamily="49" charset="0"/>
+                          <a:cs typeface="Courier New" panose="02070309020205020404" pitchFamily="49" charset="0"/>
+                        </a:rPr>
+                        <a:t>G2SLH8</a:t>
+                      </a:r>
+                    </a:p>
+                  </a:txBody>
+                  <a:tcPr marL="6350" marR="6350" marT="6350" marB="0" anchor="b">
+                    <a:lnL w="3175" cap="flat" cmpd="sng" algn="ctr">
+                      <a:solidFill>
+                        <a:schemeClr val="bg1">
+                          <a:lumMod val="65000"/>
+                        </a:schemeClr>
+                      </a:solidFill>
+                      <a:prstDash val="solid"/>
+                      <a:round/>
+                      <a:headEnd type="none" w="med" len="med"/>
+                      <a:tailEnd type="none" w="med" len="med"/>
+                    </a:lnL>
+                    <a:lnR w="3175" cap="flat" cmpd="sng" algn="ctr">
+                      <a:solidFill>
+                        <a:schemeClr val="bg1">
+                          <a:lumMod val="65000"/>
+                        </a:schemeClr>
+                      </a:solidFill>
+                      <a:prstDash val="solid"/>
+                      <a:round/>
+                      <a:headEnd type="none" w="med" len="med"/>
+                      <a:tailEnd type="none" w="med" len="med"/>
+                    </a:lnR>
+                    <a:lnT w="3175" cap="flat" cmpd="sng" algn="ctr">
+                      <a:solidFill>
+                        <a:schemeClr val="bg1">
+                          <a:lumMod val="65000"/>
+                        </a:schemeClr>
+                      </a:solidFill>
+                      <a:prstDash val="solid"/>
+                      <a:round/>
+                      <a:headEnd type="none" w="med" len="med"/>
+                      <a:tailEnd type="none" w="med" len="med"/>
+                    </a:lnT>
+                    <a:lnB w="3175" cap="flat" cmpd="sng" algn="ctr">
+                      <a:solidFill>
+                        <a:schemeClr val="bg1">
+                          <a:lumMod val="65000"/>
+                        </a:schemeClr>
+                      </a:solidFill>
+                      <a:prstDash val="solid"/>
+                      <a:round/>
+                      <a:headEnd type="none" w="med" len="med"/>
+                      <a:tailEnd type="none" w="med" len="med"/>
+                    </a:lnB>
+                  </a:tcPr>
+                </a:tc>
+                <a:tc>
+                  <a:txBody>
+                    <a:bodyPr/>
+                    <a:lstStyle/>
+                    <a:p>
+                      <a:pPr algn="l" fontAlgn="b">
+                        <a:buNone/>
+                      </a:pPr>
+                      <a:r>
                         <a:rPr lang="en-CA" sz="1200" b="0" i="0" u="none" strike="noStrike" dirty="0">
                           <a:solidFill>
                             <a:srgbClr val="000000"/>
@@ -7432,6 +7796,74 @@
                     <a:lstStyle/>
                     <a:p>
                       <a:pPr algn="ctr" fontAlgn="b">
+                        <a:buNone/>
+                      </a:pPr>
+                      <a:r>
+                        <a:rPr lang="en-CA" sz="1100" b="0" i="0" u="none" strike="noStrike" dirty="0">
+                          <a:solidFill>
+                            <a:srgbClr val="000000"/>
+                          </a:solidFill>
+                          <a:effectLst/>
+                          <a:latin typeface="Courier New" panose="02070309020205020404" pitchFamily="49" charset="0"/>
+                          <a:cs typeface="Courier New" panose="02070309020205020404" pitchFamily="49" charset="0"/>
+                        </a:rPr>
+                        <a:t>Q8N884</a:t>
+                      </a:r>
+                    </a:p>
+                  </a:txBody>
+                  <a:tcPr marL="6350" marR="6350" marT="6350" marB="0" anchor="b">
+                    <a:lnL w="3175" cap="flat" cmpd="sng" algn="ctr">
+                      <a:solidFill>
+                        <a:schemeClr val="bg1">
+                          <a:lumMod val="65000"/>
+                        </a:schemeClr>
+                      </a:solidFill>
+                      <a:prstDash val="solid"/>
+                      <a:round/>
+                      <a:headEnd type="none" w="med" len="med"/>
+                      <a:tailEnd type="none" w="med" len="med"/>
+                    </a:lnL>
+                    <a:lnR w="3175" cap="flat" cmpd="sng" algn="ctr">
+                      <a:solidFill>
+                        <a:schemeClr val="bg1">
+                          <a:lumMod val="65000"/>
+                        </a:schemeClr>
+                      </a:solidFill>
+                      <a:prstDash val="solid"/>
+                      <a:round/>
+                      <a:headEnd type="none" w="med" len="med"/>
+                      <a:tailEnd type="none" w="med" len="med"/>
+                    </a:lnR>
+                    <a:lnT w="3175" cap="flat" cmpd="sng" algn="ctr">
+                      <a:solidFill>
+                        <a:schemeClr val="bg1">
+                          <a:lumMod val="65000"/>
+                        </a:schemeClr>
+                      </a:solidFill>
+                      <a:prstDash val="solid"/>
+                      <a:round/>
+                      <a:headEnd type="none" w="med" len="med"/>
+                      <a:tailEnd type="none" w="med" len="med"/>
+                    </a:lnT>
+                    <a:lnB w="3175" cap="flat" cmpd="sng" algn="ctr">
+                      <a:solidFill>
+                        <a:schemeClr val="bg1">
+                          <a:lumMod val="65000"/>
+                        </a:schemeClr>
+                      </a:solidFill>
+                      <a:prstDash val="solid"/>
+                      <a:round/>
+                      <a:headEnd type="none" w="med" len="med"/>
+                      <a:tailEnd type="none" w="med" len="med"/>
+                    </a:lnB>
+                  </a:tcPr>
+                </a:tc>
+                <a:tc>
+                  <a:txBody>
+                    <a:bodyPr/>
+                    <a:lstStyle/>
+                    <a:p>
+                      <a:pPr algn="l" fontAlgn="b">
                         <a:buNone/>
                       </a:pPr>
                       <a:r>
@@ -7507,7 +7939,7 @@
                     <a:bodyPr/>
                     <a:lstStyle/>
                     <a:p>
-                      <a:pPr algn="ctr" fontAlgn="b">
+                      <a:pPr algn="l" fontAlgn="b">
                         <a:buNone/>
                       </a:pPr>
                       <a:r>
@@ -7580,6 +8012,74 @@
                         <a:buNone/>
                       </a:pPr>
                       <a:r>
+                        <a:rPr lang="en-CA" sz="1100" b="0" i="0" u="none" strike="noStrike" dirty="0">
+                          <a:solidFill>
+                            <a:srgbClr val="000000"/>
+                          </a:solidFill>
+                          <a:effectLst/>
+                          <a:latin typeface="Courier New" panose="02070309020205020404" pitchFamily="49" charset="0"/>
+                          <a:cs typeface="Courier New" panose="02070309020205020404" pitchFamily="49" charset="0"/>
+                        </a:rPr>
+                        <a:t>J8G6Z1</a:t>
+                      </a:r>
+                    </a:p>
+                  </a:txBody>
+                  <a:tcPr marL="6350" marR="6350" marT="6350" marB="0" anchor="b">
+                    <a:lnL w="3175" cap="flat" cmpd="sng" algn="ctr">
+                      <a:solidFill>
+                        <a:schemeClr val="bg1">
+                          <a:lumMod val="65000"/>
+                        </a:schemeClr>
+                      </a:solidFill>
+                      <a:prstDash val="solid"/>
+                      <a:round/>
+                      <a:headEnd type="none" w="med" len="med"/>
+                      <a:tailEnd type="none" w="med" len="med"/>
+                    </a:lnL>
+                    <a:lnR w="3175" cap="flat" cmpd="sng" algn="ctr">
+                      <a:solidFill>
+                        <a:schemeClr val="bg1">
+                          <a:lumMod val="65000"/>
+                        </a:schemeClr>
+                      </a:solidFill>
+                      <a:prstDash val="solid"/>
+                      <a:round/>
+                      <a:headEnd type="none" w="med" len="med"/>
+                      <a:tailEnd type="none" w="med" len="med"/>
+                    </a:lnR>
+                    <a:lnT w="3175" cap="flat" cmpd="sng" algn="ctr">
+                      <a:solidFill>
+                        <a:schemeClr val="bg1">
+                          <a:lumMod val="65000"/>
+                        </a:schemeClr>
+                      </a:solidFill>
+                      <a:prstDash val="solid"/>
+                      <a:round/>
+                      <a:headEnd type="none" w="med" len="med"/>
+                      <a:tailEnd type="none" w="med" len="med"/>
+                    </a:lnT>
+                    <a:lnB w="3175" cap="flat" cmpd="sng" algn="ctr">
+                      <a:solidFill>
+                        <a:schemeClr val="bg1">
+                          <a:lumMod val="65000"/>
+                        </a:schemeClr>
+                      </a:solidFill>
+                      <a:prstDash val="solid"/>
+                      <a:round/>
+                      <a:headEnd type="none" w="med" len="med"/>
+                      <a:tailEnd type="none" w="med" len="med"/>
+                    </a:lnB>
+                  </a:tcPr>
+                </a:tc>
+                <a:tc>
+                  <a:txBody>
+                    <a:bodyPr/>
+                    <a:lstStyle/>
+                    <a:p>
+                      <a:pPr algn="l" fontAlgn="b">
+                        <a:buNone/>
+                      </a:pPr>
+                      <a:r>
                         <a:rPr lang="en-CA" sz="1200" b="0" i="0" u="none" strike="noStrike" dirty="0">
                           <a:solidFill>
                             <a:srgbClr val="000000"/>
@@ -7645,6 +8145,74 @@
                     <a:lstStyle/>
                     <a:p>
                       <a:pPr algn="ctr" fontAlgn="b">
+                        <a:buNone/>
+                      </a:pPr>
+                      <a:r>
+                        <a:rPr lang="en-CA" sz="1100" b="0" i="0" u="none" strike="noStrike" dirty="0">
+                          <a:solidFill>
+                            <a:srgbClr val="000000"/>
+                          </a:solidFill>
+                          <a:effectLst/>
+                          <a:latin typeface="Courier New" panose="02070309020205020404" pitchFamily="49" charset="0"/>
+                          <a:cs typeface="Courier New" panose="02070309020205020404" pitchFamily="49" charset="0"/>
+                        </a:rPr>
+                        <a:t>Q9BPY3</a:t>
+                      </a:r>
+                    </a:p>
+                  </a:txBody>
+                  <a:tcPr marL="6350" marR="6350" marT="6350" marB="0" anchor="b">
+                    <a:lnL w="3175" cap="flat" cmpd="sng" algn="ctr">
+                      <a:solidFill>
+                        <a:schemeClr val="bg1">
+                          <a:lumMod val="65000"/>
+                        </a:schemeClr>
+                      </a:solidFill>
+                      <a:prstDash val="solid"/>
+                      <a:round/>
+                      <a:headEnd type="none" w="med" len="med"/>
+                      <a:tailEnd type="none" w="med" len="med"/>
+                    </a:lnL>
+                    <a:lnR w="3175" cap="flat" cmpd="sng" algn="ctr">
+                      <a:solidFill>
+                        <a:schemeClr val="bg1">
+                          <a:lumMod val="65000"/>
+                        </a:schemeClr>
+                      </a:solidFill>
+                      <a:prstDash val="solid"/>
+                      <a:round/>
+                      <a:headEnd type="none" w="med" len="med"/>
+                      <a:tailEnd type="none" w="med" len="med"/>
+                    </a:lnR>
+                    <a:lnT w="3175" cap="flat" cmpd="sng" algn="ctr">
+                      <a:solidFill>
+                        <a:schemeClr val="bg1">
+                          <a:lumMod val="65000"/>
+                        </a:schemeClr>
+                      </a:solidFill>
+                      <a:prstDash val="solid"/>
+                      <a:round/>
+                      <a:headEnd type="none" w="med" len="med"/>
+                      <a:tailEnd type="none" w="med" len="med"/>
+                    </a:lnT>
+                    <a:lnB w="3175" cap="flat" cmpd="sng" algn="ctr">
+                      <a:solidFill>
+                        <a:schemeClr val="bg1">
+                          <a:lumMod val="65000"/>
+                        </a:schemeClr>
+                      </a:solidFill>
+                      <a:prstDash val="solid"/>
+                      <a:round/>
+                      <a:headEnd type="none" w="med" len="med"/>
+                      <a:tailEnd type="none" w="med" len="med"/>
+                    </a:lnB>
+                  </a:tcPr>
+                </a:tc>
+                <a:tc>
+                  <a:txBody>
+                    <a:bodyPr/>
+                    <a:lstStyle/>
+                    <a:p>
+                      <a:pPr algn="l" fontAlgn="b">
                         <a:buNone/>
                       </a:pPr>
                       <a:r>
@@ -7720,7 +8288,7 @@
                     <a:bodyPr/>
                     <a:lstStyle/>
                     <a:p>
-                      <a:pPr algn="ctr" fontAlgn="b">
+                      <a:pPr algn="l" fontAlgn="b">
                         <a:buNone/>
                       </a:pPr>
                       <a:r>
@@ -7793,6 +8361,74 @@
                         <a:buNone/>
                       </a:pPr>
                       <a:r>
+                        <a:rPr lang="en-CA" sz="1100" b="0" i="0" u="none" strike="noStrike" dirty="0">
+                          <a:solidFill>
+                            <a:srgbClr val="000000"/>
+                          </a:solidFill>
+                          <a:effectLst/>
+                          <a:latin typeface="Courier New" panose="02070309020205020404" pitchFamily="49" charset="0"/>
+                          <a:cs typeface="Courier New" panose="02070309020205020404" pitchFamily="49" charset="0"/>
+                        </a:rPr>
+                        <a:t>J8G6Z1</a:t>
+                      </a:r>
+                    </a:p>
+                  </a:txBody>
+                  <a:tcPr marL="6350" marR="6350" marT="6350" marB="0" anchor="b">
+                    <a:lnL w="3175" cap="flat" cmpd="sng" algn="ctr">
+                      <a:solidFill>
+                        <a:schemeClr val="bg1">
+                          <a:lumMod val="65000"/>
+                        </a:schemeClr>
+                      </a:solidFill>
+                      <a:prstDash val="solid"/>
+                      <a:round/>
+                      <a:headEnd type="none" w="med" len="med"/>
+                      <a:tailEnd type="none" w="med" len="med"/>
+                    </a:lnL>
+                    <a:lnR w="3175" cap="flat" cmpd="sng" algn="ctr">
+                      <a:solidFill>
+                        <a:schemeClr val="bg1">
+                          <a:lumMod val="65000"/>
+                        </a:schemeClr>
+                      </a:solidFill>
+                      <a:prstDash val="solid"/>
+                      <a:round/>
+                      <a:headEnd type="none" w="med" len="med"/>
+                      <a:tailEnd type="none" w="med" len="med"/>
+                    </a:lnR>
+                    <a:lnT w="3175" cap="flat" cmpd="sng" algn="ctr">
+                      <a:solidFill>
+                        <a:schemeClr val="bg1">
+                          <a:lumMod val="65000"/>
+                        </a:schemeClr>
+                      </a:solidFill>
+                      <a:prstDash val="solid"/>
+                      <a:round/>
+                      <a:headEnd type="none" w="med" len="med"/>
+                      <a:tailEnd type="none" w="med" len="med"/>
+                    </a:lnT>
+                    <a:lnB w="3175" cap="flat" cmpd="sng" algn="ctr">
+                      <a:solidFill>
+                        <a:schemeClr val="bg1">
+                          <a:lumMod val="65000"/>
+                        </a:schemeClr>
+                      </a:solidFill>
+                      <a:prstDash val="solid"/>
+                      <a:round/>
+                      <a:headEnd type="none" w="med" len="med"/>
+                      <a:tailEnd type="none" w="med" len="med"/>
+                    </a:lnB>
+                  </a:tcPr>
+                </a:tc>
+                <a:tc>
+                  <a:txBody>
+                    <a:bodyPr/>
+                    <a:lstStyle/>
+                    <a:p>
+                      <a:pPr algn="l" fontAlgn="b">
+                        <a:buNone/>
+                      </a:pPr>
+                      <a:r>
                         <a:rPr lang="en-CA" sz="1200" b="0" i="0" u="none" strike="noStrike" dirty="0">
                           <a:solidFill>
                             <a:srgbClr val="000000"/>
@@ -7861,7 +8497,75 @@
                         <a:buNone/>
                       </a:pPr>
                       <a:r>
-                        <a:rPr lang="en-CA" sz="1200" b="0" i="0" u="none" strike="noStrike">
+                        <a:rPr lang="en-CA" sz="1100" b="0" i="0" u="none" strike="noStrike" dirty="0">
+                          <a:solidFill>
+                            <a:srgbClr val="000000"/>
+                          </a:solidFill>
+                          <a:effectLst/>
+                          <a:latin typeface="Courier New" panose="02070309020205020404" pitchFamily="49" charset="0"/>
+                          <a:cs typeface="Courier New" panose="02070309020205020404" pitchFamily="49" charset="0"/>
+                        </a:rPr>
+                        <a:t>Q96EB6</a:t>
+                      </a:r>
+                    </a:p>
+                  </a:txBody>
+                  <a:tcPr marL="6350" marR="6350" marT="6350" marB="0" anchor="b">
+                    <a:lnL w="3175" cap="flat" cmpd="sng" algn="ctr">
+                      <a:solidFill>
+                        <a:schemeClr val="bg1">
+                          <a:lumMod val="65000"/>
+                        </a:schemeClr>
+                      </a:solidFill>
+                      <a:prstDash val="solid"/>
+                      <a:round/>
+                      <a:headEnd type="none" w="med" len="med"/>
+                      <a:tailEnd type="none" w="med" len="med"/>
+                    </a:lnL>
+                    <a:lnR w="3175" cap="flat" cmpd="sng" algn="ctr">
+                      <a:solidFill>
+                        <a:schemeClr val="bg1">
+                          <a:lumMod val="65000"/>
+                        </a:schemeClr>
+                      </a:solidFill>
+                      <a:prstDash val="solid"/>
+                      <a:round/>
+                      <a:headEnd type="none" w="med" len="med"/>
+                      <a:tailEnd type="none" w="med" len="med"/>
+                    </a:lnR>
+                    <a:lnT w="3175" cap="flat" cmpd="sng" algn="ctr">
+                      <a:solidFill>
+                        <a:schemeClr val="bg1">
+                          <a:lumMod val="65000"/>
+                        </a:schemeClr>
+                      </a:solidFill>
+                      <a:prstDash val="solid"/>
+                      <a:round/>
+                      <a:headEnd type="none" w="med" len="med"/>
+                      <a:tailEnd type="none" w="med" len="med"/>
+                    </a:lnT>
+                    <a:lnB w="3175" cap="flat" cmpd="sng" algn="ctr">
+                      <a:solidFill>
+                        <a:schemeClr val="bg1">
+                          <a:lumMod val="65000"/>
+                        </a:schemeClr>
+                      </a:solidFill>
+                      <a:prstDash val="solid"/>
+                      <a:round/>
+                      <a:headEnd type="none" w="med" len="med"/>
+                      <a:tailEnd type="none" w="med" len="med"/>
+                    </a:lnB>
+                  </a:tcPr>
+                </a:tc>
+                <a:tc>
+                  <a:txBody>
+                    <a:bodyPr/>
+                    <a:lstStyle/>
+                    <a:p>
+                      <a:pPr algn="l" fontAlgn="b">
+                        <a:buNone/>
+                      </a:pPr>
+                      <a:r>
+                        <a:rPr lang="en-CA" sz="1200" b="0" i="0" u="none" strike="noStrike" dirty="0">
                           <a:solidFill>
                             <a:srgbClr val="000000"/>
                           </a:solidFill>
@@ -7933,7 +8637,7 @@
                     <a:bodyPr/>
                     <a:lstStyle/>
                     <a:p>
-                      <a:pPr algn="ctr" fontAlgn="b">
+                      <a:pPr algn="l" fontAlgn="b">
                         <a:buNone/>
                       </a:pPr>
                       <a:r>
@@ -8006,6 +8710,74 @@
                         <a:buNone/>
                       </a:pPr>
                       <a:r>
+                        <a:rPr lang="en-CA" sz="1100" b="0" i="0" u="none" strike="noStrike" dirty="0">
+                          <a:solidFill>
+                            <a:srgbClr val="000000"/>
+                          </a:solidFill>
+                          <a:effectLst/>
+                          <a:latin typeface="Courier New" panose="02070309020205020404" pitchFamily="49" charset="0"/>
+                          <a:cs typeface="Courier New" panose="02070309020205020404" pitchFamily="49" charset="0"/>
+                        </a:rPr>
+                        <a:t>J8G6Z1</a:t>
+                      </a:r>
+                    </a:p>
+                  </a:txBody>
+                  <a:tcPr marL="6350" marR="6350" marT="6350" marB="0" anchor="b">
+                    <a:lnL w="3175" cap="flat" cmpd="sng" algn="ctr">
+                      <a:solidFill>
+                        <a:schemeClr val="bg1">
+                          <a:lumMod val="65000"/>
+                        </a:schemeClr>
+                      </a:solidFill>
+                      <a:prstDash val="solid"/>
+                      <a:round/>
+                      <a:headEnd type="none" w="med" len="med"/>
+                      <a:tailEnd type="none" w="med" len="med"/>
+                    </a:lnL>
+                    <a:lnR w="3175" cap="flat" cmpd="sng" algn="ctr">
+                      <a:solidFill>
+                        <a:schemeClr val="bg1">
+                          <a:lumMod val="65000"/>
+                        </a:schemeClr>
+                      </a:solidFill>
+                      <a:prstDash val="solid"/>
+                      <a:round/>
+                      <a:headEnd type="none" w="med" len="med"/>
+                      <a:tailEnd type="none" w="med" len="med"/>
+                    </a:lnR>
+                    <a:lnT w="3175" cap="flat" cmpd="sng" algn="ctr">
+                      <a:solidFill>
+                        <a:schemeClr val="bg1">
+                          <a:lumMod val="65000"/>
+                        </a:schemeClr>
+                      </a:solidFill>
+                      <a:prstDash val="solid"/>
+                      <a:round/>
+                      <a:headEnd type="none" w="med" len="med"/>
+                      <a:tailEnd type="none" w="med" len="med"/>
+                    </a:lnT>
+                    <a:lnB w="3175" cap="flat" cmpd="sng" algn="ctr">
+                      <a:solidFill>
+                        <a:schemeClr val="bg1">
+                          <a:lumMod val="65000"/>
+                        </a:schemeClr>
+                      </a:solidFill>
+                      <a:prstDash val="solid"/>
+                      <a:round/>
+                      <a:headEnd type="none" w="med" len="med"/>
+                      <a:tailEnd type="none" w="med" len="med"/>
+                    </a:lnB>
+                  </a:tcPr>
+                </a:tc>
+                <a:tc>
+                  <a:txBody>
+                    <a:bodyPr/>
+                    <a:lstStyle/>
+                    <a:p>
+                      <a:pPr algn="l" fontAlgn="b">
+                        <a:buNone/>
+                      </a:pPr>
+                      <a:r>
                         <a:rPr lang="en-CA" sz="1200" b="0" i="0" u="none" strike="noStrike" dirty="0">
                           <a:solidFill>
                             <a:srgbClr val="000000"/>
@@ -8071,6 +8843,74 @@
                     <a:lstStyle/>
                     <a:p>
                       <a:pPr algn="ctr" fontAlgn="b">
+                        <a:buNone/>
+                      </a:pPr>
+                      <a:r>
+                        <a:rPr lang="en-CA" sz="1100" b="0" i="0" u="none" strike="noStrike" dirty="0">
+                          <a:solidFill>
+                            <a:srgbClr val="000000"/>
+                          </a:solidFill>
+                          <a:effectLst/>
+                          <a:latin typeface="Courier New" panose="02070309020205020404" pitchFamily="49" charset="0"/>
+                          <a:cs typeface="Courier New" panose="02070309020205020404" pitchFamily="49" charset="0"/>
+                        </a:rPr>
+                        <a:t>Q8IXJ6</a:t>
+                      </a:r>
+                    </a:p>
+                  </a:txBody>
+                  <a:tcPr marL="6350" marR="6350" marT="6350" marB="0" anchor="b">
+                    <a:lnL w="3175" cap="flat" cmpd="sng" algn="ctr">
+                      <a:solidFill>
+                        <a:schemeClr val="bg1">
+                          <a:lumMod val="65000"/>
+                        </a:schemeClr>
+                      </a:solidFill>
+                      <a:prstDash val="solid"/>
+                      <a:round/>
+                      <a:headEnd type="none" w="med" len="med"/>
+                      <a:tailEnd type="none" w="med" len="med"/>
+                    </a:lnL>
+                    <a:lnR w="3175" cap="flat" cmpd="sng" algn="ctr">
+                      <a:solidFill>
+                        <a:schemeClr val="bg1">
+                          <a:lumMod val="65000"/>
+                        </a:schemeClr>
+                      </a:solidFill>
+                      <a:prstDash val="solid"/>
+                      <a:round/>
+                      <a:headEnd type="none" w="med" len="med"/>
+                      <a:tailEnd type="none" w="med" len="med"/>
+                    </a:lnR>
+                    <a:lnT w="3175" cap="flat" cmpd="sng" algn="ctr">
+                      <a:solidFill>
+                        <a:schemeClr val="bg1">
+                          <a:lumMod val="65000"/>
+                        </a:schemeClr>
+                      </a:solidFill>
+                      <a:prstDash val="solid"/>
+                      <a:round/>
+                      <a:headEnd type="none" w="med" len="med"/>
+                      <a:tailEnd type="none" w="med" len="med"/>
+                    </a:lnT>
+                    <a:lnB w="3175" cap="flat" cmpd="sng" algn="ctr">
+                      <a:solidFill>
+                        <a:schemeClr val="bg1">
+                          <a:lumMod val="65000"/>
+                        </a:schemeClr>
+                      </a:solidFill>
+                      <a:prstDash val="solid"/>
+                      <a:round/>
+                      <a:headEnd type="none" w="med" len="med"/>
+                      <a:tailEnd type="none" w="med" len="med"/>
+                    </a:lnB>
+                  </a:tcPr>
+                </a:tc>
+                <a:tc>
+                  <a:txBody>
+                    <a:bodyPr/>
+                    <a:lstStyle/>
+                    <a:p>
+                      <a:pPr algn="l" fontAlgn="b">
                         <a:buNone/>
                       </a:pPr>
                       <a:r>
@@ -8146,7 +8986,7 @@
                     <a:bodyPr/>
                     <a:lstStyle/>
                     <a:p>
-                      <a:pPr algn="ctr" fontAlgn="b">
+                      <a:pPr algn="l" fontAlgn="b">
                         <a:buNone/>
                       </a:pPr>
                       <a:r>
@@ -8219,6 +9059,74 @@
                         <a:buNone/>
                       </a:pPr>
                       <a:r>
+                        <a:rPr lang="en-CA" sz="1100" b="0" i="0" u="none" strike="noStrike">
+                          <a:solidFill>
+                            <a:srgbClr val="000000"/>
+                          </a:solidFill>
+                          <a:effectLst/>
+                          <a:latin typeface="Courier New" panose="02070309020205020404" pitchFamily="49" charset="0"/>
+                          <a:cs typeface="Courier New" panose="02070309020205020404" pitchFamily="49" charset="0"/>
+                        </a:rPr>
+                        <a:t>J8G6Z1</a:t>
+                      </a:r>
+                    </a:p>
+                  </a:txBody>
+                  <a:tcPr marL="6350" marR="6350" marT="6350" marB="0" anchor="b">
+                    <a:lnL w="3175" cap="flat" cmpd="sng" algn="ctr">
+                      <a:solidFill>
+                        <a:schemeClr val="bg1">
+                          <a:lumMod val="65000"/>
+                        </a:schemeClr>
+                      </a:solidFill>
+                      <a:prstDash val="solid"/>
+                      <a:round/>
+                      <a:headEnd type="none" w="med" len="med"/>
+                      <a:tailEnd type="none" w="med" len="med"/>
+                    </a:lnL>
+                    <a:lnR w="3175" cap="flat" cmpd="sng" algn="ctr">
+                      <a:solidFill>
+                        <a:schemeClr val="bg1">
+                          <a:lumMod val="65000"/>
+                        </a:schemeClr>
+                      </a:solidFill>
+                      <a:prstDash val="solid"/>
+                      <a:round/>
+                      <a:headEnd type="none" w="med" len="med"/>
+                      <a:tailEnd type="none" w="med" len="med"/>
+                    </a:lnR>
+                    <a:lnT w="3175" cap="flat" cmpd="sng" algn="ctr">
+                      <a:solidFill>
+                        <a:schemeClr val="bg1">
+                          <a:lumMod val="65000"/>
+                        </a:schemeClr>
+                      </a:solidFill>
+                      <a:prstDash val="solid"/>
+                      <a:round/>
+                      <a:headEnd type="none" w="med" len="med"/>
+                      <a:tailEnd type="none" w="med" len="med"/>
+                    </a:lnT>
+                    <a:lnB w="3175" cap="flat" cmpd="sng" algn="ctr">
+                      <a:solidFill>
+                        <a:schemeClr val="bg1">
+                          <a:lumMod val="65000"/>
+                        </a:schemeClr>
+                      </a:solidFill>
+                      <a:prstDash val="solid"/>
+                      <a:round/>
+                      <a:headEnd type="none" w="med" len="med"/>
+                      <a:tailEnd type="none" w="med" len="med"/>
+                    </a:lnB>
+                  </a:tcPr>
+                </a:tc>
+                <a:tc>
+                  <a:txBody>
+                    <a:bodyPr/>
+                    <a:lstStyle/>
+                    <a:p>
+                      <a:pPr algn="l" fontAlgn="b">
+                        <a:buNone/>
+                      </a:pPr>
+                      <a:r>
                         <a:rPr lang="en-CA" sz="1200" b="0" i="0" u="none" strike="noStrike" dirty="0">
                           <a:solidFill>
                             <a:srgbClr val="000000"/>
@@ -8284,6 +9192,74 @@
                     <a:lstStyle/>
                     <a:p>
                       <a:pPr algn="ctr" fontAlgn="b">
+                        <a:buNone/>
+                      </a:pPr>
+                      <a:r>
+                        <a:rPr lang="en-CA" sz="1100" b="0" i="0" u="none" strike="noStrike" dirty="0">
+                          <a:solidFill>
+                            <a:srgbClr val="000000"/>
+                          </a:solidFill>
+                          <a:effectLst/>
+                          <a:latin typeface="Courier New" panose="02070309020205020404" pitchFamily="49" charset="0"/>
+                          <a:cs typeface="Courier New" panose="02070309020205020404" pitchFamily="49" charset="0"/>
+                        </a:rPr>
+                        <a:t>Q9Y6E7</a:t>
+                      </a:r>
+                    </a:p>
+                  </a:txBody>
+                  <a:tcPr marL="6350" marR="6350" marT="6350" marB="0" anchor="b">
+                    <a:lnL w="3175" cap="flat" cmpd="sng" algn="ctr">
+                      <a:solidFill>
+                        <a:schemeClr val="bg1">
+                          <a:lumMod val="65000"/>
+                        </a:schemeClr>
+                      </a:solidFill>
+                      <a:prstDash val="solid"/>
+                      <a:round/>
+                      <a:headEnd type="none" w="med" len="med"/>
+                      <a:tailEnd type="none" w="med" len="med"/>
+                    </a:lnL>
+                    <a:lnR w="3175" cap="flat" cmpd="sng" algn="ctr">
+                      <a:solidFill>
+                        <a:schemeClr val="bg1">
+                          <a:lumMod val="65000"/>
+                        </a:schemeClr>
+                      </a:solidFill>
+                      <a:prstDash val="solid"/>
+                      <a:round/>
+                      <a:headEnd type="none" w="med" len="med"/>
+                      <a:tailEnd type="none" w="med" len="med"/>
+                    </a:lnR>
+                    <a:lnT w="3175" cap="flat" cmpd="sng" algn="ctr">
+                      <a:solidFill>
+                        <a:schemeClr val="bg1">
+                          <a:lumMod val="65000"/>
+                        </a:schemeClr>
+                      </a:solidFill>
+                      <a:prstDash val="solid"/>
+                      <a:round/>
+                      <a:headEnd type="none" w="med" len="med"/>
+                      <a:tailEnd type="none" w="med" len="med"/>
+                    </a:lnT>
+                    <a:lnB w="3175" cap="flat" cmpd="sng" algn="ctr">
+                      <a:solidFill>
+                        <a:schemeClr val="bg1">
+                          <a:lumMod val="65000"/>
+                        </a:schemeClr>
+                      </a:solidFill>
+                      <a:prstDash val="solid"/>
+                      <a:round/>
+                      <a:headEnd type="none" w="med" len="med"/>
+                      <a:tailEnd type="none" w="med" len="med"/>
+                    </a:lnB>
+                  </a:tcPr>
+                </a:tc>
+                <a:tc>
+                  <a:txBody>
+                    <a:bodyPr/>
+                    <a:lstStyle/>
+                    <a:p>
+                      <a:pPr algn="l" fontAlgn="b">
                         <a:buNone/>
                       </a:pPr>
                       <a:r>
@@ -8359,7 +9335,7 @@
                     <a:bodyPr/>
                     <a:lstStyle/>
                     <a:p>
-                      <a:pPr algn="ctr" fontAlgn="b">
+                      <a:pPr algn="l" fontAlgn="b">
                         <a:buNone/>
                       </a:pPr>
                       <a:r>
@@ -8432,6 +9408,74 @@
                         <a:buNone/>
                       </a:pPr>
                       <a:r>
+                        <a:rPr lang="en-CA" sz="1100" b="0" i="0" u="none" strike="noStrike">
+                          <a:solidFill>
+                            <a:srgbClr val="000000"/>
+                          </a:solidFill>
+                          <a:effectLst/>
+                          <a:latin typeface="Courier New" panose="02070309020205020404" pitchFamily="49" charset="0"/>
+                          <a:cs typeface="Courier New" panose="02070309020205020404" pitchFamily="49" charset="0"/>
+                        </a:rPr>
+                        <a:t>J8G6Z1</a:t>
+                      </a:r>
+                    </a:p>
+                  </a:txBody>
+                  <a:tcPr marL="6350" marR="6350" marT="6350" marB="0" anchor="b">
+                    <a:lnL w="3175" cap="flat" cmpd="sng" algn="ctr">
+                      <a:solidFill>
+                        <a:schemeClr val="bg1">
+                          <a:lumMod val="65000"/>
+                        </a:schemeClr>
+                      </a:solidFill>
+                      <a:prstDash val="solid"/>
+                      <a:round/>
+                      <a:headEnd type="none" w="med" len="med"/>
+                      <a:tailEnd type="none" w="med" len="med"/>
+                    </a:lnL>
+                    <a:lnR w="3175" cap="flat" cmpd="sng" algn="ctr">
+                      <a:solidFill>
+                        <a:schemeClr val="bg1">
+                          <a:lumMod val="65000"/>
+                        </a:schemeClr>
+                      </a:solidFill>
+                      <a:prstDash val="solid"/>
+                      <a:round/>
+                      <a:headEnd type="none" w="med" len="med"/>
+                      <a:tailEnd type="none" w="med" len="med"/>
+                    </a:lnR>
+                    <a:lnT w="3175" cap="flat" cmpd="sng" algn="ctr">
+                      <a:solidFill>
+                        <a:schemeClr val="bg1">
+                          <a:lumMod val="65000"/>
+                        </a:schemeClr>
+                      </a:solidFill>
+                      <a:prstDash val="solid"/>
+                      <a:round/>
+                      <a:headEnd type="none" w="med" len="med"/>
+                      <a:tailEnd type="none" w="med" len="med"/>
+                    </a:lnT>
+                    <a:lnB w="3175" cap="flat" cmpd="sng" algn="ctr">
+                      <a:solidFill>
+                        <a:schemeClr val="bg1">
+                          <a:lumMod val="65000"/>
+                        </a:schemeClr>
+                      </a:solidFill>
+                      <a:prstDash val="solid"/>
+                      <a:round/>
+                      <a:headEnd type="none" w="med" len="med"/>
+                      <a:tailEnd type="none" w="med" len="med"/>
+                    </a:lnB>
+                  </a:tcPr>
+                </a:tc>
+                <a:tc>
+                  <a:txBody>
+                    <a:bodyPr/>
+                    <a:lstStyle/>
+                    <a:p>
+                      <a:pPr algn="l" fontAlgn="b">
+                        <a:buNone/>
+                      </a:pPr>
+                      <a:r>
                         <a:rPr lang="en-CA" sz="1200" b="0" i="0" u="none" strike="noStrike" dirty="0">
                           <a:solidFill>
                             <a:srgbClr val="000000"/>
@@ -8497,6 +9541,74 @@
                     <a:lstStyle/>
                     <a:p>
                       <a:pPr algn="ctr" fontAlgn="b">
+                        <a:buNone/>
+                      </a:pPr>
+                      <a:r>
+                        <a:rPr lang="en-CA" sz="1100" b="0" i="0" u="none" strike="noStrike" dirty="0">
+                          <a:solidFill>
+                            <a:srgbClr val="000000"/>
+                          </a:solidFill>
+                          <a:effectLst/>
+                          <a:latin typeface="Courier New" panose="02070309020205020404" pitchFamily="49" charset="0"/>
+                          <a:cs typeface="Courier New" panose="02070309020205020404" pitchFamily="49" charset="0"/>
+                        </a:rPr>
+                        <a:t>Q9NXA8</a:t>
+                      </a:r>
+                    </a:p>
+                  </a:txBody>
+                  <a:tcPr marL="6350" marR="6350" marT="6350" marB="0" anchor="b">
+                    <a:lnL w="3175" cap="flat" cmpd="sng" algn="ctr">
+                      <a:solidFill>
+                        <a:schemeClr val="bg1">
+                          <a:lumMod val="65000"/>
+                        </a:schemeClr>
+                      </a:solidFill>
+                      <a:prstDash val="solid"/>
+                      <a:round/>
+                      <a:headEnd type="none" w="med" len="med"/>
+                      <a:tailEnd type="none" w="med" len="med"/>
+                    </a:lnL>
+                    <a:lnR w="3175" cap="flat" cmpd="sng" algn="ctr">
+                      <a:solidFill>
+                        <a:schemeClr val="bg1">
+                          <a:lumMod val="65000"/>
+                        </a:schemeClr>
+                      </a:solidFill>
+                      <a:prstDash val="solid"/>
+                      <a:round/>
+                      <a:headEnd type="none" w="med" len="med"/>
+                      <a:tailEnd type="none" w="med" len="med"/>
+                    </a:lnR>
+                    <a:lnT w="3175" cap="flat" cmpd="sng" algn="ctr">
+                      <a:solidFill>
+                        <a:schemeClr val="bg1">
+                          <a:lumMod val="65000"/>
+                        </a:schemeClr>
+                      </a:solidFill>
+                      <a:prstDash val="solid"/>
+                      <a:round/>
+                      <a:headEnd type="none" w="med" len="med"/>
+                      <a:tailEnd type="none" w="med" len="med"/>
+                    </a:lnT>
+                    <a:lnB w="3175" cap="flat" cmpd="sng" algn="ctr">
+                      <a:solidFill>
+                        <a:schemeClr val="bg1">
+                          <a:lumMod val="65000"/>
+                        </a:schemeClr>
+                      </a:solidFill>
+                      <a:prstDash val="solid"/>
+                      <a:round/>
+                      <a:headEnd type="none" w="med" len="med"/>
+                      <a:tailEnd type="none" w="med" len="med"/>
+                    </a:lnB>
+                  </a:tcPr>
+                </a:tc>
+                <a:tc>
+                  <a:txBody>
+                    <a:bodyPr/>
+                    <a:lstStyle/>
+                    <a:p>
+                      <a:pPr algn="l" fontAlgn="b">
                         <a:buNone/>
                       </a:pPr>
                       <a:r>
@@ -8572,7 +9684,7 @@
                     <a:bodyPr/>
                     <a:lstStyle/>
                     <a:p>
-                      <a:pPr algn="ctr" fontAlgn="b">
+                      <a:pPr algn="l" fontAlgn="b">
                         <a:buNone/>
                       </a:pPr>
                       <a:r>
@@ -8645,6 +9757,74 @@
                         <a:buNone/>
                       </a:pPr>
                       <a:r>
+                        <a:rPr lang="en-CA" sz="1100" b="0" i="0" u="none" strike="noStrike" dirty="0">
+                          <a:solidFill>
+                            <a:srgbClr val="000000"/>
+                          </a:solidFill>
+                          <a:effectLst/>
+                          <a:latin typeface="Courier New" panose="02070309020205020404" pitchFamily="49" charset="0"/>
+                          <a:cs typeface="Courier New" panose="02070309020205020404" pitchFamily="49" charset="0"/>
+                        </a:rPr>
+                        <a:t>J8G6Z1</a:t>
+                      </a:r>
+                    </a:p>
+                  </a:txBody>
+                  <a:tcPr marL="6350" marR="6350" marT="6350" marB="0" anchor="b">
+                    <a:lnL w="3175" cap="flat" cmpd="sng" algn="ctr">
+                      <a:solidFill>
+                        <a:schemeClr val="bg1">
+                          <a:lumMod val="65000"/>
+                        </a:schemeClr>
+                      </a:solidFill>
+                      <a:prstDash val="solid"/>
+                      <a:round/>
+                      <a:headEnd type="none" w="med" len="med"/>
+                      <a:tailEnd type="none" w="med" len="med"/>
+                    </a:lnL>
+                    <a:lnR w="3175" cap="flat" cmpd="sng" algn="ctr">
+                      <a:solidFill>
+                        <a:schemeClr val="bg1">
+                          <a:lumMod val="65000"/>
+                        </a:schemeClr>
+                      </a:solidFill>
+                      <a:prstDash val="solid"/>
+                      <a:round/>
+                      <a:headEnd type="none" w="med" len="med"/>
+                      <a:tailEnd type="none" w="med" len="med"/>
+                    </a:lnR>
+                    <a:lnT w="3175" cap="flat" cmpd="sng" algn="ctr">
+                      <a:solidFill>
+                        <a:schemeClr val="bg1">
+                          <a:lumMod val="65000"/>
+                        </a:schemeClr>
+                      </a:solidFill>
+                      <a:prstDash val="solid"/>
+                      <a:round/>
+                      <a:headEnd type="none" w="med" len="med"/>
+                      <a:tailEnd type="none" w="med" len="med"/>
+                    </a:lnT>
+                    <a:lnB w="3175" cap="flat" cmpd="sng" algn="ctr">
+                      <a:solidFill>
+                        <a:schemeClr val="bg1">
+                          <a:lumMod val="65000"/>
+                        </a:schemeClr>
+                      </a:solidFill>
+                      <a:prstDash val="solid"/>
+                      <a:round/>
+                      <a:headEnd type="none" w="med" len="med"/>
+                      <a:tailEnd type="none" w="med" len="med"/>
+                    </a:lnB>
+                  </a:tcPr>
+                </a:tc>
+                <a:tc>
+                  <a:txBody>
+                    <a:bodyPr/>
+                    <a:lstStyle/>
+                    <a:p>
+                      <a:pPr algn="l" fontAlgn="b">
+                        <a:buNone/>
+                      </a:pPr>
+                      <a:r>
                         <a:rPr lang="en-CA" sz="1200" b="0" i="0" u="none" strike="noStrike" dirty="0">
                           <a:solidFill>
                             <a:srgbClr val="000000"/>
@@ -8710,6 +9890,74 @@
                     <a:lstStyle/>
                     <a:p>
                       <a:pPr algn="ctr" fontAlgn="b">
+                        <a:buNone/>
+                      </a:pPr>
+                      <a:r>
+                        <a:rPr lang="en-CA" sz="1100" b="0" i="0" u="none" strike="noStrike" dirty="0">
+                          <a:solidFill>
+                            <a:srgbClr val="000000"/>
+                          </a:solidFill>
+                          <a:effectLst/>
+                          <a:latin typeface="Courier New" panose="02070309020205020404" pitchFamily="49" charset="0"/>
+                          <a:cs typeface="Courier New" panose="02070309020205020404" pitchFamily="49" charset="0"/>
+                        </a:rPr>
+                        <a:t>Q8N6T7</a:t>
+                      </a:r>
+                    </a:p>
+                  </a:txBody>
+                  <a:tcPr marL="6350" marR="6350" marT="6350" marB="0" anchor="b">
+                    <a:lnL w="3175" cap="flat" cmpd="sng" algn="ctr">
+                      <a:solidFill>
+                        <a:schemeClr val="bg1">
+                          <a:lumMod val="65000"/>
+                        </a:schemeClr>
+                      </a:solidFill>
+                      <a:prstDash val="solid"/>
+                      <a:round/>
+                      <a:headEnd type="none" w="med" len="med"/>
+                      <a:tailEnd type="none" w="med" len="med"/>
+                    </a:lnL>
+                    <a:lnR w="3175" cap="flat" cmpd="sng" algn="ctr">
+                      <a:solidFill>
+                        <a:schemeClr val="bg1">
+                          <a:lumMod val="65000"/>
+                        </a:schemeClr>
+                      </a:solidFill>
+                      <a:prstDash val="solid"/>
+                      <a:round/>
+                      <a:headEnd type="none" w="med" len="med"/>
+                      <a:tailEnd type="none" w="med" len="med"/>
+                    </a:lnR>
+                    <a:lnT w="3175" cap="flat" cmpd="sng" algn="ctr">
+                      <a:solidFill>
+                        <a:schemeClr val="bg1">
+                          <a:lumMod val="65000"/>
+                        </a:schemeClr>
+                      </a:solidFill>
+                      <a:prstDash val="solid"/>
+                      <a:round/>
+                      <a:headEnd type="none" w="med" len="med"/>
+                      <a:tailEnd type="none" w="med" len="med"/>
+                    </a:lnT>
+                    <a:lnB w="3175" cap="flat" cmpd="sng" algn="ctr">
+                      <a:solidFill>
+                        <a:schemeClr val="bg1">
+                          <a:lumMod val="65000"/>
+                        </a:schemeClr>
+                      </a:solidFill>
+                      <a:prstDash val="solid"/>
+                      <a:round/>
+                      <a:headEnd type="none" w="med" len="med"/>
+                      <a:tailEnd type="none" w="med" len="med"/>
+                    </a:lnB>
+                  </a:tcPr>
+                </a:tc>
+                <a:tc>
+                  <a:txBody>
+                    <a:bodyPr/>
+                    <a:lstStyle/>
+                    <a:p>
+                      <a:pPr algn="l" fontAlgn="b">
                         <a:buNone/>
                       </a:pPr>
                       <a:r>
@@ -8785,7 +10033,7 @@
                     <a:bodyPr/>
                     <a:lstStyle/>
                     <a:p>
-                      <a:pPr algn="ctr" fontAlgn="b">
+                      <a:pPr algn="l" fontAlgn="b">
                         <a:buNone/>
                       </a:pPr>
                       <a:r>
@@ -8858,6 +10106,74 @@
                         <a:buNone/>
                       </a:pPr>
                       <a:r>
+                        <a:rPr lang="en-CA" sz="1100" b="0" i="0" u="none" strike="noStrike" dirty="0">
+                          <a:solidFill>
+                            <a:srgbClr val="000000"/>
+                          </a:solidFill>
+                          <a:effectLst/>
+                          <a:latin typeface="Courier New" panose="02070309020205020404" pitchFamily="49" charset="0"/>
+                          <a:cs typeface="Courier New" panose="02070309020205020404" pitchFamily="49" charset="0"/>
+                        </a:rPr>
+                        <a:t>J8G6Z1</a:t>
+                      </a:r>
+                    </a:p>
+                  </a:txBody>
+                  <a:tcPr marL="6350" marR="6350" marT="6350" marB="0" anchor="b">
+                    <a:lnL w="3175" cap="flat" cmpd="sng" algn="ctr">
+                      <a:solidFill>
+                        <a:schemeClr val="bg1">
+                          <a:lumMod val="65000"/>
+                        </a:schemeClr>
+                      </a:solidFill>
+                      <a:prstDash val="solid"/>
+                      <a:round/>
+                      <a:headEnd type="none" w="med" len="med"/>
+                      <a:tailEnd type="none" w="med" len="med"/>
+                    </a:lnL>
+                    <a:lnR w="3175" cap="flat" cmpd="sng" algn="ctr">
+                      <a:solidFill>
+                        <a:schemeClr val="bg1">
+                          <a:lumMod val="65000"/>
+                        </a:schemeClr>
+                      </a:solidFill>
+                      <a:prstDash val="solid"/>
+                      <a:round/>
+                      <a:headEnd type="none" w="med" len="med"/>
+                      <a:tailEnd type="none" w="med" len="med"/>
+                    </a:lnR>
+                    <a:lnT w="3175" cap="flat" cmpd="sng" algn="ctr">
+                      <a:solidFill>
+                        <a:schemeClr val="bg1">
+                          <a:lumMod val="65000"/>
+                        </a:schemeClr>
+                      </a:solidFill>
+                      <a:prstDash val="solid"/>
+                      <a:round/>
+                      <a:headEnd type="none" w="med" len="med"/>
+                      <a:tailEnd type="none" w="med" len="med"/>
+                    </a:lnT>
+                    <a:lnB w="3175" cap="flat" cmpd="sng" algn="ctr">
+                      <a:solidFill>
+                        <a:schemeClr val="bg1">
+                          <a:lumMod val="65000"/>
+                        </a:schemeClr>
+                      </a:solidFill>
+                      <a:prstDash val="solid"/>
+                      <a:round/>
+                      <a:headEnd type="none" w="med" len="med"/>
+                      <a:tailEnd type="none" w="med" len="med"/>
+                    </a:lnB>
+                  </a:tcPr>
+                </a:tc>
+                <a:tc>
+                  <a:txBody>
+                    <a:bodyPr/>
+                    <a:lstStyle/>
+                    <a:p>
+                      <a:pPr algn="l" fontAlgn="b">
+                        <a:buNone/>
+                      </a:pPr>
+                      <a:r>
                         <a:rPr lang="en-CA" sz="1200" b="0" i="0" u="none" strike="noStrike" dirty="0">
                           <a:solidFill>
                             <a:srgbClr val="000000"/>
@@ -8923,6 +10239,74 @@
                     <a:lstStyle/>
                     <a:p>
                       <a:pPr algn="ctr" fontAlgn="b">
+                        <a:buNone/>
+                      </a:pPr>
+                      <a:r>
+                        <a:rPr lang="en-CA" sz="1100" b="0" i="0" u="none" strike="noStrike" dirty="0">
+                          <a:solidFill>
+                            <a:srgbClr val="000000"/>
+                          </a:solidFill>
+                          <a:effectLst/>
+                          <a:latin typeface="Courier New" panose="02070309020205020404" pitchFamily="49" charset="0"/>
+                          <a:cs typeface="Courier New" panose="02070309020205020404" pitchFamily="49" charset="0"/>
+                        </a:rPr>
+                        <a:t>Q9NRC8</a:t>
+                      </a:r>
+                    </a:p>
+                  </a:txBody>
+                  <a:tcPr marL="6350" marR="6350" marT="6350" marB="0" anchor="b">
+                    <a:lnL w="3175" cap="flat" cmpd="sng" algn="ctr">
+                      <a:solidFill>
+                        <a:schemeClr val="bg1">
+                          <a:lumMod val="65000"/>
+                        </a:schemeClr>
+                      </a:solidFill>
+                      <a:prstDash val="solid"/>
+                      <a:round/>
+                      <a:headEnd type="none" w="med" len="med"/>
+                      <a:tailEnd type="none" w="med" len="med"/>
+                    </a:lnL>
+                    <a:lnR w="3175" cap="flat" cmpd="sng" algn="ctr">
+                      <a:solidFill>
+                        <a:schemeClr val="bg1">
+                          <a:lumMod val="65000"/>
+                        </a:schemeClr>
+                      </a:solidFill>
+                      <a:prstDash val="solid"/>
+                      <a:round/>
+                      <a:headEnd type="none" w="med" len="med"/>
+                      <a:tailEnd type="none" w="med" len="med"/>
+                    </a:lnR>
+                    <a:lnT w="3175" cap="flat" cmpd="sng" algn="ctr">
+                      <a:solidFill>
+                        <a:schemeClr val="bg1">
+                          <a:lumMod val="65000"/>
+                        </a:schemeClr>
+                      </a:solidFill>
+                      <a:prstDash val="solid"/>
+                      <a:round/>
+                      <a:headEnd type="none" w="med" len="med"/>
+                      <a:tailEnd type="none" w="med" len="med"/>
+                    </a:lnT>
+                    <a:lnB w="3175" cap="flat" cmpd="sng" algn="ctr">
+                      <a:solidFill>
+                        <a:schemeClr val="bg1">
+                          <a:lumMod val="65000"/>
+                        </a:schemeClr>
+                      </a:solidFill>
+                      <a:prstDash val="solid"/>
+                      <a:round/>
+                      <a:headEnd type="none" w="med" len="med"/>
+                      <a:tailEnd type="none" w="med" len="med"/>
+                    </a:lnB>
+                  </a:tcPr>
+                </a:tc>
+                <a:tc>
+                  <a:txBody>
+                    <a:bodyPr/>
+                    <a:lstStyle/>
+                    <a:p>
+                      <a:pPr algn="l" fontAlgn="b">
                         <a:buNone/>
                       </a:pPr>
                       <a:r>
@@ -8998,7 +10382,7 @@
                     <a:bodyPr/>
                     <a:lstStyle/>
                     <a:p>
-                      <a:pPr algn="ctr" fontAlgn="b">
+                      <a:pPr algn="l" fontAlgn="b">
                         <a:buNone/>
                       </a:pPr>
                       <a:r>
@@ -9071,6 +10455,74 @@
                         <a:buNone/>
                       </a:pPr>
                       <a:r>
+                        <a:rPr lang="en-CA" sz="1100" b="0" i="0" u="none" strike="noStrike" dirty="0">
+                          <a:solidFill>
+                            <a:srgbClr val="000000"/>
+                          </a:solidFill>
+                          <a:effectLst/>
+                          <a:latin typeface="Courier New" panose="02070309020205020404" pitchFamily="49" charset="0"/>
+                          <a:cs typeface="Courier New" panose="02070309020205020404" pitchFamily="49" charset="0"/>
+                        </a:rPr>
+                        <a:t>A0A1H0NKS3</a:t>
+                      </a:r>
+                    </a:p>
+                  </a:txBody>
+                  <a:tcPr marL="6350" marR="6350" marT="6350" marB="0" anchor="b">
+                    <a:lnL w="3175" cap="flat" cmpd="sng" algn="ctr">
+                      <a:solidFill>
+                        <a:schemeClr val="bg1">
+                          <a:lumMod val="65000"/>
+                        </a:schemeClr>
+                      </a:solidFill>
+                      <a:prstDash val="solid"/>
+                      <a:round/>
+                      <a:headEnd type="none" w="med" len="med"/>
+                      <a:tailEnd type="none" w="med" len="med"/>
+                    </a:lnL>
+                    <a:lnR w="3175" cap="flat" cmpd="sng" algn="ctr">
+                      <a:solidFill>
+                        <a:schemeClr val="bg1">
+                          <a:lumMod val="65000"/>
+                        </a:schemeClr>
+                      </a:solidFill>
+                      <a:prstDash val="solid"/>
+                      <a:round/>
+                      <a:headEnd type="none" w="med" len="med"/>
+                      <a:tailEnd type="none" w="med" len="med"/>
+                    </a:lnR>
+                    <a:lnT w="3175" cap="flat" cmpd="sng" algn="ctr">
+                      <a:solidFill>
+                        <a:schemeClr val="bg1">
+                          <a:lumMod val="65000"/>
+                        </a:schemeClr>
+                      </a:solidFill>
+                      <a:prstDash val="solid"/>
+                      <a:round/>
+                      <a:headEnd type="none" w="med" len="med"/>
+                      <a:tailEnd type="none" w="med" len="med"/>
+                    </a:lnT>
+                    <a:lnB w="3175" cap="flat" cmpd="sng" algn="ctr">
+                      <a:solidFill>
+                        <a:schemeClr val="bg1">
+                          <a:lumMod val="65000"/>
+                        </a:schemeClr>
+                      </a:solidFill>
+                      <a:prstDash val="solid"/>
+                      <a:round/>
+                      <a:headEnd type="none" w="med" len="med"/>
+                      <a:tailEnd type="none" w="med" len="med"/>
+                    </a:lnB>
+                  </a:tcPr>
+                </a:tc>
+                <a:tc>
+                  <a:txBody>
+                    <a:bodyPr/>
+                    <a:lstStyle/>
+                    <a:p>
+                      <a:pPr algn="l" fontAlgn="b">
+                        <a:buNone/>
+                      </a:pPr>
+                      <a:r>
                         <a:rPr lang="en-CA" sz="1200" b="0" i="0" u="none" strike="noStrike" dirty="0">
                           <a:solidFill>
                             <a:srgbClr val="000000"/>
@@ -9136,6 +10588,74 @@
                     <a:lstStyle/>
                     <a:p>
                       <a:pPr algn="ctr" fontAlgn="b">
+                        <a:buNone/>
+                      </a:pPr>
+                      <a:r>
+                        <a:rPr lang="en-CA" sz="1100" b="0" i="0" u="none" strike="noStrike" dirty="0">
+                          <a:solidFill>
+                            <a:srgbClr val="000000"/>
+                          </a:solidFill>
+                          <a:effectLst/>
+                          <a:latin typeface="Courier New" panose="02070309020205020404" pitchFamily="49" charset="0"/>
+                          <a:cs typeface="Courier New" panose="02070309020205020404" pitchFamily="49" charset="0"/>
+                        </a:rPr>
+                        <a:t>Q8WXG1</a:t>
+                      </a:r>
+                    </a:p>
+                  </a:txBody>
+                  <a:tcPr marL="6350" marR="6350" marT="6350" marB="0" anchor="b">
+                    <a:lnL w="3175" cap="flat" cmpd="sng" algn="ctr">
+                      <a:solidFill>
+                        <a:schemeClr val="bg1">
+                          <a:lumMod val="65000"/>
+                        </a:schemeClr>
+                      </a:solidFill>
+                      <a:prstDash val="solid"/>
+                      <a:round/>
+                      <a:headEnd type="none" w="med" len="med"/>
+                      <a:tailEnd type="none" w="med" len="med"/>
+                    </a:lnL>
+                    <a:lnR w="3175" cap="flat" cmpd="sng" algn="ctr">
+                      <a:solidFill>
+                        <a:schemeClr val="bg1">
+                          <a:lumMod val="65000"/>
+                        </a:schemeClr>
+                      </a:solidFill>
+                      <a:prstDash val="solid"/>
+                      <a:round/>
+                      <a:headEnd type="none" w="med" len="med"/>
+                      <a:tailEnd type="none" w="med" len="med"/>
+                    </a:lnR>
+                    <a:lnT w="3175" cap="flat" cmpd="sng" algn="ctr">
+                      <a:solidFill>
+                        <a:schemeClr val="bg1">
+                          <a:lumMod val="65000"/>
+                        </a:schemeClr>
+                      </a:solidFill>
+                      <a:prstDash val="solid"/>
+                      <a:round/>
+                      <a:headEnd type="none" w="med" len="med"/>
+                      <a:tailEnd type="none" w="med" len="med"/>
+                    </a:lnT>
+                    <a:lnB w="3175" cap="flat" cmpd="sng" algn="ctr">
+                      <a:solidFill>
+                        <a:schemeClr val="bg1">
+                          <a:lumMod val="65000"/>
+                        </a:schemeClr>
+                      </a:solidFill>
+                      <a:prstDash val="solid"/>
+                      <a:round/>
+                      <a:headEnd type="none" w="med" len="med"/>
+                      <a:tailEnd type="none" w="med" len="med"/>
+                    </a:lnB>
+                  </a:tcPr>
+                </a:tc>
+                <a:tc>
+                  <a:txBody>
+                    <a:bodyPr/>
+                    <a:lstStyle/>
+                    <a:p>
+                      <a:pPr algn="l" fontAlgn="b">
                         <a:buNone/>
                       </a:pPr>
                       <a:r>
@@ -9211,7 +10731,7 @@
                     <a:bodyPr/>
                     <a:lstStyle/>
                     <a:p>
-                      <a:pPr algn="ctr" fontAlgn="b">
+                      <a:pPr algn="l" fontAlgn="b">
                         <a:buNone/>
                       </a:pPr>
                       <a:r>
@@ -9284,6 +10804,74 @@
                         <a:buNone/>
                       </a:pPr>
                       <a:r>
+                        <a:rPr lang="en-CA" sz="1100" b="0" i="0" u="none" strike="noStrike" dirty="0">
+                          <a:solidFill>
+                            <a:srgbClr val="000000"/>
+                          </a:solidFill>
+                          <a:effectLst/>
+                          <a:latin typeface="Courier New" panose="02070309020205020404" pitchFamily="49" charset="0"/>
+                          <a:cs typeface="Courier New" panose="02070309020205020404" pitchFamily="49" charset="0"/>
+                        </a:rPr>
+                        <a:t>P0DW49</a:t>
+                      </a:r>
+                    </a:p>
+                  </a:txBody>
+                  <a:tcPr marL="6350" marR="6350" marT="6350" marB="0" anchor="b">
+                    <a:lnL w="3175" cap="flat" cmpd="sng" algn="ctr">
+                      <a:solidFill>
+                        <a:schemeClr val="bg1">
+                          <a:lumMod val="65000"/>
+                        </a:schemeClr>
+                      </a:solidFill>
+                      <a:prstDash val="solid"/>
+                      <a:round/>
+                      <a:headEnd type="none" w="med" len="med"/>
+                      <a:tailEnd type="none" w="med" len="med"/>
+                    </a:lnL>
+                    <a:lnR w="3175" cap="flat" cmpd="sng" algn="ctr">
+                      <a:solidFill>
+                        <a:schemeClr val="bg1">
+                          <a:lumMod val="65000"/>
+                        </a:schemeClr>
+                      </a:solidFill>
+                      <a:prstDash val="solid"/>
+                      <a:round/>
+                      <a:headEnd type="none" w="med" len="med"/>
+                      <a:tailEnd type="none" w="med" len="med"/>
+                    </a:lnR>
+                    <a:lnT w="3175" cap="flat" cmpd="sng" algn="ctr">
+                      <a:solidFill>
+                        <a:schemeClr val="bg1">
+                          <a:lumMod val="65000"/>
+                        </a:schemeClr>
+                      </a:solidFill>
+                      <a:prstDash val="solid"/>
+                      <a:round/>
+                      <a:headEnd type="none" w="med" len="med"/>
+                      <a:tailEnd type="none" w="med" len="med"/>
+                    </a:lnT>
+                    <a:lnB w="3175" cap="flat" cmpd="sng" algn="ctr">
+                      <a:solidFill>
+                        <a:schemeClr val="bg1">
+                          <a:lumMod val="65000"/>
+                        </a:schemeClr>
+                      </a:solidFill>
+                      <a:prstDash val="solid"/>
+                      <a:round/>
+                      <a:headEnd type="none" w="med" len="med"/>
+                      <a:tailEnd type="none" w="med" len="med"/>
+                    </a:lnB>
+                  </a:tcPr>
+                </a:tc>
+                <a:tc>
+                  <a:txBody>
+                    <a:bodyPr/>
+                    <a:lstStyle/>
+                    <a:p>
+                      <a:pPr algn="l" fontAlgn="b">
+                        <a:buNone/>
+                      </a:pPr>
+                      <a:r>
                         <a:rPr lang="en-CA" sz="1200" b="0" i="0" u="none" strike="noStrike" dirty="0">
                           <a:solidFill>
                             <a:srgbClr val="000000"/>
@@ -9349,6 +10937,74 @@
                     <a:lstStyle/>
                     <a:p>
                       <a:pPr algn="ctr" fontAlgn="b">
+                        <a:buNone/>
+                      </a:pPr>
+                      <a:r>
+                        <a:rPr lang="en-CA" sz="1100" b="0" i="0" u="none" strike="noStrike" dirty="0">
+                          <a:solidFill>
+                            <a:srgbClr val="000000"/>
+                          </a:solidFill>
+                          <a:effectLst/>
+                          <a:latin typeface="Courier New" panose="02070309020205020404" pitchFamily="49" charset="0"/>
+                          <a:cs typeface="Courier New" panose="02070309020205020404" pitchFamily="49" charset="0"/>
+                        </a:rPr>
+                        <a:t>Q8WXG1</a:t>
+                      </a:r>
+                    </a:p>
+                  </a:txBody>
+                  <a:tcPr marL="6350" marR="6350" marT="6350" marB="0" anchor="b">
+                    <a:lnL w="3175" cap="flat" cmpd="sng" algn="ctr">
+                      <a:solidFill>
+                        <a:schemeClr val="bg1">
+                          <a:lumMod val="65000"/>
+                        </a:schemeClr>
+                      </a:solidFill>
+                      <a:prstDash val="solid"/>
+                      <a:round/>
+                      <a:headEnd type="none" w="med" len="med"/>
+                      <a:tailEnd type="none" w="med" len="med"/>
+                    </a:lnL>
+                    <a:lnR w="3175" cap="flat" cmpd="sng" algn="ctr">
+                      <a:solidFill>
+                        <a:schemeClr val="bg1">
+                          <a:lumMod val="65000"/>
+                        </a:schemeClr>
+                      </a:solidFill>
+                      <a:prstDash val="solid"/>
+                      <a:round/>
+                      <a:headEnd type="none" w="med" len="med"/>
+                      <a:tailEnd type="none" w="med" len="med"/>
+                    </a:lnR>
+                    <a:lnT w="3175" cap="flat" cmpd="sng" algn="ctr">
+                      <a:solidFill>
+                        <a:schemeClr val="bg1">
+                          <a:lumMod val="65000"/>
+                        </a:schemeClr>
+                      </a:solidFill>
+                      <a:prstDash val="solid"/>
+                      <a:round/>
+                      <a:headEnd type="none" w="med" len="med"/>
+                      <a:tailEnd type="none" w="med" len="med"/>
+                    </a:lnT>
+                    <a:lnB w="3175" cap="flat" cmpd="sng" algn="ctr">
+                      <a:solidFill>
+                        <a:schemeClr val="bg1">
+                          <a:lumMod val="65000"/>
+                        </a:schemeClr>
+                      </a:solidFill>
+                      <a:prstDash val="solid"/>
+                      <a:round/>
+                      <a:headEnd type="none" w="med" len="med"/>
+                      <a:tailEnd type="none" w="med" len="med"/>
+                    </a:lnB>
+                  </a:tcPr>
+                </a:tc>
+                <a:tc>
+                  <a:txBody>
+                    <a:bodyPr/>
+                    <a:lstStyle/>
+                    <a:p>
+                      <a:pPr algn="l" fontAlgn="b">
                         <a:buNone/>
                       </a:pPr>
                       <a:r>
@@ -9424,7 +11080,7 @@
                     <a:bodyPr/>
                     <a:lstStyle/>
                     <a:p>
-                      <a:pPr algn="ctr" fontAlgn="b">
+                      <a:pPr algn="l" fontAlgn="b">
                         <a:buNone/>
                       </a:pPr>
                       <a:r>
@@ -9497,6 +11153,74 @@
                         <a:buNone/>
                       </a:pPr>
                       <a:r>
+                        <a:rPr lang="en-CA" sz="1100" b="0" i="0" u="none" strike="noStrike" dirty="0">
+                          <a:solidFill>
+                            <a:srgbClr val="000000"/>
+                          </a:solidFill>
+                          <a:effectLst/>
+                          <a:latin typeface="Courier New" panose="02070309020205020404" pitchFamily="49" charset="0"/>
+                          <a:cs typeface="Courier New" panose="02070309020205020404" pitchFamily="49" charset="0"/>
+                        </a:rPr>
+                        <a:t>D5EID4</a:t>
+                      </a:r>
+                    </a:p>
+                  </a:txBody>
+                  <a:tcPr marL="6350" marR="6350" marT="6350" marB="0" anchor="b">
+                    <a:lnL w="3175" cap="flat" cmpd="sng" algn="ctr">
+                      <a:solidFill>
+                        <a:schemeClr val="bg1">
+                          <a:lumMod val="65000"/>
+                        </a:schemeClr>
+                      </a:solidFill>
+                      <a:prstDash val="solid"/>
+                      <a:round/>
+                      <a:headEnd type="none" w="med" len="med"/>
+                      <a:tailEnd type="none" w="med" len="med"/>
+                    </a:lnL>
+                    <a:lnR w="3175" cap="flat" cmpd="sng" algn="ctr">
+                      <a:solidFill>
+                        <a:schemeClr val="bg1">
+                          <a:lumMod val="65000"/>
+                        </a:schemeClr>
+                      </a:solidFill>
+                      <a:prstDash val="solid"/>
+                      <a:round/>
+                      <a:headEnd type="none" w="med" len="med"/>
+                      <a:tailEnd type="none" w="med" len="med"/>
+                    </a:lnR>
+                    <a:lnT w="3175" cap="flat" cmpd="sng" algn="ctr">
+                      <a:solidFill>
+                        <a:schemeClr val="bg1">
+                          <a:lumMod val="65000"/>
+                        </a:schemeClr>
+                      </a:solidFill>
+                      <a:prstDash val="solid"/>
+                      <a:round/>
+                      <a:headEnd type="none" w="med" len="med"/>
+                      <a:tailEnd type="none" w="med" len="med"/>
+                    </a:lnT>
+                    <a:lnB w="3175" cap="flat" cmpd="sng" algn="ctr">
+                      <a:solidFill>
+                        <a:schemeClr val="bg1">
+                          <a:lumMod val="65000"/>
+                        </a:schemeClr>
+                      </a:solidFill>
+                      <a:prstDash val="solid"/>
+                      <a:round/>
+                      <a:headEnd type="none" w="med" len="med"/>
+                      <a:tailEnd type="none" w="med" len="med"/>
+                    </a:lnB>
+                  </a:tcPr>
+                </a:tc>
+                <a:tc>
+                  <a:txBody>
+                    <a:bodyPr/>
+                    <a:lstStyle/>
+                    <a:p>
+                      <a:pPr algn="l" fontAlgn="b">
+                        <a:buNone/>
+                      </a:pPr>
+                      <a:r>
                         <a:rPr lang="en-CA" sz="1200" b="0" i="0" u="none" strike="noStrike" dirty="0">
                           <a:solidFill>
                             <a:srgbClr val="000000"/>
@@ -9562,6 +11286,74 @@
                     <a:lstStyle/>
                     <a:p>
                       <a:pPr algn="ctr" fontAlgn="b">
+                        <a:buNone/>
+                      </a:pPr>
+                      <a:r>
+                        <a:rPr lang="en-CA" sz="1100" b="0" i="0" u="none" strike="noStrike" dirty="0">
+                          <a:solidFill>
+                            <a:srgbClr val="000000"/>
+                          </a:solidFill>
+                          <a:effectLst/>
+                          <a:latin typeface="Courier New" panose="02070309020205020404" pitchFamily="49" charset="0"/>
+                          <a:cs typeface="Courier New" panose="02070309020205020404" pitchFamily="49" charset="0"/>
+                        </a:rPr>
+                        <a:t>Q8WXG1</a:t>
+                      </a:r>
+                    </a:p>
+                  </a:txBody>
+                  <a:tcPr marL="6350" marR="6350" marT="6350" marB="0" anchor="b">
+                    <a:lnL w="3175" cap="flat" cmpd="sng" algn="ctr">
+                      <a:solidFill>
+                        <a:schemeClr val="bg1">
+                          <a:lumMod val="65000"/>
+                        </a:schemeClr>
+                      </a:solidFill>
+                      <a:prstDash val="solid"/>
+                      <a:round/>
+                      <a:headEnd type="none" w="med" len="med"/>
+                      <a:tailEnd type="none" w="med" len="med"/>
+                    </a:lnL>
+                    <a:lnR w="3175" cap="flat" cmpd="sng" algn="ctr">
+                      <a:solidFill>
+                        <a:schemeClr val="bg1">
+                          <a:lumMod val="65000"/>
+                        </a:schemeClr>
+                      </a:solidFill>
+                      <a:prstDash val="solid"/>
+                      <a:round/>
+                      <a:headEnd type="none" w="med" len="med"/>
+                      <a:tailEnd type="none" w="med" len="med"/>
+                    </a:lnR>
+                    <a:lnT w="3175" cap="flat" cmpd="sng" algn="ctr">
+                      <a:solidFill>
+                        <a:schemeClr val="bg1">
+                          <a:lumMod val="65000"/>
+                        </a:schemeClr>
+                      </a:solidFill>
+                      <a:prstDash val="solid"/>
+                      <a:round/>
+                      <a:headEnd type="none" w="med" len="med"/>
+                      <a:tailEnd type="none" w="med" len="med"/>
+                    </a:lnT>
+                    <a:lnB w="3175" cap="flat" cmpd="sng" algn="ctr">
+                      <a:solidFill>
+                        <a:schemeClr val="bg1">
+                          <a:lumMod val="65000"/>
+                        </a:schemeClr>
+                      </a:solidFill>
+                      <a:prstDash val="solid"/>
+                      <a:round/>
+                      <a:headEnd type="none" w="med" len="med"/>
+                      <a:tailEnd type="none" w="med" len="med"/>
+                    </a:lnB>
+                  </a:tcPr>
+                </a:tc>
+                <a:tc>
+                  <a:txBody>
+                    <a:bodyPr/>
+                    <a:lstStyle/>
+                    <a:p>
+                      <a:pPr algn="l" fontAlgn="b">
                         <a:buNone/>
                       </a:pPr>
                       <a:r>
@@ -9637,7 +11429,7 @@
                     <a:bodyPr/>
                     <a:lstStyle/>
                     <a:p>
-                      <a:pPr algn="ctr" fontAlgn="b">
+                      <a:pPr algn="l" fontAlgn="b">
                         <a:buNone/>
                       </a:pPr>
                       <a:r>
@@ -9710,6 +11502,74 @@
                         <a:buNone/>
                       </a:pPr>
                       <a:r>
+                        <a:rPr lang="en-CA" sz="1100" b="0" i="0" u="none" strike="noStrike" dirty="0">
+                          <a:solidFill>
+                            <a:srgbClr val="000000"/>
+                          </a:solidFill>
+                          <a:effectLst/>
+                          <a:latin typeface="Courier New" panose="02070309020205020404" pitchFamily="49" charset="0"/>
+                          <a:cs typeface="Courier New" panose="02070309020205020404" pitchFamily="49" charset="0"/>
+                        </a:rPr>
+                        <a:t>P0DW52</a:t>
+                      </a:r>
+                    </a:p>
+                  </a:txBody>
+                  <a:tcPr marL="6350" marR="6350" marT="6350" marB="0" anchor="b">
+                    <a:lnL w="3175" cap="flat" cmpd="sng" algn="ctr">
+                      <a:solidFill>
+                        <a:schemeClr val="bg1">
+                          <a:lumMod val="65000"/>
+                        </a:schemeClr>
+                      </a:solidFill>
+                      <a:prstDash val="solid"/>
+                      <a:round/>
+                      <a:headEnd type="none" w="med" len="med"/>
+                      <a:tailEnd type="none" w="med" len="med"/>
+                    </a:lnL>
+                    <a:lnR w="3175" cap="flat" cmpd="sng" algn="ctr">
+                      <a:solidFill>
+                        <a:schemeClr val="bg1">
+                          <a:lumMod val="65000"/>
+                        </a:schemeClr>
+                      </a:solidFill>
+                      <a:prstDash val="solid"/>
+                      <a:round/>
+                      <a:headEnd type="none" w="med" len="med"/>
+                      <a:tailEnd type="none" w="med" len="med"/>
+                    </a:lnR>
+                    <a:lnT w="3175" cap="flat" cmpd="sng" algn="ctr">
+                      <a:solidFill>
+                        <a:schemeClr val="bg1">
+                          <a:lumMod val="65000"/>
+                        </a:schemeClr>
+                      </a:solidFill>
+                      <a:prstDash val="solid"/>
+                      <a:round/>
+                      <a:headEnd type="none" w="med" len="med"/>
+                      <a:tailEnd type="none" w="med" len="med"/>
+                    </a:lnT>
+                    <a:lnB w="3175" cap="flat" cmpd="sng" algn="ctr">
+                      <a:solidFill>
+                        <a:schemeClr val="bg1">
+                          <a:lumMod val="65000"/>
+                        </a:schemeClr>
+                      </a:solidFill>
+                      <a:prstDash val="solid"/>
+                      <a:round/>
+                      <a:headEnd type="none" w="med" len="med"/>
+                      <a:tailEnd type="none" w="med" len="med"/>
+                    </a:lnB>
+                  </a:tcPr>
+                </a:tc>
+                <a:tc>
+                  <a:txBody>
+                    <a:bodyPr/>
+                    <a:lstStyle/>
+                    <a:p>
+                      <a:pPr algn="l" fontAlgn="b">
+                        <a:buNone/>
+                      </a:pPr>
+                      <a:r>
                         <a:rPr lang="en-CA" sz="1200" b="0" i="0" u="none" strike="noStrike" dirty="0">
                           <a:solidFill>
                             <a:srgbClr val="000000"/>
@@ -9775,6 +11635,74 @@
                     <a:lstStyle/>
                     <a:p>
                       <a:pPr algn="ctr" fontAlgn="b">
+                        <a:buNone/>
+                      </a:pPr>
+                      <a:r>
+                        <a:rPr lang="en-CA" sz="1100" b="0" i="0" u="none" strike="noStrike" dirty="0">
+                          <a:solidFill>
+                            <a:srgbClr val="000000"/>
+                          </a:solidFill>
+                          <a:effectLst/>
+                          <a:latin typeface="Courier New" panose="02070309020205020404" pitchFamily="49" charset="0"/>
+                          <a:cs typeface="Courier New" panose="02070309020205020404" pitchFamily="49" charset="0"/>
+                        </a:rPr>
+                        <a:t>Q8WXG1</a:t>
+                      </a:r>
+                    </a:p>
+                  </a:txBody>
+                  <a:tcPr marL="6350" marR="6350" marT="6350" marB="0" anchor="b">
+                    <a:lnL w="3175" cap="flat" cmpd="sng" algn="ctr">
+                      <a:solidFill>
+                        <a:schemeClr val="bg1">
+                          <a:lumMod val="65000"/>
+                        </a:schemeClr>
+                      </a:solidFill>
+                      <a:prstDash val="solid"/>
+                      <a:round/>
+                      <a:headEnd type="none" w="med" len="med"/>
+                      <a:tailEnd type="none" w="med" len="med"/>
+                    </a:lnL>
+                    <a:lnR w="3175" cap="flat" cmpd="sng" algn="ctr">
+                      <a:solidFill>
+                        <a:schemeClr val="bg1">
+                          <a:lumMod val="65000"/>
+                        </a:schemeClr>
+                      </a:solidFill>
+                      <a:prstDash val="solid"/>
+                      <a:round/>
+                      <a:headEnd type="none" w="med" len="med"/>
+                      <a:tailEnd type="none" w="med" len="med"/>
+                    </a:lnR>
+                    <a:lnT w="3175" cap="flat" cmpd="sng" algn="ctr">
+                      <a:solidFill>
+                        <a:schemeClr val="bg1">
+                          <a:lumMod val="65000"/>
+                        </a:schemeClr>
+                      </a:solidFill>
+                      <a:prstDash val="solid"/>
+                      <a:round/>
+                      <a:headEnd type="none" w="med" len="med"/>
+                      <a:tailEnd type="none" w="med" len="med"/>
+                    </a:lnT>
+                    <a:lnB w="3175" cap="flat" cmpd="sng" algn="ctr">
+                      <a:solidFill>
+                        <a:schemeClr val="bg1">
+                          <a:lumMod val="65000"/>
+                        </a:schemeClr>
+                      </a:solidFill>
+                      <a:prstDash val="solid"/>
+                      <a:round/>
+                      <a:headEnd type="none" w="med" len="med"/>
+                      <a:tailEnd type="none" w="med" len="med"/>
+                    </a:lnB>
+                  </a:tcPr>
+                </a:tc>
+                <a:tc>
+                  <a:txBody>
+                    <a:bodyPr/>
+                    <a:lstStyle/>
+                    <a:p>
+                      <a:pPr algn="l" fontAlgn="b">
                         <a:buNone/>
                       </a:pPr>
                       <a:r>
@@ -9850,7 +11778,7 @@
                     <a:bodyPr/>
                     <a:lstStyle/>
                     <a:p>
-                      <a:pPr algn="ctr" fontAlgn="b">
+                      <a:pPr algn="l" fontAlgn="b">
                         <a:buNone/>
                       </a:pPr>
                       <a:r>
@@ -9923,6 +11851,74 @@
                         <a:buNone/>
                       </a:pPr>
                       <a:r>
+                        <a:rPr lang="en-CA" sz="1100" b="0" i="0" u="none" strike="noStrike" dirty="0">
+                          <a:solidFill>
+                            <a:srgbClr val="000000"/>
+                          </a:solidFill>
+                          <a:effectLst/>
+                          <a:latin typeface="Courier New" panose="02070309020205020404" pitchFamily="49" charset="0"/>
+                          <a:cs typeface="Courier New" panose="02070309020205020404" pitchFamily="49" charset="0"/>
+                        </a:rPr>
+                        <a:t>A0A1S1YUU1</a:t>
+                      </a:r>
+                    </a:p>
+                  </a:txBody>
+                  <a:tcPr marL="6350" marR="6350" marT="6350" marB="0" anchor="b">
+                    <a:lnL w="3175" cap="flat" cmpd="sng" algn="ctr">
+                      <a:solidFill>
+                        <a:schemeClr val="bg1">
+                          <a:lumMod val="65000"/>
+                        </a:schemeClr>
+                      </a:solidFill>
+                      <a:prstDash val="solid"/>
+                      <a:round/>
+                      <a:headEnd type="none" w="med" len="med"/>
+                      <a:tailEnd type="none" w="med" len="med"/>
+                    </a:lnL>
+                    <a:lnR w="3175" cap="flat" cmpd="sng" algn="ctr">
+                      <a:solidFill>
+                        <a:schemeClr val="bg1">
+                          <a:lumMod val="65000"/>
+                        </a:schemeClr>
+                      </a:solidFill>
+                      <a:prstDash val="solid"/>
+                      <a:round/>
+                      <a:headEnd type="none" w="med" len="med"/>
+                      <a:tailEnd type="none" w="med" len="med"/>
+                    </a:lnR>
+                    <a:lnT w="3175" cap="flat" cmpd="sng" algn="ctr">
+                      <a:solidFill>
+                        <a:schemeClr val="bg1">
+                          <a:lumMod val="65000"/>
+                        </a:schemeClr>
+                      </a:solidFill>
+                      <a:prstDash val="solid"/>
+                      <a:round/>
+                      <a:headEnd type="none" w="med" len="med"/>
+                      <a:tailEnd type="none" w="med" len="med"/>
+                    </a:lnT>
+                    <a:lnB w="3175" cap="flat" cmpd="sng" algn="ctr">
+                      <a:solidFill>
+                        <a:schemeClr val="bg1">
+                          <a:lumMod val="65000"/>
+                        </a:schemeClr>
+                      </a:solidFill>
+                      <a:prstDash val="solid"/>
+                      <a:round/>
+                      <a:headEnd type="none" w="med" len="med"/>
+                      <a:tailEnd type="none" w="med" len="med"/>
+                    </a:lnB>
+                  </a:tcPr>
+                </a:tc>
+                <a:tc>
+                  <a:txBody>
+                    <a:bodyPr/>
+                    <a:lstStyle/>
+                    <a:p>
+                      <a:pPr algn="l" fontAlgn="b">
+                        <a:buNone/>
+                      </a:pPr>
+                      <a:r>
                         <a:rPr lang="en-CA" sz="1200" b="0" i="0" u="none" strike="noStrike" dirty="0">
                           <a:solidFill>
                             <a:srgbClr val="000000"/>
@@ -9988,6 +11984,74 @@
                     <a:lstStyle/>
                     <a:p>
                       <a:pPr algn="ctr" fontAlgn="b">
+                        <a:buNone/>
+                      </a:pPr>
+                      <a:r>
+                        <a:rPr lang="en-CA" sz="1100" b="0" i="0" u="none" strike="noStrike" dirty="0">
+                          <a:solidFill>
+                            <a:srgbClr val="000000"/>
+                          </a:solidFill>
+                          <a:effectLst/>
+                          <a:latin typeface="Courier New" panose="02070309020205020404" pitchFamily="49" charset="0"/>
+                          <a:cs typeface="Courier New" panose="02070309020205020404" pitchFamily="49" charset="0"/>
+                        </a:rPr>
+                        <a:t>Q8WXG1</a:t>
+                      </a:r>
+                    </a:p>
+                  </a:txBody>
+                  <a:tcPr marL="6350" marR="6350" marT="6350" marB="0" anchor="b">
+                    <a:lnL w="3175" cap="flat" cmpd="sng" algn="ctr">
+                      <a:solidFill>
+                        <a:schemeClr val="bg1">
+                          <a:lumMod val="65000"/>
+                        </a:schemeClr>
+                      </a:solidFill>
+                      <a:prstDash val="solid"/>
+                      <a:round/>
+                      <a:headEnd type="none" w="med" len="med"/>
+                      <a:tailEnd type="none" w="med" len="med"/>
+                    </a:lnL>
+                    <a:lnR w="3175" cap="flat" cmpd="sng" algn="ctr">
+                      <a:solidFill>
+                        <a:schemeClr val="bg1">
+                          <a:lumMod val="65000"/>
+                        </a:schemeClr>
+                      </a:solidFill>
+                      <a:prstDash val="solid"/>
+                      <a:round/>
+                      <a:headEnd type="none" w="med" len="med"/>
+                      <a:tailEnd type="none" w="med" len="med"/>
+                    </a:lnR>
+                    <a:lnT w="3175" cap="flat" cmpd="sng" algn="ctr">
+                      <a:solidFill>
+                        <a:schemeClr val="bg1">
+                          <a:lumMod val="65000"/>
+                        </a:schemeClr>
+                      </a:solidFill>
+                      <a:prstDash val="solid"/>
+                      <a:round/>
+                      <a:headEnd type="none" w="med" len="med"/>
+                      <a:tailEnd type="none" w="med" len="med"/>
+                    </a:lnT>
+                    <a:lnB w="3175" cap="flat" cmpd="sng" algn="ctr">
+                      <a:solidFill>
+                        <a:schemeClr val="bg1">
+                          <a:lumMod val="65000"/>
+                        </a:schemeClr>
+                      </a:solidFill>
+                      <a:prstDash val="solid"/>
+                      <a:round/>
+                      <a:headEnd type="none" w="med" len="med"/>
+                      <a:tailEnd type="none" w="med" len="med"/>
+                    </a:lnB>
+                  </a:tcPr>
+                </a:tc>
+                <a:tc>
+                  <a:txBody>
+                    <a:bodyPr/>
+                    <a:lstStyle/>
+                    <a:p>
+                      <a:pPr algn="l" fontAlgn="b">
                         <a:buNone/>
                       </a:pPr>
                       <a:r>
@@ -10063,7 +12127,7 @@
                     <a:bodyPr/>
                     <a:lstStyle/>
                     <a:p>
-                      <a:pPr algn="ctr" fontAlgn="b">
+                      <a:pPr algn="l" fontAlgn="b">
                         <a:buNone/>
                       </a:pPr>
                       <a:r>
@@ -10136,6 +12200,74 @@
                         <a:buNone/>
                       </a:pPr>
                       <a:r>
+                        <a:rPr lang="en-CA" sz="1100" b="0" i="0" u="none" strike="noStrike" dirty="0">
+                          <a:solidFill>
+                            <a:srgbClr val="000000"/>
+                          </a:solidFill>
+                          <a:effectLst/>
+                          <a:latin typeface="Courier New" panose="02070309020205020404" pitchFamily="49" charset="0"/>
+                          <a:cs typeface="Courier New" panose="02070309020205020404" pitchFamily="49" charset="0"/>
+                        </a:rPr>
+                        <a:t>A0A110A2W7</a:t>
+                      </a:r>
+                    </a:p>
+                  </a:txBody>
+                  <a:tcPr marL="6350" marR="6350" marT="6350" marB="0" anchor="b">
+                    <a:lnL w="3175" cap="flat" cmpd="sng" algn="ctr">
+                      <a:solidFill>
+                        <a:schemeClr val="bg1">
+                          <a:lumMod val="65000"/>
+                        </a:schemeClr>
+                      </a:solidFill>
+                      <a:prstDash val="solid"/>
+                      <a:round/>
+                      <a:headEnd type="none" w="med" len="med"/>
+                      <a:tailEnd type="none" w="med" len="med"/>
+                    </a:lnL>
+                    <a:lnR w="3175" cap="flat" cmpd="sng" algn="ctr">
+                      <a:solidFill>
+                        <a:schemeClr val="bg1">
+                          <a:lumMod val="65000"/>
+                        </a:schemeClr>
+                      </a:solidFill>
+                      <a:prstDash val="solid"/>
+                      <a:round/>
+                      <a:headEnd type="none" w="med" len="med"/>
+                      <a:tailEnd type="none" w="med" len="med"/>
+                    </a:lnR>
+                    <a:lnT w="3175" cap="flat" cmpd="sng" algn="ctr">
+                      <a:solidFill>
+                        <a:schemeClr val="bg1">
+                          <a:lumMod val="65000"/>
+                        </a:schemeClr>
+                      </a:solidFill>
+                      <a:prstDash val="solid"/>
+                      <a:round/>
+                      <a:headEnd type="none" w="med" len="med"/>
+                      <a:tailEnd type="none" w="med" len="med"/>
+                    </a:lnT>
+                    <a:lnB w="3175" cap="flat" cmpd="sng" algn="ctr">
+                      <a:solidFill>
+                        <a:schemeClr val="bg1">
+                          <a:lumMod val="65000"/>
+                        </a:schemeClr>
+                      </a:solidFill>
+                      <a:prstDash val="solid"/>
+                      <a:round/>
+                      <a:headEnd type="none" w="med" len="med"/>
+                      <a:tailEnd type="none" w="med" len="med"/>
+                    </a:lnB>
+                  </a:tcPr>
+                </a:tc>
+                <a:tc>
+                  <a:txBody>
+                    <a:bodyPr/>
+                    <a:lstStyle/>
+                    <a:p>
+                      <a:pPr algn="l" fontAlgn="b">
+                        <a:buNone/>
+                      </a:pPr>
+                      <a:r>
                         <a:rPr lang="en-CA" sz="1200" b="0" i="0" u="none" strike="noStrike" dirty="0">
                           <a:solidFill>
                             <a:srgbClr val="000000"/>
@@ -10201,6 +12333,74 @@
                     <a:lstStyle/>
                     <a:p>
                       <a:pPr algn="ctr" fontAlgn="b">
+                        <a:buNone/>
+                      </a:pPr>
+                      <a:r>
+                        <a:rPr lang="en-CA" sz="1100" b="0" i="0" u="none" strike="noStrike" dirty="0">
+                          <a:solidFill>
+                            <a:srgbClr val="000000"/>
+                          </a:solidFill>
+                          <a:effectLst/>
+                          <a:latin typeface="Courier New" panose="02070309020205020404" pitchFamily="49" charset="0"/>
+                          <a:cs typeface="Courier New" panose="02070309020205020404" pitchFamily="49" charset="0"/>
+                        </a:rPr>
+                        <a:t>Q8WXG1</a:t>
+                      </a:r>
+                    </a:p>
+                  </a:txBody>
+                  <a:tcPr marL="6350" marR="6350" marT="6350" marB="0" anchor="b">
+                    <a:lnL w="3175" cap="flat" cmpd="sng" algn="ctr">
+                      <a:solidFill>
+                        <a:schemeClr val="bg1">
+                          <a:lumMod val="65000"/>
+                        </a:schemeClr>
+                      </a:solidFill>
+                      <a:prstDash val="solid"/>
+                      <a:round/>
+                      <a:headEnd type="none" w="med" len="med"/>
+                      <a:tailEnd type="none" w="med" len="med"/>
+                    </a:lnL>
+                    <a:lnR w="3175" cap="flat" cmpd="sng" algn="ctr">
+                      <a:solidFill>
+                        <a:schemeClr val="bg1">
+                          <a:lumMod val="65000"/>
+                        </a:schemeClr>
+                      </a:solidFill>
+                      <a:prstDash val="solid"/>
+                      <a:round/>
+                      <a:headEnd type="none" w="med" len="med"/>
+                      <a:tailEnd type="none" w="med" len="med"/>
+                    </a:lnR>
+                    <a:lnT w="3175" cap="flat" cmpd="sng" algn="ctr">
+                      <a:solidFill>
+                        <a:schemeClr val="bg1">
+                          <a:lumMod val="65000"/>
+                        </a:schemeClr>
+                      </a:solidFill>
+                      <a:prstDash val="solid"/>
+                      <a:round/>
+                      <a:headEnd type="none" w="med" len="med"/>
+                      <a:tailEnd type="none" w="med" len="med"/>
+                    </a:lnT>
+                    <a:lnB w="3175" cap="flat" cmpd="sng" algn="ctr">
+                      <a:solidFill>
+                        <a:schemeClr val="bg1">
+                          <a:lumMod val="65000"/>
+                        </a:schemeClr>
+                      </a:solidFill>
+                      <a:prstDash val="solid"/>
+                      <a:round/>
+                      <a:headEnd type="none" w="med" len="med"/>
+                      <a:tailEnd type="none" w="med" len="med"/>
+                    </a:lnB>
+                  </a:tcPr>
+                </a:tc>
+                <a:tc>
+                  <a:txBody>
+                    <a:bodyPr/>
+                    <a:lstStyle/>
+                    <a:p>
+                      <a:pPr algn="l" fontAlgn="b">
                         <a:buNone/>
                       </a:pPr>
                       <a:r>
@@ -10276,7 +12476,7 @@
                     <a:bodyPr/>
                     <a:lstStyle/>
                     <a:p>
-                      <a:pPr algn="ctr" fontAlgn="b">
+                      <a:pPr algn="l" fontAlgn="b">
                         <a:buNone/>
                       </a:pPr>
                       <a:r>
@@ -10349,6 +12549,74 @@
                         <a:buNone/>
                       </a:pPr>
                       <a:r>
+                        <a:rPr lang="en-CA" sz="1100" b="0" i="0" u="none" strike="noStrike" dirty="0">
+                          <a:solidFill>
+                            <a:srgbClr val="000000"/>
+                          </a:solidFill>
+                          <a:effectLst/>
+                          <a:latin typeface="Courier New" panose="02070309020205020404" pitchFamily="49" charset="0"/>
+                          <a:cs typeface="Courier New" panose="02070309020205020404" pitchFamily="49" charset="0"/>
+                        </a:rPr>
+                        <a:t>A0A1M7D0R2</a:t>
+                      </a:r>
+                    </a:p>
+                  </a:txBody>
+                  <a:tcPr marL="6350" marR="6350" marT="6350" marB="0" anchor="b">
+                    <a:lnL w="3175" cap="flat" cmpd="sng" algn="ctr">
+                      <a:solidFill>
+                        <a:schemeClr val="bg1">
+                          <a:lumMod val="65000"/>
+                        </a:schemeClr>
+                      </a:solidFill>
+                      <a:prstDash val="solid"/>
+                      <a:round/>
+                      <a:headEnd type="none" w="med" len="med"/>
+                      <a:tailEnd type="none" w="med" len="med"/>
+                    </a:lnL>
+                    <a:lnR w="3175" cap="flat" cmpd="sng" algn="ctr">
+                      <a:solidFill>
+                        <a:schemeClr val="bg1">
+                          <a:lumMod val="65000"/>
+                        </a:schemeClr>
+                      </a:solidFill>
+                      <a:prstDash val="solid"/>
+                      <a:round/>
+                      <a:headEnd type="none" w="med" len="med"/>
+                      <a:tailEnd type="none" w="med" len="med"/>
+                    </a:lnR>
+                    <a:lnT w="3175" cap="flat" cmpd="sng" algn="ctr">
+                      <a:solidFill>
+                        <a:schemeClr val="bg1">
+                          <a:lumMod val="65000"/>
+                        </a:schemeClr>
+                      </a:solidFill>
+                      <a:prstDash val="solid"/>
+                      <a:round/>
+                      <a:headEnd type="none" w="med" len="med"/>
+                      <a:tailEnd type="none" w="med" len="med"/>
+                    </a:lnT>
+                    <a:lnB w="3175" cap="flat" cmpd="sng" algn="ctr">
+                      <a:solidFill>
+                        <a:schemeClr val="bg1">
+                          <a:lumMod val="65000"/>
+                        </a:schemeClr>
+                      </a:solidFill>
+                      <a:prstDash val="solid"/>
+                      <a:round/>
+                      <a:headEnd type="none" w="med" len="med"/>
+                      <a:tailEnd type="none" w="med" len="med"/>
+                    </a:lnB>
+                  </a:tcPr>
+                </a:tc>
+                <a:tc>
+                  <a:txBody>
+                    <a:bodyPr/>
+                    <a:lstStyle/>
+                    <a:p>
+                      <a:pPr algn="l" fontAlgn="b">
+                        <a:buNone/>
+                      </a:pPr>
+                      <a:r>
                         <a:rPr lang="en-CA" sz="1200" b="0" i="0" u="none" strike="noStrike" dirty="0">
                           <a:solidFill>
                             <a:srgbClr val="000000"/>
@@ -10414,6 +12682,74 @@
                     <a:lstStyle/>
                     <a:p>
                       <a:pPr algn="ctr" fontAlgn="b">
+                        <a:buNone/>
+                      </a:pPr>
+                      <a:r>
+                        <a:rPr lang="en-CA" sz="1100" b="0" i="0" u="none" strike="noStrike" dirty="0">
+                          <a:solidFill>
+                            <a:srgbClr val="000000"/>
+                          </a:solidFill>
+                          <a:effectLst/>
+                          <a:latin typeface="Courier New" panose="02070309020205020404" pitchFamily="49" charset="0"/>
+                          <a:cs typeface="Courier New" panose="02070309020205020404" pitchFamily="49" charset="0"/>
+                        </a:rPr>
+                        <a:t>Q8WXG1</a:t>
+                      </a:r>
+                    </a:p>
+                  </a:txBody>
+                  <a:tcPr marL="6350" marR="6350" marT="6350" marB="0" anchor="b">
+                    <a:lnL w="3175" cap="flat" cmpd="sng" algn="ctr">
+                      <a:solidFill>
+                        <a:schemeClr val="bg1">
+                          <a:lumMod val="65000"/>
+                        </a:schemeClr>
+                      </a:solidFill>
+                      <a:prstDash val="solid"/>
+                      <a:round/>
+                      <a:headEnd type="none" w="med" len="med"/>
+                      <a:tailEnd type="none" w="med" len="med"/>
+                    </a:lnL>
+                    <a:lnR w="3175" cap="flat" cmpd="sng" algn="ctr">
+                      <a:solidFill>
+                        <a:schemeClr val="bg1">
+                          <a:lumMod val="65000"/>
+                        </a:schemeClr>
+                      </a:solidFill>
+                      <a:prstDash val="solid"/>
+                      <a:round/>
+                      <a:headEnd type="none" w="med" len="med"/>
+                      <a:tailEnd type="none" w="med" len="med"/>
+                    </a:lnR>
+                    <a:lnT w="3175" cap="flat" cmpd="sng" algn="ctr">
+                      <a:solidFill>
+                        <a:schemeClr val="bg1">
+                          <a:lumMod val="65000"/>
+                        </a:schemeClr>
+                      </a:solidFill>
+                      <a:prstDash val="solid"/>
+                      <a:round/>
+                      <a:headEnd type="none" w="med" len="med"/>
+                      <a:tailEnd type="none" w="med" len="med"/>
+                    </a:lnT>
+                    <a:lnB w="3175" cap="flat" cmpd="sng" algn="ctr">
+                      <a:solidFill>
+                        <a:schemeClr val="bg1">
+                          <a:lumMod val="65000"/>
+                        </a:schemeClr>
+                      </a:solidFill>
+                      <a:prstDash val="solid"/>
+                      <a:round/>
+                      <a:headEnd type="none" w="med" len="med"/>
+                      <a:tailEnd type="none" w="med" len="med"/>
+                    </a:lnB>
+                  </a:tcPr>
+                </a:tc>
+                <a:tc>
+                  <a:txBody>
+                    <a:bodyPr/>
+                    <a:lstStyle/>
+                    <a:p>
+                      <a:pPr algn="l" fontAlgn="b">
                         <a:buNone/>
                       </a:pPr>
                       <a:r>
@@ -10489,7 +12825,7 @@
                     <a:bodyPr/>
                     <a:lstStyle/>
                     <a:p>
-                      <a:pPr algn="ctr" fontAlgn="b">
+                      <a:pPr algn="l" fontAlgn="b">
                         <a:buNone/>
                       </a:pPr>
                       <a:r>
@@ -10562,6 +12898,74 @@
                         <a:buNone/>
                       </a:pPr>
                       <a:r>
+                        <a:rPr lang="en-CA" sz="1100" b="0" i="0" u="none" strike="noStrike" dirty="0">
+                          <a:solidFill>
+                            <a:srgbClr val="000000"/>
+                          </a:solidFill>
+                          <a:effectLst/>
+                          <a:latin typeface="Courier New" panose="02070309020205020404" pitchFamily="49" charset="0"/>
+                          <a:cs typeface="Courier New" panose="02070309020205020404" pitchFamily="49" charset="0"/>
+                        </a:rPr>
+                        <a:t>A0A244CMP0</a:t>
+                      </a:r>
+                    </a:p>
+                  </a:txBody>
+                  <a:tcPr marL="6350" marR="6350" marT="6350" marB="0" anchor="b">
+                    <a:lnL w="3175" cap="flat" cmpd="sng" algn="ctr">
+                      <a:solidFill>
+                        <a:schemeClr val="bg1">
+                          <a:lumMod val="65000"/>
+                        </a:schemeClr>
+                      </a:solidFill>
+                      <a:prstDash val="solid"/>
+                      <a:round/>
+                      <a:headEnd type="none" w="med" len="med"/>
+                      <a:tailEnd type="none" w="med" len="med"/>
+                    </a:lnL>
+                    <a:lnR w="3175" cap="flat" cmpd="sng" algn="ctr">
+                      <a:solidFill>
+                        <a:schemeClr val="bg1">
+                          <a:lumMod val="65000"/>
+                        </a:schemeClr>
+                      </a:solidFill>
+                      <a:prstDash val="solid"/>
+                      <a:round/>
+                      <a:headEnd type="none" w="med" len="med"/>
+                      <a:tailEnd type="none" w="med" len="med"/>
+                    </a:lnR>
+                    <a:lnT w="3175" cap="flat" cmpd="sng" algn="ctr">
+                      <a:solidFill>
+                        <a:schemeClr val="bg1">
+                          <a:lumMod val="65000"/>
+                        </a:schemeClr>
+                      </a:solidFill>
+                      <a:prstDash val="solid"/>
+                      <a:round/>
+                      <a:headEnd type="none" w="med" len="med"/>
+                      <a:tailEnd type="none" w="med" len="med"/>
+                    </a:lnT>
+                    <a:lnB w="3175" cap="flat" cmpd="sng" algn="ctr">
+                      <a:solidFill>
+                        <a:schemeClr val="bg1">
+                          <a:lumMod val="65000"/>
+                        </a:schemeClr>
+                      </a:solidFill>
+                      <a:prstDash val="solid"/>
+                      <a:round/>
+                      <a:headEnd type="none" w="med" len="med"/>
+                      <a:tailEnd type="none" w="med" len="med"/>
+                    </a:lnB>
+                  </a:tcPr>
+                </a:tc>
+                <a:tc>
+                  <a:txBody>
+                    <a:bodyPr/>
+                    <a:lstStyle/>
+                    <a:p>
+                      <a:pPr algn="l" fontAlgn="b">
+                        <a:buNone/>
+                      </a:pPr>
+                      <a:r>
                         <a:rPr lang="en-CA" sz="1200" b="0" i="0" u="none" strike="noStrike" dirty="0">
                           <a:solidFill>
                             <a:srgbClr val="000000"/>
@@ -10627,6 +13031,74 @@
                     <a:lstStyle/>
                     <a:p>
                       <a:pPr algn="ctr" fontAlgn="b">
+                        <a:buNone/>
+                      </a:pPr>
+                      <a:r>
+                        <a:rPr lang="en-CA" sz="1100" b="0" i="0" u="none" strike="noStrike" dirty="0">
+                          <a:solidFill>
+                            <a:srgbClr val="000000"/>
+                          </a:solidFill>
+                          <a:effectLst/>
+                          <a:latin typeface="Courier New" panose="02070309020205020404" pitchFamily="49" charset="0"/>
+                          <a:cs typeface="Courier New" panose="02070309020205020404" pitchFamily="49" charset="0"/>
+                        </a:rPr>
+                        <a:t>Q8WXG1</a:t>
+                      </a:r>
+                    </a:p>
+                  </a:txBody>
+                  <a:tcPr marL="6350" marR="6350" marT="6350" marB="0" anchor="b">
+                    <a:lnL w="3175" cap="flat" cmpd="sng" algn="ctr">
+                      <a:solidFill>
+                        <a:schemeClr val="bg1">
+                          <a:lumMod val="65000"/>
+                        </a:schemeClr>
+                      </a:solidFill>
+                      <a:prstDash val="solid"/>
+                      <a:round/>
+                      <a:headEnd type="none" w="med" len="med"/>
+                      <a:tailEnd type="none" w="med" len="med"/>
+                    </a:lnL>
+                    <a:lnR w="3175" cap="flat" cmpd="sng" algn="ctr">
+                      <a:solidFill>
+                        <a:schemeClr val="bg1">
+                          <a:lumMod val="65000"/>
+                        </a:schemeClr>
+                      </a:solidFill>
+                      <a:prstDash val="solid"/>
+                      <a:round/>
+                      <a:headEnd type="none" w="med" len="med"/>
+                      <a:tailEnd type="none" w="med" len="med"/>
+                    </a:lnR>
+                    <a:lnT w="3175" cap="flat" cmpd="sng" algn="ctr">
+                      <a:solidFill>
+                        <a:schemeClr val="bg1">
+                          <a:lumMod val="65000"/>
+                        </a:schemeClr>
+                      </a:solidFill>
+                      <a:prstDash val="solid"/>
+                      <a:round/>
+                      <a:headEnd type="none" w="med" len="med"/>
+                      <a:tailEnd type="none" w="med" len="med"/>
+                    </a:lnT>
+                    <a:lnB w="3175" cap="flat" cmpd="sng" algn="ctr">
+                      <a:solidFill>
+                        <a:schemeClr val="bg1">
+                          <a:lumMod val="65000"/>
+                        </a:schemeClr>
+                      </a:solidFill>
+                      <a:prstDash val="solid"/>
+                      <a:round/>
+                      <a:headEnd type="none" w="med" len="med"/>
+                      <a:tailEnd type="none" w="med" len="med"/>
+                    </a:lnB>
+                  </a:tcPr>
+                </a:tc>
+                <a:tc>
+                  <a:txBody>
+                    <a:bodyPr/>
+                    <a:lstStyle/>
+                    <a:p>
+                      <a:pPr algn="l" fontAlgn="b">
                         <a:buNone/>
                       </a:pPr>
                       <a:r>
@@ -10702,7 +13174,7 @@
                     <a:bodyPr/>
                     <a:lstStyle/>
                     <a:p>
-                      <a:pPr algn="ctr" fontAlgn="b">
+                      <a:pPr algn="l" fontAlgn="b">
                         <a:buNone/>
                       </a:pPr>
                       <a:r>
@@ -10776,6 +13248,75 @@
                         <a:buNone/>
                       </a:pPr>
                       <a:r>
+                        <a:rPr lang="en-CA" sz="1100" b="0" i="0" u="none" strike="noStrike" dirty="0">
+                          <a:solidFill>
+                            <a:srgbClr val="000000"/>
+                          </a:solidFill>
+                          <a:effectLst/>
+                          <a:latin typeface="Courier New" panose="02070309020205020404" pitchFamily="49" charset="0"/>
+                          <a:cs typeface="Courier New" panose="02070309020205020404" pitchFamily="49" charset="0"/>
+                        </a:rPr>
+                        <a:t>P0DW53</a:t>
+                      </a:r>
+                    </a:p>
+                  </a:txBody>
+                  <a:tcPr marL="6350" marR="6350" marT="6350" marB="0" anchor="b">
+                    <a:lnL w="3175" cap="flat" cmpd="sng" algn="ctr">
+                      <a:solidFill>
+                        <a:schemeClr val="bg1">
+                          <a:lumMod val="65000"/>
+                        </a:schemeClr>
+                      </a:solidFill>
+                      <a:prstDash val="solid"/>
+                      <a:round/>
+                      <a:headEnd type="none" w="med" len="med"/>
+                      <a:tailEnd type="none" w="med" len="med"/>
+                    </a:lnL>
+                    <a:lnR w="3175" cap="flat" cmpd="sng" algn="ctr">
+                      <a:solidFill>
+                        <a:schemeClr val="bg1">
+                          <a:lumMod val="65000"/>
+                        </a:schemeClr>
+                      </a:solidFill>
+                      <a:prstDash val="solid"/>
+                      <a:round/>
+                      <a:headEnd type="none" w="med" len="med"/>
+                      <a:tailEnd type="none" w="med" len="med"/>
+                    </a:lnR>
+                    <a:lnT w="3175" cap="flat" cmpd="sng" algn="ctr">
+                      <a:solidFill>
+                        <a:schemeClr val="bg1">
+                          <a:lumMod val="65000"/>
+                        </a:schemeClr>
+                      </a:solidFill>
+                      <a:prstDash val="solid"/>
+                      <a:round/>
+                      <a:headEnd type="none" w="med" len="med"/>
+                      <a:tailEnd type="none" w="med" len="med"/>
+                    </a:lnT>
+                    <a:lnB w="6350" cap="flat" cmpd="sng" algn="ctr">
+                      <a:solidFill>
+                        <a:schemeClr val="tx1">
+                          <a:lumMod val="95000"/>
+                          <a:lumOff val="5000"/>
+                        </a:schemeClr>
+                      </a:solidFill>
+                      <a:prstDash val="solid"/>
+                      <a:round/>
+                      <a:headEnd type="none" w="med" len="med"/>
+                      <a:tailEnd type="none" w="med" len="med"/>
+                    </a:lnB>
+                  </a:tcPr>
+                </a:tc>
+                <a:tc>
+                  <a:txBody>
+                    <a:bodyPr/>
+                    <a:lstStyle/>
+                    <a:p>
+                      <a:pPr algn="l" fontAlgn="b">
+                        <a:buNone/>
+                      </a:pPr>
+                      <a:r>
                         <a:rPr lang="en-CA" sz="1200" b="0" i="0" u="none" strike="noStrike" dirty="0">
                           <a:solidFill>
                             <a:srgbClr val="000000"/>
@@ -10842,6 +13383,75 @@
                     <a:lstStyle/>
                     <a:p>
                       <a:pPr algn="ctr" fontAlgn="b">
+                        <a:buNone/>
+                      </a:pPr>
+                      <a:r>
+                        <a:rPr lang="en-CA" sz="1100" b="0" i="0" u="none" strike="noStrike" dirty="0">
+                          <a:solidFill>
+                            <a:srgbClr val="000000"/>
+                          </a:solidFill>
+                          <a:effectLst/>
+                          <a:latin typeface="Courier New" panose="02070309020205020404" pitchFamily="49" charset="0"/>
+                          <a:cs typeface="Courier New" panose="02070309020205020404" pitchFamily="49" charset="0"/>
+                        </a:rPr>
+                        <a:t>Q8WXG1</a:t>
+                      </a:r>
+                    </a:p>
+                  </a:txBody>
+                  <a:tcPr marL="6350" marR="6350" marT="6350" marB="0" anchor="b">
+                    <a:lnL w="3175" cap="flat" cmpd="sng" algn="ctr">
+                      <a:solidFill>
+                        <a:schemeClr val="bg1">
+                          <a:lumMod val="65000"/>
+                        </a:schemeClr>
+                      </a:solidFill>
+                      <a:prstDash val="solid"/>
+                      <a:round/>
+                      <a:headEnd type="none" w="med" len="med"/>
+                      <a:tailEnd type="none" w="med" len="med"/>
+                    </a:lnL>
+                    <a:lnR w="3175" cap="flat" cmpd="sng" algn="ctr">
+                      <a:solidFill>
+                        <a:schemeClr val="bg1">
+                          <a:lumMod val="65000"/>
+                        </a:schemeClr>
+                      </a:solidFill>
+                      <a:prstDash val="solid"/>
+                      <a:round/>
+                      <a:headEnd type="none" w="med" len="med"/>
+                      <a:tailEnd type="none" w="med" len="med"/>
+                    </a:lnR>
+                    <a:lnT w="3175" cap="flat" cmpd="sng" algn="ctr">
+                      <a:solidFill>
+                        <a:schemeClr val="bg1">
+                          <a:lumMod val="65000"/>
+                        </a:schemeClr>
+                      </a:solidFill>
+                      <a:prstDash val="solid"/>
+                      <a:round/>
+                      <a:headEnd type="none" w="med" len="med"/>
+                      <a:tailEnd type="none" w="med" len="med"/>
+                    </a:lnT>
+                    <a:lnB w="6350" cap="flat" cmpd="sng" algn="ctr">
+                      <a:solidFill>
+                        <a:schemeClr val="tx1">
+                          <a:lumMod val="95000"/>
+                          <a:lumOff val="5000"/>
+                        </a:schemeClr>
+                      </a:solidFill>
+                      <a:prstDash val="solid"/>
+                      <a:round/>
+                      <a:headEnd type="none" w="med" len="med"/>
+                      <a:tailEnd type="none" w="med" len="med"/>
+                    </a:lnB>
+                  </a:tcPr>
+                </a:tc>
+                <a:tc>
+                  <a:txBody>
+                    <a:bodyPr/>
+                    <a:lstStyle/>
+                    <a:p>
+                      <a:pPr algn="l" fontAlgn="b">
                         <a:buNone/>
                       </a:pPr>
                       <a:r>
@@ -11087,7 +13697,7 @@
         </p:nvSpPr>
         <p:spPr>
           <a:xfrm>
-            <a:off x="1232048" y="6222191"/>
+            <a:off x="8762017" y="6258617"/>
             <a:ext cx="2670048" cy="276999"/>
           </a:xfrm>
           <a:prstGeom prst="rect">
@@ -11191,66 +13801,6 @@
           <a:chExt cx="0" cy="0"/>
         </a:xfrm>
       </p:grpSpPr>
-      <p:pic>
-        <p:nvPicPr>
-          <p:cNvPr id="19" name="Picture 18">
-            <a:extLst>
-              <a:ext uri="{FF2B5EF4-FFF2-40B4-BE49-F238E27FC236}">
-                <a16:creationId xmlns:a16="http://schemas.microsoft.com/office/drawing/2014/main" id="{60892281-A612-FA53-E8FB-6D1DE9E9A3DA}"/>
-              </a:ext>
-            </a:extLst>
-          </p:cNvPr>
-          <p:cNvPicPr>
-            <a:picLocks noChangeAspect="1"/>
-          </p:cNvPicPr>
-          <p:nvPr/>
-        </p:nvPicPr>
-        <p:blipFill>
-          <a:blip r:embed="rId2"/>
-          <a:stretch>
-            <a:fillRect/>
-          </a:stretch>
-        </p:blipFill>
-        <p:spPr>
-          <a:xfrm>
-            <a:off x="8703998" y="518096"/>
-            <a:ext cx="3055583" cy="3250207"/>
-          </a:xfrm>
-          <a:prstGeom prst="rect">
-            <a:avLst/>
-          </a:prstGeom>
-        </p:spPr>
-      </p:pic>
-      <p:pic>
-        <p:nvPicPr>
-          <p:cNvPr id="13" name="Picture 12">
-            <a:extLst>
-              <a:ext uri="{FF2B5EF4-FFF2-40B4-BE49-F238E27FC236}">
-                <a16:creationId xmlns:a16="http://schemas.microsoft.com/office/drawing/2014/main" id="{92532399-C48E-5C46-EC46-47F6748A9249}"/>
-              </a:ext>
-            </a:extLst>
-          </p:cNvPr>
-          <p:cNvPicPr>
-            <a:picLocks noChangeAspect="1"/>
-          </p:cNvPicPr>
-          <p:nvPr/>
-        </p:nvPicPr>
-        <p:blipFill>
-          <a:blip r:embed="rId3"/>
-          <a:stretch>
-            <a:fillRect/>
-          </a:stretch>
-        </p:blipFill>
-        <p:spPr>
-          <a:xfrm>
-            <a:off x="8703999" y="3696091"/>
-            <a:ext cx="3074211" cy="2395740"/>
-          </a:xfrm>
-          <a:prstGeom prst="rect">
-            <a:avLst/>
-          </a:prstGeom>
-        </p:spPr>
-      </p:pic>
       <p:sp>
         <p:nvSpPr>
           <p:cNvPr id="17" name="Rectangle 16">
@@ -11266,7 +13816,7 @@
         <p:spPr>
           <a:xfrm>
             <a:off x="3540154" y="4447846"/>
-            <a:ext cx="5156171" cy="845389"/>
+            <a:ext cx="7242865" cy="845389"/>
           </a:xfrm>
           <a:prstGeom prst="rect">
             <a:avLst/>
@@ -11333,17 +13883,11 @@
           <a:p>
             <a:r>
               <a:rPr lang="en-US" sz="1400" dirty="0">
-                <a:solidFill>
-                  <a:srgbClr val="0000FF"/>
-                </a:solidFill>
                 <a:latin typeface="Verdana Pro" panose="020B0604030504040204" pitchFamily="34" charset="0"/>
               </a:rPr>
               <a:t>A0A1S1YUU1 [F. pacifica][vip47]</a:t>
             </a:r>
             <a:endParaRPr lang="en-CA" sz="1400" dirty="0">
-              <a:solidFill>
-                <a:srgbClr val="0000FF"/>
-              </a:solidFill>
               <a:latin typeface="Verdana Pro" panose="020B0604030504040204" pitchFamily="34" charset="0"/>
             </a:endParaRPr>
           </a:p>
@@ -11379,17 +13923,11 @@
           <a:p>
             <a:r>
               <a:rPr lang="en-US" sz="1400" dirty="0">
-                <a:solidFill>
-                  <a:srgbClr val="FF0000"/>
-                </a:solidFill>
                 <a:latin typeface="Verdana Pro" panose="020B0604030504040204" pitchFamily="34" charset="0"/>
               </a:rPr>
               <a:t>Q8WXG1 [H. sapiens][RSAD2]</a:t>
             </a:r>
             <a:endParaRPr lang="en-CA" sz="1400" dirty="0">
-              <a:solidFill>
-                <a:srgbClr val="FF0000"/>
-              </a:solidFill>
               <a:latin typeface="Verdana Pro" panose="020B0604030504040204" pitchFamily="34" charset="0"/>
             </a:endParaRPr>
           </a:p>
@@ -11410,7 +13948,7 @@
         <p:spPr>
           <a:xfrm>
             <a:off x="3540154" y="5305725"/>
-            <a:ext cx="5156172" cy="845389"/>
+            <a:ext cx="7242864" cy="845389"/>
           </a:xfrm>
           <a:prstGeom prst="rect">
             <a:avLst/>
@@ -11465,7 +14003,7 @@
         </p:nvSpPr>
         <p:spPr>
           <a:xfrm>
-            <a:off x="9394672" y="595943"/>
+            <a:off x="7039691" y="586752"/>
             <a:ext cx="2421147" cy="307777"/>
           </a:xfrm>
           <a:prstGeom prst="rect">
@@ -11532,19 +14070,13 @@
             </a:pPr>
             <a:r>
               <a:rPr lang="en-US" sz="1200" dirty="0">
-                <a:solidFill>
-                  <a:srgbClr val="0000FF"/>
-                </a:solidFill>
-                <a:latin typeface="Courier New" panose="02070309020205020404" pitchFamily="49" charset="0"/>
+                <a:latin typeface="Verdana Pro" panose="020B0604030504040204" pitchFamily="34" charset="0"/>
                 <a:cs typeface="Courier New" panose="02070309020205020404" pitchFamily="49" charset="0"/>
               </a:rPr>
               <a:t>confers resistance to phage P1</a:t>
             </a:r>
             <a:endParaRPr lang="en-CA" sz="1200" dirty="0">
-              <a:solidFill>
-                <a:srgbClr val="0000FF"/>
-              </a:solidFill>
-              <a:latin typeface="Courier New" panose="02070309020205020404" pitchFamily="49" charset="0"/>
+              <a:latin typeface="Verdana Pro" panose="020B0604030504040204" pitchFamily="34" charset="0"/>
               <a:cs typeface="Courier New" panose="02070309020205020404" pitchFamily="49" charset="0"/>
             </a:endParaRPr>
           </a:p>
@@ -11584,19 +14116,13 @@
             </a:pPr>
             <a:r>
               <a:rPr lang="en-US" sz="1200" dirty="0">
-                <a:solidFill>
-                  <a:srgbClr val="FF0000"/>
-                </a:solidFill>
-                <a:latin typeface="Courier New" panose="02070309020205020404" pitchFamily="49" charset="0"/>
+                <a:latin typeface="Verdana Pro" panose="020B0604030504040204" pitchFamily="34" charset="0"/>
                 <a:cs typeface="Courier New" panose="02070309020205020404" pitchFamily="49" charset="0"/>
               </a:rPr>
               <a:t>interferon-inducible antiviral protein</a:t>
             </a:r>
             <a:endParaRPr lang="en-CA" sz="1200" dirty="0">
-              <a:solidFill>
-                <a:srgbClr val="FF0000"/>
-              </a:solidFill>
-              <a:latin typeface="Courier New" panose="02070309020205020404" pitchFamily="49" charset="0"/>
+              <a:latin typeface="Verdana Pro" panose="020B0604030504040204" pitchFamily="34" charset="0"/>
               <a:cs typeface="Courier New" panose="02070309020205020404" pitchFamily="49" charset="0"/>
             </a:endParaRPr>
           </a:p>
@@ -11636,19 +14162,13 @@
             </a:pPr>
             <a:r>
               <a:rPr lang="en-US" sz="1200" dirty="0">
-                <a:solidFill>
-                  <a:srgbClr val="FF0000"/>
-                </a:solidFill>
-                <a:latin typeface="Courier New" panose="02070309020205020404" pitchFamily="49" charset="0"/>
+                <a:latin typeface="Verdana Pro" panose="020B0604030504040204" pitchFamily="34" charset="0"/>
                 <a:cs typeface="Courier New" panose="02070309020205020404" pitchFamily="49" charset="0"/>
               </a:rPr>
               <a:t>initiates pathway to repress RNA polymerase action</a:t>
             </a:r>
             <a:endParaRPr lang="en-CA" sz="1200" dirty="0">
-              <a:solidFill>
-                <a:srgbClr val="FF0000"/>
-              </a:solidFill>
-              <a:latin typeface="Courier New" panose="02070309020205020404" pitchFamily="49" charset="0"/>
+              <a:latin typeface="Verdana Pro" panose="020B0604030504040204" pitchFamily="34" charset="0"/>
               <a:cs typeface="Courier New" panose="02070309020205020404" pitchFamily="49" charset="0"/>
             </a:endParaRPr>
           </a:p>
@@ -11668,7 +14188,7 @@
         </p:nvSpPr>
         <p:spPr>
           <a:xfrm>
-            <a:off x="9349399" y="3773967"/>
+            <a:off x="6640705" y="2080663"/>
             <a:ext cx="2421147" cy="307777"/>
           </a:xfrm>
           <a:prstGeom prst="rect">
@@ -11716,13 +14236,13 @@
           <p:nvPr>
             <p:extLst>
               <p:ext uri="{D42A27DB-BD31-4B8C-83A1-F6EECF244321}">
-                <p14:modId xmlns:p14="http://schemas.microsoft.com/office/powerpoint/2010/main" val="1319146353"/>
+                <p14:modId xmlns:p14="http://schemas.microsoft.com/office/powerpoint/2010/main" val="2455075749"/>
               </p:ext>
             </p:extLst>
           </p:nvPr>
         </p:nvGraphicFramePr>
         <p:xfrm>
-          <a:off x="411929" y="3828403"/>
+          <a:off x="334082" y="4722579"/>
           <a:ext cx="2782890" cy="1005840"/>
         </p:xfrm>
         <a:graphic>
@@ -12135,7 +14655,7 @@
           <a:blip>
             <a:extLst>
               <a:ext uri="{96DAC541-7B7A-43D3-8B79-37D633B846F1}">
-                <asvg:svgBlip xmlns:asvg="http://schemas.microsoft.com/office/drawing/2016/SVG/main" r:embed="rId4"/>
+                <asvg:svgBlip xmlns:asvg="http://schemas.microsoft.com/office/drawing/2016/SVG/main" r:embed="rId2"/>
               </a:ext>
             </a:extLst>
           </a:blip>
@@ -12146,7 +14666,7 @@
         </p:blipFill>
         <p:spPr>
           <a:xfrm>
-            <a:off x="219800" y="483593"/>
+            <a:off x="105518" y="894529"/>
             <a:ext cx="3011454" cy="2945407"/>
           </a:xfrm>
           <a:prstGeom prst="rect">
@@ -12168,7 +14688,7 @@
         </p:nvSpPr>
         <p:spPr>
           <a:xfrm>
-            <a:off x="723900" y="586752"/>
+            <a:off x="609618" y="997688"/>
             <a:ext cx="158750" cy="93382"/>
           </a:xfrm>
           <a:prstGeom prst="rect">
@@ -12206,36 +14726,6 @@
           </a:p>
         </p:txBody>
       </p:sp>
-      <p:pic>
-        <p:nvPicPr>
-          <p:cNvPr id="7" name="Picture 6">
-            <a:extLst>
-              <a:ext uri="{FF2B5EF4-FFF2-40B4-BE49-F238E27FC236}">
-                <a16:creationId xmlns:a16="http://schemas.microsoft.com/office/drawing/2014/main" id="{2FE5CB3A-1BF6-F93D-2280-4A448917748C}"/>
-              </a:ext>
-            </a:extLst>
-          </p:cNvPr>
-          <p:cNvPicPr>
-            <a:picLocks noChangeAspect="1"/>
-          </p:cNvPicPr>
-          <p:nvPr/>
-        </p:nvPicPr>
-        <p:blipFill>
-          <a:blip r:embed="rId5"/>
-          <a:stretch>
-            <a:fillRect/>
-          </a:stretch>
-        </p:blipFill>
-        <p:spPr>
-          <a:xfrm>
-            <a:off x="3540162" y="516376"/>
-            <a:ext cx="5156163" cy="3886555"/>
-          </a:xfrm>
-          <a:prstGeom prst="rect">
-            <a:avLst/>
-          </a:prstGeom>
-        </p:spPr>
-      </p:pic>
       <p:sp>
         <p:nvSpPr>
           <p:cNvPr id="10" name="TextBox 9">
@@ -12270,24 +14760,129 @@
             </a:pPr>
             <a:r>
               <a:rPr lang="en-US" sz="1200" dirty="0">
-                <a:solidFill>
-                  <a:srgbClr val="0000FF"/>
-                </a:solidFill>
-                <a:latin typeface="Courier New" panose="02070309020205020404" pitchFamily="49" charset="0"/>
+                <a:latin typeface="Verdana Pro" panose="020B0604030504040204" pitchFamily="34" charset="0"/>
                 <a:cs typeface="Courier New" panose="02070309020205020404" pitchFamily="49" charset="0"/>
               </a:rPr>
               <a:t>represses T7 RNA-polymerase action</a:t>
             </a:r>
             <a:endParaRPr lang="en-CA" sz="1200" dirty="0">
-              <a:solidFill>
-                <a:srgbClr val="0000FF"/>
-              </a:solidFill>
-              <a:latin typeface="Courier New" panose="02070309020205020404" pitchFamily="49" charset="0"/>
+              <a:latin typeface="Verdana Pro" panose="020B0604030504040204" pitchFamily="34" charset="0"/>
               <a:cs typeface="Courier New" panose="02070309020205020404" pitchFamily="49" charset="0"/>
             </a:endParaRPr>
           </a:p>
         </p:txBody>
       </p:sp>
+      <p:pic>
+        <p:nvPicPr>
+          <p:cNvPr id="5" name="Picture 4">
+            <a:extLst>
+              <a:ext uri="{FF2B5EF4-FFF2-40B4-BE49-F238E27FC236}">
+                <a16:creationId xmlns:a16="http://schemas.microsoft.com/office/drawing/2014/main" id="{615665F2-2467-7F1C-7B6C-40CFBA21E1B2}"/>
+              </a:ext>
+            </a:extLst>
+          </p:cNvPr>
+          <p:cNvPicPr>
+            <a:picLocks noChangeAspect="1"/>
+          </p:cNvPicPr>
+          <p:nvPr/>
+        </p:nvPicPr>
+        <p:blipFill>
+          <a:blip r:embed="rId3">
+            <a:extLst>
+              <a:ext uri="{28A0092B-C50C-407E-A947-70E740481C1C}">
+                <a14:useLocalDpi xmlns:a14="http://schemas.microsoft.com/office/drawing/2010/main" val="0"/>
+              </a:ext>
+            </a:extLst>
+          </a:blip>
+          <a:srcRect l="17595" t="18994" r="28632" b="11516"/>
+          <a:stretch>
+            <a:fillRect/>
+          </a:stretch>
+        </p:blipFill>
+        <p:spPr>
+          <a:xfrm>
+            <a:off x="3840219" y="460159"/>
+            <a:ext cx="4109981" cy="3983417"/>
+          </a:xfrm>
+          <a:prstGeom prst="rect">
+            <a:avLst/>
+          </a:prstGeom>
+        </p:spPr>
+      </p:pic>
+      <p:pic>
+        <p:nvPicPr>
+          <p:cNvPr id="27" name="Picture 26">
+            <a:extLst>
+              <a:ext uri="{FF2B5EF4-FFF2-40B4-BE49-F238E27FC236}">
+                <a16:creationId xmlns:a16="http://schemas.microsoft.com/office/drawing/2014/main" id="{7CDA7D12-0464-48D9-38EE-19DEF771E434}"/>
+              </a:ext>
+            </a:extLst>
+          </p:cNvPr>
+          <p:cNvPicPr>
+            <a:picLocks noChangeAspect="1"/>
+          </p:cNvPicPr>
+          <p:nvPr/>
+        </p:nvPicPr>
+        <p:blipFill>
+          <a:blip r:embed="rId4">
+            <a:extLst>
+              <a:ext uri="{28A0092B-C50C-407E-A947-70E740481C1C}">
+                <a14:useLocalDpi xmlns:a14="http://schemas.microsoft.com/office/drawing/2010/main" val="0"/>
+              </a:ext>
+            </a:extLst>
+          </a:blip>
+          <a:srcRect l="31709" t="67171" r="37259"/>
+          <a:stretch>
+            <a:fillRect/>
+          </a:stretch>
+        </p:blipFill>
+        <p:spPr>
+          <a:xfrm>
+            <a:off x="7824207" y="2043615"/>
+            <a:ext cx="2972164" cy="2358209"/>
+          </a:xfrm>
+          <a:prstGeom prst="rect">
+            <a:avLst/>
+          </a:prstGeom>
+        </p:spPr>
+      </p:pic>
+      <p:pic>
+        <p:nvPicPr>
+          <p:cNvPr id="31" name="Picture 30">
+            <a:extLst>
+              <a:ext uri="{FF2B5EF4-FFF2-40B4-BE49-F238E27FC236}">
+                <a16:creationId xmlns:a16="http://schemas.microsoft.com/office/drawing/2014/main" id="{DF0B3C77-5F6E-1991-4200-9D9E25584753}"/>
+              </a:ext>
+            </a:extLst>
+          </p:cNvPr>
+          <p:cNvPicPr>
+            <a:picLocks noChangeAspect="1"/>
+          </p:cNvPicPr>
+          <p:nvPr/>
+        </p:nvPicPr>
+        <p:blipFill>
+          <a:blip r:embed="rId5">
+            <a:extLst>
+              <a:ext uri="{28A0092B-C50C-407E-A947-70E740481C1C}">
+                <a14:useLocalDpi xmlns:a14="http://schemas.microsoft.com/office/drawing/2010/main" val="0"/>
+              </a:ext>
+            </a:extLst>
+          </a:blip>
+          <a:srcRect l="37847" t="73289" r="39931" b="-63"/>
+          <a:stretch>
+            <a:fillRect/>
+          </a:stretch>
+        </p:blipFill>
+        <p:spPr>
+          <a:xfrm>
+            <a:off x="8372475" y="604065"/>
+            <a:ext cx="2128368" cy="1923235"/>
+          </a:xfrm>
+          <a:prstGeom prst="rect">
+            <a:avLst/>
+          </a:prstGeom>
+        </p:spPr>
+      </p:pic>
     </p:spTree>
     <p:extLst>
       <p:ext uri="{BB962C8B-B14F-4D97-AF65-F5344CB8AC3E}">
@@ -12324,66 +14919,6 @@
           <a:chExt cx="0" cy="0"/>
         </a:xfrm>
       </p:grpSpPr>
-      <p:pic>
-        <p:nvPicPr>
-          <p:cNvPr id="23" name="Picture 22">
-            <a:extLst>
-              <a:ext uri="{FF2B5EF4-FFF2-40B4-BE49-F238E27FC236}">
-                <a16:creationId xmlns:a16="http://schemas.microsoft.com/office/drawing/2014/main" id="{B1769DC9-071C-942B-7241-1434998AFAA4}"/>
-              </a:ext>
-            </a:extLst>
-          </p:cNvPr>
-          <p:cNvPicPr>
-            <a:picLocks noChangeAspect="1"/>
-          </p:cNvPicPr>
-          <p:nvPr/>
-        </p:nvPicPr>
-        <p:blipFill>
-          <a:blip r:embed="rId2"/>
-          <a:stretch>
-            <a:fillRect/>
-          </a:stretch>
-        </p:blipFill>
-        <p:spPr>
-          <a:xfrm>
-            <a:off x="8717360" y="3607360"/>
-            <a:ext cx="3067478" cy="2866392"/>
-          </a:xfrm>
-          <a:prstGeom prst="rect">
-            <a:avLst/>
-          </a:prstGeom>
-        </p:spPr>
-      </p:pic>
-      <p:pic>
-        <p:nvPicPr>
-          <p:cNvPr id="11" name="Picture 10">
-            <a:extLst>
-              <a:ext uri="{FF2B5EF4-FFF2-40B4-BE49-F238E27FC236}">
-                <a16:creationId xmlns:a16="http://schemas.microsoft.com/office/drawing/2014/main" id="{3550C085-A054-8291-7541-982601739DB5}"/>
-              </a:ext>
-            </a:extLst>
-          </p:cNvPr>
-          <p:cNvPicPr>
-            <a:picLocks noChangeAspect="1"/>
-          </p:cNvPicPr>
-          <p:nvPr/>
-        </p:nvPicPr>
-        <p:blipFill>
-          <a:blip r:embed="rId3"/>
-          <a:stretch>
-            <a:fillRect/>
-          </a:stretch>
-        </p:blipFill>
-        <p:spPr>
-          <a:xfrm>
-            <a:off x="8720959" y="504772"/>
-            <a:ext cx="3060280" cy="3106647"/>
-          </a:xfrm>
-          <a:prstGeom prst="rect">
-            <a:avLst/>
-          </a:prstGeom>
-        </p:spPr>
-      </p:pic>
       <p:sp>
         <p:nvSpPr>
           <p:cNvPr id="17" name="Rectangle 16">
@@ -12399,7 +14934,7 @@
         <p:spPr>
           <a:xfrm>
             <a:off x="3540154" y="4761874"/>
-            <a:ext cx="5156171" cy="845389"/>
+            <a:ext cx="7445346" cy="845389"/>
           </a:xfrm>
           <a:prstGeom prst="rect">
             <a:avLst/>
@@ -12432,7 +14967,12 @@
           <a:lstStyle/>
           <a:p>
             <a:pPr algn="ctr"/>
-            <a:endParaRPr lang="en-CA"/>
+            <a:endParaRPr lang="en-CA">
+              <a:solidFill>
+                <a:schemeClr val="tx1"/>
+              </a:solidFill>
+              <a:latin typeface="Verdana Pro" panose="020B0604030504040204" pitchFamily="34" charset="0"/>
+            </a:endParaRPr>
           </a:p>
         </p:txBody>
       </p:sp>
@@ -12466,17 +15006,11 @@
           <a:p>
             <a:r>
               <a:rPr lang="en-US" sz="1400" dirty="0">
-                <a:solidFill>
-                  <a:srgbClr val="0000FF"/>
-                </a:solidFill>
                 <a:latin typeface="Verdana Pro" panose="020B0604030504040204" pitchFamily="34" charset="0"/>
               </a:rPr>
               <a:t>Q6XGD5 [E. coli][cdnE]</a:t>
             </a:r>
             <a:endParaRPr lang="en-CA" sz="1400" dirty="0">
-              <a:solidFill>
-                <a:srgbClr val="0000FF"/>
-              </a:solidFill>
               <a:latin typeface="Verdana Pro" panose="020B0604030504040204" pitchFamily="34" charset="0"/>
             </a:endParaRPr>
           </a:p>
@@ -12512,17 +15046,11 @@
           <a:p>
             <a:r>
               <a:rPr lang="en-US" sz="1400" dirty="0">
-                <a:solidFill>
-                  <a:srgbClr val="FF0000"/>
-                </a:solidFill>
                 <a:latin typeface="Verdana Pro" panose="020B0604030504040204" pitchFamily="34" charset="0"/>
               </a:rPr>
               <a:t>Q8N884 [H. sapiens][CGAS]</a:t>
             </a:r>
             <a:endParaRPr lang="en-CA" sz="1400" dirty="0">
-              <a:solidFill>
-                <a:srgbClr val="FF0000"/>
-              </a:solidFill>
               <a:latin typeface="Verdana Pro" panose="020B0604030504040204" pitchFamily="34" charset="0"/>
             </a:endParaRPr>
           </a:p>
@@ -12542,8 +15070,8 @@
         </p:nvSpPr>
         <p:spPr>
           <a:xfrm>
-            <a:off x="3540154" y="5619753"/>
-            <a:ext cx="5156172" cy="845389"/>
+            <a:off x="3540153" y="5619753"/>
+            <a:ext cx="7445347" cy="845389"/>
           </a:xfrm>
           <a:prstGeom prst="rect">
             <a:avLst/>
@@ -12578,8 +15106,9 @@
             <a:pPr algn="ctr"/>
             <a:endParaRPr lang="en-CA">
               <a:solidFill>
-                <a:srgbClr val="FF0000"/>
+                <a:schemeClr val="tx1"/>
               </a:solidFill>
+              <a:latin typeface="Verdana Pro" panose="020B0604030504040204" pitchFamily="34" charset="0"/>
             </a:endParaRPr>
           </a:p>
         </p:txBody>
@@ -12598,7 +15127,7 @@
         </p:nvSpPr>
         <p:spPr>
           <a:xfrm>
-            <a:off x="9394672" y="568235"/>
+            <a:off x="6582804" y="439278"/>
             <a:ext cx="2421147" cy="307777"/>
           </a:xfrm>
           <a:prstGeom prst="rect">
@@ -12665,19 +15194,13 @@
             </a:pPr>
             <a:r>
               <a:rPr lang="en-US" sz="1200" dirty="0">
-                <a:solidFill>
-                  <a:srgbClr val="0000FF"/>
-                </a:solidFill>
-                <a:latin typeface="Courier New" panose="02070309020205020404" pitchFamily="49" charset="0"/>
+                <a:latin typeface="Verdana Pro" panose="020B0604030504040204" pitchFamily="34" charset="0"/>
                 <a:cs typeface="Courier New" panose="02070309020205020404" pitchFamily="49" charset="0"/>
               </a:rPr>
               <a:t>Cyclic nucleotide synthase (second messenger synthesis) in CBASS system</a:t>
             </a:r>
             <a:endParaRPr lang="en-CA" sz="1200" dirty="0">
-              <a:solidFill>
-                <a:srgbClr val="0000FF"/>
-              </a:solidFill>
-              <a:latin typeface="Courier New" panose="02070309020205020404" pitchFamily="49" charset="0"/>
+              <a:latin typeface="Verdana Pro" panose="020B0604030504040204" pitchFamily="34" charset="0"/>
               <a:cs typeface="Courier New" panose="02070309020205020404" pitchFamily="49" charset="0"/>
             </a:endParaRPr>
           </a:p>
@@ -12717,19 +15240,13 @@
             </a:pPr>
             <a:r>
               <a:rPr lang="en-US" sz="1200" dirty="0">
-                <a:solidFill>
-                  <a:srgbClr val="FF0000"/>
-                </a:solidFill>
-                <a:latin typeface="Courier New" panose="02070309020205020404" pitchFamily="49" charset="0"/>
+                <a:latin typeface="Verdana Pro" panose="020B0604030504040204" pitchFamily="34" charset="0"/>
                 <a:cs typeface="Courier New" panose="02070309020205020404" pitchFamily="49" charset="0"/>
               </a:rPr>
               <a:t>nucleotidyltransferase catalyzing formation of cyclic GMP-AMP; plays role in innate immunity</a:t>
             </a:r>
             <a:endParaRPr lang="en-CA" sz="1200" dirty="0">
-              <a:solidFill>
-                <a:srgbClr val="FF0000"/>
-              </a:solidFill>
-              <a:latin typeface="Courier New" panose="02070309020205020404" pitchFamily="49" charset="0"/>
+              <a:latin typeface="Verdana Pro" panose="020B0604030504040204" pitchFamily="34" charset="0"/>
               <a:cs typeface="Courier New" panose="02070309020205020404" pitchFamily="49" charset="0"/>
             </a:endParaRPr>
           </a:p>
@@ -12749,7 +15266,7 @@
         </p:nvSpPr>
         <p:spPr>
           <a:xfrm>
-            <a:off x="9375440" y="3520993"/>
+            <a:off x="6582805" y="2110867"/>
             <a:ext cx="2421147" cy="307777"/>
           </a:xfrm>
           <a:prstGeom prst="rect">
@@ -12797,13 +15314,13 @@
           <p:nvPr>
             <p:extLst>
               <p:ext uri="{D42A27DB-BD31-4B8C-83A1-F6EECF244321}">
-                <p14:modId xmlns:p14="http://schemas.microsoft.com/office/powerpoint/2010/main" val="561089354"/>
+                <p14:modId xmlns:p14="http://schemas.microsoft.com/office/powerpoint/2010/main" val="3875270993"/>
               </p:ext>
             </p:extLst>
           </p:nvPr>
         </p:nvGraphicFramePr>
         <p:xfrm>
-          <a:off x="411929" y="3828403"/>
+          <a:off x="448364" y="5116833"/>
           <a:ext cx="2782890" cy="1005840"/>
         </p:xfrm>
         <a:graphic>
@@ -13216,7 +15733,7 @@
           <a:blip>
             <a:extLst>
               <a:ext uri="{96DAC541-7B7A-43D3-8B79-37D633B846F1}">
-                <asvg:svgBlip xmlns:asvg="http://schemas.microsoft.com/office/drawing/2016/SVG/main" r:embed="rId4"/>
+                <asvg:svgBlip xmlns:asvg="http://schemas.microsoft.com/office/drawing/2016/SVG/main" r:embed="rId2"/>
               </a:ext>
             </a:extLst>
           </a:blip>
@@ -13227,7 +15744,7 @@
         </p:blipFill>
         <p:spPr>
           <a:xfrm>
-            <a:off x="219800" y="483593"/>
+            <a:off x="219800" y="1385293"/>
             <a:ext cx="3011454" cy="2945407"/>
           </a:xfrm>
           <a:prstGeom prst="rect">
@@ -13249,7 +15766,7 @@
         </p:nvSpPr>
         <p:spPr>
           <a:xfrm>
-            <a:off x="1860550" y="759356"/>
+            <a:off x="1860550" y="1661056"/>
             <a:ext cx="158750" cy="93382"/>
           </a:xfrm>
           <a:prstGeom prst="rect">
@@ -13289,10 +15806,10 @@
       </p:sp>
       <p:pic>
         <p:nvPicPr>
-          <p:cNvPr id="8" name="Picture 7">
+          <p:cNvPr id="4" name="Picture 3">
             <a:extLst>
               <a:ext uri="{FF2B5EF4-FFF2-40B4-BE49-F238E27FC236}">
-                <a16:creationId xmlns:a16="http://schemas.microsoft.com/office/drawing/2014/main" id="{88E56A6B-1F75-72CB-CF5D-77E89748A917}"/>
+                <a16:creationId xmlns:a16="http://schemas.microsoft.com/office/drawing/2014/main" id="{A967FE4B-2CC6-3D45-48A6-471835C0682D}"/>
               </a:ext>
             </a:extLst>
           </p:cNvPr>
@@ -13302,63 +15819,102 @@
           <p:nvPr/>
         </p:nvPicPr>
         <p:blipFill>
-          <a:blip r:embed="rId5"/>
+          <a:blip r:embed="rId3">
+            <a:extLst>
+              <a:ext uri="{28A0092B-C50C-407E-A947-70E740481C1C}">
+                <a14:useLocalDpi xmlns:a14="http://schemas.microsoft.com/office/drawing/2010/main" val="0"/>
+              </a:ext>
+            </a:extLst>
+          </a:blip>
+          <a:srcRect l="7986" r="22135" b="13290"/>
           <a:stretch>
             <a:fillRect/>
           </a:stretch>
         </p:blipFill>
         <p:spPr>
           <a:xfrm>
-            <a:off x="3540154" y="505185"/>
-            <a:ext cx="5173131" cy="4235970"/>
+            <a:off x="3425869" y="568235"/>
+            <a:ext cx="4367510" cy="4064682"/>
           </a:xfrm>
           <a:prstGeom prst="rect">
             <a:avLst/>
           </a:prstGeom>
         </p:spPr>
       </p:pic>
-      <p:sp>
-        <p:nvSpPr>
-          <p:cNvPr id="30" name="TextBox 29">
+      <p:pic>
+        <p:nvPicPr>
+          <p:cNvPr id="6" name="Picture 5">
             <a:extLst>
               <a:ext uri="{FF2B5EF4-FFF2-40B4-BE49-F238E27FC236}">
-                <a16:creationId xmlns:a16="http://schemas.microsoft.com/office/drawing/2014/main" id="{815541B2-51F2-28FA-A2E0-CE5A70B2B1C1}"/>
+                <a16:creationId xmlns:a16="http://schemas.microsoft.com/office/drawing/2014/main" id="{111014E1-8AD8-A077-42C5-E195D80C6B32}"/>
               </a:ext>
             </a:extLst>
           </p:cNvPr>
-          <p:cNvSpPr txBox="1"/>
+          <p:cNvPicPr>
+            <a:picLocks noChangeAspect="1"/>
+          </p:cNvPicPr>
           <p:nvPr/>
-        </p:nvSpPr>
+        </p:nvPicPr>
+        <p:blipFill>
+          <a:blip r:embed="rId4">
+            <a:extLst>
+              <a:ext uri="{28A0092B-C50C-407E-A947-70E740481C1C}">
+                <a14:useLocalDpi xmlns:a14="http://schemas.microsoft.com/office/drawing/2010/main" val="0"/>
+              </a:ext>
+            </a:extLst>
+          </a:blip>
+          <a:srcRect l="22903" t="26887" r="29875" b="26817"/>
+          <a:stretch>
+            <a:fillRect/>
+          </a:stretch>
+        </p:blipFill>
         <p:spPr>
           <a:xfrm>
-            <a:off x="8769613" y="6248589"/>
-            <a:ext cx="1796787" cy="246221"/>
+            <a:off x="8320372" y="430958"/>
+            <a:ext cx="1996341" cy="1467897"/>
           </a:xfrm>
           <a:prstGeom prst="rect">
             <a:avLst/>
           </a:prstGeom>
-          <a:noFill/>
         </p:spPr>
-        <p:txBody>
-          <a:bodyPr wrap="square" rtlCol="0">
-            <a:spAutoFit/>
-          </a:bodyPr>
-          <a:lstStyle/>
-          <a:p>
-            <a:r>
-              <a:rPr lang="en-US" sz="1000" dirty="0">
-                <a:latin typeface="Courier New" panose="02070309020205020404" pitchFamily="49" charset="0"/>
-                <a:cs typeface="Courier New" panose="02070309020205020404" pitchFamily="49" charset="0"/>
-              </a:rPr>
-              <a:t>X-ray cryst. [PDB]</a:t>
-            </a:r>
-            <a:endParaRPr lang="en-CA" sz="1000" dirty="0">
-              <a:latin typeface="Courier New" panose="02070309020205020404" pitchFamily="49" charset="0"/>
-              <a:cs typeface="Courier New" panose="02070309020205020404" pitchFamily="49" charset="0"/>
-            </a:endParaRPr>
-          </a:p>
-        </p:txBody>
-      </p:sp>
+      </p:pic>
+      <p:pic>
+        <p:nvPicPr>
+          <p:cNvPr id="12" name="Picture 11">
+            <a:extLst>
+              <a:ext uri="{FF2B5EF4-FFF2-40B4-BE49-F238E27FC236}">
+                <a16:creationId xmlns:a16="http://schemas.microsoft.com/office/drawing/2014/main" id="{A1E98958-B2C4-90CB-90E5-A82770B5F13C}"/>
+              </a:ext>
+            </a:extLst>
+          </p:cNvPr>
+          <p:cNvPicPr>
+            <a:picLocks noChangeAspect="1"/>
+          </p:cNvPicPr>
+          <p:nvPr/>
+        </p:nvPicPr>
+        <p:blipFill>
+          <a:blip r:embed="rId5">
+            <a:extLst>
+              <a:ext uri="{28A0092B-C50C-407E-A947-70E740481C1C}">
+                <a14:useLocalDpi xmlns:a14="http://schemas.microsoft.com/office/drawing/2010/main" val="0"/>
+              </a:ext>
+            </a:extLst>
+          </a:blip>
+          <a:srcRect l="7416" t="1151" r="26389" b="10423"/>
+          <a:stretch>
+            <a:fillRect/>
+          </a:stretch>
+        </p:blipFill>
+        <p:spPr>
+          <a:xfrm>
+            <a:off x="7793379" y="1781123"/>
+            <a:ext cx="2798421" cy="2803685"/>
+          </a:xfrm>
+          <a:prstGeom prst="rect">
+            <a:avLst/>
+          </a:prstGeom>
+        </p:spPr>
+      </p:pic>
     </p:spTree>
     <p:extLst>
       <p:ext uri="{BB962C8B-B14F-4D97-AF65-F5344CB8AC3E}">
@@ -13397,10 +15953,10 @@
       </p:grpSpPr>
       <p:pic>
         <p:nvPicPr>
-          <p:cNvPr id="9" name="Picture 8">
+          <p:cNvPr id="8" name="Picture 7">
             <a:extLst>
               <a:ext uri="{FF2B5EF4-FFF2-40B4-BE49-F238E27FC236}">
-                <a16:creationId xmlns:a16="http://schemas.microsoft.com/office/drawing/2014/main" id="{0A7EA34A-389B-294B-1509-395D7C80363C}"/>
+                <a16:creationId xmlns:a16="http://schemas.microsoft.com/office/drawing/2014/main" id="{53F25BDC-4CCC-D19A-30CD-326627AB07B2}"/>
               </a:ext>
             </a:extLst>
           </p:cNvPr>
@@ -13410,47 +15966,22 @@
           <p:nvPr/>
         </p:nvPicPr>
         <p:blipFill>
-          <a:blip r:embed="rId2"/>
-          <a:srcRect l="4961" r="6923"/>
+          <a:blip r:embed="rId2">
+            <a:extLst>
+              <a:ext uri="{28A0092B-C50C-407E-A947-70E740481C1C}">
+                <a14:useLocalDpi xmlns:a14="http://schemas.microsoft.com/office/drawing/2010/main" val="0"/>
+              </a:ext>
+            </a:extLst>
+          </a:blip>
+          <a:srcRect l="16627" t="24933" r="23390" b="22289"/>
           <a:stretch>
             <a:fillRect/>
           </a:stretch>
         </p:blipFill>
         <p:spPr>
           <a:xfrm>
-            <a:off x="9396646" y="522917"/>
-            <a:ext cx="2216709" cy="4208488"/>
-          </a:xfrm>
-          <a:prstGeom prst="rect">
-            <a:avLst/>
-          </a:prstGeom>
-        </p:spPr>
-      </p:pic>
-      <p:pic>
-        <p:nvPicPr>
-          <p:cNvPr id="4" name="Picture 3">
-            <a:extLst>
-              <a:ext uri="{FF2B5EF4-FFF2-40B4-BE49-F238E27FC236}">
-                <a16:creationId xmlns:a16="http://schemas.microsoft.com/office/drawing/2014/main" id="{98002850-0030-6EF1-A0D7-7E47C33C2AD5}"/>
-              </a:ext>
-            </a:extLst>
-          </p:cNvPr>
-          <p:cNvPicPr>
-            <a:picLocks noChangeAspect="1"/>
-          </p:cNvPicPr>
-          <p:nvPr/>
-        </p:nvPicPr>
-        <p:blipFill>
-          <a:blip r:embed="rId3"/>
-          <a:srcRect l="6805" r="7569"/>
-          <a:stretch>
-            <a:fillRect/>
-          </a:stretch>
-        </p:blipFill>
-        <p:spPr>
-          <a:xfrm>
-            <a:off x="6764284" y="522917"/>
-            <a:ext cx="2632363" cy="4208488"/>
+            <a:off x="8071324" y="465806"/>
+            <a:ext cx="2193925" cy="1447800"/>
           </a:xfrm>
           <a:prstGeom prst="rect">
             <a:avLst/>
@@ -13472,7 +16003,7 @@
         <p:spPr>
           <a:xfrm>
             <a:off x="3540154" y="4761874"/>
-            <a:ext cx="5156171" cy="845389"/>
+            <a:ext cx="7000846" cy="845389"/>
           </a:xfrm>
           <a:prstGeom prst="rect">
             <a:avLst/>
@@ -13505,7 +16036,12 @@
           <a:lstStyle/>
           <a:p>
             <a:pPr algn="ctr"/>
-            <a:endParaRPr lang="en-CA"/>
+            <a:endParaRPr lang="en-CA">
+              <a:solidFill>
+                <a:schemeClr val="tx1"/>
+              </a:solidFill>
+              <a:latin typeface="Verdana Pro" panose="020B0604030504040204" pitchFamily="34" charset="0"/>
+            </a:endParaRPr>
           </a:p>
         </p:txBody>
       </p:sp>
@@ -13539,17 +16075,11 @@
           <a:p>
             <a:r>
               <a:rPr lang="en-US" sz="1400" dirty="0">
-                <a:solidFill>
-                  <a:srgbClr val="0000FF"/>
-                </a:solidFill>
                 <a:latin typeface="Verdana Pro" panose="020B0604030504040204" pitchFamily="34" charset="0"/>
               </a:rPr>
               <a:t>J8G6Z1 [B. cereus][thsA]</a:t>
             </a:r>
             <a:endParaRPr lang="en-CA" sz="1400" dirty="0">
-              <a:solidFill>
-                <a:srgbClr val="0000FF"/>
-              </a:solidFill>
               <a:latin typeface="Verdana Pro" panose="020B0604030504040204" pitchFamily="34" charset="0"/>
             </a:endParaRPr>
           </a:p>
@@ -13585,17 +16115,11 @@
           <a:p>
             <a:r>
               <a:rPr lang="en-US" sz="1400" dirty="0">
-                <a:solidFill>
-                  <a:srgbClr val="FF0000"/>
-                </a:solidFill>
                 <a:latin typeface="Verdana Pro" panose="020B0604030504040204" pitchFamily="34" charset="0"/>
               </a:rPr>
               <a:t>Q9BPY3 [H. sapiens][FAM118B]</a:t>
             </a:r>
             <a:endParaRPr lang="en-CA" sz="1400" dirty="0">
-              <a:solidFill>
-                <a:srgbClr val="FF0000"/>
-              </a:solidFill>
               <a:latin typeface="Verdana Pro" panose="020B0604030504040204" pitchFamily="34" charset="0"/>
             </a:endParaRPr>
           </a:p>
@@ -13615,8 +16139,8 @@
         </p:nvSpPr>
         <p:spPr>
           <a:xfrm>
-            <a:off x="3540154" y="5619753"/>
-            <a:ext cx="5156172" cy="845389"/>
+            <a:off x="3540153" y="5619753"/>
+            <a:ext cx="7000847" cy="845389"/>
           </a:xfrm>
           <a:prstGeom prst="rect">
             <a:avLst/>
@@ -13651,8 +16175,9 @@
             <a:pPr algn="ctr"/>
             <a:endParaRPr lang="en-CA">
               <a:solidFill>
-                <a:srgbClr val="FF0000"/>
+                <a:schemeClr val="tx1"/>
               </a:solidFill>
+              <a:latin typeface="Verdana Pro" panose="020B0604030504040204" pitchFamily="34" charset="0"/>
             </a:endParaRPr>
           </a:p>
         </p:txBody>
@@ -13671,8 +16196,8 @@
         </p:nvSpPr>
         <p:spPr>
           <a:xfrm>
-            <a:off x="6869891" y="526109"/>
-            <a:ext cx="2421147" cy="307777"/>
+            <a:off x="7789866" y="392858"/>
+            <a:ext cx="1266825" cy="307777"/>
           </a:xfrm>
           <a:prstGeom prst="rect">
             <a:avLst/>
@@ -13719,7 +16244,7 @@
         <p:spPr>
           <a:xfrm>
             <a:off x="3590958" y="4973886"/>
-            <a:ext cx="5107802" cy="461665"/>
+            <a:ext cx="4940567" cy="461665"/>
           </a:xfrm>
           <a:prstGeom prst="rect">
             <a:avLst/>
@@ -13738,19 +16263,13 @@
             </a:pPr>
             <a:r>
               <a:rPr lang="en-US" sz="1200" dirty="0">
-                <a:solidFill>
-                  <a:srgbClr val="0000FF"/>
-                </a:solidFill>
-                <a:latin typeface="Courier New" panose="02070309020205020404" pitchFamily="49" charset="0"/>
+                <a:latin typeface="Verdana Pro" panose="020B0604030504040204" pitchFamily="34" charset="0"/>
                 <a:cs typeface="Courier New" panose="02070309020205020404" pitchFamily="49" charset="0"/>
               </a:rPr>
               <a:t>NAD+ hydrolyzing component (NADase) of Thoeris antiviral defense system</a:t>
             </a:r>
             <a:endParaRPr lang="en-CA" sz="1200" dirty="0">
-              <a:solidFill>
-                <a:srgbClr val="0000FF"/>
-              </a:solidFill>
-              <a:latin typeface="Courier New" panose="02070309020205020404" pitchFamily="49" charset="0"/>
+              <a:latin typeface="Verdana Pro" panose="020B0604030504040204" pitchFamily="34" charset="0"/>
               <a:cs typeface="Courier New" panose="02070309020205020404" pitchFamily="49" charset="0"/>
             </a:endParaRPr>
           </a:p>
@@ -13790,19 +16309,13 @@
             </a:pPr>
             <a:r>
               <a:rPr lang="en-US" sz="1200" dirty="0">
-                <a:solidFill>
-                  <a:srgbClr val="FF0000"/>
-                </a:solidFill>
-                <a:latin typeface="Courier New" panose="02070309020205020404" pitchFamily="49" charset="0"/>
+                <a:latin typeface="Verdana Pro" panose="020B0604030504040204" pitchFamily="34" charset="0"/>
                 <a:cs typeface="Courier New" panose="02070309020205020404" pitchFamily="49" charset="0"/>
               </a:rPr>
               <a:t>Cajal body regulation</a:t>
             </a:r>
             <a:endParaRPr lang="en-CA" sz="1200" dirty="0">
-              <a:solidFill>
-                <a:srgbClr val="FF0000"/>
-              </a:solidFill>
-              <a:latin typeface="Courier New" panose="02070309020205020404" pitchFamily="49" charset="0"/>
+              <a:latin typeface="Verdana Pro" panose="020B0604030504040204" pitchFamily="34" charset="0"/>
               <a:cs typeface="Courier New" panose="02070309020205020404" pitchFamily="49" charset="0"/>
             </a:endParaRPr>
           </a:p>
@@ -13822,8 +16335,8 @@
         </p:nvSpPr>
         <p:spPr>
           <a:xfrm>
-            <a:off x="9192208" y="517361"/>
-            <a:ext cx="2421147" cy="307777"/>
+            <a:off x="7921419" y="1939049"/>
+            <a:ext cx="1135272" cy="307777"/>
           </a:xfrm>
           <a:prstGeom prst="rect">
             <a:avLst/>
@@ -13870,13 +16383,13 @@
           <p:nvPr>
             <p:extLst>
               <p:ext uri="{D42A27DB-BD31-4B8C-83A1-F6EECF244321}">
-                <p14:modId xmlns:p14="http://schemas.microsoft.com/office/powerpoint/2010/main" val="2977545053"/>
+                <p14:modId xmlns:p14="http://schemas.microsoft.com/office/powerpoint/2010/main" val="1125086360"/>
               </p:ext>
             </p:extLst>
           </p:nvPr>
         </p:nvGraphicFramePr>
         <p:xfrm>
-          <a:off x="411929" y="3828403"/>
+          <a:off x="448364" y="5095593"/>
           <a:ext cx="2782890" cy="1005840"/>
         </p:xfrm>
         <a:graphic>
@@ -14289,7 +16802,7 @@
           <a:blip>
             <a:extLst>
               <a:ext uri="{96DAC541-7B7A-43D3-8B79-37D633B846F1}">
-                <asvg:svgBlip xmlns:asvg="http://schemas.microsoft.com/office/drawing/2016/SVG/main" r:embed="rId4"/>
+                <asvg:svgBlip xmlns:asvg="http://schemas.microsoft.com/office/drawing/2016/SVG/main" r:embed="rId3"/>
               </a:ext>
             </a:extLst>
           </a:blip>
@@ -14300,7 +16813,7 @@
         </p:blipFill>
         <p:spPr>
           <a:xfrm>
-            <a:off x="219800" y="483593"/>
+            <a:off x="219800" y="1182093"/>
             <a:ext cx="3011454" cy="2945407"/>
           </a:xfrm>
           <a:prstGeom prst="rect">
@@ -14322,7 +16835,7 @@
         </p:nvSpPr>
         <p:spPr>
           <a:xfrm>
-            <a:off x="1454150" y="1024261"/>
+            <a:off x="1454150" y="1722761"/>
             <a:ext cx="158750" cy="93382"/>
           </a:xfrm>
           <a:prstGeom prst="rect">
@@ -14362,10 +16875,10 @@
       </p:sp>
       <p:pic>
         <p:nvPicPr>
-          <p:cNvPr id="6" name="Picture 5">
+          <p:cNvPr id="5" name="Picture 4">
             <a:extLst>
               <a:ext uri="{FF2B5EF4-FFF2-40B4-BE49-F238E27FC236}">
-                <a16:creationId xmlns:a16="http://schemas.microsoft.com/office/drawing/2014/main" id="{F6E9BAA3-133D-6128-ADED-040408343B27}"/>
+                <a16:creationId xmlns:a16="http://schemas.microsoft.com/office/drawing/2014/main" id="{203C8650-AB27-C535-5337-57A9A96ACB62}"/>
               </a:ext>
             </a:extLst>
           </p:cNvPr>
@@ -14375,15 +16888,59 @@
           <p:nvPr/>
         </p:nvPicPr>
         <p:blipFill>
-          <a:blip r:embed="rId5"/>
+          <a:blip r:embed="rId4">
+            <a:extLst>
+              <a:ext uri="{28A0092B-C50C-407E-A947-70E740481C1C}">
+                <a14:useLocalDpi xmlns:a14="http://schemas.microsoft.com/office/drawing/2010/main" val="0"/>
+              </a:ext>
+            </a:extLst>
+          </a:blip>
+          <a:srcRect l="8766" t="7467" r="21790"/>
           <a:stretch>
             <a:fillRect/>
           </a:stretch>
         </p:blipFill>
         <p:spPr>
           <a:xfrm>
-            <a:off x="3540154" y="522917"/>
-            <a:ext cx="3224130" cy="4208488"/>
+            <a:off x="3500153" y="365519"/>
+            <a:ext cx="4302272" cy="4299506"/>
+          </a:xfrm>
+          <a:prstGeom prst="rect">
+            <a:avLst/>
+          </a:prstGeom>
+        </p:spPr>
+      </p:pic>
+      <p:pic>
+        <p:nvPicPr>
+          <p:cNvPr id="11" name="Picture 10">
+            <a:extLst>
+              <a:ext uri="{FF2B5EF4-FFF2-40B4-BE49-F238E27FC236}">
+                <a16:creationId xmlns:a16="http://schemas.microsoft.com/office/drawing/2014/main" id="{B3150A87-D2FB-2BFF-5F0C-310E078D4BFA}"/>
+              </a:ext>
+            </a:extLst>
+          </p:cNvPr>
+          <p:cNvPicPr>
+            <a:picLocks noChangeAspect="1"/>
+          </p:cNvPicPr>
+          <p:nvPr/>
+        </p:nvPicPr>
+        <p:blipFill>
+          <a:blip r:embed="rId5">
+            <a:extLst>
+              <a:ext uri="{28A0092B-C50C-407E-A947-70E740481C1C}">
+                <a14:useLocalDpi xmlns:a14="http://schemas.microsoft.com/office/drawing/2010/main" val="0"/>
+              </a:ext>
+            </a:extLst>
+          </a:blip>
+          <a:srcRect l="9623" t="6469" r="24182"/>
+          <a:stretch>
+            <a:fillRect/>
+          </a:stretch>
+        </p:blipFill>
+        <p:spPr>
+          <a:xfrm>
+            <a:off x="7802425" y="1882485"/>
+            <a:ext cx="2421147" cy="2565765"/>
           </a:xfrm>
           <a:prstGeom prst="rect">
             <a:avLst/>

</xml_diff>

<commit_message>
Removed watermarks on s1, s2 structures.
</commit_message>
<xml_diff>
--- a/reports/2026-04-10_projectUpdate_2_jmoran.pptx
+++ b/reports/2026-04-10_projectUpdate_2_jmoran.pptx
@@ -15843,10 +15843,10 @@
       </p:pic>
       <p:pic>
         <p:nvPicPr>
-          <p:cNvPr id="6" name="Picture 5">
+          <p:cNvPr id="14" name="Picture 13">
             <a:extLst>
               <a:ext uri="{FF2B5EF4-FFF2-40B4-BE49-F238E27FC236}">
-                <a16:creationId xmlns:a16="http://schemas.microsoft.com/office/drawing/2014/main" id="{111014E1-8AD8-A077-42C5-E195D80C6B32}"/>
+                <a16:creationId xmlns:a16="http://schemas.microsoft.com/office/drawing/2014/main" id="{78C65CB3-2FEF-EABD-3D6A-BC8864300282}"/>
               </a:ext>
             </a:extLst>
           </p:cNvPr>
@@ -15863,15 +15863,15 @@
               </a:ext>
             </a:extLst>
           </a:blip>
-          <a:srcRect l="22903" t="26887" r="29875" b="26817"/>
+          <a:srcRect l="40123" t="69182" r="39358"/>
           <a:stretch>
             <a:fillRect/>
           </a:stretch>
         </p:blipFill>
         <p:spPr>
           <a:xfrm>
-            <a:off x="8320372" y="430958"/>
-            <a:ext cx="1996341" cy="1467897"/>
+            <a:off x="8372475" y="360362"/>
+            <a:ext cx="1740245" cy="1960277"/>
           </a:xfrm>
           <a:prstGeom prst="rect">
             <a:avLst/>
@@ -15880,10 +15880,10 @@
       </p:pic>
       <p:pic>
         <p:nvPicPr>
-          <p:cNvPr id="12" name="Picture 11">
+          <p:cNvPr id="20" name="Picture 19">
             <a:extLst>
               <a:ext uri="{FF2B5EF4-FFF2-40B4-BE49-F238E27FC236}">
-                <a16:creationId xmlns:a16="http://schemas.microsoft.com/office/drawing/2014/main" id="{A1E98958-B2C4-90CB-90E5-A82770B5F13C}"/>
+                <a16:creationId xmlns:a16="http://schemas.microsoft.com/office/drawing/2014/main" id="{4818336F-2397-0EF1-4EBA-A626ED12BB41}"/>
               </a:ext>
             </a:extLst>
           </p:cNvPr>
@@ -15900,15 +15900,15 @@
               </a:ext>
             </a:extLst>
           </a:blip>
-          <a:srcRect l="7416" t="1151" r="26389" b="10423"/>
+          <a:srcRect l="30895" t="60625" r="38916"/>
           <a:stretch>
             <a:fillRect/>
           </a:stretch>
         </p:blipFill>
         <p:spPr>
           <a:xfrm>
-            <a:off x="7793379" y="1781123"/>
-            <a:ext cx="2798421" cy="2803685"/>
+            <a:off x="7582618" y="2005014"/>
+            <a:ext cx="2560363" cy="2504598"/>
           </a:xfrm>
           <a:prstGeom prst="rect">
             <a:avLst/>
@@ -15953,10 +15953,10 @@
       </p:grpSpPr>
       <p:pic>
         <p:nvPicPr>
-          <p:cNvPr id="8" name="Picture 7">
+          <p:cNvPr id="19" name="Picture 18">
             <a:extLst>
               <a:ext uri="{FF2B5EF4-FFF2-40B4-BE49-F238E27FC236}">
-                <a16:creationId xmlns:a16="http://schemas.microsoft.com/office/drawing/2014/main" id="{53F25BDC-4CCC-D19A-30CD-326627AB07B2}"/>
+                <a16:creationId xmlns:a16="http://schemas.microsoft.com/office/drawing/2014/main" id="{D7CA461C-AB95-3E4B-73EB-87FFCB666F74}"/>
               </a:ext>
             </a:extLst>
           </p:cNvPr>
@@ -15973,21 +15973,68 @@
               </a:ext>
             </a:extLst>
           </a:blip>
-          <a:srcRect l="16627" t="24933" r="23390" b="22289"/>
+          <a:srcRect l="35148" t="66578" r="34644"/>
           <a:stretch>
             <a:fillRect/>
           </a:stretch>
         </p:blipFill>
         <p:spPr>
           <a:xfrm>
-            <a:off x="8071324" y="465806"/>
-            <a:ext cx="2193925" cy="1447800"/>
+            <a:off x="8071324" y="2349284"/>
+            <a:ext cx="2790765" cy="2315741"/>
           </a:xfrm>
           <a:prstGeom prst="rect">
             <a:avLst/>
           </a:prstGeom>
         </p:spPr>
       </p:pic>
+      <p:sp>
+        <p:nvSpPr>
+          <p:cNvPr id="21" name="TextBox 20">
+            <a:extLst>
+              <a:ext uri="{FF2B5EF4-FFF2-40B4-BE49-F238E27FC236}">
+                <a16:creationId xmlns:a16="http://schemas.microsoft.com/office/drawing/2014/main" id="{AB15CA2F-4F07-6703-1917-EF06DBBCDC7C}"/>
+              </a:ext>
+            </a:extLst>
+          </p:cNvPr>
+          <p:cNvSpPr txBox="1"/>
+          <p:nvPr/>
+        </p:nvSpPr>
+        <p:spPr>
+          <a:xfrm>
+            <a:off x="7789866" y="392858"/>
+            <a:ext cx="1266825" cy="307777"/>
+          </a:xfrm>
+          <a:prstGeom prst="rect">
+            <a:avLst/>
+          </a:prstGeom>
+          <a:noFill/>
+        </p:spPr>
+        <p:txBody>
+          <a:bodyPr wrap="square" rtlCol="0">
+            <a:spAutoFit/>
+          </a:bodyPr>
+          <a:lstStyle/>
+          <a:p>
+            <a:pPr algn="r"/>
+            <a:r>
+              <a:rPr lang="en-US" sz="1400" dirty="0">
+                <a:solidFill>
+                  <a:srgbClr val="0000FF"/>
+                </a:solidFill>
+                <a:latin typeface="Verdana Pro" panose="020B0604030504040204" pitchFamily="34" charset="0"/>
+              </a:rPr>
+              <a:t>J8G6Z1</a:t>
+            </a:r>
+            <a:endParaRPr lang="en-CA" sz="1400" dirty="0">
+              <a:solidFill>
+                <a:srgbClr val="0000FF"/>
+              </a:solidFill>
+              <a:latin typeface="Verdana Pro" panose="020B0604030504040204" pitchFamily="34" charset="0"/>
+            </a:endParaRPr>
+          </a:p>
+        </p:txBody>
+      </p:sp>
       <p:sp>
         <p:nvSpPr>
           <p:cNvPr id="17" name="Rectangle 16">
@@ -16176,53 +16223,6 @@
             <a:endParaRPr lang="en-CA">
               <a:solidFill>
                 <a:schemeClr val="tx1"/>
-              </a:solidFill>
-              <a:latin typeface="Verdana Pro" panose="020B0604030504040204" pitchFamily="34" charset="0"/>
-            </a:endParaRPr>
-          </a:p>
-        </p:txBody>
-      </p:sp>
-      <p:sp>
-        <p:nvSpPr>
-          <p:cNvPr id="21" name="TextBox 20">
-            <a:extLst>
-              <a:ext uri="{FF2B5EF4-FFF2-40B4-BE49-F238E27FC236}">
-                <a16:creationId xmlns:a16="http://schemas.microsoft.com/office/drawing/2014/main" id="{AB15CA2F-4F07-6703-1917-EF06DBBCDC7C}"/>
-              </a:ext>
-            </a:extLst>
-          </p:cNvPr>
-          <p:cNvSpPr txBox="1"/>
-          <p:nvPr/>
-        </p:nvSpPr>
-        <p:spPr>
-          <a:xfrm>
-            <a:off x="7789866" y="392858"/>
-            <a:ext cx="1266825" cy="307777"/>
-          </a:xfrm>
-          <a:prstGeom prst="rect">
-            <a:avLst/>
-          </a:prstGeom>
-          <a:noFill/>
-        </p:spPr>
-        <p:txBody>
-          <a:bodyPr wrap="square" rtlCol="0">
-            <a:spAutoFit/>
-          </a:bodyPr>
-          <a:lstStyle/>
-          <a:p>
-            <a:pPr algn="r"/>
-            <a:r>
-              <a:rPr lang="en-US" sz="1400" dirty="0">
-                <a:solidFill>
-                  <a:srgbClr val="0000FF"/>
-                </a:solidFill>
-                <a:latin typeface="Verdana Pro" panose="020B0604030504040204" pitchFamily="34" charset="0"/>
-              </a:rPr>
-              <a:t>J8G6Z1</a:t>
-            </a:r>
-            <a:endParaRPr lang="en-CA" sz="1400" dirty="0">
-              <a:solidFill>
-                <a:srgbClr val="0000FF"/>
               </a:solidFill>
               <a:latin typeface="Verdana Pro" panose="020B0604030504040204" pitchFamily="34" charset="0"/>
             </a:endParaRPr>
@@ -16912,10 +16912,10 @@
       </p:pic>
       <p:pic>
         <p:nvPicPr>
-          <p:cNvPr id="11" name="Picture 10">
+          <p:cNvPr id="13" name="Picture 12">
             <a:extLst>
               <a:ext uri="{FF2B5EF4-FFF2-40B4-BE49-F238E27FC236}">
-                <a16:creationId xmlns:a16="http://schemas.microsoft.com/office/drawing/2014/main" id="{B3150A87-D2FB-2BFF-5F0C-310E078D4BFA}"/>
+                <a16:creationId xmlns:a16="http://schemas.microsoft.com/office/drawing/2014/main" id="{569C0F12-5F8D-F474-1E8D-B708B6BFAE96}"/>
               </a:ext>
             </a:extLst>
           </p:cNvPr>
@@ -16932,15 +16932,15 @@
               </a:ext>
             </a:extLst>
           </a:blip>
-          <a:srcRect l="9623" t="6469" r="24182"/>
+          <a:srcRect l="36355" t="74322" r="36286" b="4700"/>
           <a:stretch>
             <a:fillRect/>
           </a:stretch>
         </p:blipFill>
         <p:spPr>
           <a:xfrm>
-            <a:off x="7802425" y="1882485"/>
-            <a:ext cx="2421147" cy="2565765"/>
+            <a:off x="8174388" y="743943"/>
+            <a:ext cx="2527485" cy="1453524"/>
           </a:xfrm>
           <a:prstGeom prst="rect">
             <a:avLst/>

</xml_diff>

<commit_message>
Rendered PNGs for exploratory Zorya.
</commit_message>
<xml_diff>
--- a/reports/2026-04-10_projectUpdate_2_jmoran.pptx
+++ b/reports/2026-04-10_projectUpdate_2_jmoran.pptx
@@ -4584,64 +4584,12 @@
           <a:chExt cx="0" cy="0"/>
         </a:xfrm>
       </p:grpSpPr>
-      <p:sp>
-        <p:nvSpPr>
-          <p:cNvPr id="12" name="Rectangle 11">
-            <a:extLst>
-              <a:ext uri="{FF2B5EF4-FFF2-40B4-BE49-F238E27FC236}">
-                <a16:creationId xmlns:a16="http://schemas.microsoft.com/office/drawing/2014/main" id="{BECFF34D-EF51-9242-5410-5F51BAC36330}"/>
-              </a:ext>
-            </a:extLst>
-          </p:cNvPr>
-          <p:cNvSpPr/>
-          <p:nvPr/>
-        </p:nvSpPr>
-        <p:spPr>
-          <a:xfrm>
-            <a:off x="8711459" y="405442"/>
-            <a:ext cx="3059085" cy="2391754"/>
-          </a:xfrm>
-          <a:prstGeom prst="rect">
-            <a:avLst/>
-          </a:prstGeom>
-          <a:solidFill>
-            <a:srgbClr val="EEEEEE"/>
-          </a:solidFill>
-          <a:ln>
-            <a:noFill/>
-          </a:ln>
-        </p:spPr>
-        <p:style>
-          <a:lnRef idx="2">
-            <a:schemeClr val="accent1">
-              <a:shade val="15000"/>
-            </a:schemeClr>
-          </a:lnRef>
-          <a:fillRef idx="1">
-            <a:schemeClr val="accent1"/>
-          </a:fillRef>
-          <a:effectRef idx="0">
-            <a:schemeClr val="accent1"/>
-          </a:effectRef>
-          <a:fontRef idx="minor">
-            <a:schemeClr val="lt1"/>
-          </a:fontRef>
-        </p:style>
-        <p:txBody>
-          <a:bodyPr rtlCol="0" anchor="ctr"/>
-          <a:lstStyle/>
-          <a:p>
-            <a:pPr algn="ctr"/>
-            <a:endParaRPr lang="en-CA"/>
-          </a:p>
-        </p:txBody>
-      </p:sp>
       <p:pic>
         <p:nvPicPr>
-          <p:cNvPr id="10" name="Picture 9">
+          <p:cNvPr id="11" name="Picture 10">
             <a:extLst>
               <a:ext uri="{FF2B5EF4-FFF2-40B4-BE49-F238E27FC236}">
-                <a16:creationId xmlns:a16="http://schemas.microsoft.com/office/drawing/2014/main" id="{10A8A3A6-B805-4754-949B-A2994CFE8017}"/>
+                <a16:creationId xmlns:a16="http://schemas.microsoft.com/office/drawing/2014/main" id="{D8FCA25C-C618-51FB-36CB-E534671EDB6E}"/>
               </a:ext>
             </a:extLst>
           </p:cNvPr>
@@ -4651,79 +4599,34 @@
           <p:nvPr/>
         </p:nvPicPr>
         <p:blipFill>
-          <a:blip r:embed="rId2"/>
+          <a:blip r:embed="rId2">
+            <a:extLst>
+              <a:ext uri="{28A0092B-C50C-407E-A947-70E740481C1C}">
+                <a14:useLocalDpi xmlns:a14="http://schemas.microsoft.com/office/drawing/2010/main" val="0"/>
+              </a:ext>
+            </a:extLst>
+          </a:blip>
+          <a:srcRect l="33486" t="60028" r="35785" b="5597"/>
           <a:stretch>
             <a:fillRect/>
           </a:stretch>
         </p:blipFill>
         <p:spPr>
           <a:xfrm>
-            <a:off x="8748902" y="405442"/>
-            <a:ext cx="2823973" cy="2388458"/>
+            <a:off x="7939286" y="500618"/>
+            <a:ext cx="2193512" cy="1840319"/>
           </a:xfrm>
           <a:prstGeom prst="rect">
             <a:avLst/>
           </a:prstGeom>
         </p:spPr>
       </p:pic>
-      <p:sp>
-        <p:nvSpPr>
-          <p:cNvPr id="8" name="Rectangle 7">
-            <a:extLst>
-              <a:ext uri="{FF2B5EF4-FFF2-40B4-BE49-F238E27FC236}">
-                <a16:creationId xmlns:a16="http://schemas.microsoft.com/office/drawing/2014/main" id="{6E82F74D-D5FE-D9CF-114A-0F5783339A1D}"/>
-              </a:ext>
-            </a:extLst>
-          </p:cNvPr>
-          <p:cNvSpPr/>
-          <p:nvPr/>
-        </p:nvSpPr>
-        <p:spPr>
-          <a:xfrm>
-            <a:off x="8711460" y="2785987"/>
-            <a:ext cx="3059085" cy="3163726"/>
-          </a:xfrm>
-          <a:prstGeom prst="rect">
-            <a:avLst/>
-          </a:prstGeom>
-          <a:solidFill>
-            <a:srgbClr val="EEEEEE"/>
-          </a:solidFill>
-          <a:ln>
-            <a:noFill/>
-          </a:ln>
-        </p:spPr>
-        <p:style>
-          <a:lnRef idx="2">
-            <a:schemeClr val="accent1">
-              <a:shade val="15000"/>
-            </a:schemeClr>
-          </a:lnRef>
-          <a:fillRef idx="1">
-            <a:schemeClr val="accent1"/>
-          </a:fillRef>
-          <a:effectRef idx="0">
-            <a:schemeClr val="accent1"/>
-          </a:effectRef>
-          <a:fontRef idx="minor">
-            <a:schemeClr val="lt1"/>
-          </a:fontRef>
-        </p:style>
-        <p:txBody>
-          <a:bodyPr rtlCol="0" anchor="ctr"/>
-          <a:lstStyle/>
-          <a:p>
-            <a:pPr algn="ctr"/>
-            <a:endParaRPr lang="en-CA"/>
-          </a:p>
-        </p:txBody>
-      </p:sp>
       <p:pic>
         <p:nvPicPr>
-          <p:cNvPr id="7" name="Picture 6">
+          <p:cNvPr id="14" name="Picture 13">
             <a:extLst>
               <a:ext uri="{FF2B5EF4-FFF2-40B4-BE49-F238E27FC236}">
-                <a16:creationId xmlns:a16="http://schemas.microsoft.com/office/drawing/2014/main" id="{C6430691-1876-0115-553C-DEAE38981349}"/>
+                <a16:creationId xmlns:a16="http://schemas.microsoft.com/office/drawing/2014/main" id="{1CFBD10F-DC06-DA84-984A-2FCA404A541F}"/>
               </a:ext>
             </a:extLst>
           </p:cNvPr>
@@ -4733,16 +4636,22 @@
           <p:nvPr/>
         </p:nvPicPr>
         <p:blipFill>
-          <a:blip r:embed="rId3"/>
-          <a:srcRect b="3305"/>
+          <a:blip r:embed="rId3">
+            <a:extLst>
+              <a:ext uri="{28A0092B-C50C-407E-A947-70E740481C1C}">
+                <a14:useLocalDpi xmlns:a14="http://schemas.microsoft.com/office/drawing/2010/main" val="0"/>
+              </a:ext>
+            </a:extLst>
+          </a:blip>
+          <a:srcRect l="46094" t="57483" r="37761" b="5555"/>
           <a:stretch>
             <a:fillRect/>
           </a:stretch>
         </p:blipFill>
         <p:spPr>
           <a:xfrm>
-            <a:off x="8711460" y="2946791"/>
-            <a:ext cx="2934109" cy="3002921"/>
+            <a:off x="8893066" y="2057621"/>
+            <a:ext cx="1152525" cy="1978766"/>
           </a:xfrm>
           <a:prstGeom prst="rect">
             <a:avLst/>
@@ -4764,7 +4673,7 @@
         <p:spPr>
           <a:xfrm>
             <a:off x="3540154" y="4246444"/>
-            <a:ext cx="5156171" cy="845389"/>
+            <a:ext cx="6746846" cy="845389"/>
           </a:xfrm>
           <a:prstGeom prst="rect">
             <a:avLst/>
@@ -4830,7 +4739,7 @@
         </p:blipFill>
         <p:spPr>
           <a:xfrm>
-            <a:off x="276405" y="405443"/>
+            <a:off x="261242" y="1158179"/>
             <a:ext cx="2955856" cy="2994101"/>
           </a:xfrm>
           <a:prstGeom prst="rect">
@@ -4868,17 +4777,11 @@
           <a:p>
             <a:r>
               <a:rPr lang="en-US" sz="1400" dirty="0">
-                <a:solidFill>
-                  <a:srgbClr val="0000FF"/>
-                </a:solidFill>
                 <a:latin typeface="Verdana Pro" panose="020B0604030504040204" pitchFamily="34" charset="0"/>
               </a:rPr>
               <a:t>A0A6L8M512 [A. baumannii]</a:t>
             </a:r>
             <a:endParaRPr lang="en-CA" sz="1400" dirty="0">
-              <a:solidFill>
-                <a:srgbClr val="0000FF"/>
-              </a:solidFill>
               <a:latin typeface="Verdana Pro" panose="020B0604030504040204" pitchFamily="34" charset="0"/>
             </a:endParaRPr>
           </a:p>
@@ -4914,17 +4817,11 @@
           <a:p>
             <a:r>
               <a:rPr lang="en-US" sz="1400" dirty="0">
-                <a:solidFill>
-                  <a:srgbClr val="FF0000"/>
-                </a:solidFill>
                 <a:latin typeface="Verdana Pro" panose="020B0604030504040204" pitchFamily="34" charset="0"/>
               </a:rPr>
               <a:t>Q8N6J1 [H. sapiens][BTAF1]</a:t>
             </a:r>
             <a:endParaRPr lang="en-CA" sz="1400" dirty="0">
-              <a:solidFill>
-                <a:srgbClr val="FF0000"/>
-              </a:solidFill>
               <a:latin typeface="Verdana Pro" panose="020B0604030504040204" pitchFamily="34" charset="0"/>
             </a:endParaRPr>
           </a:p>
@@ -4944,8 +4841,8 @@
         </p:nvSpPr>
         <p:spPr>
           <a:xfrm>
-            <a:off x="3540154" y="5104323"/>
-            <a:ext cx="5156172" cy="845389"/>
+            <a:off x="3540153" y="5104323"/>
+            <a:ext cx="6746847" cy="845389"/>
           </a:xfrm>
           <a:prstGeom prst="rect">
             <a:avLst/>
@@ -5000,7 +4897,7 @@
         </p:nvSpPr>
         <p:spPr>
           <a:xfrm>
-            <a:off x="9394672" y="405443"/>
+            <a:off x="6905625" y="458073"/>
             <a:ext cx="2421147" cy="307777"/>
           </a:xfrm>
           <a:prstGeom prst="rect">
@@ -5048,7 +4945,7 @@
         <p:spPr>
           <a:xfrm>
             <a:off x="3590958" y="4458456"/>
-            <a:ext cx="5107802" cy="276999"/>
+            <a:ext cx="5029167" cy="276999"/>
           </a:xfrm>
           <a:prstGeom prst="rect">
             <a:avLst/>
@@ -5067,19 +4964,13 @@
             </a:pPr>
             <a:r>
               <a:rPr lang="en-US" sz="1200" dirty="0">
-                <a:solidFill>
-                  <a:srgbClr val="0000FF"/>
-                </a:solidFill>
-                <a:latin typeface="Courier New" panose="02070309020205020404" pitchFamily="49" charset="0"/>
+                <a:latin typeface="Verdana Pro" panose="020B0604030504040204" pitchFamily="34" charset="0"/>
                 <a:cs typeface="Courier New" panose="02070309020205020404" pitchFamily="49" charset="0"/>
               </a:rPr>
               <a:t>DEAD box helicase protein</a:t>
             </a:r>
             <a:endParaRPr lang="en-CA" sz="1200" dirty="0">
-              <a:solidFill>
-                <a:srgbClr val="0000FF"/>
-              </a:solidFill>
-              <a:latin typeface="Courier New" panose="02070309020205020404" pitchFamily="49" charset="0"/>
+              <a:latin typeface="Verdana Pro" panose="020B0604030504040204" pitchFamily="34" charset="0"/>
               <a:cs typeface="Courier New" panose="02070309020205020404" pitchFamily="49" charset="0"/>
             </a:endParaRPr>
           </a:p>
@@ -5100,7 +4991,7 @@
         <p:spPr>
           <a:xfrm>
             <a:off x="3540154" y="5363852"/>
-            <a:ext cx="5419693" cy="276999"/>
+            <a:ext cx="5079971" cy="276999"/>
           </a:xfrm>
           <a:prstGeom prst="rect">
             <a:avLst/>
@@ -5119,19 +5010,13 @@
             </a:pPr>
             <a:r>
               <a:rPr lang="en-US" sz="1200" dirty="0">
-                <a:solidFill>
-                  <a:srgbClr val="FF0000"/>
-                </a:solidFill>
-                <a:latin typeface="Courier New" panose="02070309020205020404" pitchFamily="49" charset="0"/>
+                <a:latin typeface="Verdana Pro" panose="020B0604030504040204" pitchFamily="34" charset="0"/>
                 <a:cs typeface="Courier New" panose="02070309020205020404" pitchFamily="49" charset="0"/>
               </a:rPr>
               <a:t>evidence of existence only at transcript level</a:t>
             </a:r>
             <a:endParaRPr lang="en-CA" sz="1200" dirty="0">
-              <a:solidFill>
-                <a:srgbClr val="FF0000"/>
-              </a:solidFill>
-              <a:latin typeface="Courier New" panose="02070309020205020404" pitchFamily="49" charset="0"/>
+              <a:latin typeface="Verdana Pro" panose="020B0604030504040204" pitchFamily="34" charset="0"/>
               <a:cs typeface="Courier New" panose="02070309020205020404" pitchFamily="49" charset="0"/>
             </a:endParaRPr>
           </a:p>
@@ -5152,7 +5037,7 @@
         <p:spPr>
           <a:xfrm>
             <a:off x="3533804" y="5542654"/>
-            <a:ext cx="5164955" cy="276999"/>
+            <a:ext cx="5086321" cy="276999"/>
           </a:xfrm>
           <a:prstGeom prst="rect">
             <a:avLst/>
@@ -5171,19 +5056,13 @@
             </a:pPr>
             <a:r>
               <a:rPr lang="en-US" sz="1200" dirty="0">
-                <a:solidFill>
-                  <a:srgbClr val="FF0000"/>
-                </a:solidFill>
-                <a:latin typeface="Courier New" panose="02070309020205020404" pitchFamily="49" charset="0"/>
+                <a:latin typeface="Verdana Pro" panose="020B0604030504040204" pitchFamily="34" charset="0"/>
                 <a:cs typeface="Courier New" panose="02070309020205020404" pitchFamily="49" charset="0"/>
               </a:rPr>
               <a:t>predicted helicase, hydrolase activity</a:t>
             </a:r>
             <a:endParaRPr lang="en-CA" sz="1200" dirty="0">
-              <a:solidFill>
-                <a:srgbClr val="FF0000"/>
-              </a:solidFill>
-              <a:latin typeface="Courier New" panose="02070309020205020404" pitchFamily="49" charset="0"/>
+              <a:latin typeface="Verdana Pro" panose="020B0604030504040204" pitchFamily="34" charset="0"/>
               <a:cs typeface="Courier New" panose="02070309020205020404" pitchFamily="49" charset="0"/>
             </a:endParaRPr>
           </a:p>
@@ -5203,8 +5082,8 @@
         </p:nvSpPr>
         <p:spPr>
           <a:xfrm>
-            <a:off x="9349399" y="3091767"/>
-            <a:ext cx="2421147" cy="307777"/>
+            <a:off x="8372475" y="2243217"/>
+            <a:ext cx="1045396" cy="307777"/>
           </a:xfrm>
           <a:prstGeom prst="rect">
             <a:avLst/>
@@ -5251,13 +5130,13 @@
           <p:nvPr>
             <p:extLst>
               <p:ext uri="{D42A27DB-BD31-4B8C-83A1-F6EECF244321}">
-                <p14:modId xmlns:p14="http://schemas.microsoft.com/office/powerpoint/2010/main" val="1113874521"/>
+                <p14:modId xmlns:p14="http://schemas.microsoft.com/office/powerpoint/2010/main" val="208563635"/>
               </p:ext>
             </p:extLst>
           </p:nvPr>
         </p:nvGraphicFramePr>
         <p:xfrm>
-          <a:off x="411929" y="3754941"/>
+          <a:off x="434208" y="4445374"/>
           <a:ext cx="2782890" cy="1097280"/>
         </p:xfrm>
         <a:graphic>
@@ -5783,7 +5662,7 @@
         </p:nvSpPr>
         <p:spPr>
           <a:xfrm>
-            <a:off x="2438837" y="1401961"/>
+            <a:off x="2423674" y="2154697"/>
             <a:ext cx="160146" cy="121490"/>
           </a:xfrm>
           <a:prstGeom prst="rect">
@@ -5823,10 +5702,10 @@
       </p:sp>
       <p:pic>
         <p:nvPicPr>
-          <p:cNvPr id="4" name="Picture 3">
+          <p:cNvPr id="6" name="Picture 5">
             <a:extLst>
               <a:ext uri="{FF2B5EF4-FFF2-40B4-BE49-F238E27FC236}">
-                <a16:creationId xmlns:a16="http://schemas.microsoft.com/office/drawing/2014/main" id="{D3A0F643-970A-26FF-175C-D976A558A202}"/>
+                <a16:creationId xmlns:a16="http://schemas.microsoft.com/office/drawing/2014/main" id="{66014C88-8AC4-6AE7-605B-0BF554056B80}"/>
               </a:ext>
             </a:extLst>
           </p:cNvPr>
@@ -5836,15 +5715,22 @@
           <p:nvPr/>
         </p:nvPicPr>
         <p:blipFill>
-          <a:blip r:embed="rId5"/>
+          <a:blip r:embed="rId5">
+            <a:extLst>
+              <a:ext uri="{28A0092B-C50C-407E-A947-70E740481C1C}">
+                <a14:useLocalDpi xmlns:a14="http://schemas.microsoft.com/office/drawing/2010/main" val="0"/>
+              </a:ext>
+            </a:extLst>
+          </a:blip>
+          <a:srcRect l="10615" t="7520" r="21094" b="15745"/>
           <a:stretch>
             <a:fillRect/>
           </a:stretch>
         </p:blipFill>
         <p:spPr>
           <a:xfrm>
-            <a:off x="3540154" y="405443"/>
-            <a:ext cx="5171304" cy="3815709"/>
+            <a:off x="3533804" y="455645"/>
+            <a:ext cx="4386432" cy="3696635"/>
           </a:xfrm>
           <a:prstGeom prst="rect">
             <a:avLst/>
@@ -17437,7 +17323,7 @@
                 </a:solidFill>
                 <a:latin typeface="Georgia Pro" panose="02040502050405020303" pitchFamily="18" charset="0"/>
               </a:rPr>
-              <a:t>Review – next steps</a:t>
+              <a:t>Aims</a:t>
             </a:r>
             <a:endParaRPr lang="en-CA" sz="2600" b="1" dirty="0">
               <a:solidFill>
@@ -19443,10 +19329,10 @@
       </p:grpSpPr>
       <p:pic>
         <p:nvPicPr>
-          <p:cNvPr id="11" name="Picture 10">
+          <p:cNvPr id="13" name="Picture 12">
             <a:extLst>
               <a:ext uri="{FF2B5EF4-FFF2-40B4-BE49-F238E27FC236}">
-                <a16:creationId xmlns:a16="http://schemas.microsoft.com/office/drawing/2014/main" id="{2CA1410C-3E75-3DA4-B14E-C13268097F8D}"/>
+                <a16:creationId xmlns:a16="http://schemas.microsoft.com/office/drawing/2014/main" id="{EB4B0AFB-FFE7-9A7B-2F17-394EE482F139}"/>
               </a:ext>
             </a:extLst>
           </p:cNvPr>
@@ -19463,14 +19349,15 @@
               </a:ext>
             </a:extLst>
           </a:blip>
+          <a:srcRect l="40886" t="59641" r="27865" b="4620"/>
           <a:stretch>
             <a:fillRect/>
           </a:stretch>
         </p:blipFill>
         <p:spPr>
           <a:xfrm>
-            <a:off x="8711460" y="405443"/>
-            <a:ext cx="3068612" cy="2541348"/>
+            <a:off x="8772524" y="2742724"/>
+            <a:ext cx="2019301" cy="1732046"/>
           </a:xfrm>
           <a:prstGeom prst="rect">
             <a:avLst/>
@@ -19479,10 +19366,10 @@
       </p:pic>
       <p:pic>
         <p:nvPicPr>
-          <p:cNvPr id="27" name="Picture 26">
+          <p:cNvPr id="6" name="Picture 5">
             <a:extLst>
               <a:ext uri="{FF2B5EF4-FFF2-40B4-BE49-F238E27FC236}">
-                <a16:creationId xmlns:a16="http://schemas.microsoft.com/office/drawing/2014/main" id="{32372D3B-10A7-BA1C-E1C1-2FF420E6F201}"/>
+                <a16:creationId xmlns:a16="http://schemas.microsoft.com/office/drawing/2014/main" id="{263CFE49-F1C6-2C66-ECB0-2A5C9EB619E5}"/>
               </a:ext>
             </a:extLst>
           </p:cNvPr>
@@ -19492,15 +19379,59 @@
           <p:nvPr/>
         </p:nvPicPr>
         <p:blipFill>
-          <a:blip r:embed="rId3"/>
+          <a:blip r:embed="rId3">
+            <a:extLst>
+              <a:ext uri="{28A0092B-C50C-407E-A947-70E740481C1C}">
+                <a14:useLocalDpi xmlns:a14="http://schemas.microsoft.com/office/drawing/2010/main" val="0"/>
+              </a:ext>
+            </a:extLst>
+          </a:blip>
+          <a:srcRect l="8897" t="7716" r="183" b="4529"/>
           <a:stretch>
             <a:fillRect/>
           </a:stretch>
         </p:blipFill>
         <p:spPr>
           <a:xfrm>
-            <a:off x="8711460" y="2946790"/>
-            <a:ext cx="3068611" cy="2791517"/>
+            <a:off x="3585442" y="512119"/>
+            <a:ext cx="5140806" cy="3721363"/>
+          </a:xfrm>
+          <a:prstGeom prst="rect">
+            <a:avLst/>
+          </a:prstGeom>
+        </p:spPr>
+      </p:pic>
+      <p:pic>
+        <p:nvPicPr>
+          <p:cNvPr id="9" name="Picture 8">
+            <a:extLst>
+              <a:ext uri="{FF2B5EF4-FFF2-40B4-BE49-F238E27FC236}">
+                <a16:creationId xmlns:a16="http://schemas.microsoft.com/office/drawing/2014/main" id="{46407528-094B-67C7-E59F-E1CA3AA5F3D9}"/>
+              </a:ext>
+            </a:extLst>
+          </p:cNvPr>
+          <p:cNvPicPr>
+            <a:picLocks noChangeAspect="1"/>
+          </p:cNvPicPr>
+          <p:nvPr/>
+        </p:nvPicPr>
+        <p:blipFill>
+          <a:blip r:embed="rId4">
+            <a:extLst>
+              <a:ext uri="{28A0092B-C50C-407E-A947-70E740481C1C}">
+                <a14:useLocalDpi xmlns:a14="http://schemas.microsoft.com/office/drawing/2010/main" val="0"/>
+              </a:ext>
+            </a:extLst>
+          </a:blip>
+          <a:srcRect l="32899" t="60851" r="35851" b="3410"/>
+          <a:stretch>
+            <a:fillRect/>
+          </a:stretch>
+        </p:blipFill>
+        <p:spPr>
+          <a:xfrm>
+            <a:off x="8651879" y="452614"/>
+            <a:ext cx="2019301" cy="1732046"/>
           </a:xfrm>
           <a:prstGeom prst="rect">
             <a:avLst/>
@@ -19522,7 +19453,7 @@
         <p:spPr>
           <a:xfrm>
             <a:off x="3540154" y="4749290"/>
-            <a:ext cx="5156171" cy="845389"/>
+            <a:ext cx="7184996" cy="845389"/>
           </a:xfrm>
           <a:prstGeom prst="rect">
             <a:avLst/>
@@ -19555,7 +19486,12 @@
           <a:lstStyle/>
           <a:p>
             <a:pPr algn="ctr"/>
-            <a:endParaRPr lang="en-CA"/>
+            <a:endParaRPr lang="en-CA">
+              <a:solidFill>
+                <a:schemeClr val="tx1"/>
+              </a:solidFill>
+              <a:latin typeface="Verdana Pro" panose="020B0604030504040204" pitchFamily="34" charset="0"/>
+            </a:endParaRPr>
           </a:p>
         </p:txBody>
       </p:sp>
@@ -19573,7 +19509,7 @@
         </p:nvGrpSpPr>
         <p:grpSpPr>
           <a:xfrm>
-            <a:off x="276405" y="405443"/>
+            <a:off x="238963" y="1167443"/>
             <a:ext cx="2955856" cy="2994101"/>
             <a:chOff x="1144437" y="1392623"/>
             <a:chExt cx="4876801" cy="4939901"/>
@@ -19597,7 +19533,7 @@
             <a:blip>
               <a:extLst>
                 <a:ext uri="{96DAC541-7B7A-43D3-8B79-37D633B846F1}">
-                  <asvg:svgBlip xmlns:asvg="http://schemas.microsoft.com/office/drawing/2016/SVG/main" r:embed="rId4"/>
+                  <asvg:svgBlip xmlns:asvg="http://schemas.microsoft.com/office/drawing/2016/SVG/main" r:embed="rId5"/>
                 </a:ext>
               </a:extLst>
             </a:blip>
@@ -19699,17 +19635,11 @@
           <a:p>
             <a:r>
               <a:rPr lang="en-US" sz="1400" dirty="0">
-                <a:solidFill>
-                  <a:srgbClr val="0000FF"/>
-                </a:solidFill>
                 <a:latin typeface="Verdana Pro" panose="020B0604030504040204" pitchFamily="34" charset="0"/>
               </a:rPr>
               <a:t>A0A0H4VDC2 [A. atlanticus]</a:t>
             </a:r>
             <a:endParaRPr lang="en-CA" sz="1400" dirty="0">
-              <a:solidFill>
-                <a:srgbClr val="0000FF"/>
-              </a:solidFill>
               <a:latin typeface="Verdana Pro" panose="020B0604030504040204" pitchFamily="34" charset="0"/>
             </a:endParaRPr>
           </a:p>
@@ -19745,17 +19675,11 @@
           <a:p>
             <a:r>
               <a:rPr lang="en-US" sz="1400" dirty="0">
-                <a:solidFill>
-                  <a:srgbClr val="FF0000"/>
-                </a:solidFill>
                 <a:latin typeface="Verdana Pro" panose="020B0604030504040204" pitchFamily="34" charset="0"/>
               </a:rPr>
               <a:t>X5D2E5 [H. sapiens][CHD1L]</a:t>
             </a:r>
             <a:endParaRPr lang="en-CA" sz="1400" dirty="0">
-              <a:solidFill>
-                <a:srgbClr val="FF0000"/>
-              </a:solidFill>
               <a:latin typeface="Verdana Pro" panose="020B0604030504040204" pitchFamily="34" charset="0"/>
             </a:endParaRPr>
           </a:p>
@@ -19775,8 +19699,8 @@
         </p:nvSpPr>
         <p:spPr>
           <a:xfrm>
-            <a:off x="3540154" y="5607169"/>
-            <a:ext cx="5156172" cy="845389"/>
+            <a:off x="3540153" y="5607169"/>
+            <a:ext cx="7184997" cy="845389"/>
           </a:xfrm>
           <a:prstGeom prst="rect">
             <a:avLst/>
@@ -19811,42 +19735,13 @@
             <a:pPr algn="ctr"/>
             <a:endParaRPr lang="en-CA">
               <a:solidFill>
-                <a:srgbClr val="FF0000"/>
+                <a:schemeClr val="tx1"/>
               </a:solidFill>
+              <a:latin typeface="Verdana Pro" panose="020B0604030504040204" pitchFamily="34" charset="0"/>
             </a:endParaRPr>
           </a:p>
         </p:txBody>
       </p:sp>
-      <p:pic>
-        <p:nvPicPr>
-          <p:cNvPr id="20" name="Picture 19">
-            <a:extLst>
-              <a:ext uri="{FF2B5EF4-FFF2-40B4-BE49-F238E27FC236}">
-                <a16:creationId xmlns:a16="http://schemas.microsoft.com/office/drawing/2014/main" id="{775E2953-C92B-DD97-A158-9DF0CD353A27}"/>
-              </a:ext>
-            </a:extLst>
-          </p:cNvPr>
-          <p:cNvPicPr>
-            <a:picLocks noChangeAspect="1"/>
-          </p:cNvPicPr>
-          <p:nvPr/>
-        </p:nvPicPr>
-        <p:blipFill>
-          <a:blip r:embed="rId5"/>
-          <a:stretch>
-            <a:fillRect/>
-          </a:stretch>
-        </p:blipFill>
-        <p:spPr>
-          <a:xfrm>
-            <a:off x="3533804" y="405443"/>
-            <a:ext cx="5171306" cy="4339086"/>
-          </a:xfrm>
-          <a:prstGeom prst="rect">
-            <a:avLst/>
-          </a:prstGeom>
-        </p:spPr>
-      </p:pic>
       <p:sp>
         <p:nvSpPr>
           <p:cNvPr id="21" name="TextBox 20">
@@ -19861,8 +19756,8 @@
         </p:nvSpPr>
         <p:spPr>
           <a:xfrm>
-            <a:off x="9394672" y="405443"/>
-            <a:ext cx="2421147" cy="307777"/>
+            <a:off x="8267700" y="452614"/>
+            <a:ext cx="1660529" cy="307777"/>
           </a:xfrm>
           <a:prstGeom prst="rect">
             <a:avLst/>
@@ -19909,7 +19804,7 @@
         <p:spPr>
           <a:xfrm>
             <a:off x="3590958" y="4961302"/>
-            <a:ext cx="5107802" cy="276999"/>
+            <a:ext cx="5010117" cy="276999"/>
           </a:xfrm>
           <a:prstGeom prst="rect">
             <a:avLst/>
@@ -19928,19 +19823,13 @@
             </a:pPr>
             <a:r>
               <a:rPr lang="en-US" sz="1200" dirty="0">
-                <a:solidFill>
-                  <a:srgbClr val="0000FF"/>
-                </a:solidFill>
-                <a:latin typeface="Courier New" panose="02070309020205020404" pitchFamily="49" charset="0"/>
+                <a:latin typeface="Verdana Pro" panose="020B0604030504040204" pitchFamily="34" charset="0"/>
                 <a:cs typeface="Courier New" panose="02070309020205020404" pitchFamily="49" charset="0"/>
               </a:rPr>
               <a:t>unreviewed, uncharacterised protein</a:t>
             </a:r>
             <a:endParaRPr lang="en-CA" sz="1200" dirty="0">
-              <a:solidFill>
-                <a:srgbClr val="0000FF"/>
-              </a:solidFill>
-              <a:latin typeface="Courier New" panose="02070309020205020404" pitchFamily="49" charset="0"/>
+              <a:latin typeface="Verdana Pro" panose="020B0604030504040204" pitchFamily="34" charset="0"/>
               <a:cs typeface="Courier New" panose="02070309020205020404" pitchFamily="49" charset="0"/>
             </a:endParaRPr>
           </a:p>
@@ -19961,7 +19850,7 @@
         <p:spPr>
           <a:xfrm>
             <a:off x="3590957" y="5163595"/>
-            <a:ext cx="5114152" cy="461665"/>
+            <a:ext cx="5060922" cy="461665"/>
           </a:xfrm>
           <a:prstGeom prst="rect">
             <a:avLst/>
@@ -19980,19 +19869,13 @@
             </a:pPr>
             <a:r>
               <a:rPr lang="en-US" sz="1200" dirty="0">
-                <a:solidFill>
-                  <a:srgbClr val="0000FF"/>
-                </a:solidFill>
-                <a:latin typeface="Courier New" panose="02070309020205020404" pitchFamily="49" charset="0"/>
+                <a:latin typeface="Verdana Pro" panose="020B0604030504040204" pitchFamily="34" charset="0"/>
                 <a:cs typeface="Courier New" panose="02070309020205020404" pitchFamily="49" charset="0"/>
               </a:rPr>
               <a:t>strong sequence homology to ATP-, DEAD-box helicases in other bacterial species</a:t>
             </a:r>
             <a:endParaRPr lang="en-CA" sz="1200" dirty="0">
-              <a:solidFill>
-                <a:srgbClr val="0000FF"/>
-              </a:solidFill>
-              <a:latin typeface="Courier New" panose="02070309020205020404" pitchFamily="49" charset="0"/>
+              <a:latin typeface="Verdana Pro" panose="020B0604030504040204" pitchFamily="34" charset="0"/>
               <a:cs typeface="Courier New" panose="02070309020205020404" pitchFamily="49" charset="0"/>
             </a:endParaRPr>
           </a:p>
@@ -20013,7 +19896,7 @@
         <p:spPr>
           <a:xfrm>
             <a:off x="3540154" y="5866698"/>
-            <a:ext cx="5419693" cy="276999"/>
+            <a:ext cx="4984721" cy="276999"/>
           </a:xfrm>
           <a:prstGeom prst="rect">
             <a:avLst/>
@@ -20032,19 +19915,13 @@
             </a:pPr>
             <a:r>
               <a:rPr lang="en-US" sz="1200" dirty="0">
-                <a:solidFill>
-                  <a:srgbClr val="FF0000"/>
-                </a:solidFill>
-                <a:latin typeface="Courier New" panose="02070309020205020404" pitchFamily="49" charset="0"/>
+                <a:latin typeface="Verdana Pro" panose="020B0604030504040204" pitchFamily="34" charset="0"/>
                 <a:cs typeface="Courier New" panose="02070309020205020404" pitchFamily="49" charset="0"/>
               </a:rPr>
               <a:t>ATP-binding, helicase activity</a:t>
             </a:r>
             <a:endParaRPr lang="en-CA" sz="1200" dirty="0">
-              <a:solidFill>
-                <a:srgbClr val="FF0000"/>
-              </a:solidFill>
-              <a:latin typeface="Courier New" panose="02070309020205020404" pitchFamily="49" charset="0"/>
+              <a:latin typeface="Verdana Pro" panose="020B0604030504040204" pitchFamily="34" charset="0"/>
               <a:cs typeface="Courier New" panose="02070309020205020404" pitchFamily="49" charset="0"/>
             </a:endParaRPr>
           </a:p>
@@ -20064,8 +19941,8 @@
         </p:nvSpPr>
         <p:spPr>
           <a:xfrm>
-            <a:off x="3533804" y="6045500"/>
-            <a:ext cx="5164955" cy="461665"/>
+            <a:off x="3533805" y="6045500"/>
+            <a:ext cx="5060922" cy="461665"/>
           </a:xfrm>
           <a:prstGeom prst="rect">
             <a:avLst/>
@@ -20084,39 +19961,27 @@
             </a:pPr>
             <a:r>
               <a:rPr lang="en-US" sz="1200" dirty="0">
-                <a:solidFill>
-                  <a:srgbClr val="FF0000"/>
-                </a:solidFill>
-                <a:latin typeface="Courier New" panose="02070309020205020404" pitchFamily="49" charset="0"/>
+                <a:latin typeface="Verdana Pro" panose="020B0604030504040204" pitchFamily="34" charset="0"/>
                 <a:cs typeface="Courier New" panose="02070309020205020404" pitchFamily="49" charset="0"/>
               </a:rPr>
               <a:t>"binds histones that are poly-ADP-</a:t>
             </a:r>
             <a:r>
               <a:rPr lang="en-US" sz="1200" dirty="0" err="1">
-                <a:solidFill>
-                  <a:srgbClr val="FF0000"/>
-                </a:solidFill>
-                <a:latin typeface="Courier New" panose="02070309020205020404" pitchFamily="49" charset="0"/>
+                <a:latin typeface="Verdana Pro" panose="020B0604030504040204" pitchFamily="34" charset="0"/>
                 <a:cs typeface="Courier New" panose="02070309020205020404" pitchFamily="49" charset="0"/>
               </a:rPr>
               <a:t>ribosylated</a:t>
             </a:r>
             <a:r>
               <a:rPr lang="en-US" sz="1200" dirty="0">
-                <a:solidFill>
-                  <a:srgbClr val="FF0000"/>
-                </a:solidFill>
-                <a:latin typeface="Courier New" panose="02070309020205020404" pitchFamily="49" charset="0"/>
+                <a:latin typeface="Verdana Pro" panose="020B0604030504040204" pitchFamily="34" charset="0"/>
                 <a:cs typeface="Courier New" panose="02070309020205020404" pitchFamily="49" charset="0"/>
               </a:rPr>
               <a:t> on serine residues in response to DNA damage"</a:t>
             </a:r>
             <a:endParaRPr lang="en-CA" sz="1200" dirty="0">
-              <a:solidFill>
-                <a:srgbClr val="FF0000"/>
-              </a:solidFill>
-              <a:latin typeface="Courier New" panose="02070309020205020404" pitchFamily="49" charset="0"/>
+              <a:latin typeface="Verdana Pro" panose="020B0604030504040204" pitchFamily="34" charset="0"/>
               <a:cs typeface="Courier New" panose="02070309020205020404" pitchFamily="49" charset="0"/>
             </a:endParaRPr>
           </a:p>
@@ -20136,8 +20001,8 @@
         </p:nvSpPr>
         <p:spPr>
           <a:xfrm>
-            <a:off x="9349399" y="3091767"/>
-            <a:ext cx="2421147" cy="307777"/>
+            <a:off x="8401429" y="2918317"/>
+            <a:ext cx="1034299" cy="307777"/>
           </a:xfrm>
           <a:prstGeom prst="rect">
             <a:avLst/>
@@ -20184,13 +20049,13 @@
           <p:nvPr>
             <p:extLst>
               <p:ext uri="{D42A27DB-BD31-4B8C-83A1-F6EECF244321}">
-                <p14:modId xmlns:p14="http://schemas.microsoft.com/office/powerpoint/2010/main" val="553997062"/>
+                <p14:modId xmlns:p14="http://schemas.microsoft.com/office/powerpoint/2010/main" val="156444382"/>
               </p:ext>
             </p:extLst>
           </p:nvPr>
         </p:nvGraphicFramePr>
         <p:xfrm>
-          <a:off x="411929" y="3754941"/>
+          <a:off x="411929" y="4961302"/>
           <a:ext cx="2782890" cy="1097280"/>
         </p:xfrm>
         <a:graphic>
@@ -20740,10 +20605,10 @@
       </p:grpSpPr>
       <p:pic>
         <p:nvPicPr>
-          <p:cNvPr id="9" name="Picture 8">
+          <p:cNvPr id="20" name="Picture 19">
             <a:extLst>
               <a:ext uri="{FF2B5EF4-FFF2-40B4-BE49-F238E27FC236}">
-                <a16:creationId xmlns:a16="http://schemas.microsoft.com/office/drawing/2014/main" id="{029B9206-4383-222B-653B-DC4D92132894}"/>
+                <a16:creationId xmlns:a16="http://schemas.microsoft.com/office/drawing/2014/main" id="{A494934C-AADA-807E-DCC0-6A6F2A976C0F}"/>
               </a:ext>
             </a:extLst>
           </p:cNvPr>
@@ -20753,15 +20618,22 @@
           <p:nvPr/>
         </p:nvPicPr>
         <p:blipFill>
-          <a:blip r:embed="rId2"/>
+          <a:blip r:embed="rId2">
+            <a:extLst>
+              <a:ext uri="{28A0092B-C50C-407E-A947-70E740481C1C}">
+                <a14:useLocalDpi xmlns:a14="http://schemas.microsoft.com/office/drawing/2010/main" val="0"/>
+              </a:ext>
+            </a:extLst>
+          </a:blip>
+          <a:srcRect l="36851" t="59941" r="38054" b="3682"/>
           <a:stretch>
             <a:fillRect/>
           </a:stretch>
         </p:blipFill>
         <p:spPr>
           <a:xfrm>
-            <a:off x="8717809" y="2574759"/>
-            <a:ext cx="3052737" cy="2876132"/>
+            <a:off x="8254390" y="2746454"/>
+            <a:ext cx="1760830" cy="1914356"/>
           </a:xfrm>
           <a:prstGeom prst="rect">
             <a:avLst/>
@@ -20770,10 +20642,10 @@
       </p:pic>
       <p:pic>
         <p:nvPicPr>
-          <p:cNvPr id="7" name="Picture 6">
+          <p:cNvPr id="14" name="Picture 13">
             <a:extLst>
               <a:ext uri="{FF2B5EF4-FFF2-40B4-BE49-F238E27FC236}">
-                <a16:creationId xmlns:a16="http://schemas.microsoft.com/office/drawing/2014/main" id="{478B2DC9-11AE-F408-0C77-180D3EB66B9F}"/>
+                <a16:creationId xmlns:a16="http://schemas.microsoft.com/office/drawing/2014/main" id="{9B9B67B6-0446-6666-8D67-7D8E7E8DB8B3}"/>
               </a:ext>
             </a:extLst>
           </p:cNvPr>
@@ -20783,15 +20655,22 @@
           <p:nvPr/>
         </p:nvPicPr>
         <p:blipFill>
-          <a:blip r:embed="rId3"/>
+          <a:blip r:embed="rId3">
+            <a:extLst>
+              <a:ext uri="{28A0092B-C50C-407E-A947-70E740481C1C}">
+                <a14:useLocalDpi xmlns:a14="http://schemas.microsoft.com/office/drawing/2010/main" val="0"/>
+              </a:ext>
+            </a:extLst>
+          </a:blip>
+          <a:srcRect l="32178" t="59941" r="35667"/>
           <a:stretch>
             <a:fillRect/>
           </a:stretch>
         </p:blipFill>
         <p:spPr>
           <a:xfrm>
-            <a:off x="8717809" y="114300"/>
-            <a:ext cx="3059385" cy="2460458"/>
+            <a:off x="7926935" y="620089"/>
+            <a:ext cx="2256230" cy="2108120"/>
           </a:xfrm>
           <a:prstGeom prst="rect">
             <a:avLst/>
@@ -20813,7 +20692,7 @@
         <p:spPr>
           <a:xfrm>
             <a:off x="3540154" y="4749290"/>
-            <a:ext cx="5156171" cy="845389"/>
+            <a:ext cx="6984971" cy="845389"/>
           </a:xfrm>
           <a:prstGeom prst="rect">
             <a:avLst/>
@@ -20846,7 +20725,12 @@
           <a:lstStyle/>
           <a:p>
             <a:pPr algn="ctr"/>
-            <a:endParaRPr lang="en-CA"/>
+            <a:endParaRPr lang="en-CA">
+              <a:solidFill>
+                <a:schemeClr val="tx1"/>
+              </a:solidFill>
+              <a:latin typeface="Verdana Pro" panose="020B0604030504040204" pitchFamily="34" charset="0"/>
+            </a:endParaRPr>
           </a:p>
         </p:txBody>
       </p:sp>
@@ -20879,7 +20763,7 @@
         </p:blipFill>
         <p:spPr>
           <a:xfrm>
-            <a:off x="276405" y="405443"/>
+            <a:off x="313877" y="1501316"/>
             <a:ext cx="2955856" cy="2994101"/>
           </a:xfrm>
           <a:prstGeom prst="rect">
@@ -20917,17 +20801,11 @@
           <a:p>
             <a:r>
               <a:rPr lang="en-US" sz="1400" dirty="0">
-                <a:solidFill>
-                  <a:srgbClr val="0000FF"/>
-                </a:solidFill>
                 <a:latin typeface="Verdana Pro" panose="020B0604030504040204" pitchFamily="34" charset="0"/>
               </a:rPr>
               <a:t>A0A5B8XTL3 [M. marinus]</a:t>
             </a:r>
             <a:endParaRPr lang="en-CA" sz="1400" dirty="0">
-              <a:solidFill>
-                <a:srgbClr val="0000FF"/>
-              </a:solidFill>
               <a:latin typeface="Verdana Pro" panose="020B0604030504040204" pitchFamily="34" charset="0"/>
             </a:endParaRPr>
           </a:p>
@@ -20963,17 +20841,11 @@
           <a:p>
             <a:r>
               <a:rPr lang="en-US" sz="1400" dirty="0">
-                <a:solidFill>
-                  <a:srgbClr val="FF0000"/>
-                </a:solidFill>
                 <a:latin typeface="Verdana Pro" panose="020B0604030504040204" pitchFamily="34" charset="0"/>
               </a:rPr>
               <a:t>A0A0A0MSH9 [H. sapiens][CHD1L]</a:t>
             </a:r>
             <a:endParaRPr lang="en-CA" sz="1400" dirty="0">
-              <a:solidFill>
-                <a:srgbClr val="FF0000"/>
-              </a:solidFill>
               <a:latin typeface="Verdana Pro" panose="020B0604030504040204" pitchFamily="34" charset="0"/>
             </a:endParaRPr>
           </a:p>
@@ -20994,7 +20866,7 @@
         <p:spPr>
           <a:xfrm>
             <a:off x="3540154" y="5607169"/>
-            <a:ext cx="5156172" cy="845389"/>
+            <a:ext cx="6984972" cy="845389"/>
           </a:xfrm>
           <a:prstGeom prst="rect">
             <a:avLst/>
@@ -21029,8 +20901,9 @@
             <a:pPr algn="ctr"/>
             <a:endParaRPr lang="en-CA">
               <a:solidFill>
-                <a:srgbClr val="FF0000"/>
+                <a:schemeClr val="tx1"/>
               </a:solidFill>
+              <a:latin typeface="Verdana Pro" panose="020B0604030504040204" pitchFamily="34" charset="0"/>
             </a:endParaRPr>
           </a:p>
         </p:txBody>
@@ -21049,8 +20922,8 @@
         </p:nvSpPr>
         <p:spPr>
           <a:xfrm>
-            <a:off x="9394672" y="106993"/>
-            <a:ext cx="2421147" cy="307777"/>
+            <a:off x="7727496" y="669509"/>
+            <a:ext cx="1643119" cy="307777"/>
           </a:xfrm>
           <a:prstGeom prst="rect">
             <a:avLst/>
@@ -21097,7 +20970,7 @@
         <p:spPr>
           <a:xfrm>
             <a:off x="3590958" y="4961302"/>
-            <a:ext cx="5107802" cy="276999"/>
+            <a:ext cx="4921764" cy="276999"/>
           </a:xfrm>
           <a:prstGeom prst="rect">
             <a:avLst/>
@@ -21116,19 +20989,13 @@
             </a:pPr>
             <a:r>
               <a:rPr lang="en-US" sz="1200" dirty="0">
-                <a:solidFill>
-                  <a:srgbClr val="0000FF"/>
-                </a:solidFill>
-                <a:latin typeface="Courier New" panose="02070309020205020404" pitchFamily="49" charset="0"/>
+                <a:latin typeface="Verdana Pro" panose="020B0604030504040204" pitchFamily="34" charset="0"/>
                 <a:cs typeface="Courier New" panose="02070309020205020404" pitchFamily="49" charset="0"/>
               </a:rPr>
               <a:t>DEAD-box helicase</a:t>
             </a:r>
             <a:endParaRPr lang="en-CA" sz="1200" dirty="0">
-              <a:solidFill>
-                <a:srgbClr val="0000FF"/>
-              </a:solidFill>
-              <a:latin typeface="Courier New" panose="02070309020205020404" pitchFamily="49" charset="0"/>
+              <a:latin typeface="Verdana Pro" panose="020B0604030504040204" pitchFamily="34" charset="0"/>
               <a:cs typeface="Courier New" panose="02070309020205020404" pitchFamily="49" charset="0"/>
             </a:endParaRPr>
           </a:p>
@@ -21148,8 +21015,8 @@
         </p:nvSpPr>
         <p:spPr>
           <a:xfrm>
-            <a:off x="3540154" y="5866698"/>
-            <a:ext cx="5419693" cy="461665"/>
+            <a:off x="3540155" y="5866698"/>
+            <a:ext cx="4708496" cy="461665"/>
           </a:xfrm>
           <a:prstGeom prst="rect">
             <a:avLst/>
@@ -21168,19 +21035,13 @@
             </a:pPr>
             <a:r>
               <a:rPr lang="en-US" sz="1200" dirty="0">
-                <a:solidFill>
-                  <a:srgbClr val="FF0000"/>
-                </a:solidFill>
-                <a:latin typeface="Courier New" panose="02070309020205020404" pitchFamily="49" charset="0"/>
+                <a:latin typeface="Verdana Pro" panose="020B0604030504040204" pitchFamily="34" charset="0"/>
                 <a:cs typeface="Courier New" panose="02070309020205020404" pitchFamily="49" charset="0"/>
               </a:rPr>
               <a:t>ATP-binding, helicase activity</a:t>
             </a:r>
             <a:endParaRPr lang="en-CA" sz="1200" dirty="0">
-              <a:solidFill>
-                <a:srgbClr val="FF0000"/>
-              </a:solidFill>
-              <a:latin typeface="Courier New" panose="02070309020205020404" pitchFamily="49" charset="0"/>
+              <a:latin typeface="Verdana Pro" panose="020B0604030504040204" pitchFamily="34" charset="0"/>
               <a:cs typeface="Courier New" panose="02070309020205020404" pitchFamily="49" charset="0"/>
             </a:endParaRPr>
           </a:p>
@@ -21190,10 +21051,7 @@
               <a:buChar char="•"/>
             </a:pPr>
             <a:endParaRPr lang="en-CA" sz="1200" dirty="0">
-              <a:solidFill>
-                <a:srgbClr val="FF0000"/>
-              </a:solidFill>
-              <a:latin typeface="Courier New" panose="02070309020205020404" pitchFamily="49" charset="0"/>
+              <a:latin typeface="Verdana Pro" panose="020B0604030504040204" pitchFamily="34" charset="0"/>
               <a:cs typeface="Courier New" panose="02070309020205020404" pitchFamily="49" charset="0"/>
             </a:endParaRPr>
           </a:p>
@@ -21213,8 +21071,8 @@
         </p:nvSpPr>
         <p:spPr>
           <a:xfrm>
-            <a:off x="3533804" y="6045500"/>
-            <a:ext cx="5164955" cy="461665"/>
+            <a:off x="3533805" y="6045500"/>
+            <a:ext cx="4978918" cy="461665"/>
           </a:xfrm>
           <a:prstGeom prst="rect">
             <a:avLst/>
@@ -21233,39 +21091,27 @@
             </a:pPr>
             <a:r>
               <a:rPr lang="en-US" sz="1200" dirty="0">
-                <a:solidFill>
-                  <a:srgbClr val="FF0000"/>
-                </a:solidFill>
-                <a:latin typeface="Courier New" panose="02070309020205020404" pitchFamily="49" charset="0"/>
+                <a:latin typeface="Verdana Pro" panose="020B0604030504040204" pitchFamily="34" charset="0"/>
                 <a:cs typeface="Courier New" panose="02070309020205020404" pitchFamily="49" charset="0"/>
               </a:rPr>
               <a:t>"binds histones that are poly-ADP-</a:t>
             </a:r>
             <a:r>
               <a:rPr lang="en-US" sz="1200" dirty="0" err="1">
-                <a:solidFill>
-                  <a:srgbClr val="FF0000"/>
-                </a:solidFill>
-                <a:latin typeface="Courier New" panose="02070309020205020404" pitchFamily="49" charset="0"/>
+                <a:latin typeface="Verdana Pro" panose="020B0604030504040204" pitchFamily="34" charset="0"/>
                 <a:cs typeface="Courier New" panose="02070309020205020404" pitchFamily="49" charset="0"/>
               </a:rPr>
               <a:t>ribosylated</a:t>
             </a:r>
             <a:r>
               <a:rPr lang="en-US" sz="1200" dirty="0">
-                <a:solidFill>
-                  <a:srgbClr val="FF0000"/>
-                </a:solidFill>
-                <a:latin typeface="Courier New" panose="02070309020205020404" pitchFamily="49" charset="0"/>
+                <a:latin typeface="Verdana Pro" panose="020B0604030504040204" pitchFamily="34" charset="0"/>
                 <a:cs typeface="Courier New" panose="02070309020205020404" pitchFamily="49" charset="0"/>
               </a:rPr>
               <a:t> on serine residues in response to DNA damage"</a:t>
             </a:r>
             <a:endParaRPr lang="en-CA" sz="1200" dirty="0">
-              <a:solidFill>
-                <a:srgbClr val="FF0000"/>
-              </a:solidFill>
-              <a:latin typeface="Courier New" panose="02070309020205020404" pitchFamily="49" charset="0"/>
+              <a:latin typeface="Verdana Pro" panose="020B0604030504040204" pitchFamily="34" charset="0"/>
               <a:cs typeface="Courier New" panose="02070309020205020404" pitchFamily="49" charset="0"/>
             </a:endParaRPr>
           </a:p>
@@ -21285,8 +21131,8 @@
         </p:nvSpPr>
         <p:spPr>
           <a:xfrm>
-            <a:off x="9394672" y="2515033"/>
-            <a:ext cx="2421147" cy="307777"/>
+            <a:off x="7972575" y="2707018"/>
+            <a:ext cx="1505848" cy="307777"/>
           </a:xfrm>
           <a:prstGeom prst="rect">
             <a:avLst/>
@@ -21333,13 +21179,13 @@
           <p:nvPr>
             <p:extLst>
               <p:ext uri="{D42A27DB-BD31-4B8C-83A1-F6EECF244321}">
-                <p14:modId xmlns:p14="http://schemas.microsoft.com/office/powerpoint/2010/main" val="3215456144"/>
+                <p14:modId xmlns:p14="http://schemas.microsoft.com/office/powerpoint/2010/main" val="3143692871"/>
               </p:ext>
             </p:extLst>
           </p:nvPr>
         </p:nvGraphicFramePr>
         <p:xfrm>
-          <a:off x="411929" y="3754941"/>
+          <a:off x="486843" y="4932583"/>
           <a:ext cx="2782890" cy="1097280"/>
         </p:xfrm>
         <a:graphic>
@@ -21865,7 +21711,7 @@
         </p:nvSpPr>
         <p:spPr>
           <a:xfrm>
-            <a:off x="2176780" y="2515033"/>
+            <a:off x="2214880" y="3610408"/>
             <a:ext cx="160146" cy="121490"/>
           </a:xfrm>
           <a:prstGeom prst="rect">
@@ -21905,10 +21751,10 @@
       </p:sp>
       <p:pic>
         <p:nvPicPr>
-          <p:cNvPr id="4" name="Picture 3">
+          <p:cNvPr id="6" name="Picture 5">
             <a:extLst>
               <a:ext uri="{FF2B5EF4-FFF2-40B4-BE49-F238E27FC236}">
-                <a16:creationId xmlns:a16="http://schemas.microsoft.com/office/drawing/2014/main" id="{EB418ABC-1873-F644-A689-9C592995058C}"/>
+                <a16:creationId xmlns:a16="http://schemas.microsoft.com/office/drawing/2014/main" id="{F3F453C3-7C58-7772-1638-F7BAF91DA6E2}"/>
               </a:ext>
             </a:extLst>
           </p:cNvPr>
@@ -21918,15 +21764,21 @@
           <p:nvPr/>
         </p:nvPicPr>
         <p:blipFill>
-          <a:blip r:embed="rId5"/>
+          <a:blip r:embed="rId5">
+            <a:extLst>
+              <a:ext uri="{28A0092B-C50C-407E-A947-70E740481C1C}">
+                <a14:useLocalDpi xmlns:a14="http://schemas.microsoft.com/office/drawing/2010/main" val="0"/>
+              </a:ext>
+            </a:extLst>
+          </a:blip>
           <a:stretch>
             <a:fillRect/>
           </a:stretch>
         </p:blipFill>
         <p:spPr>
           <a:xfrm>
-            <a:off x="3533804" y="114300"/>
-            <a:ext cx="5168872" cy="4630227"/>
+            <a:off x="3194819" y="756099"/>
+            <a:ext cx="5317903" cy="3988428"/>
           </a:xfrm>
           <a:prstGeom prst="rect">
             <a:avLst/>
@@ -21969,12 +21821,86 @@
           <a:chExt cx="0" cy="0"/>
         </a:xfrm>
       </p:grpSpPr>
+      <p:pic>
+        <p:nvPicPr>
+          <p:cNvPr id="25" name="Picture 24">
+            <a:extLst>
+              <a:ext uri="{FF2B5EF4-FFF2-40B4-BE49-F238E27FC236}">
+                <a16:creationId xmlns:a16="http://schemas.microsoft.com/office/drawing/2014/main" id="{32724986-C337-7545-45C8-EDD49ABAC0F8}"/>
+              </a:ext>
+            </a:extLst>
+          </p:cNvPr>
+          <p:cNvPicPr>
+            <a:picLocks noChangeAspect="1"/>
+          </p:cNvPicPr>
+          <p:nvPr/>
+        </p:nvPicPr>
+        <p:blipFill>
+          <a:blip r:embed="rId2">
+            <a:extLst>
+              <a:ext uri="{28A0092B-C50C-407E-A947-70E740481C1C}">
+                <a14:useLocalDpi xmlns:a14="http://schemas.microsoft.com/office/drawing/2010/main" val="0"/>
+              </a:ext>
+            </a:extLst>
+          </a:blip>
+          <a:srcRect l="34116" t="62018" r="30381" b="12984"/>
+          <a:stretch>
+            <a:fillRect/>
+          </a:stretch>
+        </p:blipFill>
+        <p:spPr>
+          <a:xfrm>
+            <a:off x="7853800" y="1108453"/>
+            <a:ext cx="3034895" cy="1602673"/>
+          </a:xfrm>
+          <a:prstGeom prst="rect">
+            <a:avLst/>
+          </a:prstGeom>
+        </p:spPr>
+      </p:pic>
+      <p:pic>
+        <p:nvPicPr>
+          <p:cNvPr id="27" name="Picture 26">
+            <a:extLst>
+              <a:ext uri="{FF2B5EF4-FFF2-40B4-BE49-F238E27FC236}">
+                <a16:creationId xmlns:a16="http://schemas.microsoft.com/office/drawing/2014/main" id="{71D1DA5C-5D00-7D2B-8D8A-525BE8E74CB8}"/>
+              </a:ext>
+            </a:extLst>
+          </p:cNvPr>
+          <p:cNvPicPr>
+            <a:picLocks noChangeAspect="1"/>
+          </p:cNvPicPr>
+          <p:nvPr/>
+        </p:nvPicPr>
+        <p:blipFill>
+          <a:blip r:embed="rId3">
+            <a:extLst>
+              <a:ext uri="{28A0092B-C50C-407E-A947-70E740481C1C}">
+                <a14:useLocalDpi xmlns:a14="http://schemas.microsoft.com/office/drawing/2010/main" val="0"/>
+              </a:ext>
+            </a:extLst>
+          </a:blip>
+          <a:srcRect l="35000" t="59666" r="44725" b="9516"/>
+          <a:stretch>
+            <a:fillRect/>
+          </a:stretch>
+        </p:blipFill>
+        <p:spPr>
+          <a:xfrm>
+            <a:off x="7922252" y="2381542"/>
+            <a:ext cx="1733142" cy="1975789"/>
+          </a:xfrm>
+          <a:prstGeom prst="rect">
+            <a:avLst/>
+          </a:prstGeom>
+        </p:spPr>
+      </p:pic>
       <p:sp>
         <p:nvSpPr>
-          <p:cNvPr id="13" name="Rectangle 12">
+          <p:cNvPr id="17" name="Rectangle 16">
             <a:extLst>
               <a:ext uri="{FF2B5EF4-FFF2-40B4-BE49-F238E27FC236}">
-                <a16:creationId xmlns:a16="http://schemas.microsoft.com/office/drawing/2014/main" id="{9B619D5C-1957-C731-D7C7-99ABC25BBDD9}"/>
+                <a16:creationId xmlns:a16="http://schemas.microsoft.com/office/drawing/2014/main" id="{FB7E53FD-3B6C-6871-B74A-A418007335B0}"/>
               </a:ext>
             </a:extLst>
           </p:cNvPr>
@@ -21983,60 +21909,8 @@
         </p:nvSpPr>
         <p:spPr>
           <a:xfrm>
-            <a:off x="8711460" y="2785987"/>
-            <a:ext cx="3059085" cy="2627976"/>
-          </a:xfrm>
-          <a:prstGeom prst="rect">
-            <a:avLst/>
-          </a:prstGeom>
-          <a:solidFill>
-            <a:srgbClr val="EEEEEE"/>
-          </a:solidFill>
-          <a:ln>
-            <a:noFill/>
-          </a:ln>
-        </p:spPr>
-        <p:style>
-          <a:lnRef idx="2">
-            <a:schemeClr val="accent1">
-              <a:shade val="15000"/>
-            </a:schemeClr>
-          </a:lnRef>
-          <a:fillRef idx="1">
-            <a:schemeClr val="accent1"/>
-          </a:fillRef>
-          <a:effectRef idx="0">
-            <a:schemeClr val="accent1"/>
-          </a:effectRef>
-          <a:fontRef idx="minor">
-            <a:schemeClr val="lt1"/>
-          </a:fontRef>
-        </p:style>
-        <p:txBody>
-          <a:bodyPr rtlCol="0" anchor="ctr"/>
-          <a:lstStyle/>
-          <a:p>
-            <a:pPr algn="ctr"/>
-            <a:endParaRPr lang="en-CA"/>
-          </a:p>
-        </p:txBody>
-      </p:sp>
-      <p:sp>
-        <p:nvSpPr>
-          <p:cNvPr id="17" name="Rectangle 16">
-            <a:extLst>
-              <a:ext uri="{FF2B5EF4-FFF2-40B4-BE49-F238E27FC236}">
-                <a16:creationId xmlns:a16="http://schemas.microsoft.com/office/drawing/2014/main" id="{FB7E53FD-3B6C-6871-B74A-A418007335B0}"/>
-              </a:ext>
-            </a:extLst>
-          </p:cNvPr>
-          <p:cNvSpPr/>
-          <p:nvPr/>
-        </p:nvSpPr>
-        <p:spPr>
-          <a:xfrm>
-            <a:off x="3540154" y="3920615"/>
-            <a:ext cx="5156171" cy="845389"/>
+            <a:off x="3540153" y="4415915"/>
+            <a:ext cx="7442171" cy="845389"/>
           </a:xfrm>
           <a:prstGeom prst="rect">
             <a:avLst/>
@@ -22069,7 +21943,12 @@
           <a:lstStyle/>
           <a:p>
             <a:pPr algn="ctr"/>
-            <a:endParaRPr lang="en-CA"/>
+            <a:endParaRPr lang="en-CA">
+              <a:solidFill>
+                <a:schemeClr val="tx1"/>
+              </a:solidFill>
+              <a:latin typeface="Verdana Pro" panose="020B0604030504040204" pitchFamily="34" charset="0"/>
+            </a:endParaRPr>
           </a:p>
         </p:txBody>
       </p:sp>
@@ -22091,7 +21970,7 @@
           <a:blip>
             <a:extLst>
               <a:ext uri="{96DAC541-7B7A-43D3-8B79-37D633B846F1}">
-                <asvg:svgBlip xmlns:asvg="http://schemas.microsoft.com/office/drawing/2016/SVG/main" r:embed="rId2"/>
+                <asvg:svgBlip xmlns:asvg="http://schemas.microsoft.com/office/drawing/2016/SVG/main" r:embed="rId4"/>
               </a:ext>
             </a:extLst>
           </a:blip>
@@ -22102,7 +21981,7 @@
         </p:blipFill>
         <p:spPr>
           <a:xfrm>
-            <a:off x="276405" y="405443"/>
+            <a:off x="276405" y="1081718"/>
             <a:ext cx="2955856" cy="2994101"/>
           </a:xfrm>
           <a:prstGeom prst="rect">
@@ -22124,7 +22003,7 @@
         </p:nvSpPr>
         <p:spPr>
           <a:xfrm>
-            <a:off x="3590957" y="3915852"/>
+            <a:off x="3590957" y="4411152"/>
             <a:ext cx="4781518" cy="307777"/>
           </a:xfrm>
           <a:prstGeom prst="rect">
@@ -22140,17 +22019,11 @@
           <a:p>
             <a:r>
               <a:rPr lang="en-US" sz="1400" dirty="0">
-                <a:solidFill>
-                  <a:srgbClr val="0000FF"/>
-                </a:solidFill>
                 <a:latin typeface="Verdana Pro" panose="020B0604030504040204" pitchFamily="34" charset="0"/>
               </a:rPr>
               <a:t>A0A4Y6RC84 [J. tructae]</a:t>
             </a:r>
             <a:endParaRPr lang="en-CA" sz="1400" dirty="0">
-              <a:solidFill>
-                <a:srgbClr val="0000FF"/>
-              </a:solidFill>
               <a:latin typeface="Verdana Pro" panose="020B0604030504040204" pitchFamily="34" charset="0"/>
             </a:endParaRPr>
           </a:p>
@@ -22170,7 +22043,7 @@
         </p:nvSpPr>
         <p:spPr>
           <a:xfrm>
-            <a:off x="3590957" y="4803281"/>
+            <a:off x="3590957" y="5298581"/>
             <a:ext cx="3314668" cy="307777"/>
           </a:xfrm>
           <a:prstGeom prst="rect">
@@ -22186,17 +22059,11 @@
           <a:p>
             <a:r>
               <a:rPr lang="en-US" sz="1400" dirty="0">
-                <a:solidFill>
-                  <a:srgbClr val="FF0000"/>
-                </a:solidFill>
                 <a:latin typeface="Verdana Pro" panose="020B0604030504040204" pitchFamily="34" charset="0"/>
               </a:rPr>
               <a:t>B4DLS6 [H. sapiens][unreviewed]</a:t>
             </a:r>
             <a:endParaRPr lang="en-CA" sz="1400" dirty="0">
-              <a:solidFill>
-                <a:srgbClr val="FF0000"/>
-              </a:solidFill>
               <a:latin typeface="Verdana Pro" panose="020B0604030504040204" pitchFamily="34" charset="0"/>
             </a:endParaRPr>
           </a:p>
@@ -22216,8 +22083,8 @@
         </p:nvSpPr>
         <p:spPr>
           <a:xfrm>
-            <a:off x="3540154" y="4778494"/>
-            <a:ext cx="5156172" cy="845389"/>
+            <a:off x="3540153" y="5273794"/>
+            <a:ext cx="7442172" cy="845389"/>
           </a:xfrm>
           <a:prstGeom prst="rect">
             <a:avLst/>
@@ -22252,8 +22119,9 @@
             <a:pPr algn="ctr"/>
             <a:endParaRPr lang="en-CA">
               <a:solidFill>
-                <a:srgbClr val="FF0000"/>
+                <a:schemeClr val="tx1"/>
               </a:solidFill>
+              <a:latin typeface="Verdana Pro" panose="020B0604030504040204" pitchFamily="34" charset="0"/>
             </a:endParaRPr>
           </a:p>
         </p:txBody>
@@ -22272,7 +22140,7 @@
         </p:nvSpPr>
         <p:spPr>
           <a:xfrm>
-            <a:off x="3590958" y="4132627"/>
+            <a:off x="3590958" y="4627927"/>
             <a:ext cx="5107802" cy="276999"/>
           </a:xfrm>
           <a:prstGeom prst="rect">
@@ -22292,19 +22160,13 @@
             </a:pPr>
             <a:r>
               <a:rPr lang="en-US" sz="1200" dirty="0">
-                <a:solidFill>
-                  <a:srgbClr val="0000FF"/>
-                </a:solidFill>
-                <a:latin typeface="Courier New" panose="02070309020205020404" pitchFamily="49" charset="0"/>
+                <a:latin typeface="Verdana Pro" panose="020B0604030504040204" pitchFamily="34" charset="0"/>
                 <a:cs typeface="Courier New" panose="02070309020205020404" pitchFamily="49" charset="0"/>
               </a:rPr>
               <a:t>ATP-dependent helicase</a:t>
             </a:r>
             <a:endParaRPr lang="en-CA" sz="1200" dirty="0">
-              <a:solidFill>
-                <a:srgbClr val="0000FF"/>
-              </a:solidFill>
-              <a:latin typeface="Courier New" panose="02070309020205020404" pitchFamily="49" charset="0"/>
+              <a:latin typeface="Verdana Pro" panose="020B0604030504040204" pitchFamily="34" charset="0"/>
               <a:cs typeface="Courier New" panose="02070309020205020404" pitchFamily="49" charset="0"/>
             </a:endParaRPr>
           </a:p>
@@ -22324,7 +22186,7 @@
         </p:nvSpPr>
         <p:spPr>
           <a:xfrm>
-            <a:off x="3590957" y="4334920"/>
+            <a:off x="3590957" y="4830220"/>
             <a:ext cx="5114152" cy="276999"/>
           </a:xfrm>
           <a:prstGeom prst="rect">
@@ -22344,19 +22206,13 @@
             </a:pPr>
             <a:r>
               <a:rPr lang="en-US" sz="1200" dirty="0">
-                <a:solidFill>
-                  <a:srgbClr val="0000FF"/>
-                </a:solidFill>
-                <a:latin typeface="Courier New" panose="02070309020205020404" pitchFamily="49" charset="0"/>
+                <a:latin typeface="Verdana Pro" panose="020B0604030504040204" pitchFamily="34" charset="0"/>
                 <a:cs typeface="Courier New" panose="02070309020205020404" pitchFamily="49" charset="0"/>
               </a:rPr>
               <a:t>unreviewed</a:t>
             </a:r>
             <a:endParaRPr lang="en-CA" sz="1200" dirty="0">
-              <a:solidFill>
-                <a:srgbClr val="0000FF"/>
-              </a:solidFill>
-              <a:latin typeface="Courier New" panose="02070309020205020404" pitchFamily="49" charset="0"/>
+              <a:latin typeface="Verdana Pro" panose="020B0604030504040204" pitchFamily="34" charset="0"/>
               <a:cs typeface="Courier New" panose="02070309020205020404" pitchFamily="49" charset="0"/>
             </a:endParaRPr>
           </a:p>
@@ -22376,8 +22232,8 @@
         </p:nvSpPr>
         <p:spPr>
           <a:xfrm>
-            <a:off x="3540154" y="5038023"/>
-            <a:ext cx="5419693" cy="461665"/>
+            <a:off x="3540155" y="5533323"/>
+            <a:ext cx="5032346" cy="461665"/>
           </a:xfrm>
           <a:prstGeom prst="rect">
             <a:avLst/>
@@ -22396,19 +22252,13 @@
             </a:pPr>
             <a:r>
               <a:rPr lang="en-US" sz="1200" dirty="0">
-                <a:solidFill>
-                  <a:srgbClr val="FF0000"/>
-                </a:solidFill>
-                <a:latin typeface="Courier New" panose="02070309020205020404" pitchFamily="49" charset="0"/>
+                <a:latin typeface="Verdana Pro" panose="020B0604030504040204" pitchFamily="34" charset="0"/>
                 <a:cs typeface="Courier New" panose="02070309020205020404" pitchFamily="49" charset="0"/>
               </a:rPr>
               <a:t>"highly similar to Homo sapiens chromodomain helicase DNA binding protein 1-like (CHD1L)"</a:t>
             </a:r>
             <a:endParaRPr lang="en-CA" sz="1200" dirty="0">
-              <a:solidFill>
-                <a:srgbClr val="FF0000"/>
-              </a:solidFill>
-              <a:latin typeface="Courier New" panose="02070309020205020404" pitchFamily="49" charset="0"/>
+              <a:latin typeface="Verdana Pro" panose="020B0604030504040204" pitchFamily="34" charset="0"/>
               <a:cs typeface="Courier New" panose="02070309020205020404" pitchFamily="49" charset="0"/>
             </a:endParaRPr>
           </a:p>
@@ -22428,7 +22278,7 @@
         </p:nvSpPr>
         <p:spPr>
           <a:xfrm>
-            <a:off x="9349397" y="2785987"/>
+            <a:off x="8335930" y="2605642"/>
             <a:ext cx="2421147" cy="307777"/>
           </a:xfrm>
           <a:prstGeom prst="rect">
@@ -22476,13 +22326,13 @@
           <p:nvPr>
             <p:extLst>
               <p:ext uri="{D42A27DB-BD31-4B8C-83A1-F6EECF244321}">
-                <p14:modId xmlns:p14="http://schemas.microsoft.com/office/powerpoint/2010/main" val="3080920282"/>
+                <p14:modId xmlns:p14="http://schemas.microsoft.com/office/powerpoint/2010/main" val="1274061072"/>
               </p:ext>
             </p:extLst>
           </p:nvPr>
         </p:nvGraphicFramePr>
         <p:xfrm>
-          <a:off x="411929" y="3754941"/>
+          <a:off x="362888" y="4647043"/>
           <a:ext cx="2782890" cy="1097280"/>
         </p:xfrm>
         <a:graphic>
@@ -23008,7 +22858,7 @@
         </p:nvSpPr>
         <p:spPr>
           <a:xfrm>
-            <a:off x="1405374" y="2750222"/>
+            <a:off x="1405374" y="3416972"/>
             <a:ext cx="160146" cy="121490"/>
           </a:xfrm>
           <a:prstGeom prst="rect">
@@ -23046,66 +22896,6 @@
           </a:p>
         </p:txBody>
       </p:sp>
-      <p:pic>
-        <p:nvPicPr>
-          <p:cNvPr id="4" name="Picture 3">
-            <a:extLst>
-              <a:ext uri="{FF2B5EF4-FFF2-40B4-BE49-F238E27FC236}">
-                <a16:creationId xmlns:a16="http://schemas.microsoft.com/office/drawing/2014/main" id="{E3BDC0A7-B788-0015-0D36-BD5E1319F4DA}"/>
-              </a:ext>
-            </a:extLst>
-          </p:cNvPr>
-          <p:cNvPicPr>
-            <a:picLocks noChangeAspect="1"/>
-          </p:cNvPicPr>
-          <p:nvPr/>
-        </p:nvPicPr>
-        <p:blipFill>
-          <a:blip r:embed="rId3"/>
-          <a:stretch>
-            <a:fillRect/>
-          </a:stretch>
-        </p:blipFill>
-        <p:spPr>
-          <a:xfrm>
-            <a:off x="3529372" y="559331"/>
-            <a:ext cx="5162279" cy="3348794"/>
-          </a:xfrm>
-          <a:prstGeom prst="rect">
-            <a:avLst/>
-          </a:prstGeom>
-        </p:spPr>
-      </p:pic>
-      <p:pic>
-        <p:nvPicPr>
-          <p:cNvPr id="8" name="Picture 7">
-            <a:extLst>
-              <a:ext uri="{FF2B5EF4-FFF2-40B4-BE49-F238E27FC236}">
-                <a16:creationId xmlns:a16="http://schemas.microsoft.com/office/drawing/2014/main" id="{351AB855-A635-3FCC-D993-3997626F1A21}"/>
-              </a:ext>
-            </a:extLst>
-          </p:cNvPr>
-          <p:cNvPicPr>
-            <a:picLocks noChangeAspect="1"/>
-          </p:cNvPicPr>
-          <p:nvPr/>
-        </p:nvPicPr>
-        <p:blipFill>
-          <a:blip r:embed="rId4"/>
-          <a:stretch>
-            <a:fillRect/>
-          </a:stretch>
-        </p:blipFill>
-        <p:spPr>
-          <a:xfrm>
-            <a:off x="8711460" y="559331"/>
-            <a:ext cx="3062834" cy="2245122"/>
-          </a:xfrm>
-          <a:prstGeom prst="rect">
-            <a:avLst/>
-          </a:prstGeom>
-        </p:spPr>
-      </p:pic>
       <p:sp>
         <p:nvSpPr>
           <p:cNvPr id="21" name="TextBox 20">
@@ -23120,7 +22910,7 @@
         </p:nvSpPr>
         <p:spPr>
           <a:xfrm>
-            <a:off x="9349398" y="559331"/>
+            <a:off x="8467548" y="738817"/>
             <a:ext cx="2421147" cy="307777"/>
           </a:xfrm>
           <a:prstGeom prst="rect">
@@ -23155,10 +22945,10 @@
       </p:sp>
       <p:pic>
         <p:nvPicPr>
-          <p:cNvPr id="10" name="Picture 9">
+          <p:cNvPr id="6" name="Picture 5">
             <a:extLst>
               <a:ext uri="{FF2B5EF4-FFF2-40B4-BE49-F238E27FC236}">
-                <a16:creationId xmlns:a16="http://schemas.microsoft.com/office/drawing/2014/main" id="{9713C82C-7182-409C-E2EA-E67D63249EF5}"/>
+                <a16:creationId xmlns:a16="http://schemas.microsoft.com/office/drawing/2014/main" id="{D23227FA-4A37-A558-9DEB-DAB326CBF1EA}"/>
               </a:ext>
             </a:extLst>
           </p:cNvPr>
@@ -23168,15 +22958,22 @@
           <p:nvPr/>
         </p:nvPicPr>
         <p:blipFill>
-          <a:blip r:embed="rId5"/>
+          <a:blip r:embed="rId5">
+            <a:extLst>
+              <a:ext uri="{28A0092B-C50C-407E-A947-70E740481C1C}">
+                <a14:useLocalDpi xmlns:a14="http://schemas.microsoft.com/office/drawing/2010/main" val="0"/>
+              </a:ext>
+            </a:extLst>
+          </a:blip>
+          <a:srcRect l="25414" t="25149" r="11826" b="20684"/>
           <a:stretch>
             <a:fillRect/>
           </a:stretch>
         </p:blipFill>
         <p:spPr>
           <a:xfrm>
-            <a:off x="8717237" y="2783050"/>
-            <a:ext cx="2069389" cy="2593455"/>
+            <a:off x="3232261" y="863012"/>
+            <a:ext cx="4972051" cy="3218423"/>
           </a:xfrm>
           <a:prstGeom prst="rect">
             <a:avLst/>

</xml_diff>